<commit_message>
Ensure latest PPTX and presentation.html are pushed
</commit_message>
<xml_diff>
--- a/NCT_Water_Nexus_Report_and_Pricing.pptx
+++ b/NCT_Water_Nexus_Report_and_Pricing.pptx
@@ -3181,7 +3181,7 @@
               </a:defRPr>
             </a:pPr>
             <a:r>
-              <a:t>💧 โครงการระบบตรวจวัดคุณภาพน้ำอัจฉริยะและแจ้งเตือนอัตโนมัติ (100 จุด)</a:t>
+              <a:t>💧 โครงการระบบตรวจวัดคุณภาพน้ำอัจฉริยะ 100 ชุด (Modela + Cybertice)</a:t>
             </a:r>
           </a:p>
           <a:p>
@@ -3211,7 +3211,7 @@
               </a:defRPr>
             </a:pPr>
             <a:r>
-              <a:t>สรุปราคาและรูปแบบแจ้งเตือน: ตรวจวัด pH / TDS / อุณหภูมิ / คลอรีนคงเหลือ</a:t>
+              <a:t>สรุปรายการต้นทุน (BOM) และราคาขายโครงการตรวจวัดคุณภาพน้ำ (100 ชุด)</a:t>
             </a:r>
           </a:p>
           <a:p>
@@ -3226,15 +3226,15 @@
               </a:defRPr>
             </a:pPr>
             <a:r>
-              <a:t>• ต้นทุนฮาร์ดแวร์ตู้คอนโทรล 4 ค่า: ฿21,000 / ชุด (รวม 100 จุด = ฿2,100,000)</a:t>
+              <a:t>• ตรวจวัด 4 ค่าหลัก: pH / TDS / อุณหภูมิ / คลอรีนคงเหลือ (Modela One + Cybertice)</a:t>
             </a:r>
             <a:br/>
             <a:r>
-              <a:t>• 3 ออปชันซอฟต์แวร์และระบบแจ้งเตือน (Option 1: App+Telegram | Option 2: Web+Telegram | Option 3: Web+App+LINE OA)</a:t>
+              <a:t>• ต้นทุนฮาร์ดแวร์ตู้คอนโทรล: ฿21,000 / ชุด (โครงการ 100 ชุด = ฿2,100,000)</a:t>
             </a:r>
             <a:br/>
             <a:r>
-              <a:t>• รูปแบบการลงทุน: 【 แบบซื้อขาด (2.5 - 6.0 แสน) 】 vs 【 แบบรายปี (1.2 - 3.6 แสน/ปี Recurring Income) 】</a:t>
+              <a:t>• 2 รูปแบบข้อเสนอราคา: 【 แบบที่ 1 Plug &amp; Play (2.95 - 3.20 ล้าน) 】 vs 【 แบบที่ 2 Turnkey (3.80 - 4.20 ล้าน) 】</a:t>
             </a:r>
           </a:p>
           <a:p>
@@ -3310,7 +3310,7 @@
               </a:defRPr>
             </a:pPr>
             <a:r>
-              <a:t>โครงการระบบวัดคุณภาพน้ำอัจฉริยะ 100 จุด (NCT WATER NEXUS)</a:t>
+              <a:t>โครงการระบบตรวจวัดคุณภาพน้ำ 100 ชุด (NCT WATER NEXUS)</a:t>
             </a:r>
           </a:p>
           <a:p>
@@ -3322,7 +3322,7 @@
               </a:defRPr>
             </a:pPr>
             <a:r>
-              <a:t>1. ต้นทุนฮาร์ดแวร์ตู้คอนโทรลต่อชุดและรวม 100 จุด (Hardware BOM)</a:t>
+              <a:t>1. ตารางต้นทุนฮาร์ดแวร์และอุปกรณ์ต่อชุด (BOM per Unit)</a:t>
             </a:r>
           </a:p>
         </p:txBody>
@@ -3336,7 +3336,7 @@
         <p:spPr>
           <a:xfrm>
             <a:off x="731520" y="1463040"/>
-            <a:ext cx="3383280" cy="3474720"/>
+            <a:ext cx="2468880" cy="3291840"/>
           </a:xfrm>
           <a:prstGeom prst="roundRect">
             <a:avLst/>
@@ -3381,7 +3381,7 @@
         <p:spPr>
           <a:xfrm>
             <a:off x="731520" y="1463040"/>
-            <a:ext cx="3383280" cy="1097280"/>
+            <a:ext cx="2468880" cy="1097280"/>
           </a:xfrm>
           <a:prstGeom prst="roundRect">
             <a:avLst/>
@@ -3423,8 +3423,8 @@
         </p:nvSpPr>
         <p:spPr>
           <a:xfrm>
-            <a:off x="868680" y="1554480"/>
-            <a:ext cx="3108960" cy="914400"/>
+            <a:off x="841248" y="1536192"/>
+            <a:ext cx="2249424" cy="960120"/>
           </a:xfrm>
           <a:prstGeom prst="rect">
             <a:avLst/>
@@ -3438,26 +3438,26 @@
           <a:lstStyle/>
           <a:p>
             <a:pPr>
-              <a:defRPr sz="1150" b="1">
+              <a:defRPr sz="1000" b="1">
                 <a:solidFill>
                   <a:srgbClr val="FFFFFF"/>
                 </a:solidFill>
               </a:defRPr>
             </a:pPr>
             <a:r>
-              <a:t>ชุดเซนเซอร์ 4 ค่า (Modela + คลอรีน)</a:t>
-            </a:r>
-          </a:p>
-          <a:p>
-            <a:pPr>
-              <a:defRPr sz="1400" b="1">
+              <a:t>ชุดเซนเซอร์หลัก (Modela One + pH/TDS/Temp + คลอรีน Cybertice)</a:t>
+            </a:r>
+          </a:p>
+          <a:p>
+            <a:pPr>
+              <a:defRPr sz="1500" b="1">
                 <a:solidFill>
                   <a:srgbClr val="FFFFFF"/>
                 </a:solidFill>
               </a:defRPr>
             </a:pPr>
             <a:r>
-              <a:t>ต้นทุน: ฿17,000 / ชุด</a:t>
+              <a:t>฿17,000</a:t>
             </a:r>
           </a:p>
         </p:txBody>
@@ -3470,8 +3470,8 @@
         </p:nvSpPr>
         <p:spPr>
           <a:xfrm>
-            <a:off x="868680" y="2697480"/>
-            <a:ext cx="3108960" cy="2103120"/>
+            <a:off x="841248" y="2651760"/>
+            <a:ext cx="2249424" cy="2011680"/>
           </a:xfrm>
           <a:prstGeom prst="rect">
             <a:avLst/>
@@ -3485,13 +3485,17 @@
           <a:lstStyle/>
           <a:p>
             <a:pPr>
-              <a:defRPr sz="1000">
+              <a:defRPr sz="880">
                 <a:solidFill>
                   <a:srgbClr val="64748B"/>
                 </a:solidFill>
               </a:defRPr>
             </a:pPr>
             <a:r>
+              <a:t>• บอร์ดควบคุมหลัก Modela One (Modbus RTU/RS-485)</a:t>
+            </a:r>
+            <a:br/>
+            <a:r>
               <a:t>• หัววัด pH แก้วอุตสาหกรรม (±0.01 pH)</a:t>
             </a:r>
             <a:br/>
@@ -3500,11 +3504,11 @@
             </a:r>
             <a:br/>
             <a:r>
-              <a:t>• หัววัดอุณหภูมิน้ำ PT1000 RTD พร้อมระบบ ATC</a:t>
+              <a:t>• หัววัดอุณหภูมิ PT1000 (พร้อม ATC ชดเชยอุณหภูมิ)</a:t>
             </a:r>
             <a:br/>
             <a:r>
-              <a:t>• หัววัดคลอรีนคงเหลือ (Residual Chlorine)</a:t>
+              <a:t>• เซนเซอร์คลอรีนคงเหลือ Cybertice (Residual Chlorine)</a:t>
             </a:r>
           </a:p>
         </p:txBody>
@@ -3517,8 +3521,8 @@
         </p:nvSpPr>
         <p:spPr>
           <a:xfrm>
-            <a:off x="4389120" y="1463040"/>
-            <a:ext cx="3383280" cy="3474720"/>
+            <a:off x="3474720" y="1463040"/>
+            <a:ext cx="2468880" cy="3291840"/>
           </a:xfrm>
           <a:prstGeom prst="roundRect">
             <a:avLst/>
@@ -3562,8 +3566,8 @@
         </p:nvSpPr>
         <p:spPr>
           <a:xfrm>
-            <a:off x="4389120" y="1463040"/>
-            <a:ext cx="3383280" cy="1097280"/>
+            <a:off x="3474720" y="1463040"/>
+            <a:ext cx="2468880" cy="1097280"/>
           </a:xfrm>
           <a:prstGeom prst="roundRect">
             <a:avLst/>
@@ -3605,8 +3609,8 @@
         </p:nvSpPr>
         <p:spPr>
           <a:xfrm>
-            <a:off x="4526280" y="1554480"/>
-            <a:ext cx="3108960" cy="914400"/>
+            <a:off x="3584448" y="1536192"/>
+            <a:ext cx="2249424" cy="960120"/>
           </a:xfrm>
           <a:prstGeom prst="rect">
             <a:avLst/>
@@ -3620,26 +3624,26 @@
           <a:lstStyle/>
           <a:p>
             <a:pPr>
-              <a:defRPr sz="1150" b="1">
+              <a:defRPr sz="1000" b="1">
                 <a:solidFill>
                   <a:srgbClr val="FFFFFF"/>
                 </a:solidFill>
               </a:defRPr>
             </a:pPr>
             <a:r>
-              <a:t>4G Router + ซิมรายปี</a:t>
-            </a:r>
-          </a:p>
-          <a:p>
-            <a:pPr>
-              <a:defRPr sz="1400" b="1">
+              <a:t>4G LTE Router (TP-Link TL-MR100)</a:t>
+            </a:r>
+          </a:p>
+          <a:p>
+            <a:pPr>
+              <a:defRPr sz="1500" b="1">
                 <a:solidFill>
                   <a:srgbClr val="FFFFFF"/>
                 </a:solidFill>
               </a:defRPr>
             </a:pPr>
             <a:r>
-              <a:t>ต้นทุน: ฿2,800 / ชุด</a:t>
+              <a:t>฿1,000</a:t>
             </a:r>
           </a:p>
         </p:txBody>
@@ -3652,8 +3656,8 @@
         </p:nvSpPr>
         <p:spPr>
           <a:xfrm>
-            <a:off x="4526280" y="2697480"/>
-            <a:ext cx="3108960" cy="2103120"/>
+            <a:off x="3584448" y="2651760"/>
+            <a:ext cx="2249424" cy="2011680"/>
           </a:xfrm>
           <a:prstGeom prst="rect">
             <a:avLst/>
@@ -3667,22 +3671,22 @@
           <a:lstStyle/>
           <a:p>
             <a:pPr>
-              <a:defRPr sz="1000">
+              <a:defRPr sz="880">
                 <a:solidFill>
                   <a:srgbClr val="64748B"/>
                 </a:solidFill>
               </a:defRPr>
             </a:pPr>
             <a:r>
-              <a:t>• Industrial 4G LTE Router เสาสัญญาณภายนอก</a:t>
+              <a:t>• เราเตอร์ 4G LTE Wi-Fi ความเร็ว 300 Mbps</a:t>
             </a:r>
             <a:br/>
             <a:r>
-              <a:t>• ซิมอินเทอร์เน็ต IoT รายปี ไม่จำกัดปริมาณข้อมูล</a:t>
+              <a:t>• เสารับสัญญาณภายนอก 2 เสา สัญญาณนิ่งเสถียร</a:t>
             </a:r>
             <a:br/>
             <a:r>
-              <a:t>• ส่งข้อมูล Telemetry สดทุก 1 วินาที สู่คลาวด์</a:t>
+              <a:t>• เชื่อมต่อระบบ Telemetry สดทุก 1 วินาที</a:t>
             </a:r>
           </a:p>
         </p:txBody>
@@ -3695,8 +3699,8 @@
         </p:nvSpPr>
         <p:spPr>
           <a:xfrm>
-            <a:off x="8046720" y="1463040"/>
-            <a:ext cx="3383280" cy="3474720"/>
+            <a:off x="6217920" y="1463040"/>
+            <a:ext cx="2468880" cy="3291840"/>
           </a:xfrm>
           <a:prstGeom prst="roundRect">
             <a:avLst/>
@@ -3740,8 +3744,8 @@
         </p:nvSpPr>
         <p:spPr>
           <a:xfrm>
-            <a:off x="8046720" y="1463040"/>
-            <a:ext cx="3383280" cy="1097280"/>
+            <a:off x="6217920" y="1463040"/>
+            <a:ext cx="2468880" cy="1097280"/>
           </a:xfrm>
           <a:prstGeom prst="roundRect">
             <a:avLst/>
@@ -3783,8 +3787,8 @@
         </p:nvSpPr>
         <p:spPr>
           <a:xfrm>
-            <a:off x="8183880" y="1554480"/>
-            <a:ext cx="3108960" cy="914400"/>
+            <a:off x="6327648" y="1536192"/>
+            <a:ext cx="2249424" cy="960120"/>
           </a:xfrm>
           <a:prstGeom prst="rect">
             <a:avLst/>
@@ -3798,26 +3802,26 @@
           <a:lstStyle/>
           <a:p>
             <a:pPr>
-              <a:defRPr sz="1150" b="1">
+              <a:defRPr sz="1000" b="1">
                 <a:solidFill>
                   <a:srgbClr val="FFFFFF"/>
                 </a:solidFill>
               </a:defRPr>
             </a:pPr>
             <a:r>
-              <a:t>ตู้กันน้ำ IP65 + สวิตชิ่ง + เบรกเกอร์</a:t>
-            </a:r>
-          </a:p>
-          <a:p>
-            <a:pPr>
-              <a:defRPr sz="1400" b="1">
+              <a:t>ซิมการ์ด 4G รายปี (Unlimited 15-20 Mbps)</a:t>
+            </a:r>
+          </a:p>
+          <a:p>
+            <a:pPr>
+              <a:defRPr sz="1500" b="1">
                 <a:solidFill>
                   <a:srgbClr val="FFFFFF"/>
                 </a:solidFill>
               </a:defRPr>
             </a:pPr>
             <a:r>
-              <a:t>ต้นทุน: ฿1,200 / ชุด</a:t>
+              <a:t>฿1,800</a:t>
             </a:r>
           </a:p>
         </p:txBody>
@@ -3830,8 +3834,8 @@
         </p:nvSpPr>
         <p:spPr>
           <a:xfrm>
-            <a:off x="8183880" y="2697480"/>
-            <a:ext cx="3108960" cy="2103120"/>
+            <a:off x="6327648" y="2651760"/>
+            <a:ext cx="2249424" cy="2011680"/>
           </a:xfrm>
           <a:prstGeom prst="rect">
             <a:avLst/>
@@ -3845,22 +3849,22 @@
           <a:lstStyle/>
           <a:p>
             <a:pPr>
-              <a:defRPr sz="1000">
+              <a:defRPr sz="880">
                 <a:solidFill>
                   <a:srgbClr val="64748B"/>
                 </a:solidFill>
               </a:defRPr>
             </a:pPr>
             <a:r>
-              <a:t>• ตู้ควบคุมกันน้ำกันฝุ่นมาตรฐาน IP65</a:t>
+              <a:t>• ซิมเน็ต IoT รายปี ไม่อั้น ไม่ลดสปีด (15-20 Mbps)</a:t>
             </a:r>
             <a:br/>
             <a:r>
-              <a:t>• แหล่งจ่ายไฟ Switching Power Supply 12V/24V</a:t>
+              <a:t>• รวมค่าบริการเครือข่าย 12 เดือนเต็ม</a:t>
             </a:r>
             <a:br/>
             <a:r>
-              <a:t>• เบรกเกอร์ป้องกันไฟกระชากและไฟเกิน (Surge)</a:t>
+              <a:t>• ส่งข้อมูลขึ้นระบบคลาวด์และแจ้งเตือน 24 ชม.</a:t>
             </a:r>
           </a:p>
         </p:txBody>
@@ -3873,8 +3877,186 @@
         </p:nvSpPr>
         <p:spPr>
           <a:xfrm>
-            <a:off x="731520" y="5120640"/>
-            <a:ext cx="10728655" cy="1188720"/>
+            <a:off x="8961120" y="1463040"/>
+            <a:ext cx="2468880" cy="3291840"/>
+          </a:xfrm>
+          <a:prstGeom prst="roundRect">
+            <a:avLst/>
+          </a:prstGeom>
+          <a:solidFill>
+            <a:srgbClr val="FFFFFF"/>
+          </a:solidFill>
+          <a:ln w="19050">
+            <a:solidFill>
+              <a:srgbClr val="1E293B"/>
+            </a:solidFill>
+          </a:ln>
+        </p:spPr>
+        <p:style>
+          <a:lnRef idx="1">
+            <a:schemeClr val="accent1"/>
+          </a:lnRef>
+          <a:fillRef idx="3">
+            <a:schemeClr val="accent1"/>
+          </a:fillRef>
+          <a:effectRef idx="2">
+            <a:schemeClr val="accent1"/>
+          </a:effectRef>
+          <a:fontRef idx="minor">
+            <a:schemeClr val="lt1"/>
+          </a:fontRef>
+        </p:style>
+        <p:txBody>
+          <a:bodyPr rtlCol="0" anchor="ctr"/>
+          <a:lstStyle/>
+          <a:p>
+            <a:pPr algn="ctr"/>
+          </a:p>
+        </p:txBody>
+      </p:sp>
+      <p:sp>
+        <p:nvSpPr>
+          <p:cNvPr id="16" name="Rounded Rectangle 15"/>
+          <p:cNvSpPr/>
+          <p:nvPr/>
+        </p:nvSpPr>
+        <p:spPr>
+          <a:xfrm>
+            <a:off x="8961120" y="1463040"/>
+            <a:ext cx="2468880" cy="1097280"/>
+          </a:xfrm>
+          <a:prstGeom prst="roundRect">
+            <a:avLst/>
+          </a:prstGeom>
+          <a:solidFill>
+            <a:srgbClr val="1E293B"/>
+          </a:solidFill>
+          <a:ln>
+            <a:noFill/>
+          </a:ln>
+        </p:spPr>
+        <p:style>
+          <a:lnRef idx="1">
+            <a:schemeClr val="accent1"/>
+          </a:lnRef>
+          <a:fillRef idx="3">
+            <a:schemeClr val="accent1"/>
+          </a:fillRef>
+          <a:effectRef idx="2">
+            <a:schemeClr val="accent1"/>
+          </a:effectRef>
+          <a:fontRef idx="minor">
+            <a:schemeClr val="lt1"/>
+          </a:fontRef>
+        </p:style>
+        <p:txBody>
+          <a:bodyPr rtlCol="0" anchor="ctr"/>
+          <a:lstStyle/>
+          <a:p>
+            <a:pPr algn="ctr"/>
+          </a:p>
+        </p:txBody>
+      </p:sp>
+      <p:sp>
+        <p:nvSpPr>
+          <p:cNvPr id="17" name="TextBox 16"/>
+          <p:cNvSpPr txBox="1"/>
+          <p:nvPr/>
+        </p:nvSpPr>
+        <p:spPr>
+          <a:xfrm>
+            <a:off x="9070848" y="1536192"/>
+            <a:ext cx="2249424" cy="960120"/>
+          </a:xfrm>
+          <a:prstGeom prst="rect">
+            <a:avLst/>
+          </a:prstGeom>
+          <a:noFill/>
+        </p:spPr>
+        <p:txBody>
+          <a:bodyPr wrap="square">
+            <a:spAutoFit/>
+          </a:bodyPr>
+          <a:lstStyle/>
+          <a:p>
+            <a:pPr>
+              <a:defRPr sz="1000" b="1">
+                <a:solidFill>
+                  <a:srgbClr val="FFFFFF"/>
+                </a:solidFill>
+              </a:defRPr>
+            </a:pPr>
+            <a:r>
+              <a:t>ตู้คอนโทรล IP65 + Switching 24V + Breaker + Wiring</a:t>
+            </a:r>
+          </a:p>
+          <a:p>
+            <a:pPr>
+              <a:defRPr sz="1500" b="1">
+                <a:solidFill>
+                  <a:srgbClr val="FFFFFF"/>
+                </a:solidFill>
+              </a:defRPr>
+            </a:pPr>
+            <a:r>
+              <a:t>฿1,200</a:t>
+            </a:r>
+          </a:p>
+        </p:txBody>
+      </p:sp>
+      <p:sp>
+        <p:nvSpPr>
+          <p:cNvPr id="18" name="TextBox 17"/>
+          <p:cNvSpPr txBox="1"/>
+          <p:nvPr/>
+        </p:nvSpPr>
+        <p:spPr>
+          <a:xfrm>
+            <a:off x="9070848" y="2651760"/>
+            <a:ext cx="2249424" cy="2011680"/>
+          </a:xfrm>
+          <a:prstGeom prst="rect">
+            <a:avLst/>
+          </a:prstGeom>
+          <a:noFill/>
+        </p:spPr>
+        <p:txBody>
+          <a:bodyPr wrap="square">
+            <a:spAutoFit/>
+          </a:bodyPr>
+          <a:lstStyle/>
+          <a:p>
+            <a:pPr>
+              <a:defRPr sz="880">
+                <a:solidFill>
+                  <a:srgbClr val="64748B"/>
+                </a:solidFill>
+              </a:defRPr>
+            </a:pPr>
+            <a:r>
+              <a:t>• ตู้กันน้ำกันฝุ่นมาตรฐาน IP65</a:t>
+            </a:r>
+            <a:br/>
+            <a:r>
+              <a:t>• แหล่งจ่ายไฟ Switching Power Supply 24V</a:t>
+            </a:r>
+            <a:br/>
+            <a:r>
+              <a:t>• Breaker ป้องกันไฟเกิน + Terminal + สายไฟประกอบครบ</a:t>
+            </a:r>
+          </a:p>
+        </p:txBody>
+      </p:sp>
+      <p:sp>
+        <p:nvSpPr>
+          <p:cNvPr id="19" name="Rounded Rectangle 18"/>
+          <p:cNvSpPr/>
+          <p:nvPr/>
+        </p:nvSpPr>
+        <p:spPr>
+          <a:xfrm>
+            <a:off x="731520" y="4937760"/>
+            <a:ext cx="10728655" cy="1371600"/>
           </a:xfrm>
           <a:prstGeom prst="roundRect">
             <a:avLst/>
@@ -3912,14 +4094,14 @@
       </p:sp>
       <p:sp>
         <p:nvSpPr>
-          <p:cNvPr id="16" name="TextBox 15"/>
+          <p:cNvPr id="20" name="TextBox 19"/>
           <p:cNvSpPr txBox="1"/>
           <p:nvPr/>
         </p:nvSpPr>
         <p:spPr>
           <a:xfrm>
-            <a:off x="1005840" y="5257800"/>
-            <a:ext cx="10149840" cy="914400"/>
+            <a:off x="1005840" y="5074920"/>
+            <a:ext cx="10149840" cy="1097280"/>
           </a:xfrm>
           <a:prstGeom prst="rect">
             <a:avLst/>
@@ -3936,26 +4118,26 @@
               <a:spcAft>
                 <a:spcPts val="400"/>
               </a:spcAft>
-              <a:defRPr sz="1500" b="1">
+              <a:defRPr sz="1600" b="1">
                 <a:solidFill>
                   <a:srgbClr val="2DD4BF"/>
                 </a:solidFill>
               </a:defRPr>
             </a:pPr>
             <a:r>
-              <a:t>➡️ รวมต้นทุนฮาร์ดแวร์: ฿21,000 บ./ชุด  |  โครงการ 100 จุด = ฿2,100,000 บาท</a:t>
-            </a:r>
-          </a:p>
-          <a:p>
-            <a:pPr>
-              <a:defRPr sz="1050">
+              <a:t>➡️ รวมต้นทุนต่อชุด: ฿21,000 บาท  |  รวมต้นทุนโครงการ (100 ชุด): ฿2,100,000 บาท</a:t>
+            </a:r>
+          </a:p>
+          <a:p>
+            <a:pPr>
+              <a:defRPr sz="1000">
                 <a:solidFill>
                   <a:srgbClr val="E2E8F0"/>
                 </a:solidFill>
               </a:defRPr>
             </a:pPr>
             <a:r>
-              <a:t>วัดค่าครบ 4 พารามิเตอร์: pH (กรด-ด่าง) • TDS (สารละลายรวม) • อุณหภูมิน้ำ (ATC) • คลอรีนคงเหลือ (Residual Chlorine) พร้อมส่งสัญญาณ 4G เรียบร้อย</a:t>
+              <a:t>ต้นทุนนี้ครอบคลุมชุดหัววัดเซนเซอร์ 4 ค่า (pH / TDS / Temp / Cl) + กล่อง Modela One + เราเตอร์ 4G TP-Link + ซิมรายปี + ตู้ IP65 ประกอบสำเร็จพร้อมใช้งาน</a:t>
             </a:r>
           </a:p>
         </p:txBody>
@@ -4019,7 +4201,7 @@
               </a:defRPr>
             </a:pPr>
             <a:r>
-              <a:t>โครงการระบบวัดคุณภาพน้ำอัจฉริยะ 100 จุด (NCT WATER NEXUS)</a:t>
+              <a:t>โครงการระบบตรวจวัดคุณภาพน้ำ 100 ชุด (NCT WATER NEXUS)</a:t>
             </a:r>
           </a:p>
           <a:p>
@@ -4031,7 +4213,7 @@
               </a:defRPr>
             </a:pPr>
             <a:r>
-              <a:t>2. ราคาซอฟต์แวร์ Dashboard &amp; ระบบแจ้งเตือน (โครงการ 100 จุด)</a:t>
+              <a:t>2. โครงสร้างราคาขายแนะนำ (แพ็กเกจ 100 ชุด รวม App + Web Dashboard)</a:t>
             </a:r>
           </a:p>
         </p:txBody>
@@ -4045,7 +4227,7 @@
         <p:spPr>
           <a:xfrm>
             <a:off x="731520" y="1463040"/>
-            <a:ext cx="3383280" cy="4754880"/>
+            <a:ext cx="5120640" cy="4754880"/>
           </a:xfrm>
           <a:prstGeom prst="roundRect">
             <a:avLst/>
@@ -4090,7 +4272,7 @@
         <p:spPr>
           <a:xfrm>
             <a:off x="731520" y="1463040"/>
-            <a:ext cx="3383280" cy="1280160"/>
+            <a:ext cx="5120640" cy="1188720"/>
           </a:xfrm>
           <a:prstGeom prst="roundRect">
             <a:avLst/>
@@ -4133,7 +4315,7 @@
         <p:spPr>
           <a:xfrm>
             <a:off x="914400" y="1554480"/>
-            <a:ext cx="3017520" cy="1097280"/>
+            <a:ext cx="4754880" cy="1005840"/>
           </a:xfrm>
           <a:prstGeom prst="rect">
             <a:avLst/>
@@ -4147,26 +4329,26 @@
           <a:lstStyle/>
           <a:p>
             <a:pPr>
-              <a:defRPr sz="950" b="1">
+              <a:defRPr sz="1300" b="1">
                 <a:solidFill>
                   <a:srgbClr val="FFFFFF"/>
                 </a:solidFill>
               </a:defRPr>
             </a:pPr>
             <a:r>
-              <a:t>[ Option 1 ] ★ แนะนำ คุ้มค่าสูงสุด</a:t>
-            </a:r>
-          </a:p>
-          <a:p>
-            <a:pPr>
-              <a:defRPr sz="1350" b="1">
+              <a:t>[แบบที่ 1] ส่งมอบอุปกรณ์พร้อมระบบออนไลน์</a:t>
+            </a:r>
+          </a:p>
+          <a:p>
+            <a:pPr>
+              <a:defRPr sz="1100" b="1">
                 <a:solidFill>
                   <a:srgbClr val="FFFFFF"/>
                 </a:solidFill>
               </a:defRPr>
             </a:pPr>
             <a:r>
-              <a:t>แอปมือถือ + Telegram</a:t>
+              <a:t>Plug &amp; Play / Supply Only (ราคา ฿29,500 - ฿32,000 / ชุด)</a:t>
             </a:r>
           </a:p>
         </p:txBody>
@@ -4179,8 +4361,8 @@
         </p:nvSpPr>
         <p:spPr>
           <a:xfrm>
-            <a:off x="914400" y="2834640"/>
-            <a:ext cx="3017520" cy="3291840"/>
+            <a:off x="914400" y="2743200"/>
+            <a:ext cx="4754880" cy="3383280"/>
           </a:xfrm>
           <a:prstGeom prst="rect">
             <a:avLst/>
@@ -4194,48 +4376,17 @@
           <a:lstStyle/>
           <a:p>
             <a:pPr>
-              <a:defRPr b="1" sz="1050">
-                <a:solidFill>
-                  <a:srgbClr val="0284C7"/>
-                </a:solidFill>
-              </a:defRPr>
-            </a:pPr>
-            <a:r>
-              <a:t>• แบบซื้อขาด: ฿250,000 (2,500 บ./จุด)</a:t>
-            </a:r>
-          </a:p>
-          <a:p>
-            <a:pPr>
               <a:spcAft>
-                <a:spcPts val="600"/>
+                <a:spcPts val="400"/>
               </a:spcAft>
-              <a:defRPr b="1" sz="1000">
-                <a:solidFill>
-                  <a:srgbClr val="059669"/>
-                </a:solidFill>
-              </a:defRPr>
-            </a:pPr>
-            <a:r>
-              <a:t>• แบบรายปี: ฿170,000 (ปีแรก)</a:t>
-            </a:r>
-            <a:br/>
-            <a:r>
-              <a:t>  (ปีถัดไป ฿120,000 บ./ปี (1,200 บ./จุด/ปี))</a:t>
-            </a:r>
-          </a:p>
-          <a:p>
-            <a:pPr>
-              <a:spcAft>
-                <a:spcPts val="600"/>
-              </a:spcAft>
-              <a:defRPr sz="900" b="1">
+              <a:defRPr b="1" sz="1100">
                 <a:solidFill>
                   <a:srgbClr val="0F172A"/>
                 </a:solidFill>
               </a:defRPr>
             </a:pPr>
             <a:r>
-              <a:t>💡 จุดเด่น: แจ้งเตือนฟรีตลอดชีพ ไม่มีค่าส่งข้อความ</a:t>
+              <a:t>📋 ขอบเขตงาน (Scope of Work):</a:t>
             </a:r>
           </a:p>
           <a:p>
@@ -4243,14 +4394,14 @@
               <a:spcAft>
                 <a:spcPts val="200"/>
               </a:spcAft>
-              <a:defRPr sz="880">
+              <a:defRPr sz="950">
                 <a:solidFill>
                   <a:srgbClr val="64748B"/>
                 </a:solidFill>
               </a:defRPr>
             </a:pPr>
             <a:r>
-              <a:t>✓ Mobile App (iOS &amp; Android) สลับดู 100 จุด</a:t>
+              <a:t>✔ ประกอบตู้คอนโทรลสำเร็จรูป พร้อมเดินระบบไฟภายใน</a:t>
             </a:r>
           </a:p>
           <a:p>
@@ -4258,14 +4409,14 @@
               <a:spcAft>
                 <a:spcPts val="200"/>
               </a:spcAft>
-              <a:defRPr sz="880">
+              <a:defRPr sz="950">
                 <a:solidFill>
                   <a:srgbClr val="64748B"/>
                 </a:solidFill>
               </a:defRPr>
             </a:pPr>
             <a:r>
-              <a:t>✓ แจ้งเตือนผ่าน Telegram Bot แบบกลุ่ม/เดี่ยว</a:t>
+              <a:t>✔ ใส่ซิมรายปีและตั้งค่าเชื่อมต่อเน็ตเวิร์ก 4G LTE</a:t>
             </a:r>
           </a:p>
           <a:p>
@@ -4273,14 +4424,14 @@
               <a:spcAft>
                 <a:spcPts val="200"/>
               </a:spcAft>
-              <a:defRPr sz="880">
+              <a:defRPr sz="950">
                 <a:solidFill>
                   <a:srgbClr val="64748B"/>
                 </a:solidFill>
               </a:defRPr>
             </a:pPr>
             <a:r>
-              <a:t>✓ ส่งข้อความเตือนฟรี 100% ไม่จำกัดจำนวนครั้ง</a:t>
+              <a:t>✔ เชื่อมต่อ Modbus อ่านค่า pH, TDS, Temp, Chlorine</a:t>
             </a:r>
           </a:p>
           <a:p>
@@ -4288,14 +4439,14 @@
               <a:spcAft>
                 <a:spcPts val="200"/>
               </a:spcAft>
-              <a:defRPr sz="880">
+              <a:defRPr sz="950">
                 <a:solidFill>
                   <a:srgbClr val="64748B"/>
                 </a:solidFill>
               </a:defRPr>
             </a:pPr>
             <a:r>
-              <a:t>✓ ไม่มีต้นทุนแฝง กำไรเต็มเม็ดเต็มหน่วย</a:t>
+              <a:t>✔ ตั้งค่าระบบ Modela App สำหรับดูข้อมูลและแจ้งเตือนผ่านมือถือ</a:t>
             </a:r>
           </a:p>
           <a:p>
@@ -4303,14 +4454,33 @@
               <a:spcAft>
                 <a:spcPts val="200"/>
               </a:spcAft>
-              <a:defRPr sz="880">
+              <a:defRPr sz="950">
                 <a:solidFill>
                   <a:srgbClr val="64748B"/>
                 </a:solidFill>
               </a:defRPr>
             </a:pPr>
             <a:r>
-              <a:t>✓ ฟรี Support / แก้บั๊ก 1 ปีแรก</a:t>
+              <a:t>✔ จัดทำ Web Dashboard กลางรวมข้อมูลทั้ง 100 จุด</a:t>
+            </a:r>
+          </a:p>
+          <a:p>
+            <a:pPr>
+              <a:spcBef>
+                <a:spcPts val="800"/>
+              </a:spcBef>
+              <a:defRPr b="1" sz="1000">
+                <a:solidFill>
+                  <a:srgbClr val="0284C7"/>
+                </a:solidFill>
+              </a:defRPr>
+            </a:pPr>
+            <a:r>
+              <a:t>💰 มูลค่าโครงการรวม (100 ชุด): ฿2,950,000 - ฿3,200,000 บาท</a:t>
+            </a:r>
+            <a:br/>
+            <a:r>
+              <a:t>📈 กำไรขั้นต้นโดยประมาณ: ฿850,000 - ฿1,100,000 บาท (Margin ~29-34%)</a:t>
             </a:r>
           </a:p>
         </p:txBody>
@@ -4323,8 +4493,8 @@
         </p:nvSpPr>
         <p:spPr>
           <a:xfrm>
-            <a:off x="4389120" y="1463040"/>
-            <a:ext cx="3383280" cy="4754880"/>
+            <a:off x="6309360" y="1463040"/>
+            <a:ext cx="5120640" cy="4754880"/>
           </a:xfrm>
           <a:prstGeom prst="roundRect">
             <a:avLst/>
@@ -4368,8 +4538,8 @@
         </p:nvSpPr>
         <p:spPr>
           <a:xfrm>
-            <a:off x="4389120" y="1463040"/>
-            <a:ext cx="3383280" cy="1280160"/>
+            <a:off x="6309360" y="1463040"/>
+            <a:ext cx="5120640" cy="1188720"/>
           </a:xfrm>
           <a:prstGeom prst="roundRect">
             <a:avLst/>
@@ -4411,8 +4581,8 @@
         </p:nvSpPr>
         <p:spPr>
           <a:xfrm>
-            <a:off x="4572000" y="1554480"/>
-            <a:ext cx="3017520" cy="1097280"/>
+            <a:off x="6492240" y="1554480"/>
+            <a:ext cx="4754880" cy="1005840"/>
           </a:xfrm>
           <a:prstGeom prst="rect">
             <a:avLst/>
@@ -4426,26 +4596,26 @@
           <a:lstStyle/>
           <a:p>
             <a:pPr>
-              <a:defRPr sz="950" b="1">
+              <a:defRPr sz="1300" b="1">
                 <a:solidFill>
                   <a:srgbClr val="FFFFFF"/>
                 </a:solidFill>
               </a:defRPr>
             </a:pPr>
             <a:r>
-              <a:t>[ Option 2 ] สำหรับห้องควบคุม SCADA</a:t>
-            </a:r>
-          </a:p>
-          <a:p>
-            <a:pPr>
-              <a:defRPr sz="1350" b="1">
+              <a:t>[แบบที่ 2] แบบครบวงจร รวมติดตั้งหน้างาน + สอบเทียบ</a:t>
+            </a:r>
+          </a:p>
+          <a:p>
+            <a:pPr>
+              <a:defRPr sz="1100" b="1">
                 <a:solidFill>
                   <a:srgbClr val="FFFFFF"/>
                 </a:solidFill>
               </a:defRPr>
             </a:pPr>
             <a:r>
-              <a:t>เว็บกลาง 100 จุด + Telegram</a:t>
+              <a:t>Turnkey Solution (ราคา ฿38,000 - ฿42,000 / ชุด)</a:t>
             </a:r>
           </a:p>
         </p:txBody>
@@ -4458,8 +4628,8 @@
         </p:nvSpPr>
         <p:spPr>
           <a:xfrm>
-            <a:off x="4572000" y="2834640"/>
-            <a:ext cx="3017520" cy="3291840"/>
+            <a:off x="6492240" y="2743200"/>
+            <a:ext cx="4754880" cy="3383280"/>
           </a:xfrm>
           <a:prstGeom prst="rect">
             <a:avLst/>
@@ -4473,48 +4643,17 @@
           <a:lstStyle/>
           <a:p>
             <a:pPr>
-              <a:defRPr b="1" sz="1050">
-                <a:solidFill>
-                  <a:srgbClr val="0284C7"/>
-                </a:solidFill>
-              </a:defRPr>
-            </a:pPr>
-            <a:r>
-              <a:t>• แบบซื้อขาด: ฿450,000 (4,500 บ./จุด)</a:t>
-            </a:r>
-          </a:p>
-          <a:p>
-            <a:pPr>
               <a:spcAft>
-                <a:spcPts val="600"/>
+                <a:spcPts val="400"/>
               </a:spcAft>
-              <a:defRPr b="1" sz="1000">
-                <a:solidFill>
-                  <a:srgbClr val="059669"/>
-                </a:solidFill>
-              </a:defRPr>
-            </a:pPr>
-            <a:r>
-              <a:t>• แบบรายปี: ฿340,000 (ปีแรก)</a:t>
-            </a:r>
-            <a:br/>
-            <a:r>
-              <a:t>  (ปีถัดไป ฿240,000 บ./ปี (2,400 บ./จุด/ปี))</a:t>
-            </a:r>
-          </a:p>
-          <a:p>
-            <a:pPr>
-              <a:spcAft>
-                <a:spcPts val="600"/>
-              </a:spcAft>
-              <a:defRPr sz="900" b="1">
+              <a:defRPr b="1" sz="1100">
                 <a:solidFill>
                   <a:srgbClr val="0F172A"/>
                 </a:solidFill>
               </a:defRPr>
             </a:pPr>
             <a:r>
-              <a:t>💡 จุดเด่น: ดูภาพรวมและตารางสรุปทั้ง 100 จุดในจอเดียว</a:t>
+              <a:t>📋 ขอบเขตงาน (Scope of Work):</a:t>
             </a:r>
           </a:p>
           <a:p>
@@ -4522,14 +4661,14 @@
               <a:spcAft>
                 <a:spcPts val="200"/>
               </a:spcAft>
-              <a:defRPr sz="880">
+              <a:defRPr sz="950">
                 <a:solidFill>
                   <a:srgbClr val="64748B"/>
                 </a:solidFill>
               </a:defRPr>
             </a:pPr>
             <a:r>
-              <a:t>✓ Centralized Web SCADA Dashboard 100 จุด</a:t>
+              <a:t>✔ ทุกอย่างในแบบที่ 1 (ตู้ + ซิม + Modbus + App + Web Dashboard)</a:t>
             </a:r>
           </a:p>
           <a:p>
@@ -4537,14 +4676,14 @@
               <a:spcAft>
                 <a:spcPts val="200"/>
               </a:spcAft>
-              <a:defRPr sz="880">
+              <a:defRPr sz="950">
                 <a:solidFill>
                   <a:srgbClr val="64748B"/>
                 </a:solidFill>
               </a:defRPr>
             </a:pPr>
             <a:r>
-              <a:t>✓ แผนที่ GIS Map &amp; ตารางสรุปสถานะ Real-Time</a:t>
+              <a:t>✔ ค่าแรงและทีมงานเข้าติดตั้งยึดตู้ / เดินท่อบายพาสหน้างาน</a:t>
             </a:r>
           </a:p>
           <a:p>
@@ -4552,14 +4691,14 @@
               <a:spcAft>
                 <a:spcPts val="200"/>
               </a:spcAft>
-              <a:defRPr sz="880">
+              <a:defRPr sz="950">
                 <a:solidFill>
                   <a:srgbClr val="64748B"/>
                 </a:solidFill>
               </a:defRPr>
             </a:pPr>
             <a:r>
-              <a:t>✓ กราฟวิเคราะห์แนวโน้ม Multi-Axis 100 สถานี</a:t>
+              <a:t>✔ สอบเทียบ (Calibration) หัววัด pH / TDS ด้วยน้ำยามาตรฐานหน้างาน</a:t>
             </a:r>
           </a:p>
           <a:p>
@@ -4567,14 +4706,14 @@
               <a:spcAft>
                 <a:spcPts val="200"/>
               </a:spcAft>
-              <a:defRPr sz="880">
+              <a:defRPr sz="950">
                 <a:solidFill>
                   <a:srgbClr val="64748B"/>
                 </a:solidFill>
               </a:defRPr>
             </a:pPr>
             <a:r>
-              <a:t>✓ แจ้งเตือนผ่าน Telegram Bot ทันทีเมื่อผิดปกติ</a:t>
+              <a:t>✔ อบรมการใช้งานระบบและส่งมอบคู่มือการปฏิบัติงาน</a:t>
             </a:r>
           </a:p>
           <a:p>
@@ -4582,191 +4721,21 @@
               <a:spcAft>
                 <a:spcPts val="200"/>
               </a:spcAft>
-              <a:defRPr sz="880">
+              <a:defRPr sz="950">
                 <a:solidFill>
                   <a:srgbClr val="64748B"/>
                 </a:solidFill>
               </a:defRPr>
             </a:pPr>
             <a:r>
-              <a:t>✓ Export รายงาน Excel / PDF ย้อนหลังได้</a:t>
-            </a:r>
-          </a:p>
-        </p:txBody>
-      </p:sp>
-      <p:sp>
-        <p:nvSpPr>
-          <p:cNvPr id="11" name="Rounded Rectangle 10"/>
-          <p:cNvSpPr/>
-          <p:nvPr/>
-        </p:nvSpPr>
-        <p:spPr>
-          <a:xfrm>
-            <a:off x="8046720" y="1463040"/>
-            <a:ext cx="3383280" cy="4754880"/>
-          </a:xfrm>
-          <a:prstGeom prst="roundRect">
-            <a:avLst/>
-          </a:prstGeom>
-          <a:solidFill>
-            <a:srgbClr val="FFFFFF"/>
-          </a:solidFill>
-          <a:ln w="19050">
-            <a:solidFill>
-              <a:srgbClr val="1E293B"/>
-            </a:solidFill>
-          </a:ln>
-        </p:spPr>
-        <p:style>
-          <a:lnRef idx="1">
-            <a:schemeClr val="accent1"/>
-          </a:lnRef>
-          <a:fillRef idx="3">
-            <a:schemeClr val="accent1"/>
-          </a:fillRef>
-          <a:effectRef idx="2">
-            <a:schemeClr val="accent1"/>
-          </a:effectRef>
-          <a:fontRef idx="minor">
-            <a:schemeClr val="lt1"/>
-          </a:fontRef>
-        </p:style>
-        <p:txBody>
-          <a:bodyPr rtlCol="0" anchor="ctr"/>
-          <a:lstStyle/>
-          <a:p>
-            <a:pPr algn="ctr"/>
-          </a:p>
-        </p:txBody>
-      </p:sp>
-      <p:sp>
-        <p:nvSpPr>
-          <p:cNvPr id="12" name="Rounded Rectangle 11"/>
-          <p:cNvSpPr/>
-          <p:nvPr/>
-        </p:nvSpPr>
-        <p:spPr>
-          <a:xfrm>
-            <a:off x="8046720" y="1463040"/>
-            <a:ext cx="3383280" cy="1280160"/>
-          </a:xfrm>
-          <a:prstGeom prst="roundRect">
-            <a:avLst/>
-          </a:prstGeom>
-          <a:solidFill>
-            <a:srgbClr val="1E293B"/>
-          </a:solidFill>
-          <a:ln>
-            <a:noFill/>
-          </a:ln>
-        </p:spPr>
-        <p:style>
-          <a:lnRef idx="1">
-            <a:schemeClr val="accent1"/>
-          </a:lnRef>
-          <a:fillRef idx="3">
-            <a:schemeClr val="accent1"/>
-          </a:fillRef>
-          <a:effectRef idx="2">
-            <a:schemeClr val="accent1"/>
-          </a:effectRef>
-          <a:fontRef idx="minor">
-            <a:schemeClr val="lt1"/>
-          </a:fontRef>
-        </p:style>
-        <p:txBody>
-          <a:bodyPr rtlCol="0" anchor="ctr"/>
-          <a:lstStyle/>
-          <a:p>
-            <a:pPr algn="ctr"/>
-          </a:p>
-        </p:txBody>
-      </p:sp>
-      <p:sp>
-        <p:nvSpPr>
-          <p:cNvPr id="13" name="TextBox 12"/>
-          <p:cNvSpPr txBox="1"/>
-          <p:nvPr/>
-        </p:nvSpPr>
-        <p:spPr>
-          <a:xfrm>
-            <a:off x="8229600" y="1554480"/>
-            <a:ext cx="3017520" cy="1097280"/>
-          </a:xfrm>
-          <a:prstGeom prst="rect">
-            <a:avLst/>
-          </a:prstGeom>
-          <a:noFill/>
-        </p:spPr>
-        <p:txBody>
-          <a:bodyPr wrap="square">
-            <a:spAutoFit/>
-          </a:bodyPr>
-          <a:lstStyle/>
-          <a:p>
-            <a:pPr>
-              <a:defRPr sz="950" b="1">
-                <a:solidFill>
-                  <a:srgbClr val="2DD4BF"/>
-                </a:solidFill>
-              </a:defRPr>
-            </a:pPr>
-            <a:r>
-              <a:t>[ Option 3 ] ครบวงจร + แจ้งเตือน LINE</a:t>
-            </a:r>
-          </a:p>
-          <a:p>
-            <a:pPr>
-              <a:defRPr sz="1350" b="1">
-                <a:solidFill>
-                  <a:srgbClr val="FFFFFF"/>
-                </a:solidFill>
-              </a:defRPr>
-            </a:pPr>
-            <a:r>
-              <a:t>เว็บกลาง + แอป + LINE OA</a:t>
-            </a:r>
-          </a:p>
-        </p:txBody>
-      </p:sp>
-      <p:sp>
-        <p:nvSpPr>
-          <p:cNvPr id="14" name="TextBox 13"/>
-          <p:cNvSpPr txBox="1"/>
-          <p:nvPr/>
-        </p:nvSpPr>
-        <p:spPr>
-          <a:xfrm>
-            <a:off x="8229600" y="2834640"/>
-            <a:ext cx="3017520" cy="3291840"/>
-          </a:xfrm>
-          <a:prstGeom prst="rect">
-            <a:avLst/>
-          </a:prstGeom>
-          <a:noFill/>
-        </p:spPr>
-        <p:txBody>
-          <a:bodyPr wrap="square">
-            <a:spAutoFit/>
-          </a:bodyPr>
-          <a:lstStyle/>
-          <a:p>
-            <a:pPr>
-              <a:defRPr b="1" sz="1050">
-                <a:solidFill>
-                  <a:srgbClr val="0284C7"/>
-                </a:solidFill>
-              </a:defRPr>
-            </a:pPr>
-            <a:r>
-              <a:t>• แบบซื้อขาด: ฿600,000 (6,000 บ./จุด)</a:t>
-            </a:r>
-          </a:p>
-          <a:p>
-            <a:pPr>
-              <a:spcAft>
-                <a:spcPts val="600"/>
-              </a:spcAft>
+              <a:t>✔ รับประกันระบบและบริการ On-site Service ตลอด 1 ปีเต็ม</a:t>
+            </a:r>
+          </a:p>
+          <a:p>
+            <a:pPr>
+              <a:spcBef>
+                <a:spcPts val="800"/>
+              </a:spcBef>
               <a:defRPr b="1" sz="1000">
                 <a:solidFill>
                   <a:srgbClr val="059669"/>
@@ -4774,101 +4743,11 @@
               </a:defRPr>
             </a:pPr>
             <a:r>
-              <a:t>• แบบรายปี: ฿510,000 (ปีแรก)</a:t>
+              <a:t>💰 มูลค่าโครงการรวม (100 ชุด): ฿3,800,000 - ฿4,200,000 บาท</a:t>
             </a:r>
             <a:br/>
             <a:r>
-              <a:t>  (ปีถัดไป ฿360,000 บ./ปี (3,600 บ./จุด/ปี))</a:t>
-            </a:r>
-          </a:p>
-          <a:p>
-            <a:pPr>
-              <a:spcAft>
-                <a:spcPts val="600"/>
-              </a:spcAft>
-              <a:defRPr sz="900" b="1">
-                <a:solidFill>
-                  <a:srgbClr val="0F172A"/>
-                </a:solidFill>
-              </a:defRPr>
-            </a:pPr>
-            <a:r>
-              <a:t>💡 จุดเด่น: LINE มีค่าแพ็กเกจส่งข้อความรายเดือนเพิ่มเติม</a:t>
-            </a:r>
-          </a:p>
-          <a:p>
-            <a:pPr>
-              <a:spcAft>
-                <a:spcPts val="200"/>
-              </a:spcAft>
-              <a:defRPr sz="880">
-                <a:solidFill>
-                  <a:srgbClr val="64748B"/>
-                </a:solidFill>
-              </a:defRPr>
-            </a:pPr>
-            <a:r>
-              <a:t>✓ ได้ทั้ง Web SCADA + Mobile App ครบชุด</a:t>
-            </a:r>
-          </a:p>
-          <a:p>
-            <a:pPr>
-              <a:spcAft>
-                <a:spcPts val="200"/>
-              </a:spcAft>
-              <a:defRPr sz="880">
-                <a:solidFill>
-                  <a:srgbClr val="64748B"/>
-                </a:solidFill>
-              </a:defRPr>
-            </a:pPr>
-            <a:r>
-              <a:t>✓ แจ้งเตือนผ่าน LINE Official Account (LINE OA)</a:t>
-            </a:r>
-          </a:p>
-          <a:p>
-            <a:pPr>
-              <a:spcAft>
-                <a:spcPts val="200"/>
-              </a:spcAft>
-              <a:defRPr sz="880">
-                <a:solidFill>
-                  <a:srgbClr val="64748B"/>
-                </a:solidFill>
-              </a:defRPr>
-            </a:pPr>
-            <a:r>
-              <a:t>✓ ส่งการ์ดแจ้งเตือนพร้อมสีสถานะและปุ่มกดดูสด</a:t>
-            </a:r>
-          </a:p>
-          <a:p>
-            <a:pPr>
-              <a:spcAft>
-                <a:spcPts val="200"/>
-              </a:spcAft>
-              <a:defRPr sz="880">
-                <a:solidFill>
-                  <a:srgbClr val="64748B"/>
-                </a:solidFill>
-              </a:defRPr>
-            </a:pPr>
-            <a:r>
-              <a:t>✓ +฿1,500/จุด เพื่อซัพพอร์ตค่า Broadcast ของ LINE</a:t>
-            </a:r>
-          </a:p>
-          <a:p>
-            <a:pPr>
-              <a:spcAft>
-                <a:spcPts val="200"/>
-              </a:spcAft>
-              <a:defRPr sz="880">
-                <a:solidFill>
-                  <a:srgbClr val="64748B"/>
-                </a:solidFill>
-              </a:defRPr>
-            </a:pPr>
-            <a:r>
-              <a:t>✓ สัญญาบริการระดับพรีเมียม 24/7</a:t>
+              <a:t>📈 กำไรขั้นต้นโดยประมาณ: ฿1,700,000 - ฿2,100,000 บาท (Margin ~45-50%)</a:t>
             </a:r>
           </a:p>
         </p:txBody>
@@ -4932,7 +4811,7 @@
               </a:defRPr>
             </a:pPr>
             <a:r>
-              <a:t>โครงการระบบวัดคุณภาพน้ำอัจฉริยะ 100 จุด (NCT WATER NEXUS)</a:t>
+              <a:t>โครงการระบบตรวจวัดคุณภาพน้ำ 100 ชุด (NCT WATER NEXUS)</a:t>
             </a:r>
           </a:p>
           <a:p>
@@ -4944,7 +4823,7 @@
               </a:defRPr>
             </a:pPr>
             <a:r>
-              <a:t>3. ตัวอย่างข้อความแจ้งเตือนเมื่อพบค่าผิดปกติ (Telegram vs LINE OA)</a:t>
+              <a:t>3. ราคาซอฟต์แวร์ Dashboard &amp; ระบบแจ้งเตือน (3 Option ทางเลือก)</a:t>
             </a:r>
           </a:p>
         </p:txBody>
@@ -4958,7 +4837,7 @@
         <p:spPr>
           <a:xfrm>
             <a:off x="731520" y="1463040"/>
-            <a:ext cx="5120640" cy="4754880"/>
+            <a:ext cx="3383280" cy="4754880"/>
           </a:xfrm>
           <a:prstGeom prst="roundRect">
             <a:avLst/>
@@ -4996,14 +4875,57 @@
       </p:sp>
       <p:sp>
         <p:nvSpPr>
-          <p:cNvPr id="4" name="TextBox 3"/>
+          <p:cNvPr id="4" name="Rounded Rectangle 3"/>
+          <p:cNvSpPr/>
+          <p:nvPr/>
+        </p:nvSpPr>
+        <p:spPr>
+          <a:xfrm>
+            <a:off x="731520" y="1463040"/>
+            <a:ext cx="3383280" cy="1280160"/>
+          </a:xfrm>
+          <a:prstGeom prst="roundRect">
+            <a:avLst/>
+          </a:prstGeom>
+          <a:solidFill>
+            <a:srgbClr val="0284C7"/>
+          </a:solidFill>
+          <a:ln>
+            <a:noFill/>
+          </a:ln>
+        </p:spPr>
+        <p:style>
+          <a:lnRef idx="1">
+            <a:schemeClr val="accent1"/>
+          </a:lnRef>
+          <a:fillRef idx="3">
+            <a:schemeClr val="accent1"/>
+          </a:fillRef>
+          <a:effectRef idx="2">
+            <a:schemeClr val="accent1"/>
+          </a:effectRef>
+          <a:fontRef idx="minor">
+            <a:schemeClr val="lt1"/>
+          </a:fontRef>
+        </p:style>
+        <p:txBody>
+          <a:bodyPr rtlCol="0" anchor="ctr"/>
+          <a:lstStyle/>
+          <a:p>
+            <a:pPr algn="ctr"/>
+          </a:p>
+        </p:txBody>
+      </p:sp>
+      <p:sp>
+        <p:nvSpPr>
+          <p:cNvPr id="5" name="TextBox 4"/>
           <p:cNvSpPr txBox="1"/>
           <p:nvPr/>
         </p:nvSpPr>
         <p:spPr>
           <a:xfrm>
-            <a:off x="1005840" y="1691640"/>
-            <a:ext cx="4572000" cy="4297680"/>
+            <a:off x="914400" y="1554480"/>
+            <a:ext cx="3017520" cy="1097280"/>
           </a:xfrm>
           <a:prstGeom prst="rect">
             <a:avLst/>
@@ -5017,94 +4939,184 @@
           <a:lstStyle/>
           <a:p>
             <a:pPr>
+              <a:defRPr sz="950" b="1">
+                <a:solidFill>
+                  <a:srgbClr val="FFFFFF"/>
+                </a:solidFill>
+              </a:defRPr>
+            </a:pPr>
+            <a:r>
+              <a:t>[ Option 1 ] ★ แนะนำ คุ้มค่าสูงสุด</a:t>
+            </a:r>
+          </a:p>
+          <a:p>
+            <a:pPr>
+              <a:defRPr sz="1350" b="1">
+                <a:solidFill>
+                  <a:srgbClr val="FFFFFF"/>
+                </a:solidFill>
+              </a:defRPr>
+            </a:pPr>
+            <a:r>
+              <a:t>แอปมือถือ + Telegram</a:t>
+            </a:r>
+          </a:p>
+        </p:txBody>
+      </p:sp>
+      <p:sp>
+        <p:nvSpPr>
+          <p:cNvPr id="6" name="TextBox 5"/>
+          <p:cNvSpPr txBox="1"/>
+          <p:nvPr/>
+        </p:nvSpPr>
+        <p:spPr>
+          <a:xfrm>
+            <a:off x="914400" y="2834640"/>
+            <a:ext cx="3017520" cy="3291840"/>
+          </a:xfrm>
+          <a:prstGeom prst="rect">
+            <a:avLst/>
+          </a:prstGeom>
+          <a:noFill/>
+        </p:spPr>
+        <p:txBody>
+          <a:bodyPr wrap="square">
+            <a:spAutoFit/>
+          </a:bodyPr>
+          <a:lstStyle/>
+          <a:p>
+            <a:pPr>
+              <a:defRPr b="1" sz="1050">
+                <a:solidFill>
+                  <a:srgbClr val="0284C7"/>
+                </a:solidFill>
+              </a:defRPr>
+            </a:pPr>
+            <a:r>
+              <a:t>• แบบซื้อขาด: ฿250,000 (2,500 บ./จุด)</a:t>
+            </a:r>
+          </a:p>
+          <a:p>
+            <a:pPr>
               <a:spcAft>
-                <a:spcPts val="1000"/>
+                <a:spcPts val="600"/>
               </a:spcAft>
-              <a:defRPr sz="1400" b="1">
-                <a:solidFill>
-                  <a:srgbClr val="0284C7"/>
-                </a:solidFill>
-              </a:defRPr>
-            </a:pPr>
-            <a:r>
-              <a:t>✈️ รูปแบบ Telegram Alert (ส่งฟรี &amp; ไวมาก)</a:t>
+              <a:defRPr b="1" sz="1000">
+                <a:solidFill>
+                  <a:srgbClr val="059669"/>
+                </a:solidFill>
+              </a:defRPr>
+            </a:pPr>
+            <a:r>
+              <a:t>• แบบรายปี: ฿170,000 (ปีแรก)</a:t>
+            </a:r>
+            <a:br/>
+            <a:r>
+              <a:t>  (ปีถัดไป ฿120,000 บ./ปี (1,200 บ./จุด/ปี))</a:t>
             </a:r>
           </a:p>
           <a:p>
             <a:pPr>
               <a:spcAft>
-                <a:spcPts val="1000"/>
+                <a:spcPts val="600"/>
               </a:spcAft>
-              <a:defRPr sz="1050">
+              <a:defRPr sz="900" b="1">
                 <a:solidFill>
                   <a:srgbClr val="0F172A"/>
                 </a:solidFill>
               </a:defRPr>
             </a:pPr>
             <a:r>
-              <a:t>🚨 แจ้งเตือนคุณภาพน้ำผิดปกติ</a:t>
-            </a:r>
-            <a:br/>
-            <a:r>
-              <a:t>📍 จุดติดตั้ง: บ่อพักน้ำ #04 (ตู้ 1004)</a:t>
-            </a:r>
-            <a:br/>
-            <a:r>
-              <a:t>⏰ เวลา: 14:15 น.</a:t>
-            </a:r>
-            <a:br/>
-            <a:r>
-              <a:t>━━━━━━━━━━━━━━━━━━━━</a:t>
-            </a:r>
-            <a:br/>
-            <a:r>
-              <a:t>• คลอรีน: 0.15 mg/L ❌ (เกณฑ์ 0.20-2.00)</a:t>
-            </a:r>
-            <a:br/>
-            <a:r>
-              <a:t>• pH: 6.4 ❌ (เกณฑ์ 6.5-8.5)</a:t>
-            </a:r>
-            <a:br/>
-            <a:r>
-              <a:t>• TDS: 185 ppm (ปกติ)</a:t>
-            </a:r>
-            <a:br/>
-            <a:r>
-              <a:t>• อุณหภูมิ: 28.5 °C (ปกติ)</a:t>
-            </a:r>
-            <a:br/>
-            <a:r>
-              <a:t>━━━━━━━━━━━━━━━━━━━━</a:t>
-            </a:r>
-            <a:br/>
-            <a:r>
-              <a:t>🔗 ดูกราฟย้อนหลัง: https://water-iot.com/node/1004</a:t>
-            </a:r>
-          </a:p>
-          <a:p>
-            <a:pPr>
-              <a:defRPr sz="950" b="1">
-                <a:solidFill>
-                  <a:srgbClr val="059669"/>
-                </a:solidFill>
-              </a:defRPr>
-            </a:pPr>
-            <a:r>
-              <a:t>✔ จุดเด่น: ส่งฟรี 100% ไม่มีค่า Broadcast รายเดือน กำไรเต็มเม็ดเต็มหน่วย</a:t>
-            </a:r>
-          </a:p>
-        </p:txBody>
-      </p:sp>
-      <p:sp>
-        <p:nvSpPr>
-          <p:cNvPr id="5" name="Rounded Rectangle 4"/>
+              <a:t>💡 จุดเด่น: แจ้งเตือนฟรีตลอดชีพ ไม่มีค่าส่งข้อความ</a:t>
+            </a:r>
+          </a:p>
+          <a:p>
+            <a:pPr>
+              <a:spcAft>
+                <a:spcPts val="200"/>
+              </a:spcAft>
+              <a:defRPr sz="880">
+                <a:solidFill>
+                  <a:srgbClr val="64748B"/>
+                </a:solidFill>
+              </a:defRPr>
+            </a:pPr>
+            <a:r>
+              <a:t>✓ Modela App (iOS &amp; Android) สลับดู 100 จุด</a:t>
+            </a:r>
+          </a:p>
+          <a:p>
+            <a:pPr>
+              <a:spcAft>
+                <a:spcPts val="200"/>
+              </a:spcAft>
+              <a:defRPr sz="880">
+                <a:solidFill>
+                  <a:srgbClr val="64748B"/>
+                </a:solidFill>
+              </a:defRPr>
+            </a:pPr>
+            <a:r>
+              <a:t>✓ แจ้งเตือนผ่าน Telegram Bot แบบกลุ่ม/เดี่ยว</a:t>
+            </a:r>
+          </a:p>
+          <a:p>
+            <a:pPr>
+              <a:spcAft>
+                <a:spcPts val="200"/>
+              </a:spcAft>
+              <a:defRPr sz="880">
+                <a:solidFill>
+                  <a:srgbClr val="64748B"/>
+                </a:solidFill>
+              </a:defRPr>
+            </a:pPr>
+            <a:r>
+              <a:t>✓ ส่งข้อความเตือนฟรี 100% ไม่จำกัดจำนวนครั้ง</a:t>
+            </a:r>
+          </a:p>
+          <a:p>
+            <a:pPr>
+              <a:spcAft>
+                <a:spcPts val="200"/>
+              </a:spcAft>
+              <a:defRPr sz="880">
+                <a:solidFill>
+                  <a:srgbClr val="64748B"/>
+                </a:solidFill>
+              </a:defRPr>
+            </a:pPr>
+            <a:r>
+              <a:t>✓ ไม่มีต้นทุนแฝง กำไรเต็มเม็ดเต็มหน่วย</a:t>
+            </a:r>
+          </a:p>
+          <a:p>
+            <a:pPr>
+              <a:spcAft>
+                <a:spcPts val="200"/>
+              </a:spcAft>
+              <a:defRPr sz="880">
+                <a:solidFill>
+                  <a:srgbClr val="64748B"/>
+                </a:solidFill>
+              </a:defRPr>
+            </a:pPr>
+            <a:r>
+              <a:t>✓ ฟรี Support / แก้บั๊ก 1 ปีแรก</a:t>
+            </a:r>
+          </a:p>
+        </p:txBody>
+      </p:sp>
+      <p:sp>
+        <p:nvSpPr>
+          <p:cNvPr id="7" name="Rounded Rectangle 6"/>
           <p:cNvSpPr/>
           <p:nvPr/>
         </p:nvSpPr>
         <p:spPr>
           <a:xfrm>
-            <a:off x="6309360" y="1463040"/>
-            <a:ext cx="5120640" cy="4754880"/>
+            <a:off x="4389120" y="1463040"/>
+            <a:ext cx="3383280" cy="4754880"/>
           </a:xfrm>
           <a:prstGeom prst="roundRect">
             <a:avLst/>
@@ -5142,14 +5154,57 @@
       </p:sp>
       <p:sp>
         <p:nvSpPr>
-          <p:cNvPr id="6" name="TextBox 5"/>
+          <p:cNvPr id="8" name="Rounded Rectangle 7"/>
+          <p:cNvSpPr/>
+          <p:nvPr/>
+        </p:nvSpPr>
+        <p:spPr>
+          <a:xfrm>
+            <a:off x="4389120" y="1463040"/>
+            <a:ext cx="3383280" cy="1280160"/>
+          </a:xfrm>
+          <a:prstGeom prst="roundRect">
+            <a:avLst/>
+          </a:prstGeom>
+          <a:solidFill>
+            <a:srgbClr val="059669"/>
+          </a:solidFill>
+          <a:ln>
+            <a:noFill/>
+          </a:ln>
+        </p:spPr>
+        <p:style>
+          <a:lnRef idx="1">
+            <a:schemeClr val="accent1"/>
+          </a:lnRef>
+          <a:fillRef idx="3">
+            <a:schemeClr val="accent1"/>
+          </a:fillRef>
+          <a:effectRef idx="2">
+            <a:schemeClr val="accent1"/>
+          </a:effectRef>
+          <a:fontRef idx="minor">
+            <a:schemeClr val="lt1"/>
+          </a:fontRef>
+        </p:style>
+        <p:txBody>
+          <a:bodyPr rtlCol="0" anchor="ctr"/>
+          <a:lstStyle/>
+          <a:p>
+            <a:pPr algn="ctr"/>
+          </a:p>
+        </p:txBody>
+      </p:sp>
+      <p:sp>
+        <p:nvSpPr>
+          <p:cNvPr id="9" name="TextBox 8"/>
           <p:cNvSpPr txBox="1"/>
           <p:nvPr/>
         </p:nvSpPr>
         <p:spPr>
           <a:xfrm>
-            <a:off x="6583680" y="1691640"/>
-            <a:ext cx="4572000" cy="4297680"/>
+            <a:off x="4572000" y="1554480"/>
+            <a:ext cx="3017520" cy="1097280"/>
           </a:xfrm>
           <a:prstGeom prst="rect">
             <a:avLst/>
@@ -5163,76 +5218,449 @@
           <a:lstStyle/>
           <a:p>
             <a:pPr>
+              <a:defRPr sz="950" b="1">
+                <a:solidFill>
+                  <a:srgbClr val="FFFFFF"/>
+                </a:solidFill>
+              </a:defRPr>
+            </a:pPr>
+            <a:r>
+              <a:t>[ Option 2 ] สำหรับห้องควบคุม SCADA</a:t>
+            </a:r>
+          </a:p>
+          <a:p>
+            <a:pPr>
+              <a:defRPr sz="1350" b="1">
+                <a:solidFill>
+                  <a:srgbClr val="FFFFFF"/>
+                </a:solidFill>
+              </a:defRPr>
+            </a:pPr>
+            <a:r>
+              <a:t>เว็บกลาง 100 จุด + Telegram</a:t>
+            </a:r>
+          </a:p>
+        </p:txBody>
+      </p:sp>
+      <p:sp>
+        <p:nvSpPr>
+          <p:cNvPr id="10" name="TextBox 9"/>
+          <p:cNvSpPr txBox="1"/>
+          <p:nvPr/>
+        </p:nvSpPr>
+        <p:spPr>
+          <a:xfrm>
+            <a:off x="4572000" y="2834640"/>
+            <a:ext cx="3017520" cy="3291840"/>
+          </a:xfrm>
+          <a:prstGeom prst="rect">
+            <a:avLst/>
+          </a:prstGeom>
+          <a:noFill/>
+        </p:spPr>
+        <p:txBody>
+          <a:bodyPr wrap="square">
+            <a:spAutoFit/>
+          </a:bodyPr>
+          <a:lstStyle/>
+          <a:p>
+            <a:pPr>
+              <a:defRPr b="1" sz="1050">
+                <a:solidFill>
+                  <a:srgbClr val="0284C7"/>
+                </a:solidFill>
+              </a:defRPr>
+            </a:pPr>
+            <a:r>
+              <a:t>• แบบซื้อขาด: ฿450,000 (4,500 บ./จุด)</a:t>
+            </a:r>
+          </a:p>
+          <a:p>
+            <a:pPr>
               <a:spcAft>
-                <a:spcPts val="1000"/>
+                <a:spcPts val="600"/>
               </a:spcAft>
-              <a:defRPr sz="1400" b="1">
+              <a:defRPr b="1" sz="1000">
                 <a:solidFill>
                   <a:srgbClr val="059669"/>
                 </a:solidFill>
               </a:defRPr>
             </a:pPr>
             <a:r>
-              <a:t>💬 รูปแบบ LINE OA Alert (การ์ดสถานะยอดนิยม)</a:t>
+              <a:t>• แบบรายปี: ฿340,000 (ปีแรก)</a:t>
+            </a:r>
+            <a:br/>
+            <a:r>
+              <a:t>  (ปีถัดไป ฿240,000 บ./ปี (2,400 บ./จุด/ปี))</a:t>
             </a:r>
           </a:p>
           <a:p>
             <a:pPr>
               <a:spcAft>
-                <a:spcPts val="1000"/>
+                <a:spcPts val="600"/>
               </a:spcAft>
-              <a:defRPr sz="1050">
+              <a:defRPr sz="900" b="1">
                 <a:solidFill>
                   <a:srgbClr val="0F172A"/>
                 </a:solidFill>
               </a:defRPr>
             </a:pPr>
             <a:r>
-              <a:t>🚨 [CRITICAL] คุณภาพน้ำหลุดเกณฑ์</a:t>
+              <a:t>💡 จุดเด่น: ดูภาพรวมและตารางสรุปทั้ง 100 จุดในจอเดียว</a:t>
+            </a:r>
+          </a:p>
+          <a:p>
+            <a:pPr>
+              <a:spcAft>
+                <a:spcPts val="200"/>
+              </a:spcAft>
+              <a:defRPr sz="880">
+                <a:solidFill>
+                  <a:srgbClr val="64748B"/>
+                </a:solidFill>
+              </a:defRPr>
+            </a:pPr>
+            <a:r>
+              <a:t>✓ Centralized Web SCADA Dashboard 100 จุด</a:t>
+            </a:r>
+          </a:p>
+          <a:p>
+            <a:pPr>
+              <a:spcAft>
+                <a:spcPts val="200"/>
+              </a:spcAft>
+              <a:defRPr sz="880">
+                <a:solidFill>
+                  <a:srgbClr val="64748B"/>
+                </a:solidFill>
+              </a:defRPr>
+            </a:pPr>
+            <a:r>
+              <a:t>✓ แผนที่ GIS Map &amp; ตารางสรุปสถานะ Real-Time</a:t>
+            </a:r>
+          </a:p>
+          <a:p>
+            <a:pPr>
+              <a:spcAft>
+                <a:spcPts val="200"/>
+              </a:spcAft>
+              <a:defRPr sz="880">
+                <a:solidFill>
+                  <a:srgbClr val="64748B"/>
+                </a:solidFill>
+              </a:defRPr>
+            </a:pPr>
+            <a:r>
+              <a:t>✓ กราฟวิเคราะห์แนวโน้ม Multi-Axis 100 สถานี</a:t>
+            </a:r>
+          </a:p>
+          <a:p>
+            <a:pPr>
+              <a:spcAft>
+                <a:spcPts val="200"/>
+              </a:spcAft>
+              <a:defRPr sz="880">
+                <a:solidFill>
+                  <a:srgbClr val="64748B"/>
+                </a:solidFill>
+              </a:defRPr>
+            </a:pPr>
+            <a:r>
+              <a:t>✓ แจ้งเตือนผ่าน Telegram Bot ทันทีเมื่อผิดปกติ</a:t>
+            </a:r>
+          </a:p>
+          <a:p>
+            <a:pPr>
+              <a:spcAft>
+                <a:spcPts val="200"/>
+              </a:spcAft>
+              <a:defRPr sz="880">
+                <a:solidFill>
+                  <a:srgbClr val="64748B"/>
+                </a:solidFill>
+              </a:defRPr>
+            </a:pPr>
+            <a:r>
+              <a:t>✓ Export รายงาน Excel / PDF ย้อนหลังได้</a:t>
+            </a:r>
+          </a:p>
+        </p:txBody>
+      </p:sp>
+      <p:sp>
+        <p:nvSpPr>
+          <p:cNvPr id="11" name="Rounded Rectangle 10"/>
+          <p:cNvSpPr/>
+          <p:nvPr/>
+        </p:nvSpPr>
+        <p:spPr>
+          <a:xfrm>
+            <a:off x="8046720" y="1463040"/>
+            <a:ext cx="3383280" cy="4754880"/>
+          </a:xfrm>
+          <a:prstGeom prst="roundRect">
+            <a:avLst/>
+          </a:prstGeom>
+          <a:solidFill>
+            <a:srgbClr val="FFFFFF"/>
+          </a:solidFill>
+          <a:ln w="19050">
+            <a:solidFill>
+              <a:srgbClr val="1E293B"/>
+            </a:solidFill>
+          </a:ln>
+        </p:spPr>
+        <p:style>
+          <a:lnRef idx="1">
+            <a:schemeClr val="accent1"/>
+          </a:lnRef>
+          <a:fillRef idx="3">
+            <a:schemeClr val="accent1"/>
+          </a:fillRef>
+          <a:effectRef idx="2">
+            <a:schemeClr val="accent1"/>
+          </a:effectRef>
+          <a:fontRef idx="minor">
+            <a:schemeClr val="lt1"/>
+          </a:fontRef>
+        </p:style>
+        <p:txBody>
+          <a:bodyPr rtlCol="0" anchor="ctr"/>
+          <a:lstStyle/>
+          <a:p>
+            <a:pPr algn="ctr"/>
+          </a:p>
+        </p:txBody>
+      </p:sp>
+      <p:sp>
+        <p:nvSpPr>
+          <p:cNvPr id="12" name="Rounded Rectangle 11"/>
+          <p:cNvSpPr/>
+          <p:nvPr/>
+        </p:nvSpPr>
+        <p:spPr>
+          <a:xfrm>
+            <a:off x="8046720" y="1463040"/>
+            <a:ext cx="3383280" cy="1280160"/>
+          </a:xfrm>
+          <a:prstGeom prst="roundRect">
+            <a:avLst/>
+          </a:prstGeom>
+          <a:solidFill>
+            <a:srgbClr val="1E293B"/>
+          </a:solidFill>
+          <a:ln>
+            <a:noFill/>
+          </a:ln>
+        </p:spPr>
+        <p:style>
+          <a:lnRef idx="1">
+            <a:schemeClr val="accent1"/>
+          </a:lnRef>
+          <a:fillRef idx="3">
+            <a:schemeClr val="accent1"/>
+          </a:fillRef>
+          <a:effectRef idx="2">
+            <a:schemeClr val="accent1"/>
+          </a:effectRef>
+          <a:fontRef idx="minor">
+            <a:schemeClr val="lt1"/>
+          </a:fontRef>
+        </p:style>
+        <p:txBody>
+          <a:bodyPr rtlCol="0" anchor="ctr"/>
+          <a:lstStyle/>
+          <a:p>
+            <a:pPr algn="ctr"/>
+          </a:p>
+        </p:txBody>
+      </p:sp>
+      <p:sp>
+        <p:nvSpPr>
+          <p:cNvPr id="13" name="TextBox 12"/>
+          <p:cNvSpPr txBox="1"/>
+          <p:nvPr/>
+        </p:nvSpPr>
+        <p:spPr>
+          <a:xfrm>
+            <a:off x="8229600" y="1554480"/>
+            <a:ext cx="3017520" cy="1097280"/>
+          </a:xfrm>
+          <a:prstGeom prst="rect">
+            <a:avLst/>
+          </a:prstGeom>
+          <a:noFill/>
+        </p:spPr>
+        <p:txBody>
+          <a:bodyPr wrap="square">
+            <a:spAutoFit/>
+          </a:bodyPr>
+          <a:lstStyle/>
+          <a:p>
+            <a:pPr>
+              <a:defRPr sz="950" b="1">
+                <a:solidFill>
+                  <a:srgbClr val="2DD4BF"/>
+                </a:solidFill>
+              </a:defRPr>
+            </a:pPr>
+            <a:r>
+              <a:t>[ Option 3 ] ครบวงจร + แจ้งเตือน LINE</a:t>
+            </a:r>
+          </a:p>
+          <a:p>
+            <a:pPr>
+              <a:defRPr sz="1350" b="1">
+                <a:solidFill>
+                  <a:srgbClr val="FFFFFF"/>
+                </a:solidFill>
+              </a:defRPr>
+            </a:pPr>
+            <a:r>
+              <a:t>เว็บกลาง + แอป + LINE OA</a:t>
+            </a:r>
+          </a:p>
+        </p:txBody>
+      </p:sp>
+      <p:sp>
+        <p:nvSpPr>
+          <p:cNvPr id="14" name="TextBox 13"/>
+          <p:cNvSpPr txBox="1"/>
+          <p:nvPr/>
+        </p:nvSpPr>
+        <p:spPr>
+          <a:xfrm>
+            <a:off x="8229600" y="2834640"/>
+            <a:ext cx="3017520" cy="3291840"/>
+          </a:xfrm>
+          <a:prstGeom prst="rect">
+            <a:avLst/>
+          </a:prstGeom>
+          <a:noFill/>
+        </p:spPr>
+        <p:txBody>
+          <a:bodyPr wrap="square">
+            <a:spAutoFit/>
+          </a:bodyPr>
+          <a:lstStyle/>
+          <a:p>
+            <a:pPr>
+              <a:defRPr b="1" sz="1050">
+                <a:solidFill>
+                  <a:srgbClr val="0284C7"/>
+                </a:solidFill>
+              </a:defRPr>
+            </a:pPr>
+            <a:r>
+              <a:t>• แบบซื้อขาด: ฿600,000 (6,000 บ./จุด)</a:t>
+            </a:r>
+          </a:p>
+          <a:p>
+            <a:pPr>
+              <a:spcAft>
+                <a:spcPts val="600"/>
+              </a:spcAft>
+              <a:defRPr b="1" sz="1000">
+                <a:solidFill>
+                  <a:srgbClr val="059669"/>
+                </a:solidFill>
+              </a:defRPr>
+            </a:pPr>
+            <a:r>
+              <a:t>• แบบรายปี: ฿510,000 (ปีแรก)</a:t>
             </a:r>
             <a:br/>
             <a:r>
-              <a:t>📍 สถานี: บ่อจ่ายน้ำเขตเหนือ</a:t>
-            </a:r>
-            <a:br/>
-            <a:r>
-              <a:t>━━━━━━━━━━━━━━━━━━━━</a:t>
-            </a:r>
-            <a:br/>
-            <a:r>
-              <a:t>• คลอรีน: 0.12 mg/L ⚠️ (ต่ำกว่าเกณฑ์)</a:t>
-            </a:r>
-            <a:br/>
-            <a:r>
-              <a:t>• ค่า pH: 6.30 ⚠️ (ต่ำกว่าเกณฑ์)</a:t>
-            </a:r>
-            <a:br/>
-            <a:r>
-              <a:t>• ค่า TDS: 190 ppm (ปกติ)</a:t>
-            </a:r>
-            <a:br/>
-            <a:r>
-              <a:t>• อุณหภูมิ: 29.0 °C (ปกติ)</a:t>
-            </a:r>
-            <a:br/>
-            <a:r>
-              <a:t>━━━━━━━━━━━━━━━━━━━━</a:t>
-            </a:r>
-            <a:br/>
-            <a:r>
-              <a:t>👉 [เปิด Dashboard ดูข้อมูลสด]</a:t>
-            </a:r>
-          </a:p>
-          <a:p>
-            <a:pPr>
-              <a:defRPr sz="950" b="1">
-                <a:solidFill>
-                  <a:srgbClr val="0284C7"/>
-                </a:solidFill>
-              </a:defRPr>
-            </a:pPr>
-            <a:r>
-              <a:t>✔ จุดเด่น: ใช้งานง่ายในกลุ่มไลน์ผู้บริหาร (+฿1,500/จุด เพื่อซับพอร์ตค่า Broadcast LINE)</a:t>
+              <a:t>  (ปีถัดไป ฿360,000 บ./ปี (3,600 บ./จุด/ปี))</a:t>
+            </a:r>
+          </a:p>
+          <a:p>
+            <a:pPr>
+              <a:spcAft>
+                <a:spcPts val="600"/>
+              </a:spcAft>
+              <a:defRPr sz="900" b="1">
+                <a:solidFill>
+                  <a:srgbClr val="0F172A"/>
+                </a:solidFill>
+              </a:defRPr>
+            </a:pPr>
+            <a:r>
+              <a:t>💡 จุดเด่น: LINE มีค่าแพ็กเกจส่งข้อความรายเดือนเพิ่มเติม</a:t>
+            </a:r>
+          </a:p>
+          <a:p>
+            <a:pPr>
+              <a:spcAft>
+                <a:spcPts val="200"/>
+              </a:spcAft>
+              <a:defRPr sz="880">
+                <a:solidFill>
+                  <a:srgbClr val="64748B"/>
+                </a:solidFill>
+              </a:defRPr>
+            </a:pPr>
+            <a:r>
+              <a:t>✓ ได้ทั้ง Web SCADA + Modela App ครบชุด</a:t>
+            </a:r>
+          </a:p>
+          <a:p>
+            <a:pPr>
+              <a:spcAft>
+                <a:spcPts val="200"/>
+              </a:spcAft>
+              <a:defRPr sz="880">
+                <a:solidFill>
+                  <a:srgbClr val="64748B"/>
+                </a:solidFill>
+              </a:defRPr>
+            </a:pPr>
+            <a:r>
+              <a:t>✓ แจ้งเตือนผ่าน LINE Official Account (LINE OA)</a:t>
+            </a:r>
+          </a:p>
+          <a:p>
+            <a:pPr>
+              <a:spcAft>
+                <a:spcPts val="200"/>
+              </a:spcAft>
+              <a:defRPr sz="880">
+                <a:solidFill>
+                  <a:srgbClr val="64748B"/>
+                </a:solidFill>
+              </a:defRPr>
+            </a:pPr>
+            <a:r>
+              <a:t>✓ ส่งการ์ดแจ้งเตือนพร้อมสีสถานะและปุ่มกดดูสด</a:t>
+            </a:r>
+          </a:p>
+          <a:p>
+            <a:pPr>
+              <a:spcAft>
+                <a:spcPts val="200"/>
+              </a:spcAft>
+              <a:defRPr sz="880">
+                <a:solidFill>
+                  <a:srgbClr val="64748B"/>
+                </a:solidFill>
+              </a:defRPr>
+            </a:pPr>
+            <a:r>
+              <a:t>✓ +฿1,500/จุด เพื่อซัพพอร์ตค่า Broadcast ของ LINE</a:t>
+            </a:r>
+          </a:p>
+          <a:p>
+            <a:pPr>
+              <a:spcAft>
+                <a:spcPts val="200"/>
+              </a:spcAft>
+              <a:defRPr sz="880">
+                <a:solidFill>
+                  <a:srgbClr val="64748B"/>
+                </a:solidFill>
+              </a:defRPr>
+            </a:pPr>
+            <a:r>
+              <a:t>✓ สัญญาบริการระดับพรีเมียม 24/7</a:t>
             </a:r>
           </a:p>
         </p:txBody>
@@ -5296,7 +5724,7 @@
               </a:defRPr>
             </a:pPr>
             <a:r>
-              <a:t>โครงการระบบวัดคุณภาพน้ำอัจฉริยะ 100 จุด (NCT WATER NEXUS)</a:t>
+              <a:t>โครงการระบบตรวจวัดคุณภาพน้ำ 100 ชุด (NCT WATER NEXUS)</a:t>
             </a:r>
           </a:p>
           <a:p>
@@ -5308,7 +5736,7 @@
               </a:defRPr>
             </a:pPr>
             <a:r>
-              <a:t>วิเคราะห์จุดแข็ง-จุดเสี่ยงโมเดลราคา (Strategic Margin Analysis)</a:t>
+              <a:t>4. ตัวอย่างข้อความแจ้งเตือนเมื่อพบค่าผิดปกติ (Telegram vs LINE OA)</a:t>
             </a:r>
           </a:p>
         </p:txBody>
@@ -5322,6 +5750,152 @@
         <p:spPr>
           <a:xfrm>
             <a:off x="731520" y="1463040"/>
+            <a:ext cx="5120640" cy="4754880"/>
+          </a:xfrm>
+          <a:prstGeom prst="roundRect">
+            <a:avLst/>
+          </a:prstGeom>
+          <a:solidFill>
+            <a:srgbClr val="FFFFFF"/>
+          </a:solidFill>
+          <a:ln w="19050">
+            <a:solidFill>
+              <a:srgbClr val="0284C7"/>
+            </a:solidFill>
+          </a:ln>
+        </p:spPr>
+        <p:style>
+          <a:lnRef idx="1">
+            <a:schemeClr val="accent1"/>
+          </a:lnRef>
+          <a:fillRef idx="3">
+            <a:schemeClr val="accent1"/>
+          </a:fillRef>
+          <a:effectRef idx="2">
+            <a:schemeClr val="accent1"/>
+          </a:effectRef>
+          <a:fontRef idx="minor">
+            <a:schemeClr val="lt1"/>
+          </a:fontRef>
+        </p:style>
+        <p:txBody>
+          <a:bodyPr rtlCol="0" anchor="ctr"/>
+          <a:lstStyle/>
+          <a:p>
+            <a:pPr algn="ctr"/>
+          </a:p>
+        </p:txBody>
+      </p:sp>
+      <p:sp>
+        <p:nvSpPr>
+          <p:cNvPr id="4" name="TextBox 3"/>
+          <p:cNvSpPr txBox="1"/>
+          <p:nvPr/>
+        </p:nvSpPr>
+        <p:spPr>
+          <a:xfrm>
+            <a:off x="1005840" y="1691640"/>
+            <a:ext cx="4572000" cy="4297680"/>
+          </a:xfrm>
+          <a:prstGeom prst="rect">
+            <a:avLst/>
+          </a:prstGeom>
+          <a:noFill/>
+        </p:spPr>
+        <p:txBody>
+          <a:bodyPr wrap="square">
+            <a:spAutoFit/>
+          </a:bodyPr>
+          <a:lstStyle/>
+          <a:p>
+            <a:pPr>
+              <a:spcAft>
+                <a:spcPts val="1000"/>
+              </a:spcAft>
+              <a:defRPr sz="1400" b="1">
+                <a:solidFill>
+                  <a:srgbClr val="0284C7"/>
+                </a:solidFill>
+              </a:defRPr>
+            </a:pPr>
+            <a:r>
+              <a:t>✈️ รูปแบบ Telegram Alert (ส่งฟรี &amp; ไวมาก)</a:t>
+            </a:r>
+          </a:p>
+          <a:p>
+            <a:pPr>
+              <a:spcAft>
+                <a:spcPts val="1000"/>
+              </a:spcAft>
+              <a:defRPr sz="1050">
+                <a:solidFill>
+                  <a:srgbClr val="0F172A"/>
+                </a:solidFill>
+              </a:defRPr>
+            </a:pPr>
+            <a:r>
+              <a:t>🚨 แจ้งเตือนคุณภาพน้ำผิดปกติ</a:t>
+            </a:r>
+            <a:br/>
+            <a:r>
+              <a:t>📍 จุดติดตั้ง: บ่อพักน้ำ #04 (ตู้ 1004)</a:t>
+            </a:r>
+            <a:br/>
+            <a:r>
+              <a:t>⏰ เวลา: 14:15 น.</a:t>
+            </a:r>
+            <a:br/>
+            <a:r>
+              <a:t>━━━━━━━━━━━━━━━━━━━━</a:t>
+            </a:r>
+            <a:br/>
+            <a:r>
+              <a:t>• คลอรีน: 0.15 mg/L ❌ (เกณฑ์ 0.20-2.00)</a:t>
+            </a:r>
+            <a:br/>
+            <a:r>
+              <a:t>• pH: 6.4 ❌ (เกณฑ์ 6.5-8.5)</a:t>
+            </a:r>
+            <a:br/>
+            <a:r>
+              <a:t>• TDS: 185 ppm (ปกติ)</a:t>
+            </a:r>
+            <a:br/>
+            <a:r>
+              <a:t>• อุณหภูมิ: 28.5 °C (ปกติ)</a:t>
+            </a:r>
+            <a:br/>
+            <a:r>
+              <a:t>━━━━━━━━━━━━━━━━━━━━</a:t>
+            </a:r>
+            <a:br/>
+            <a:r>
+              <a:t>🔗 ดูกราฟย้อนหลัง: https://water-iot.com/node/1004</a:t>
+            </a:r>
+          </a:p>
+          <a:p>
+            <a:pPr>
+              <a:defRPr sz="950" b="1">
+                <a:solidFill>
+                  <a:srgbClr val="059669"/>
+                </a:solidFill>
+              </a:defRPr>
+            </a:pPr>
+            <a:r>
+              <a:t>✔ จุดเด่น: ส่งฟรี 100% ไม่มีค่า Broadcast รายเดือน กำไรเต็มเม็ดเต็มหน่วย</a:t>
+            </a:r>
+          </a:p>
+        </p:txBody>
+      </p:sp>
+      <p:sp>
+        <p:nvSpPr>
+          <p:cNvPr id="5" name="Rounded Rectangle 4"/>
+          <p:cNvSpPr/>
+          <p:nvPr/>
+        </p:nvSpPr>
+        <p:spPr>
+          <a:xfrm>
+            <a:off x="6309360" y="1463040"/>
             <a:ext cx="5120640" cy="4754880"/>
           </a:xfrm>
           <a:prstGeom prst="roundRect">
@@ -5360,13 +5934,13 @@
       </p:sp>
       <p:sp>
         <p:nvSpPr>
-          <p:cNvPr id="4" name="TextBox 3"/>
+          <p:cNvPr id="6" name="TextBox 5"/>
           <p:cNvSpPr txBox="1"/>
           <p:nvPr/>
         </p:nvSpPr>
         <p:spPr>
           <a:xfrm>
-            <a:off x="1005840" y="1691640"/>
+            <a:off x="6583680" y="1691640"/>
             <a:ext cx="4572000" cy="4297680"/>
           </a:xfrm>
           <a:prstGeom prst="rect">
@@ -5384,259 +5958,73 @@
               <a:spcAft>
                 <a:spcPts val="1000"/>
               </a:spcAft>
-              <a:defRPr sz="1350" b="1">
+              <a:defRPr sz="1400" b="1">
                 <a:solidFill>
                   <a:srgbClr val="059669"/>
                 </a:solidFill>
               </a:defRPr>
             </a:pPr>
             <a:r>
-              <a:t>🔄 ฝั่งรายปี (ดีมาก แนะนำให้ผลักดันลูกค้ารูปแบบนี้)</a:t>
-            </a:r>
-          </a:p>
-          <a:p>
-            <a:pPr>
-              <a:defRPr b="1" sz="1100">
-                <a:solidFill>
-                  <a:srgbClr val="0F172A"/>
-                </a:solidFill>
-              </a:defRPr>
-            </a:pPr>
-            <a:r>
-              <a:t>• ตัวเลข 1,200 – 3,600 บาท/จุด/ปี:</a:t>
-            </a:r>
-          </a:p>
-          <a:p>
-            <a:pPr>
-              <a:spcAft>
-                <a:spcPts val="600"/>
-              </a:spcAft>
-              <a:defRPr sz="1000">
-                <a:solidFill>
-                  <a:srgbClr val="64748B"/>
-                </a:solidFill>
-              </a:defRPr>
-            </a:pPr>
-            <a:r>
-              <a:t>  ตกเดือนละ 100–300 บาท/ตู้ เป็นราคาที่ลูกค้าองค์กร/โรงงาน/เทศบาล จ่ายได้ง่ายมาก</a:t>
-            </a:r>
-          </a:p>
-          <a:p>
-            <a:pPr>
-              <a:defRPr b="1" sz="1100">
-                <a:solidFill>
-                  <a:srgbClr val="0F172A"/>
-                </a:solidFill>
-              </a:defRPr>
-            </a:pPr>
-            <a:r>
-              <a:t>• Recurring Income ก้อนโตทุกปี:</a:t>
-            </a:r>
-          </a:p>
-          <a:p>
-            <a:pPr>
-              <a:spcAft>
-                <a:spcPts val="600"/>
-              </a:spcAft>
-              <a:defRPr sz="1000">
-                <a:solidFill>
-                  <a:srgbClr val="64748B"/>
-                </a:solidFill>
-              </a:defRPr>
-            </a:pPr>
-            <a:r>
-              <a:t>  มีรายรับสม่ำเสมอ 120,000 – 360,000 บาททุกปี ไว้เป็นค่า Cloud Server, ค่าซ่อมบำรุง และกำไรต่อเนื่อง</a:t>
-            </a:r>
-          </a:p>
-          <a:p>
-            <a:pPr>
-              <a:defRPr b="1" sz="1100">
-                <a:solidFill>
-                  <a:srgbClr val="0F172A"/>
-                </a:solidFill>
-              </a:defRPr>
-            </a:pPr>
-            <a:r>
-              <a:t>• ล็อกฐานลูกค้าได้ยาวนาน:</a:t>
-            </a:r>
-          </a:p>
-          <a:p>
-            <a:pPr>
-              <a:spcAft>
-                <a:spcPts val="600"/>
-              </a:spcAft>
-              <a:defRPr sz="1000">
-                <a:solidFill>
-                  <a:srgbClr val="64748B"/>
-                </a:solidFill>
-              </a:defRPr>
-            </a:pPr>
-            <a:r>
-              <a:t>  ลูกค้าไม่ต้องกังวลเรื่องการดูแล เราดูแลซ่อมบำรุงและอัปเดตระบบให้ 100%</a:t>
-            </a:r>
-          </a:p>
-        </p:txBody>
-      </p:sp>
-      <p:sp>
-        <p:nvSpPr>
-          <p:cNvPr id="5" name="Rounded Rectangle 4"/>
-          <p:cNvSpPr/>
-          <p:nvPr/>
-        </p:nvSpPr>
-        <p:spPr>
-          <a:xfrm>
-            <a:off x="6309360" y="1463040"/>
-            <a:ext cx="5120640" cy="4754880"/>
-          </a:xfrm>
-          <a:prstGeom prst="roundRect">
-            <a:avLst/>
-          </a:prstGeom>
-          <a:solidFill>
-            <a:srgbClr val="FFFFFF"/>
-          </a:solidFill>
-          <a:ln w="19050">
-            <a:solidFill>
-              <a:srgbClr val="0284C7"/>
-            </a:solidFill>
-          </a:ln>
-        </p:spPr>
-        <p:style>
-          <a:lnRef idx="1">
-            <a:schemeClr val="accent1"/>
-          </a:lnRef>
-          <a:fillRef idx="3">
-            <a:schemeClr val="accent1"/>
-          </a:fillRef>
-          <a:effectRef idx="2">
-            <a:schemeClr val="accent1"/>
-          </a:effectRef>
-          <a:fontRef idx="minor">
-            <a:schemeClr val="lt1"/>
-          </a:fontRef>
-        </p:style>
-        <p:txBody>
-          <a:bodyPr rtlCol="0" anchor="ctr"/>
-          <a:lstStyle/>
-          <a:p>
-            <a:pPr algn="ctr"/>
-          </a:p>
-        </p:txBody>
-      </p:sp>
-      <p:sp>
-        <p:nvSpPr>
-          <p:cNvPr id="6" name="TextBox 5"/>
-          <p:cNvSpPr txBox="1"/>
-          <p:nvPr/>
-        </p:nvSpPr>
-        <p:spPr>
-          <a:xfrm>
-            <a:off x="6583680" y="1691640"/>
-            <a:ext cx="4572000" cy="4297680"/>
-          </a:xfrm>
-          <a:prstGeom prst="rect">
-            <a:avLst/>
-          </a:prstGeom>
-          <a:noFill/>
-        </p:spPr>
-        <p:txBody>
-          <a:bodyPr wrap="square">
-            <a:spAutoFit/>
-          </a:bodyPr>
-          <a:lstStyle/>
+              <a:t>💬 รูปแบบ LINE OA Alert (การ์ดสถานะยอดนิยม)</a:t>
+            </a:r>
+          </a:p>
           <a:p>
             <a:pPr>
               <a:spcAft>
                 <a:spcPts val="1000"/>
               </a:spcAft>
-              <a:defRPr sz="1350" b="1">
+              <a:defRPr sz="1050">
+                <a:solidFill>
+                  <a:srgbClr val="0F172A"/>
+                </a:solidFill>
+              </a:defRPr>
+            </a:pPr>
+            <a:r>
+              <a:t>🚨 [CRITICAL] คุณภาพน้ำหลุดเกณฑ์</a:t>
+            </a:r>
+            <a:br/>
+            <a:r>
+              <a:t>📍 สถานี: บ่อจ่ายน้ำเขตเหนือ</a:t>
+            </a:r>
+            <a:br/>
+            <a:r>
+              <a:t>━━━━━━━━━━━━━━━━━━━━</a:t>
+            </a:r>
+            <a:br/>
+            <a:r>
+              <a:t>• คลอรีน: 0.12 mg/L ⚠️ (ต่ำกว่าเกณฑ์)</a:t>
+            </a:r>
+            <a:br/>
+            <a:r>
+              <a:t>• ค่า pH: 6.30 ⚠️ (ต่ำกว่าเกณฑ์)</a:t>
+            </a:r>
+            <a:br/>
+            <a:r>
+              <a:t>• ค่า TDS: 190 ppm (ปกติ)</a:t>
+            </a:r>
+            <a:br/>
+            <a:r>
+              <a:t>• อุณหภูมิ: 29.0 °C (ปกติ)</a:t>
+            </a:r>
+            <a:br/>
+            <a:r>
+              <a:t>━━━━━━━━━━━━━━━━━━━━</a:t>
+            </a:r>
+            <a:br/>
+            <a:r>
+              <a:t>👉 [เปิด Dashboard ดูข้อมูลสด]</a:t>
+            </a:r>
+          </a:p>
+          <a:p>
+            <a:pPr>
+              <a:defRPr sz="950" b="1">
                 <a:solidFill>
                   <a:srgbClr val="0284C7"/>
                 </a:solidFill>
               </a:defRPr>
             </a:pPr>
             <a:r>
-              <a:t>🏷️ ฝั่งซื้อขาด (ตัวเลขผ่าน แต่ต้องล็อคขอบเขตให้ชัด)</a:t>
-            </a:r>
-          </a:p>
-          <a:p>
-            <a:pPr>
-              <a:defRPr b="1" sz="1100">
-                <a:solidFill>
-                  <a:srgbClr val="0F172A"/>
-                </a:solidFill>
-              </a:defRPr>
-            </a:pPr>
-            <a:r>
-              <a:t>• ราคาเฉลี่ย 2,500 – 6,000 บาท/จุด:</a:t>
-            </a:r>
-          </a:p>
-          <a:p>
-            <a:pPr>
-              <a:spcAft>
-                <a:spcPts val="600"/>
-              </a:spcAft>
-              <a:defRPr sz="1000">
-                <a:solidFill>
-                  <a:srgbClr val="64748B"/>
-                </a:solidFill>
-              </a:defRPr>
-            </a:pPr>
-            <a:r>
-              <a:t>  ยอดรวม 2.5 – 6 แสนบาท ลูกค้าไม่รู้สึกว่าแพงเกินไปสำหรับระบบ 100 จุด</a:t>
-            </a:r>
-          </a:p>
-          <a:p>
-            <a:pPr>
-              <a:defRPr b="1" sz="1100">
-                <a:solidFill>
-                  <a:srgbClr val="0F172A"/>
-                </a:solidFill>
-              </a:defRPr>
-            </a:pPr>
-            <a:r>
-              <a:t>• จุดที่ต้องระวัง:</a:t>
-            </a:r>
-          </a:p>
-          <a:p>
-            <a:pPr>
-              <a:spcAft>
-                <a:spcPts val="600"/>
-              </a:spcAft>
-              <a:defRPr sz="1000">
-                <a:solidFill>
-                  <a:srgbClr val="64748B"/>
-                </a:solidFill>
-              </a:defRPr>
-            </a:pPr>
-            <a:r>
-              <a:t>  ซื้อขาดแปลว่าเราต้องแบกค่า Host/Database เองในอนาคต หรือต้องส่งมอบ Source Code ให้ลูกค้ารัน Server เอง</a:t>
-            </a:r>
-          </a:p>
-          <a:p>
-            <a:pPr>
-              <a:defRPr b="1" sz="1100">
-                <a:solidFill>
-                  <a:srgbClr val="0F172A"/>
-                </a:solidFill>
-              </a:defRPr>
-            </a:pPr>
-            <a:r>
-              <a:t>• เงื่อนไขสัญญาป้องกันต้นทุน (MA):</a:t>
-            </a:r>
-          </a:p>
-          <a:p>
-            <a:pPr>
-              <a:spcAft>
-                <a:spcPts val="600"/>
-              </a:spcAft>
-              <a:defRPr sz="1000">
-                <a:solidFill>
-                  <a:srgbClr val="64748B"/>
-                </a:solidFill>
-              </a:defRPr>
-            </a:pPr>
-            <a:r>
-              <a:t>  ควรกำหนดในสัญญาว่า ฟรี Support/แก้บั๊ก 1 ปีแรกเท่านั้น ปีถัดไปคิดสัญญา MA แยก 10–15% ต่อปี</a:t>
+              <a:t>✔ จุดเด่น: ใช้งานง่ายในกลุ่มไลน์ผู้บริหาร (+฿1,500/จุด เพื่อซับพอร์ตค่า Broadcast LINE)</a:t>
             </a:r>
           </a:p>
         </p:txBody>
@@ -5700,7 +6088,7 @@
               </a:defRPr>
             </a:pPr>
             <a:r>
-              <a:t>โครงการระบบวัดคุณภาพน้ำอัจฉริยะ 100 จุด (NCT WATER NEXUS)</a:t>
+              <a:t>โครงการระบบตรวจวัดคุณภาพน้ำ 100 ชุด (NCT WATER NEXUS)</a:t>
             </a:r>
           </a:p>
           <a:p>
@@ -5712,7 +6100,7 @@
               </a:defRPr>
             </a:pPr>
             <a:r>
-              <a:t>ระบบแดชบอร์ด SCADA และ Mobile Companion App (Software Platform)</a:t>
+              <a:t>5. วิเคราะห์จุดแข็ง-จุดเสี่ยงโมเดลราคา (Strategic Margin Analysis)</a:t>
             </a:r>
           </a:p>
         </p:txBody>
@@ -5736,7 +6124,7 @@
           </a:solidFill>
           <a:ln w="19050">
             <a:solidFill>
-              <a:srgbClr val="CBD5E1"/>
+              <a:srgbClr val="059669"/>
             </a:solidFill>
           </a:ln>
         </p:spPr>
@@ -5788,14 +6176,14 @@
               <a:spcAft>
                 <a:spcPts val="1000"/>
               </a:spcAft>
-              <a:defRPr sz="1400" b="1">
-                <a:solidFill>
-                  <a:srgbClr val="0284C7"/>
-                </a:solidFill>
-              </a:defRPr>
-            </a:pPr>
-            <a:r>
-              <a:t>💻 1. Centralized SCADA Widescreen View</a:t>
+              <a:defRPr sz="1350" b="1">
+                <a:solidFill>
+                  <a:srgbClr val="059669"/>
+                </a:solidFill>
+              </a:defRPr>
+            </a:pPr>
+            <a:r>
+              <a:t>🔄 ฝั่งรายปี (ดีมาก แนะนำให้ผลักดันลูกค้ารูปแบบนี้)</a:t>
             </a:r>
           </a:p>
           <a:p>
@@ -5807,7 +6195,7 @@
               </a:defRPr>
             </a:pPr>
             <a:r>
-              <a:t>• GIS Map &amp; 100-Node Grid Overview:</a:t>
+              <a:t>• ตัวเลข 1,200 – 3,600 บาท/จุด/ปี:</a:t>
             </a:r>
           </a:p>
           <a:p>
@@ -5822,7 +6210,7 @@
               </a:defRPr>
             </a:pPr>
             <a:r>
-              <a:t>  แสดงตำแหน่งและสถานะของทั้ง 100 สถานีบนแผนที่ GIS ตรวจเช็คจุดผิดปกติได้ทันที</a:t>
+              <a:t>  ตกเดือนละ 100–300 บาท/ตู้ เป็นราคาที่ลูกค้าองค์กร/โรงงาน/เทศบาล จ่ายได้ง่ายมาก</a:t>
             </a:r>
           </a:p>
           <a:p>
@@ -5834,7 +6222,7 @@
               </a:defRPr>
             </a:pPr>
             <a:r>
-              <a:t>• High-Frequency Telemetry Trends:</a:t>
+              <a:t>• Recurring Income ก้อนโตทุกปี:</a:t>
             </a:r>
           </a:p>
           <a:p>
@@ -5849,7 +6237,7 @@
               </a:defRPr>
             </a:pPr>
             <a:r>
-              <a:t>  กราฟ Real-Time Dynamic Charts วิเคราะห์แนวโน้มคุณภาพน้ำของแต่ละสถานี 24 ชม.</a:t>
+              <a:t>  มีรายรับสม่ำเสมอ 120,000 – 360,000 บาททุกปี ไว้เป็นค่า Cloud Server, ค่าซ่อมบำรุง และกำไรต่อเนื่อง</a:t>
             </a:r>
           </a:p>
           <a:p>
@@ -5861,7 +6249,7 @@
               </a:defRPr>
             </a:pPr>
             <a:r>
-              <a:t>• Zone Alert Management:</a:t>
+              <a:t>• ล็อกฐานลูกค้าได้ยาวนาน:</a:t>
             </a:r>
           </a:p>
           <a:p>
@@ -5876,34 +6264,7 @@
               </a:defRPr>
             </a:pPr>
             <a:r>
-              <a:t>  ระบบแยกกลุ่มโซนการแจ้งเตือนตามพื้นที่ (เช่น โซนอาคาร A, โซนโรงงาน 1-4)</a:t>
-            </a:r>
-          </a:p>
-          <a:p>
-            <a:pPr>
-              <a:defRPr b="1" sz="1100">
-                <a:solidFill>
-                  <a:srgbClr val="0F172A"/>
-                </a:solidFill>
-              </a:defRPr>
-            </a:pPr>
-            <a:r>
-              <a:t>• Automated Compliance Reports:</a:t>
-            </a:r>
-          </a:p>
-          <a:p>
-            <a:pPr>
-              <a:spcAft>
-                <a:spcPts val="600"/>
-              </a:spcAft>
-              <a:defRPr sz="1000">
-                <a:solidFill>
-                  <a:srgbClr val="64748B"/>
-                </a:solidFill>
-              </a:defRPr>
-            </a:pPr>
-            <a:r>
-              <a:t>  สร้างรายงานสรุปเปรียบเทียบ 100 จุดอัตโนมัติ ส่งออกเป็น Excel / PDF ในคลิกเดียว</a:t>
+              <a:t>  ลูกค้าไม่ต้องกังวลเรื่องการดูแล เราดูแลซ่อมบำรุงและอัปเดตระบบให้ 100%</a:t>
             </a:r>
           </a:p>
         </p:txBody>
@@ -5927,7 +6288,7 @@
           </a:solidFill>
           <a:ln w="19050">
             <a:solidFill>
-              <a:srgbClr val="CBD5E1"/>
+              <a:srgbClr val="0284C7"/>
             </a:solidFill>
           </a:ln>
         </p:spPr>
@@ -5979,14 +6340,14 @@
               <a:spcAft>
                 <a:spcPts val="1000"/>
               </a:spcAft>
-              <a:defRPr sz="1400" b="1">
-                <a:solidFill>
-                  <a:srgbClr val="059669"/>
-                </a:solidFill>
-              </a:defRPr>
-            </a:pPr>
-            <a:r>
-              <a:t>📱 2. Multi-Station Mobile Companion App</a:t>
+              <a:defRPr sz="1350" b="1">
+                <a:solidFill>
+                  <a:srgbClr val="0284C7"/>
+                </a:solidFill>
+              </a:defRPr>
+            </a:pPr>
+            <a:r>
+              <a:t>🏷️ ฝั่งซื้อขาด (ตัวเลขผ่าน แต่ต้องล็อคขอบเขตให้ชัด)</a:t>
             </a:r>
           </a:p>
           <a:p>
@@ -5998,7 +6359,7 @@
               </a:defRPr>
             </a:pPr>
             <a:r>
-              <a:t>• 100-Device Hub Selector:</a:t>
+              <a:t>• ราคาเฉลี่ย 2,500 – 6,000 บาท/จุด:</a:t>
             </a:r>
           </a:p>
           <a:p>
@@ -6013,7 +6374,7 @@
               </a:defRPr>
             </a:pPr>
             <a:r>
-              <a:t>  สลับดูข้อมูลสถานีตรวจวัดน้ำทั้ง 100 จุดได้ง่ายดายในแอปเดียว (ค้นหาตามชื่อ/โซน)</a:t>
+              <a:t>  ยอดรวม 2.5 – 6 แสนบาท ลูกค้าไม่รู้สึกว่าแพงเกินไปสำหรับระบบ 100 จุด</a:t>
             </a:r>
           </a:p>
           <a:p>
@@ -6025,7 +6386,7 @@
               </a:defRPr>
             </a:pPr>
             <a:r>
-              <a:t>• Instant Push Notification &amp; Line Alert:</a:t>
+              <a:t>• จุดที่ต้องระวัง:</a:t>
             </a:r>
           </a:p>
           <a:p>
@@ -6040,7 +6401,7 @@
               </a:defRPr>
             </a:pPr>
             <a:r>
-              <a:t>  แจ้งเตือนข้อความฉุกเฉินทันทีเมื่อมีจุดใดจุดหนึ่งใน 100 จุดหลุดเกณฑ์มาตรฐาน</a:t>
+              <a:t>  ซื้อขาดแปลว่าคุณต้องแบกค่า Host/Database เองในอนาคต หรือต้องส่งมอบ Source Code ให้ลูกค้ารัน Server เอง</a:t>
             </a:r>
           </a:p>
           <a:p>
@@ -6052,7 +6413,7 @@
               </a:defRPr>
             </a:pPr>
             <a:r>
-              <a:t>• Color-Coded Status Cards:</a:t>
+              <a:t>• เงื่อนไขสัญญาป้องกันต้นทุน (MA):</a:t>
             </a:r>
           </a:p>
           <a:p>
@@ -6067,34 +6428,7 @@
               </a:defRPr>
             </a:pPr>
             <a:r>
-              <a:t>  แสดงสถานะด้วยสีเขียว/เหลือง/แดง ชัดเจน รู้ทันทีว่าจุดไหนปกติดีหรือต้องตรวจเช็ค</a:t>
-            </a:r>
-          </a:p>
-          <a:p>
-            <a:pPr>
-              <a:defRPr b="1" sz="1100">
-                <a:solidFill>
-                  <a:srgbClr val="0F172A"/>
-                </a:solidFill>
-              </a:defRPr>
-            </a:pPr>
-            <a:r>
-              <a:t>• Offline Battery &amp; Link Monitor:</a:t>
-            </a:r>
-          </a:p>
-          <a:p>
-            <a:pPr>
-              <a:spcAft>
-                <a:spcPts val="600"/>
-              </a:spcAft>
-              <a:defRPr sz="1000">
-                <a:solidFill>
-                  <a:srgbClr val="64748B"/>
-                </a:solidFill>
-              </a:defRPr>
-            </a:pPr>
-            <a:r>
-              <a:t>  ตรวจสอบสัญญาณ WiFi/4G และระดับแบตเตอรี่สำรองของทุกตู้ได้จากระยะไกล</a:t>
+              <a:t>  ควรกำหนดในสัญญาว่า ฟรี Support/แก้บั๊ก 1 ปีแรกเท่านั้น ปีถัดไปคิดสัญญา MA แยก 10–15% ต่อปี</a:t>
             </a:r>
           </a:p>
         </p:txBody>
@@ -6158,7 +6492,7 @@
               </a:defRPr>
             </a:pPr>
             <a:r>
-              <a:t>โครงการระบบวัดคุณภาพน้ำอัจฉริยะ 100 จุด (NCT WATER NEXUS)</a:t>
+              <a:t>โครงการระบบตรวจวัดคุณภาพน้ำ 100 ชุด (NCT WATER NEXUS)</a:t>
             </a:r>
           </a:p>
           <a:p>
@@ -6170,7 +6504,7 @@
               </a:defRPr>
             </a:pPr>
             <a:r>
-              <a:t>ข้อกำหนดสัญญาและการบริการหลังการขาย (SLA &amp; MA Agreement)</a:t>
+              <a:t>6. ระบบแดชบอร์ด SCADA และ Mobile Companion App (Software Platform)</a:t>
             </a:r>
           </a:p>
         </p:txBody>
@@ -6194,7 +6528,7 @@
           </a:solidFill>
           <a:ln w="19050">
             <a:solidFill>
-              <a:srgbClr val="059669"/>
+              <a:srgbClr val="CBD5E1"/>
             </a:solidFill>
           </a:ln>
         </p:spPr>
@@ -6222,57 +6556,14 @@
       </p:sp>
       <p:sp>
         <p:nvSpPr>
-          <p:cNvPr id="4" name="Rounded Rectangle 3"/>
-          <p:cNvSpPr/>
-          <p:nvPr/>
-        </p:nvSpPr>
-        <p:spPr>
-          <a:xfrm>
-            <a:off x="731520" y="1463040"/>
-            <a:ext cx="5120640" cy="1188720"/>
-          </a:xfrm>
-          <a:prstGeom prst="roundRect">
-            <a:avLst/>
-          </a:prstGeom>
-          <a:solidFill>
-            <a:srgbClr val="059669"/>
-          </a:solidFill>
-          <a:ln>
-            <a:noFill/>
-          </a:ln>
-        </p:spPr>
-        <p:style>
-          <a:lnRef idx="1">
-            <a:schemeClr val="accent1"/>
-          </a:lnRef>
-          <a:fillRef idx="3">
-            <a:schemeClr val="accent1"/>
-          </a:fillRef>
-          <a:effectRef idx="2">
-            <a:schemeClr val="accent1"/>
-          </a:effectRef>
-          <a:fontRef idx="minor">
-            <a:schemeClr val="lt1"/>
-          </a:fontRef>
-        </p:style>
-        <p:txBody>
-          <a:bodyPr rtlCol="0" anchor="ctr"/>
-          <a:lstStyle/>
-          <a:p>
-            <a:pPr algn="ctr"/>
-          </a:p>
-        </p:txBody>
-      </p:sp>
-      <p:sp>
-        <p:nvSpPr>
-          <p:cNvPr id="5" name="TextBox 4"/>
+          <p:cNvPr id="4" name="TextBox 3"/>
           <p:cNvSpPr txBox="1"/>
           <p:nvPr/>
         </p:nvSpPr>
         <p:spPr>
           <a:xfrm>
-            <a:off x="914400" y="1554480"/>
-            <a:ext cx="4754880" cy="1005840"/>
+            <a:off x="1005840" y="1691640"/>
+            <a:ext cx="4572000" cy="4297680"/>
           </a:xfrm>
           <a:prstGeom prst="rect">
             <a:avLst/>
@@ -6286,86 +6577,138 @@
           <a:lstStyle/>
           <a:p>
             <a:pPr>
-              <a:defRPr sz="950" b="1">
-                <a:solidFill>
-                  <a:srgbClr val="FFFFFF"/>
-                </a:solidFill>
-              </a:defRPr>
-            </a:pPr>
-            <a:r>
-              <a:t>รวมทุกอย่างครบวงจร (ALL-INCLUSIVE)</a:t>
-            </a:r>
-          </a:p>
-          <a:p>
-            <a:pPr>
+              <a:spcAft>
+                <a:spcPts val="1000"/>
+              </a:spcAft>
               <a:defRPr sz="1400" b="1">
                 <a:solidFill>
-                  <a:srgbClr val="FFFFFF"/>
-                </a:solidFill>
-              </a:defRPr>
-            </a:pPr>
-            <a:r>
-              <a:t>สัญญาแบบรายปี (Subscription Model)</a:t>
-            </a:r>
-          </a:p>
-        </p:txBody>
-      </p:sp>
-      <p:sp>
-        <p:nvSpPr>
-          <p:cNvPr id="6" name="TextBox 5"/>
-          <p:cNvSpPr txBox="1"/>
-          <p:nvPr/>
-        </p:nvSpPr>
-        <p:spPr>
-          <a:xfrm>
-            <a:off x="914400" y="2834640"/>
-            <a:ext cx="4754880" cy="3200400"/>
-          </a:xfrm>
-          <a:prstGeom prst="rect">
-            <a:avLst/>
-          </a:prstGeom>
-          <a:noFill/>
-        </p:spPr>
-        <p:txBody>
-          <a:bodyPr wrap="square">
-            <a:spAutoFit/>
-          </a:bodyPr>
-          <a:lstStyle/>
-          <a:p>
-            <a:pPr>
-              <a:defRPr sz="1100">
+                  <a:srgbClr val="0284C7"/>
+                </a:solidFill>
+              </a:defRPr>
+            </a:pPr>
+            <a:r>
+              <a:t>💻 1. Centralized SCADA Widescreen View</a:t>
+            </a:r>
+          </a:p>
+          <a:p>
+            <a:pPr>
+              <a:defRPr b="1" sz="1100">
                 <a:solidFill>
                   <a:srgbClr val="0F172A"/>
                 </a:solidFill>
               </a:defRPr>
             </a:pPr>
             <a:r>
-              <a:t>• รวมค่า Cloud Server, Database &amp; ซิม 4G ตลอดสัญญา</a:t>
-            </a:r>
-            <a:br/>
-            <a:r>
-              <a:t>• ฟรีบริการแก้บั๊ก อัปเดตเฟิร์มแวร์ และปรับปรุงซอฟต์แวร์ใหม่ตลอดเวลา</a:t>
-            </a:r>
-            <a:br/>
-            <a:r>
-              <a:t>• ทีมวิศวกร On-site Support และสอบเทียบ Calibrate ตามรอบ</a:t>
-            </a:r>
-            <a:br/>
-            <a:r>
-              <a:t>• สร้าง Recurring Income ฿120,000 – ฿360,000 / ปี อย่างมั่นคง</a:t>
-            </a:r>
-          </a:p>
-        </p:txBody>
-      </p:sp>
-      <p:sp>
-        <p:nvSpPr>
-          <p:cNvPr id="7" name="Rounded Rectangle 6"/>
+              <a:t>• GIS Map &amp; 100-Node Grid Overview:</a:t>
+            </a:r>
+          </a:p>
+          <a:p>
+            <a:pPr>
+              <a:spcAft>
+                <a:spcPts val="600"/>
+              </a:spcAft>
+              <a:defRPr sz="1000">
+                <a:solidFill>
+                  <a:srgbClr val="64748B"/>
+                </a:solidFill>
+              </a:defRPr>
+            </a:pPr>
+            <a:r>
+              <a:t>  แสดงตำแหน่งและสถานะของทั้ง 100 สถานีบนแผนที่ GIS ตรวจเช็คจุดผิดปกติได้ทันที</a:t>
+            </a:r>
+          </a:p>
+          <a:p>
+            <a:pPr>
+              <a:defRPr b="1" sz="1100">
+                <a:solidFill>
+                  <a:srgbClr val="0F172A"/>
+                </a:solidFill>
+              </a:defRPr>
+            </a:pPr>
+            <a:r>
+              <a:t>• High-Frequency Telemetry Trends:</a:t>
+            </a:r>
+          </a:p>
+          <a:p>
+            <a:pPr>
+              <a:spcAft>
+                <a:spcPts val="600"/>
+              </a:spcAft>
+              <a:defRPr sz="1000">
+                <a:solidFill>
+                  <a:srgbClr val="64748B"/>
+                </a:solidFill>
+              </a:defRPr>
+            </a:pPr>
+            <a:r>
+              <a:t>  กราฟ Real-Time Dynamic Charts วิเคราะห์แนวโน้มคุณภาพน้ำของแต่ละสถานี 24 ชม.</a:t>
+            </a:r>
+          </a:p>
+          <a:p>
+            <a:pPr>
+              <a:defRPr b="1" sz="1100">
+                <a:solidFill>
+                  <a:srgbClr val="0F172A"/>
+                </a:solidFill>
+              </a:defRPr>
+            </a:pPr>
+            <a:r>
+              <a:t>• Zone Alert Management:</a:t>
+            </a:r>
+          </a:p>
+          <a:p>
+            <a:pPr>
+              <a:spcAft>
+                <a:spcPts val="600"/>
+              </a:spcAft>
+              <a:defRPr sz="1000">
+                <a:solidFill>
+                  <a:srgbClr val="64748B"/>
+                </a:solidFill>
+              </a:defRPr>
+            </a:pPr>
+            <a:r>
+              <a:t>  ระบบแยกกลุ่มโซนการแจ้งเตือนตามพื้นที่ (เช่น โซนอาคาร A, โซนโรงงาน 1-4)</a:t>
+            </a:r>
+          </a:p>
+          <a:p>
+            <a:pPr>
+              <a:defRPr b="1" sz="1100">
+                <a:solidFill>
+                  <a:srgbClr val="0F172A"/>
+                </a:solidFill>
+              </a:defRPr>
+            </a:pPr>
+            <a:r>
+              <a:t>• Automated Compliance Reports:</a:t>
+            </a:r>
+          </a:p>
+          <a:p>
+            <a:pPr>
+              <a:spcAft>
+                <a:spcPts val="600"/>
+              </a:spcAft>
+              <a:defRPr sz="1000">
+                <a:solidFill>
+                  <a:srgbClr val="64748B"/>
+                </a:solidFill>
+              </a:defRPr>
+            </a:pPr>
+            <a:r>
+              <a:t>  สร้างรายงานสรุปเปรียบเทียบ 100 จุดอัตโนมัติ ส่งออกเป็น Excel / PDF ในคลิกเดียว</a:t>
+            </a:r>
+          </a:p>
+        </p:txBody>
+      </p:sp>
+      <p:sp>
+        <p:nvSpPr>
+          <p:cNvPr id="5" name="Rounded Rectangle 4"/>
           <p:cNvSpPr/>
           <p:nvPr/>
         </p:nvSpPr>
         <p:spPr>
           <a:xfrm>
-            <a:off x="6339535" y="1463040"/>
+            <a:off x="6309360" y="1463040"/>
             <a:ext cx="5120640" cy="4754880"/>
           </a:xfrm>
           <a:prstGeom prst="roundRect">
@@ -6376,7 +6719,7 @@
           </a:solidFill>
           <a:ln w="19050">
             <a:solidFill>
-              <a:srgbClr val="0284C7"/>
+              <a:srgbClr val="CBD5E1"/>
             </a:solidFill>
           </a:ln>
         </p:spPr>
@@ -6404,57 +6747,14 @@
       </p:sp>
       <p:sp>
         <p:nvSpPr>
-          <p:cNvPr id="8" name="Rounded Rectangle 7"/>
-          <p:cNvSpPr/>
-          <p:nvPr/>
-        </p:nvSpPr>
-        <p:spPr>
-          <a:xfrm>
-            <a:off x="6339535" y="1463040"/>
-            <a:ext cx="5120640" cy="1188720"/>
-          </a:xfrm>
-          <a:prstGeom prst="roundRect">
-            <a:avLst/>
-          </a:prstGeom>
-          <a:solidFill>
-            <a:srgbClr val="0284C7"/>
-          </a:solidFill>
-          <a:ln>
-            <a:noFill/>
-          </a:ln>
-        </p:spPr>
-        <p:style>
-          <a:lnRef idx="1">
-            <a:schemeClr val="accent1"/>
-          </a:lnRef>
-          <a:fillRef idx="3">
-            <a:schemeClr val="accent1"/>
-          </a:fillRef>
-          <a:effectRef idx="2">
-            <a:schemeClr val="accent1"/>
-          </a:effectRef>
-          <a:fontRef idx="minor">
-            <a:schemeClr val="lt1"/>
-          </a:fontRef>
-        </p:style>
-        <p:txBody>
-          <a:bodyPr rtlCol="0" anchor="ctr"/>
-          <a:lstStyle/>
-          <a:p>
-            <a:pPr algn="ctr"/>
-          </a:p>
-        </p:txBody>
-      </p:sp>
-      <p:sp>
-        <p:nvSpPr>
-          <p:cNvPr id="9" name="TextBox 8"/>
+          <p:cNvPr id="6" name="TextBox 5"/>
           <p:cNvSpPr txBox="1"/>
           <p:nvPr/>
         </p:nvSpPr>
         <p:spPr>
           <a:xfrm>
-            <a:off x="6522415" y="1554480"/>
-            <a:ext cx="4754880" cy="1005840"/>
+            <a:off x="6583680" y="1691640"/>
+            <a:ext cx="4572000" cy="4297680"/>
           </a:xfrm>
           <a:prstGeom prst="rect">
             <a:avLst/>
@@ -6468,69 +6768,125 @@
           <a:lstStyle/>
           <a:p>
             <a:pPr>
-              <a:defRPr sz="950" b="1">
-                <a:solidFill>
-                  <a:srgbClr val="FFFFFF"/>
-                </a:solidFill>
-              </a:defRPr>
-            </a:pPr>
-            <a:r>
-              <a:t>ล็อคขอบเขต MA ชัดเจนตั้งแต่ปีที่ 2</a:t>
-            </a:r>
-          </a:p>
-          <a:p>
-            <a:pPr>
+              <a:spcAft>
+                <a:spcPts val="1000"/>
+              </a:spcAft>
               <a:defRPr sz="1400" b="1">
                 <a:solidFill>
-                  <a:srgbClr val="FFFFFF"/>
-                </a:solidFill>
-              </a:defRPr>
-            </a:pPr>
-            <a:r>
-              <a:t>สัญญาแบบซื้อขาด (Outright + MA 10-15%)</a:t>
-            </a:r>
-          </a:p>
-        </p:txBody>
-      </p:sp>
-      <p:sp>
-        <p:nvSpPr>
-          <p:cNvPr id="10" name="TextBox 9"/>
-          <p:cNvSpPr txBox="1"/>
-          <p:nvPr/>
-        </p:nvSpPr>
-        <p:spPr>
-          <a:xfrm>
-            <a:off x="6522415" y="2834640"/>
-            <a:ext cx="4754880" cy="3200400"/>
-          </a:xfrm>
-          <a:prstGeom prst="rect">
-            <a:avLst/>
-          </a:prstGeom>
-          <a:noFill/>
-        </p:spPr>
-        <p:txBody>
-          <a:bodyPr wrap="square">
-            <a:spAutoFit/>
-          </a:bodyPr>
-          <a:lstStyle/>
-          <a:p>
-            <a:pPr>
-              <a:defRPr sz="1100">
+                  <a:srgbClr val="059669"/>
+                </a:solidFill>
+              </a:defRPr>
+            </a:pPr>
+            <a:r>
+              <a:t>📱 2. Multi-Station Mobile Companion App</a:t>
+            </a:r>
+          </a:p>
+          <a:p>
+            <a:pPr>
+              <a:defRPr b="1" sz="1100">
                 <a:solidFill>
                   <a:srgbClr val="0F172A"/>
                 </a:solidFill>
               </a:defRPr>
             </a:pPr>
             <a:r>
-              <a:t>• ฟรี Support / แก้ไขปัญหา / ดูแลเซิร์ฟเวอร์ 1 ปีแรกเท่านั้น</a:t>
-            </a:r>
-            <a:br/>
-            <a:r>
-              <a:t>• ปีที่ 2 เป็นต้นไป คิดสัญญา MA 10–15% ต่อปี (ประมาณ ฿25,000 – ฿90,000/ปี)</a:t>
-            </a:r>
-            <a:br/>
-            <a:r>
-              <a:t>• ป้องกันภาระค่าโฮสต์และฐานข้อมูลในระยะยาวได้อย่างมีประสิทธิภาพ</a:t>
+              <a:t>• 100-Device Hub Selector:</a:t>
+            </a:r>
+          </a:p>
+          <a:p>
+            <a:pPr>
+              <a:spcAft>
+                <a:spcPts val="600"/>
+              </a:spcAft>
+              <a:defRPr sz="1000">
+                <a:solidFill>
+                  <a:srgbClr val="64748B"/>
+                </a:solidFill>
+              </a:defRPr>
+            </a:pPr>
+            <a:r>
+              <a:t>  สลับดูข้อมูลสถานีตรวจวัดน้ำทั้ง 100 จุดได้ง่ายดายในแอปเดียว (ค้นหาตามชื่อ/โซน)</a:t>
+            </a:r>
+          </a:p>
+          <a:p>
+            <a:pPr>
+              <a:defRPr b="1" sz="1100">
+                <a:solidFill>
+                  <a:srgbClr val="0F172A"/>
+                </a:solidFill>
+              </a:defRPr>
+            </a:pPr>
+            <a:r>
+              <a:t>• Instant Push Notification &amp; Line Alert:</a:t>
+            </a:r>
+          </a:p>
+          <a:p>
+            <a:pPr>
+              <a:spcAft>
+                <a:spcPts val="600"/>
+              </a:spcAft>
+              <a:defRPr sz="1000">
+                <a:solidFill>
+                  <a:srgbClr val="64748B"/>
+                </a:solidFill>
+              </a:defRPr>
+            </a:pPr>
+            <a:r>
+              <a:t>  แจ้งเตือนข้อความฉุกเฉินทันทีเมื่อมีจุดใดจุดหนึ่งใน 100 จุดหลุดเกณฑ์มาตรฐาน</a:t>
+            </a:r>
+          </a:p>
+          <a:p>
+            <a:pPr>
+              <a:defRPr b="1" sz="1100">
+                <a:solidFill>
+                  <a:srgbClr val="0F172A"/>
+                </a:solidFill>
+              </a:defRPr>
+            </a:pPr>
+            <a:r>
+              <a:t>• Color-Coded Status Cards:</a:t>
+            </a:r>
+          </a:p>
+          <a:p>
+            <a:pPr>
+              <a:spcAft>
+                <a:spcPts val="600"/>
+              </a:spcAft>
+              <a:defRPr sz="1000">
+                <a:solidFill>
+                  <a:srgbClr val="64748B"/>
+                </a:solidFill>
+              </a:defRPr>
+            </a:pPr>
+            <a:r>
+              <a:t>  แสดงสถานะด้วยสีเขียว/เหลือง/แดง ชัดเจน รู้ทันทีว่าจุดไหนปกติดีหรือต้องตรวจเช็ค</a:t>
+            </a:r>
+          </a:p>
+          <a:p>
+            <a:pPr>
+              <a:defRPr b="1" sz="1100">
+                <a:solidFill>
+                  <a:srgbClr val="0F172A"/>
+                </a:solidFill>
+              </a:defRPr>
+            </a:pPr>
+            <a:r>
+              <a:t>• Offline Battery &amp; Link Monitor:</a:t>
+            </a:r>
+          </a:p>
+          <a:p>
+            <a:pPr>
+              <a:spcAft>
+                <a:spcPts val="600"/>
+              </a:spcAft>
+              <a:defRPr sz="1000">
+                <a:solidFill>
+                  <a:srgbClr val="64748B"/>
+                </a:solidFill>
+              </a:defRPr>
+            </a:pPr>
+            <a:r>
+              <a:t>  ตรวจสอบสัญญาณ WiFi/4G และระดับแบตเตอรี่สำรองของทุกตู้ได้จากระยะไกล</a:t>
             </a:r>
           </a:p>
         </p:txBody>
@@ -6639,7 +6995,7 @@
               </a:defRPr>
             </a:pPr>
             <a:r>
-              <a:t>💧 โครงการระบบตรวจวัดคุณภาพน้ำและแดชบอร์ด 100 จุด</a:t>
+              <a:t>💧 สรุปภาพรวมข้อเสนอราคาโครงการตรวจวัดคุณภาพน้ำ 100 ชุด</a:t>
             </a:r>
           </a:p>
           <a:p>
@@ -6660,7 +7016,7 @@
           <a:p>
             <a:pPr>
               <a:spcAft>
-                <a:spcPts val="2000"/>
+                <a:spcPts val="1600"/>
               </a:spcAft>
               <a:defRPr sz="1350">
                 <a:solidFill>
@@ -6669,19 +7025,7 @@
               </a:defRPr>
             </a:pPr>
             <a:r>
-              <a:t>พร้อมให้คำปรึกษา ออกแบบระบบ และจัดทำใบเสนอราคาโครงการตามงบประมาณของลูกค้า</a:t>
-            </a:r>
-          </a:p>
-          <a:p>
-            <a:pPr>
-              <a:defRPr b="1" sz="1300">
-                <a:solidFill>
-                  <a:srgbClr val="FFFFFF"/>
-                </a:solidFill>
-              </a:defRPr>
-            </a:pPr>
-            <a:r>
-              <a:t>✨ สรุปข้อเสนอโครงการ 100 จุด:</a:t>
+              <a:t>พร้อมส่งมอบอุปกรณ์และระบบแดชบอร์ดครบวงจรตามขอบเขตที่ลูกค้าเลือก:</a:t>
             </a:r>
           </a:p>
           <a:p>
@@ -6689,30 +7033,26 @@
               <a:spcAft>
                 <a:spcPts val="2400"/>
               </a:spcAft>
-              <a:defRPr sz="1050">
+              <a:defRPr sz="1100">
                 <a:solidFill>
                   <a:srgbClr val="E2E8F0"/>
                 </a:solidFill>
               </a:defRPr>
             </a:pPr>
             <a:r>
-              <a:t>• ฮาร์ดแวร์ 4 ค่า (pH/TDS/Temp/Cl): ฿21,000/ชุด (รวม 100 จุด = ฿2,100,000)</a:t>
+              <a:t>• รวมต้นทุนต่อชุด: 21,000 บาท (100 ชุด = 2,100,000 บาท)</a:t>
             </a:r>
             <a:br/>
             <a:r>
-              <a:t>• ซอฟต์แวร์แดชบอร์ด Option 1 (App+Telegram): ซื้อขาด ฿250,000 | รายปี ฿170,000 (ปีถัดไป ฿120,000/ปี)</a:t>
+              <a:t>• [แบบที่ 1 Plug &amp; Play]: 29,500 - 32,000 บ./ชุด (รวม 2.95 - 3.20 ล้าน | กำไร 8.5 แสน - 1.1 ล้าน)</a:t>
             </a:r>
             <a:br/>
             <a:r>
-              <a:t>• ซอฟต์แวร์แดชบอร์ด Option 2 (Web+Telegram): ซื้อขาด ฿450,000 | รายปี ฿340,000 (ปีถัดไป ฿240,000/ปี)</a:t>
+              <a:t>• [แบบที่ 2 Turnkey]: 38,000 - 42,000 บ./ชุด (รวม 3.80 - 4.20 ล้าน | กำไร 1.7 - 2.1 ล้าน)</a:t>
             </a:r>
             <a:br/>
             <a:r>
-              <a:t>• ซอฟต์แวร์แดชบอร์ด Option 3 (Web+App+LINE): ซื้อขาด ฿600,000 | รายปี ฿510,000 (ปีถัดไป ฿360,000/ปี)</a:t>
-            </a:r>
-            <a:br/>
-            <a:r>
-              <a:t>• เปิดดูแดชบอร์ดและสไลด์ออนไลน์ได้ที่: https://woobwarb.github.io/nct-water-nexus/</a:t>
+              <a:t>• ซอฟต์แวร์แดชบอร์ด 100 จุด: ซื้อขาด 2.5 - 6.0 แสน | รายปี 1.2 - 3.6 แสน/ปี (Recurring Income)</a:t>
             </a:r>
           </a:p>
           <a:p>

</xml_diff>

<commit_message>
Add full UI screenshots and feature explanations to PDF, PPTX, and HTML presentation
</commit_message>
<xml_diff>
--- a/NCT_Water_Nexus_Report_and_Pricing.pptx
+++ b/NCT_Water_Nexus_Report_and_Pricing.pptx
@@ -6100,185 +6100,45 @@
               </a:defRPr>
             </a:pPr>
             <a:r>
-              <a:t>5. วิเคราะห์จุดแข็ง-จุดเสี่ยงโมเดลราคา (Strategic Margin Analysis)</a:t>
-            </a:r>
-          </a:p>
-        </p:txBody>
-      </p:sp>
-      <p:sp>
-        <p:nvSpPr>
-          <p:cNvPr id="3" name="Rounded Rectangle 2"/>
-          <p:cNvSpPr/>
+              <a:t>5. ตัวอย่างหน้าจอ Centralized Web SCADA Dashboard (จอห้องควบคุม 100 จุด)</a:t>
+            </a:r>
+          </a:p>
+        </p:txBody>
+      </p:sp>
+      <p:pic>
+        <p:nvPicPr>
+          <p:cNvPr id="3" name="Picture 2" descr="scada_preview.png"/>
+          <p:cNvPicPr>
+            <a:picLocks noChangeAspect="1"/>
+          </p:cNvPicPr>
           <p:nvPr/>
-        </p:nvSpPr>
+        </p:nvPicPr>
+        <p:blipFill>
+          <a:blip r:embed="rId2"/>
+          <a:stretch>
+            <a:fillRect/>
+          </a:stretch>
+        </p:blipFill>
         <p:spPr>
           <a:xfrm>
             <a:off x="731520" y="1463040"/>
-            <a:ext cx="5120640" cy="4754880"/>
-          </a:xfrm>
-          <a:prstGeom prst="roundRect">
-            <a:avLst/>
-          </a:prstGeom>
-          <a:solidFill>
-            <a:srgbClr val="FFFFFF"/>
-          </a:solidFill>
-          <a:ln w="19050">
-            <a:solidFill>
-              <a:srgbClr val="059669"/>
-            </a:solidFill>
-          </a:ln>
-        </p:spPr>
-        <p:style>
-          <a:lnRef idx="1">
-            <a:schemeClr val="accent1"/>
-          </a:lnRef>
-          <a:fillRef idx="3">
-            <a:schemeClr val="accent1"/>
-          </a:fillRef>
-          <a:effectRef idx="2">
-            <a:schemeClr val="accent1"/>
-          </a:effectRef>
-          <a:fontRef idx="minor">
-            <a:schemeClr val="lt1"/>
-          </a:fontRef>
-        </p:style>
-        <p:txBody>
-          <a:bodyPr rtlCol="0" anchor="ctr"/>
-          <a:lstStyle/>
-          <a:p>
-            <a:pPr algn="ctr"/>
-          </a:p>
-        </p:txBody>
-      </p:sp>
-      <p:sp>
-        <p:nvSpPr>
-          <p:cNvPr id="4" name="TextBox 3"/>
-          <p:cNvSpPr txBox="1"/>
-          <p:nvPr/>
-        </p:nvSpPr>
-        <p:spPr>
-          <a:xfrm>
-            <a:off x="1005840" y="1691640"/>
-            <a:ext cx="4572000" cy="4297680"/>
+            <a:ext cx="6217920" cy="4754880"/>
           </a:xfrm>
           <a:prstGeom prst="rect">
             <a:avLst/>
           </a:prstGeom>
-          <a:noFill/>
-        </p:spPr>
-        <p:txBody>
-          <a:bodyPr wrap="square">
-            <a:spAutoFit/>
-          </a:bodyPr>
-          <a:lstStyle/>
-          <a:p>
-            <a:pPr>
-              <a:spcAft>
-                <a:spcPts val="1000"/>
-              </a:spcAft>
-              <a:defRPr sz="1350" b="1">
-                <a:solidFill>
-                  <a:srgbClr val="059669"/>
-                </a:solidFill>
-              </a:defRPr>
-            </a:pPr>
-            <a:r>
-              <a:t>🔄 ฝั่งรายปี (ดีมาก แนะนำให้ผลักดันลูกค้ารูปแบบนี้)</a:t>
-            </a:r>
-          </a:p>
-          <a:p>
-            <a:pPr>
-              <a:defRPr b="1" sz="1100">
-                <a:solidFill>
-                  <a:srgbClr val="0F172A"/>
-                </a:solidFill>
-              </a:defRPr>
-            </a:pPr>
-            <a:r>
-              <a:t>• ตัวเลข 1,200 – 3,600 บาท/จุด/ปี:</a:t>
-            </a:r>
-          </a:p>
-          <a:p>
-            <a:pPr>
-              <a:spcAft>
-                <a:spcPts val="600"/>
-              </a:spcAft>
-              <a:defRPr sz="1000">
-                <a:solidFill>
-                  <a:srgbClr val="64748B"/>
-                </a:solidFill>
-              </a:defRPr>
-            </a:pPr>
-            <a:r>
-              <a:t>  ตกเดือนละ 100–300 บาท/ตู้ เป็นราคาที่ลูกค้าองค์กร/โรงงาน/เทศบาล จ่ายได้ง่ายมาก</a:t>
-            </a:r>
-          </a:p>
-          <a:p>
-            <a:pPr>
-              <a:defRPr b="1" sz="1100">
-                <a:solidFill>
-                  <a:srgbClr val="0F172A"/>
-                </a:solidFill>
-              </a:defRPr>
-            </a:pPr>
-            <a:r>
-              <a:t>• Recurring Income ก้อนโตทุกปี:</a:t>
-            </a:r>
-          </a:p>
-          <a:p>
-            <a:pPr>
-              <a:spcAft>
-                <a:spcPts val="600"/>
-              </a:spcAft>
-              <a:defRPr sz="1000">
-                <a:solidFill>
-                  <a:srgbClr val="64748B"/>
-                </a:solidFill>
-              </a:defRPr>
-            </a:pPr>
-            <a:r>
-              <a:t>  มีรายรับสม่ำเสมอ 120,000 – 360,000 บาททุกปี ไว้เป็นค่า Cloud Server, ค่าซ่อมบำรุง และกำไรต่อเนื่อง</a:t>
-            </a:r>
-          </a:p>
-          <a:p>
-            <a:pPr>
-              <a:defRPr b="1" sz="1100">
-                <a:solidFill>
-                  <a:srgbClr val="0F172A"/>
-                </a:solidFill>
-              </a:defRPr>
-            </a:pPr>
-            <a:r>
-              <a:t>• ล็อกฐานลูกค้าได้ยาวนาน:</a:t>
-            </a:r>
-          </a:p>
-          <a:p>
-            <a:pPr>
-              <a:spcAft>
-                <a:spcPts val="600"/>
-              </a:spcAft>
-              <a:defRPr sz="1000">
-                <a:solidFill>
-                  <a:srgbClr val="64748B"/>
-                </a:solidFill>
-              </a:defRPr>
-            </a:pPr>
-            <a:r>
-              <a:t>  ลูกค้าไม่ต้องกังวลเรื่องการดูแล เราดูแลซ่อมบำรุงและอัปเดตระบบให้ 100%</a:t>
-            </a:r>
-          </a:p>
-        </p:txBody>
-      </p:sp>
-      <p:sp>
-        <p:nvSpPr>
-          <p:cNvPr id="5" name="Rounded Rectangle 4"/>
+        </p:spPr>
+      </p:pic>
+      <p:sp>
+        <p:nvSpPr>
+          <p:cNvPr id="4" name="Rounded Rectangle 3"/>
           <p:cNvSpPr/>
           <p:nvPr/>
         </p:nvSpPr>
         <p:spPr>
           <a:xfrm>
-            <a:off x="6309360" y="1463040"/>
-            <a:ext cx="5120640" cy="4754880"/>
+            <a:off x="7132320" y="1463040"/>
+            <a:ext cx="4327855" cy="4754880"/>
           </a:xfrm>
           <a:prstGeom prst="roundRect">
             <a:avLst/>
@@ -6316,14 +6176,14 @@
       </p:sp>
       <p:sp>
         <p:nvSpPr>
-          <p:cNvPr id="6" name="TextBox 5"/>
+          <p:cNvPr id="5" name="TextBox 4"/>
           <p:cNvSpPr txBox="1"/>
           <p:nvPr/>
         </p:nvSpPr>
         <p:spPr>
           <a:xfrm>
-            <a:off x="6583680" y="1691640"/>
-            <a:ext cx="4572000" cy="4297680"/>
+            <a:off x="7315200" y="1600200"/>
+            <a:ext cx="3962095" cy="4480560"/>
           </a:xfrm>
           <a:prstGeom prst="rect">
             <a:avLst/>
@@ -6338,97 +6198,106 @@
           <a:p>
             <a:pPr>
               <a:spcAft>
-                <a:spcPts val="1000"/>
+                <a:spcPts val="800"/>
               </a:spcAft>
-              <a:defRPr sz="1350" b="1">
+              <a:defRPr sz="1300" b="1">
                 <a:solidFill>
                   <a:srgbClr val="0284C7"/>
                 </a:solidFill>
               </a:defRPr>
             </a:pPr>
             <a:r>
-              <a:t>🏷️ ฝั่งซื้อขาด (ตัวเลขผ่าน แต่ต้องล็อคขอบเขตให้ชัด)</a:t>
-            </a:r>
-          </a:p>
-          <a:p>
-            <a:pPr>
-              <a:defRPr b="1" sz="1100">
+              <a:t>💻 คำอธิบายฟังก์ชันหน้าจอ SCADA:</a:t>
+            </a:r>
+          </a:p>
+          <a:p>
+            <a:pPr>
+              <a:spcAft>
+                <a:spcPts val="300"/>
+              </a:spcAft>
+              <a:defRPr sz="950">
                 <a:solidFill>
                   <a:srgbClr val="0F172A"/>
                 </a:solidFill>
               </a:defRPr>
             </a:pPr>
             <a:r>
-              <a:t>• ราคาเฉลี่ย 2,500 – 6,000 บาท/จุด:</a:t>
+              <a:t>❶ สถานะระบบ &amp; แบตเตอรี่: แสดงสถานะ Healthy, สัญญาณ 4G/WiFi และแบต LiFePO4 (90%)</a:t>
             </a:r>
           </a:p>
           <a:p>
             <a:pPr>
               <a:spcAft>
-                <a:spcPts val="600"/>
+                <a:spcPts val="300"/>
               </a:spcAft>
-              <a:defRPr sz="1000">
-                <a:solidFill>
-                  <a:srgbClr val="64748B"/>
-                </a:solidFill>
-              </a:defRPr>
-            </a:pPr>
-            <a:r>
-              <a:t>  ยอดรวม 2.5 – 6 แสนบาท ลูกค้าไม่รู้สึกว่าแพงเกินไปสำหรับระบบ 100 จุด</a:t>
-            </a:r>
-          </a:p>
-          <a:p>
-            <a:pPr>
-              <a:defRPr b="1" sz="1100">
+              <a:defRPr sz="950">
                 <a:solidFill>
                   <a:srgbClr val="0F172A"/>
                 </a:solidFill>
               </a:defRPr>
             </a:pPr>
             <a:r>
-              <a:t>• จุดที่ต้องระวัง:</a:t>
+              <a:t>❷ การ์ดตรวจวัด 4 ค่าหลัก: อุณหภูมิน้ำ (ATC), pH (Glass Probe), TDS (ppm), Cl (mg/L)</a:t>
             </a:r>
           </a:p>
           <a:p>
             <a:pPr>
               <a:spcAft>
-                <a:spcPts val="600"/>
+                <a:spcPts val="300"/>
               </a:spcAft>
-              <a:defRPr sz="1000">
-                <a:solidFill>
-                  <a:srgbClr val="64748B"/>
-                </a:solidFill>
-              </a:defRPr>
-            </a:pPr>
-            <a:r>
-              <a:t>  ซื้อขาดแปลว่าคุณต้องแบกค่า Host/Database เองในอนาคต หรือต้องส่งมอบ Source Code ให้ลูกค้ารัน Server เอง</a:t>
-            </a:r>
-          </a:p>
-          <a:p>
-            <a:pPr>
-              <a:defRPr b="1" sz="1100">
+              <a:defRPr sz="950">
                 <a:solidFill>
                   <a:srgbClr val="0F172A"/>
                 </a:solidFill>
               </a:defRPr>
             </a:pPr>
             <a:r>
-              <a:t>• เงื่อนไขสัญญาป้องกันต้นทุน (MA):</a:t>
+              <a:t>❸ กราฟแนวโน้ม Real-Time: พล็อตข้อมูลสด 1 วินาที ติดตามค่าน้ำ 24 ชม. ย้อนหลังได้</a:t>
             </a:r>
           </a:p>
           <a:p>
             <a:pPr>
               <a:spcAft>
-                <a:spcPts val="600"/>
+                <a:spcPts val="300"/>
               </a:spcAft>
-              <a:defRPr sz="1000">
-                <a:solidFill>
-                  <a:srgbClr val="64748B"/>
-                </a:solidFill>
-              </a:defRPr>
-            </a:pPr>
-            <a:r>
-              <a:t>  ควรกำหนดในสัญญาว่า ฟรี Support/แก้บั๊ก 1 ปีแรกเท่านั้น ปีถัดไปคิดสัญญา MA แยก 10–15% ต่อปี</a:t>
+              <a:defRPr sz="950">
+                <a:solidFill>
+                  <a:srgbClr val="0F172A"/>
+                </a:solidFill>
+              </a:defRPr>
+            </a:pPr>
+            <a:r>
+              <a:t>❹ ไดอะแกรมเชื่อมต่อ: ตรวจจับสายสัญญาณ WiFi ➔ Display ➔ Sensor Probes</a:t>
+            </a:r>
+          </a:p>
+          <a:p>
+            <a:pPr>
+              <a:spcAft>
+                <a:spcPts val="300"/>
+              </a:spcAft>
+              <a:defRPr sz="950">
+                <a:solidFill>
+                  <a:srgbClr val="0F172A"/>
+                </a:solidFill>
+              </a:defRPr>
+            </a:pPr>
+            <a:r>
+              <a:t>❺ Digital Calibration: สอบเทียบหัววัด pH 7.00 / 4.01 ผ่านหน้าเว็บในคลิกเดียว</a:t>
+            </a:r>
+          </a:p>
+          <a:p>
+            <a:pPr>
+              <a:spcAft>
+                <a:spcPts val="300"/>
+              </a:spcAft>
+              <a:defRPr sz="950">
+                <a:solidFill>
+                  <a:srgbClr val="0F172A"/>
+                </a:solidFill>
+              </a:defRPr>
+            </a:pPr>
+            <a:r>
+              <a:t>❻ ส่งออกรายงาน: Export ข้อมูลเป็น Excel / PDF สำหรับรายงาน ISO ทันที</a:t>
             </a:r>
           </a:p>
         </p:txBody>
@@ -6504,21 +6373,45 @@
               </a:defRPr>
             </a:pPr>
             <a:r>
-              <a:t>6. ระบบแดชบอร์ด SCADA และ Mobile Companion App (Software Platform)</a:t>
-            </a:r>
-          </a:p>
-        </p:txBody>
-      </p:sp>
-      <p:sp>
-        <p:nvSpPr>
-          <p:cNvPr id="3" name="Rounded Rectangle 2"/>
+              <a:t>6. ตัวอย่างหน้าจอมือถือ (Modela Mobile Companion App) &amp; Mobile Features</a:t>
+            </a:r>
+          </a:p>
+        </p:txBody>
+      </p:sp>
+      <p:pic>
+        <p:nvPicPr>
+          <p:cNvPr id="3" name="Picture 2" descr="mobile_preview.png"/>
+          <p:cNvPicPr>
+            <a:picLocks noChangeAspect="1"/>
+          </p:cNvPicPr>
+          <p:nvPr/>
+        </p:nvPicPr>
+        <p:blipFill>
+          <a:blip r:embed="rId2"/>
+          <a:stretch>
+            <a:fillRect/>
+          </a:stretch>
+        </p:blipFill>
+        <p:spPr>
+          <a:xfrm>
+            <a:off x="731520" y="1463040"/>
+            <a:ext cx="2377440" cy="4754880"/>
+          </a:xfrm>
+          <a:prstGeom prst="rect">
+            <a:avLst/>
+          </a:prstGeom>
+        </p:spPr>
+      </p:pic>
+      <p:sp>
+        <p:nvSpPr>
+          <p:cNvPr id="4" name="Rounded Rectangle 3"/>
           <p:cNvSpPr/>
           <p:nvPr/>
         </p:nvSpPr>
         <p:spPr>
           <a:xfrm>
-            <a:off x="731520" y="1463040"/>
-            <a:ext cx="5120640" cy="4754880"/>
+            <a:off x="3383280" y="1463040"/>
+            <a:ext cx="8076895" cy="4754880"/>
           </a:xfrm>
           <a:prstGeom prst="roundRect">
             <a:avLst/>
@@ -6528,7 +6421,7 @@
           </a:solidFill>
           <a:ln w="19050">
             <a:solidFill>
-              <a:srgbClr val="CBD5E1"/>
+              <a:srgbClr val="059669"/>
             </a:solidFill>
           </a:ln>
         </p:spPr>
@@ -6556,14 +6449,14 @@
       </p:sp>
       <p:sp>
         <p:nvSpPr>
-          <p:cNvPr id="4" name="TextBox 3"/>
+          <p:cNvPr id="5" name="TextBox 4"/>
           <p:cNvSpPr txBox="1"/>
           <p:nvPr/>
         </p:nvSpPr>
         <p:spPr>
           <a:xfrm>
-            <a:off x="1005840" y="1691640"/>
-            <a:ext cx="4572000" cy="4297680"/>
+            <a:off x="3657600" y="1645920"/>
+            <a:ext cx="7498079" cy="4389120"/>
           </a:xfrm>
           <a:prstGeom prst="rect">
             <a:avLst/>
@@ -6580,26 +6473,14 @@
               <a:spcAft>
                 <a:spcPts val="1000"/>
               </a:spcAft>
-              <a:defRPr sz="1400" b="1">
-                <a:solidFill>
-                  <a:srgbClr val="0284C7"/>
-                </a:solidFill>
-              </a:defRPr>
-            </a:pPr>
-            <a:r>
-              <a:t>💻 1. Centralized SCADA Widescreen View</a:t>
-            </a:r>
-          </a:p>
-          <a:p>
-            <a:pPr>
-              <a:defRPr b="1" sz="1100">
-                <a:solidFill>
-                  <a:srgbClr val="0F172A"/>
-                </a:solidFill>
-              </a:defRPr>
-            </a:pPr>
-            <a:r>
-              <a:t>• GIS Map &amp; 100-Node Grid Overview:</a:t>
+              <a:defRPr sz="1300" b="1">
+                <a:solidFill>
+                  <a:srgbClr val="059669"/>
+                </a:solidFill>
+              </a:defRPr>
+            </a:pPr>
+            <a:r>
+              <a:t>📱 คำอธิบายฟังก์ชันแอปพลิเคชันมือถือ (iOS &amp; Android):</a:t>
             </a:r>
           </a:p>
           <a:p>
@@ -6607,26 +6488,14 @@
               <a:spcAft>
                 <a:spcPts val="600"/>
               </a:spcAft>
-              <a:defRPr sz="1000">
-                <a:solidFill>
-                  <a:srgbClr val="64748B"/>
-                </a:solidFill>
-              </a:defRPr>
-            </a:pPr>
-            <a:r>
-              <a:t>  แสดงตำแหน่งและสถานะของทั้ง 100 สถานีบนแผนที่ GIS ตรวจเช็คจุดผิดปกติได้ทันที</a:t>
-            </a:r>
-          </a:p>
-          <a:p>
-            <a:pPr>
-              <a:defRPr b="1" sz="1100">
+              <a:defRPr sz="1050">
                 <a:solidFill>
                   <a:srgbClr val="0F172A"/>
                 </a:solidFill>
               </a:defRPr>
             </a:pPr>
             <a:r>
-              <a:t>• High-Frequency Telemetry Trends:</a:t>
+              <a:t>✔ All Devices Hub (100 จุด): ค้นหาและสลับดูข้อมูลสถานีตรวจวัดคุณภาพน้ำทั้ง 100 จุดได้ง่ายดายในแอปเดียว</a:t>
             </a:r>
           </a:p>
           <a:p>
@@ -6634,26 +6503,14 @@
               <a:spcAft>
                 <a:spcPts val="600"/>
               </a:spcAft>
-              <a:defRPr sz="1000">
-                <a:solidFill>
-                  <a:srgbClr val="64748B"/>
-                </a:solidFill>
-              </a:defRPr>
-            </a:pPr>
-            <a:r>
-              <a:t>  กราฟ Real-Time Dynamic Charts วิเคราะห์แนวโน้มคุณภาพน้ำของแต่ละสถานี 24 ชม.</a:t>
-            </a:r>
-          </a:p>
-          <a:p>
-            <a:pPr>
-              <a:defRPr b="1" sz="1100">
+              <a:defRPr sz="1050">
                 <a:solidFill>
                   <a:srgbClr val="0F172A"/>
                 </a:solidFill>
               </a:defRPr>
             </a:pPr>
             <a:r>
-              <a:t>• Zone Alert Management:</a:t>
+              <a:t>✔ Hero Metric Display: แสดงค่า pH และ คลอรีนคงเหลือ (Cl) ด้วยตัวเลขขนาดใหญ่ สีสันอ่านง่าย รู้ผลทันที</a:t>
             </a:r>
           </a:p>
           <a:p>
@@ -6661,26 +6518,14 @@
               <a:spcAft>
                 <a:spcPts val="600"/>
               </a:spcAft>
-              <a:defRPr sz="1000">
-                <a:solidFill>
-                  <a:srgbClr val="64748B"/>
-                </a:solidFill>
-              </a:defRPr>
-            </a:pPr>
-            <a:r>
-              <a:t>  ระบบแยกกลุ่มโซนการแจ้งเตือนตามพื้นที่ (เช่น โซนอาคาร A, โซนโรงงาน 1-4)</a:t>
-            </a:r>
-          </a:p>
-          <a:p>
-            <a:pPr>
-              <a:defRPr b="1" sz="1100">
+              <a:defRPr sz="1050">
                 <a:solidFill>
                   <a:srgbClr val="0F172A"/>
                 </a:solidFill>
               </a:defRPr>
             </a:pPr>
             <a:r>
-              <a:t>• Automated Compliance Reports:</a:t>
+              <a:t>✔ Ambient &amp; Water Temp: แสดงอุณหภูมิน้ำทั้งหน่วยเซลเซียส (°C) และฟาเรนไฮต์ (°F) พร้อมระบบชดเชยอุณหภูมิ ATC</a:t>
             </a:r>
           </a:p>
           <a:p>
@@ -6688,109 +6533,14 @@
               <a:spcAft>
                 <a:spcPts val="600"/>
               </a:spcAft>
-              <a:defRPr sz="1000">
-                <a:solidFill>
-                  <a:srgbClr val="64748B"/>
-                </a:solidFill>
-              </a:defRPr>
-            </a:pPr>
-            <a:r>
-              <a:t>  สร้างรายงานสรุปเปรียบเทียบ 100 จุดอัตโนมัติ ส่งออกเป็น Excel / PDF ในคลิกเดียว</a:t>
-            </a:r>
-          </a:p>
-        </p:txBody>
-      </p:sp>
-      <p:sp>
-        <p:nvSpPr>
-          <p:cNvPr id="5" name="Rounded Rectangle 4"/>
-          <p:cNvSpPr/>
-          <p:nvPr/>
-        </p:nvSpPr>
-        <p:spPr>
-          <a:xfrm>
-            <a:off x="6309360" y="1463040"/>
-            <a:ext cx="5120640" cy="4754880"/>
-          </a:xfrm>
-          <a:prstGeom prst="roundRect">
-            <a:avLst/>
-          </a:prstGeom>
-          <a:solidFill>
-            <a:srgbClr val="FFFFFF"/>
-          </a:solidFill>
-          <a:ln w="19050">
-            <a:solidFill>
-              <a:srgbClr val="CBD5E1"/>
-            </a:solidFill>
-          </a:ln>
-        </p:spPr>
-        <p:style>
-          <a:lnRef idx="1">
-            <a:schemeClr val="accent1"/>
-          </a:lnRef>
-          <a:fillRef idx="3">
-            <a:schemeClr val="accent1"/>
-          </a:fillRef>
-          <a:effectRef idx="2">
-            <a:schemeClr val="accent1"/>
-          </a:effectRef>
-          <a:fontRef idx="minor">
-            <a:schemeClr val="lt1"/>
-          </a:fontRef>
-        </p:style>
-        <p:txBody>
-          <a:bodyPr rtlCol="0" anchor="ctr"/>
-          <a:lstStyle/>
-          <a:p>
-            <a:pPr algn="ctr"/>
-          </a:p>
-        </p:txBody>
-      </p:sp>
-      <p:sp>
-        <p:nvSpPr>
-          <p:cNvPr id="6" name="TextBox 5"/>
-          <p:cNvSpPr txBox="1"/>
-          <p:nvPr/>
-        </p:nvSpPr>
-        <p:spPr>
-          <a:xfrm>
-            <a:off x="6583680" y="1691640"/>
-            <a:ext cx="4572000" cy="4297680"/>
-          </a:xfrm>
-          <a:prstGeom prst="rect">
-            <a:avLst/>
-          </a:prstGeom>
-          <a:noFill/>
-        </p:spPr>
-        <p:txBody>
-          <a:bodyPr wrap="square">
-            <a:spAutoFit/>
-          </a:bodyPr>
-          <a:lstStyle/>
-          <a:p>
-            <a:pPr>
-              <a:spcAft>
-                <a:spcPts val="1000"/>
-              </a:spcAft>
-              <a:defRPr sz="1400" b="1">
-                <a:solidFill>
-                  <a:srgbClr val="059669"/>
-                </a:solidFill>
-              </a:defRPr>
-            </a:pPr>
-            <a:r>
-              <a:t>📱 2. Multi-Station Mobile Companion App</a:t>
-            </a:r>
-          </a:p>
-          <a:p>
-            <a:pPr>
-              <a:defRPr b="1" sz="1100">
+              <a:defRPr sz="1050">
                 <a:solidFill>
                   <a:srgbClr val="0F172A"/>
                 </a:solidFill>
               </a:defRPr>
             </a:pPr>
             <a:r>
-              <a:t>• 100-Device Hub Selector:</a:t>
+              <a:t>✔ Hardware Link &amp; Battery: ตรวจสอบระดับแบตเตอรี่สำรองและสถานะการเชื่อมต่อของทุกตู้ได้จากระยะไกลตลอด 24 ชม.</a:t>
             </a:r>
           </a:p>
           <a:p>
@@ -6798,95 +6548,14 @@
               <a:spcAft>
                 <a:spcPts val="600"/>
               </a:spcAft>
-              <a:defRPr sz="1000">
-                <a:solidFill>
-                  <a:srgbClr val="64748B"/>
-                </a:solidFill>
-              </a:defRPr>
-            </a:pPr>
-            <a:r>
-              <a:t>  สลับดูข้อมูลสถานีตรวจวัดน้ำทั้ง 100 จุดได้ง่ายดายในแอปเดียว (ค้นหาตามชื่อ/โซน)</a:t>
-            </a:r>
-          </a:p>
-          <a:p>
-            <a:pPr>
-              <a:defRPr b="1" sz="1100">
+              <a:defRPr sz="1050">
                 <a:solidFill>
                   <a:srgbClr val="0F172A"/>
                 </a:solidFill>
               </a:defRPr>
             </a:pPr>
             <a:r>
-              <a:t>• Instant Push Notification &amp; Line Alert:</a:t>
-            </a:r>
-          </a:p>
-          <a:p>
-            <a:pPr>
-              <a:spcAft>
-                <a:spcPts val="600"/>
-              </a:spcAft>
-              <a:defRPr sz="1000">
-                <a:solidFill>
-                  <a:srgbClr val="64748B"/>
-                </a:solidFill>
-              </a:defRPr>
-            </a:pPr>
-            <a:r>
-              <a:t>  แจ้งเตือนข้อความฉุกเฉินทันทีเมื่อมีจุดใดจุดหนึ่งใน 100 จุดหลุดเกณฑ์มาตรฐาน</a:t>
-            </a:r>
-          </a:p>
-          <a:p>
-            <a:pPr>
-              <a:defRPr b="1" sz="1100">
-                <a:solidFill>
-                  <a:srgbClr val="0F172A"/>
-                </a:solidFill>
-              </a:defRPr>
-            </a:pPr>
-            <a:r>
-              <a:t>• Color-Coded Status Cards:</a:t>
-            </a:r>
-          </a:p>
-          <a:p>
-            <a:pPr>
-              <a:spcAft>
-                <a:spcPts val="600"/>
-              </a:spcAft>
-              <a:defRPr sz="1000">
-                <a:solidFill>
-                  <a:srgbClr val="64748B"/>
-                </a:solidFill>
-              </a:defRPr>
-            </a:pPr>
-            <a:r>
-              <a:t>  แสดงสถานะด้วยสีเขียว/เหลือง/แดง ชัดเจน รู้ทันทีว่าจุดไหนปกติดีหรือต้องตรวจเช็ค</a:t>
-            </a:r>
-          </a:p>
-          <a:p>
-            <a:pPr>
-              <a:defRPr b="1" sz="1100">
-                <a:solidFill>
-                  <a:srgbClr val="0F172A"/>
-                </a:solidFill>
-              </a:defRPr>
-            </a:pPr>
-            <a:r>
-              <a:t>• Offline Battery &amp; Link Monitor:</a:t>
-            </a:r>
-          </a:p>
-          <a:p>
-            <a:pPr>
-              <a:spcAft>
-                <a:spcPts val="600"/>
-              </a:spcAft>
-              <a:defRPr sz="1000">
-                <a:solidFill>
-                  <a:srgbClr val="64748B"/>
-                </a:solidFill>
-              </a:defRPr>
-            </a:pPr>
-            <a:r>
-              <a:t>  ตรวจสอบสัญญาณ WiFi/4G และระดับแบตเตอรี่สำรองของทุกตู้ได้จากระยะไกล</a:t>
+              <a:t>✔ Instant Emergency Alerts: ระบบ Push Notification แจ้งเตือนข้อความด่วนเข้ามือถือทันทีเมื่อมีจุดใดผิดปกติ</a:t>
             </a:r>
           </a:p>
         </p:txBody>

</xml_diff>

<commit_message>
Restructure proposal PDF and presentation slides to place pricing on the final page
</commit_message>
<xml_diff>
--- a/NCT_Water_Nexus_Report_and_Pricing.pptx
+++ b/NCT_Water_Nexus_Report_and_Pricing.pptx
@@ -3204,14 +3204,14 @@
               <a:spcAft>
                 <a:spcPts val="1800"/>
               </a:spcAft>
-              <a:defRPr sz="1800">
+              <a:defRPr sz="1600">
                 <a:solidFill>
                   <a:srgbClr val="CBD5E1"/>
                 </a:solidFill>
               </a:defRPr>
             </a:pPr>
             <a:r>
-              <a:t>สรุปรายการต้นทุน (BOM) และราคาขายโครงการตรวจวัดคุณภาพน้ำ (100 ชุด)</a:t>
+              <a:t>รายงานนำเสนอโซลูชันระบบตรวจวัดคุณภาพน้ำ แดชบอร์ด SCADA และโครงสร้างราคา (100 ชุด)</a:t>
             </a:r>
           </a:p>
           <a:p>
@@ -3226,15 +3226,15 @@
               </a:defRPr>
             </a:pPr>
             <a:r>
-              <a:t>• ตรวจวัด 4 ค่าหลัก: pH / TDS / อุณหภูมิ / คลอรีนคงเหลือ (Modela One + Cybertice)</a:t>
+              <a:t>• 4 พารามิเตอร์คุณภาพน้ำ: pH / TDS / อุณหภูมิน้ำ (ATC) / คลอรีนคงเหลือ (Residual Cl)</a:t>
             </a:r>
             <a:br/>
             <a:r>
-              <a:t>• ต้นทุนฮาร์ดแวร์ตู้คอนโทรล: ฿21,000 / ชุด (โครงการ 100 ชุด = ฿2,100,000)</a:t>
+              <a:t>• ระบบแดชบอร์ดคู่ขนาน: Centralized Web SCADA (จอใหญ่ห้องควบคุม) + Modela Mobile App</a:t>
             </a:r>
             <a:br/>
             <a:r>
-              <a:t>• 2 รูปแบบข้อเสนอราคา: 【 แบบที่ 1 Plug &amp; Play (2.95 - 3.20 ล้าน) 】 vs 【 แบบที่ 2 Turnkey (3.80 - 4.20 ล้าน) 】</a:t>
+              <a:t>• โครงสร้างราคาและข้อเสนอโครงการ: ตารางราคาและแพ็กเกจโครงการ 100 ชุด (หน้า 7-8)</a:t>
             </a:r>
           </a:p>
           <a:p>
@@ -3322,7 +3322,7 @@
               </a:defRPr>
             </a:pPr>
             <a:r>
-              <a:t>1. ตารางต้นทุนฮาร์ดแวร์และอุปกรณ์ต่อชุด (BOM per Unit)</a:t>
+              <a:t>1. ภาพรวมโครงการและข้อกำหนดทางเทคนิค 4 พารามิเตอร์</a:t>
             </a:r>
           </a:p>
         </p:txBody>
@@ -3336,7 +3336,7 @@
         <p:spPr>
           <a:xfrm>
             <a:off x="731520" y="1463040"/>
-            <a:ext cx="2468880" cy="3291840"/>
+            <a:ext cx="2468880" cy="4754880"/>
           </a:xfrm>
           <a:prstGeom prst="roundRect">
             <a:avLst/>
@@ -3423,8 +3423,8 @@
         </p:nvSpPr>
         <p:spPr>
           <a:xfrm>
-            <a:off x="841248" y="1536192"/>
-            <a:ext cx="2249424" cy="960120"/>
+            <a:off x="841248" y="1554480"/>
+            <a:ext cx="2249424" cy="914400"/>
           </a:xfrm>
           <a:prstGeom prst="rect">
             <a:avLst/>
@@ -3438,26 +3438,26 @@
           <a:lstStyle/>
           <a:p>
             <a:pPr>
-              <a:defRPr sz="1000" b="1">
+              <a:defRPr sz="950" b="1">
                 <a:solidFill>
                   <a:srgbClr val="FFFFFF"/>
                 </a:solidFill>
               </a:defRPr>
             </a:pPr>
             <a:r>
-              <a:t>ชุดเซนเซอร์หลัก (Modela One + pH/TDS/Temp + คลอรีน Cybertice)</a:t>
-            </a:r>
-          </a:p>
-          <a:p>
-            <a:pPr>
-              <a:defRPr sz="1500" b="1">
+              <a:t>พารามิเตอร์ #1</a:t>
+            </a:r>
+          </a:p>
+          <a:p>
+            <a:pPr>
+              <a:defRPr sz="1200" b="1">
                 <a:solidFill>
                   <a:srgbClr val="FFFFFF"/>
                 </a:solidFill>
               </a:defRPr>
             </a:pPr>
             <a:r>
-              <a:t>฿17,000</a:t>
+              <a:t>ความเป็นกรด-ด่าง (pH)</a:t>
             </a:r>
           </a:p>
         </p:txBody>
@@ -3470,8 +3470,8 @@
         </p:nvSpPr>
         <p:spPr>
           <a:xfrm>
-            <a:off x="841248" y="2651760"/>
-            <a:ext cx="2249424" cy="2011680"/>
+            <a:off x="868680" y="2743200"/>
+            <a:ext cx="2194560" cy="3200400"/>
           </a:xfrm>
           <a:prstGeom prst="rect">
             <a:avLst/>
@@ -3485,30 +3485,36 @@
           <a:lstStyle/>
           <a:p>
             <a:pPr>
-              <a:defRPr sz="880">
-                <a:solidFill>
-                  <a:srgbClr val="64748B"/>
-                </a:solidFill>
-              </a:defRPr>
-            </a:pPr>
-            <a:r>
-              <a:t>• บอร์ดควบคุมหลัก Modela One (Modbus RTU/RS-485)</a:t>
+              <a:defRPr sz="1000">
+                <a:solidFill>
+                  <a:srgbClr val="0F172A"/>
+                </a:solidFill>
+              </a:defRPr>
+            </a:pPr>
+            <a:r>
+              <a:t>• ช่วงการวัด (Range):</a:t>
             </a:r>
             <a:br/>
             <a:r>
-              <a:t>• หัววัด pH แก้วอุตสาหกรรม (±0.01 pH)</a:t>
+              <a:t>  0.00 – 14.00 pH</a:t>
             </a:r>
             <a:br/>
-            <a:r>
-              <a:t>• หัววัด TDS / EC Titanium Dual-Pole</a:t>
-            </a:r>
             <a:br/>
             <a:r>
-              <a:t>• หัววัดอุณหภูมิ PT1000 (พร้อม ATC ชดเชยอุณหภูมิ)</a:t>
+              <a:t>• ความแม่นยำ (Accuracy):</a:t>
             </a:r>
             <a:br/>
             <a:r>
-              <a:t>• เซนเซอร์คลอรีนคงเหลือ Cybertice (Residual Chlorine)</a:t>
+              <a:t>  ±0.01 pH</a:t>
+            </a:r>
+            <a:br/>
+            <a:br/>
+            <a:r>
+              <a:t>• เทคโนโลยีเซนเซอร์:</a:t>
+            </a:r>
+            <a:br/>
+            <a:r>
+              <a:t>  Industrial Glass Electrode Probe</a:t>
             </a:r>
           </a:p>
         </p:txBody>
@@ -3522,7 +3528,7 @@
         <p:spPr>
           <a:xfrm>
             <a:off x="3474720" y="1463040"/>
-            <a:ext cx="2468880" cy="3291840"/>
+            <a:ext cx="2468880" cy="4754880"/>
           </a:xfrm>
           <a:prstGeom prst="roundRect">
             <a:avLst/>
@@ -3609,8 +3615,8 @@
         </p:nvSpPr>
         <p:spPr>
           <a:xfrm>
-            <a:off x="3584448" y="1536192"/>
-            <a:ext cx="2249424" cy="960120"/>
+            <a:off x="3584448" y="1554480"/>
+            <a:ext cx="2249424" cy="914400"/>
           </a:xfrm>
           <a:prstGeom prst="rect">
             <a:avLst/>
@@ -3624,26 +3630,26 @@
           <a:lstStyle/>
           <a:p>
             <a:pPr>
-              <a:defRPr sz="1000" b="1">
+              <a:defRPr sz="950" b="1">
                 <a:solidFill>
                   <a:srgbClr val="FFFFFF"/>
                 </a:solidFill>
               </a:defRPr>
             </a:pPr>
             <a:r>
-              <a:t>4G LTE Router (TP-Link TL-MR100)</a:t>
-            </a:r>
-          </a:p>
-          <a:p>
-            <a:pPr>
-              <a:defRPr sz="1500" b="1">
+              <a:t>พารามิเตอร์ #2</a:t>
+            </a:r>
+          </a:p>
+          <a:p>
+            <a:pPr>
+              <a:defRPr sz="1200" b="1">
                 <a:solidFill>
                   <a:srgbClr val="FFFFFF"/>
                 </a:solidFill>
               </a:defRPr>
             </a:pPr>
             <a:r>
-              <a:t>฿1,000</a:t>
+              <a:t>สารละลายรวม (TDS)</a:t>
             </a:r>
           </a:p>
         </p:txBody>
@@ -3656,8 +3662,8 @@
         </p:nvSpPr>
         <p:spPr>
           <a:xfrm>
-            <a:off x="3584448" y="2651760"/>
-            <a:ext cx="2249424" cy="2011680"/>
+            <a:off x="3611880" y="2743200"/>
+            <a:ext cx="2194560" cy="3200400"/>
           </a:xfrm>
           <a:prstGeom prst="rect">
             <a:avLst/>
@@ -3671,22 +3677,36 @@
           <a:lstStyle/>
           <a:p>
             <a:pPr>
-              <a:defRPr sz="880">
-                <a:solidFill>
-                  <a:srgbClr val="64748B"/>
-                </a:solidFill>
-              </a:defRPr>
-            </a:pPr>
-            <a:r>
-              <a:t>• เราเตอร์ 4G LTE Wi-Fi ความเร็ว 300 Mbps</a:t>
+              <a:defRPr sz="1000">
+                <a:solidFill>
+                  <a:srgbClr val="0F172A"/>
+                </a:solidFill>
+              </a:defRPr>
+            </a:pPr>
+            <a:r>
+              <a:t>• ช่วงการวัด (Range):</a:t>
             </a:r>
             <a:br/>
             <a:r>
-              <a:t>• เสารับสัญญาณภายนอก 2 เสา สัญญาณนิ่งเสถียร</a:t>
+              <a:t>  0 – 2,000 ppm</a:t>
             </a:r>
             <a:br/>
-            <a:r>
-              <a:t>• เชื่อมต่อระบบ Telemetry สดทุก 1 วินาที</a:t>
+            <a:br/>
+            <a:r>
+              <a:t>• ความแม่นยำ (Accuracy):</a:t>
+            </a:r>
+            <a:br/>
+            <a:r>
+              <a:t>  ±1.5% F.S.</a:t>
+            </a:r>
+            <a:br/>
+            <a:br/>
+            <a:r>
+              <a:t>• เทคโนโลยีเซนเซอร์:</a:t>
+            </a:r>
+            <a:br/>
+            <a:r>
+              <a:t>  Titanium Dual-Pole Sensor</a:t>
             </a:r>
           </a:p>
         </p:txBody>
@@ -3700,7 +3720,7 @@
         <p:spPr>
           <a:xfrm>
             <a:off x="6217920" y="1463040"/>
-            <a:ext cx="2468880" cy="3291840"/>
+            <a:ext cx="2468880" cy="4754880"/>
           </a:xfrm>
           <a:prstGeom prst="roundRect">
             <a:avLst/>
@@ -3787,8 +3807,8 @@
         </p:nvSpPr>
         <p:spPr>
           <a:xfrm>
-            <a:off x="6327648" y="1536192"/>
-            <a:ext cx="2249424" cy="960120"/>
+            <a:off x="6327648" y="1554480"/>
+            <a:ext cx="2249424" cy="914400"/>
           </a:xfrm>
           <a:prstGeom prst="rect">
             <a:avLst/>
@@ -3802,26 +3822,26 @@
           <a:lstStyle/>
           <a:p>
             <a:pPr>
-              <a:defRPr sz="1000" b="1">
+              <a:defRPr sz="950" b="1">
                 <a:solidFill>
                   <a:srgbClr val="FFFFFF"/>
                 </a:solidFill>
               </a:defRPr>
             </a:pPr>
             <a:r>
-              <a:t>ซิมการ์ด 4G รายปี (Unlimited 15-20 Mbps)</a:t>
-            </a:r>
-          </a:p>
-          <a:p>
-            <a:pPr>
-              <a:defRPr sz="1500" b="1">
+              <a:t>พารามิเตอร์ #3</a:t>
+            </a:r>
+          </a:p>
+          <a:p>
+            <a:pPr>
+              <a:defRPr sz="1200" b="1">
                 <a:solidFill>
                   <a:srgbClr val="FFFFFF"/>
                 </a:solidFill>
               </a:defRPr>
             </a:pPr>
             <a:r>
-              <a:t>฿1,800</a:t>
+              <a:t>อุณหภูมิน้ำ (Water Temp)</a:t>
             </a:r>
           </a:p>
         </p:txBody>
@@ -3834,8 +3854,8 @@
         </p:nvSpPr>
         <p:spPr>
           <a:xfrm>
-            <a:off x="6327648" y="2651760"/>
-            <a:ext cx="2249424" cy="2011680"/>
+            <a:off x="6355080" y="2743200"/>
+            <a:ext cx="2194560" cy="3200400"/>
           </a:xfrm>
           <a:prstGeom prst="rect">
             <a:avLst/>
@@ -3849,22 +3869,36 @@
           <a:lstStyle/>
           <a:p>
             <a:pPr>
-              <a:defRPr sz="880">
-                <a:solidFill>
-                  <a:srgbClr val="64748B"/>
-                </a:solidFill>
-              </a:defRPr>
-            </a:pPr>
-            <a:r>
-              <a:t>• ซิมเน็ต IoT รายปี ไม่อั้น ไม่ลดสปีด (15-20 Mbps)</a:t>
+              <a:defRPr sz="1000">
+                <a:solidFill>
+                  <a:srgbClr val="0F172A"/>
+                </a:solidFill>
+              </a:defRPr>
+            </a:pPr>
+            <a:r>
+              <a:t>• ช่วงการวัด (Range):</a:t>
             </a:r>
             <a:br/>
             <a:r>
-              <a:t>• รวมค่าบริการเครือข่าย 12 เดือนเต็ม</a:t>
+              <a:t>  -10.0 – 80.0 °C</a:t>
             </a:r>
             <a:br/>
-            <a:r>
-              <a:t>• ส่งข้อมูลขึ้นระบบคลาวด์และแจ้งเตือน 24 ชม.</a:t>
+            <a:br/>
+            <a:r>
+              <a:t>• ความแม่นยำ (Accuracy):</a:t>
+            </a:r>
+            <a:br/>
+            <a:r>
+              <a:t>  ±0.2 °C</a:t>
+            </a:r>
+            <a:br/>
+            <a:br/>
+            <a:r>
+              <a:t>• เทคโนโลยีเซนเซอร์:</a:t>
+            </a:r>
+            <a:br/>
+            <a:r>
+              <a:t>  PT1000 RTD พร้อมระบบ ATC</a:t>
             </a:r>
           </a:p>
         </p:txBody>
@@ -3878,7 +3912,7 @@
         <p:spPr>
           <a:xfrm>
             <a:off x="8961120" y="1463040"/>
-            <a:ext cx="2468880" cy="3291840"/>
+            <a:ext cx="2468880" cy="4754880"/>
           </a:xfrm>
           <a:prstGeom prst="roundRect">
             <a:avLst/>
@@ -3965,8 +3999,8 @@
         </p:nvSpPr>
         <p:spPr>
           <a:xfrm>
-            <a:off x="9070848" y="1536192"/>
-            <a:ext cx="2249424" cy="960120"/>
+            <a:off x="9070848" y="1554480"/>
+            <a:ext cx="2249424" cy="914400"/>
           </a:xfrm>
           <a:prstGeom prst="rect">
             <a:avLst/>
@@ -3980,26 +4014,26 @@
           <a:lstStyle/>
           <a:p>
             <a:pPr>
-              <a:defRPr sz="1000" b="1">
+              <a:defRPr sz="950" b="1">
                 <a:solidFill>
                   <a:srgbClr val="FFFFFF"/>
                 </a:solidFill>
               </a:defRPr>
             </a:pPr>
             <a:r>
-              <a:t>ตู้คอนโทรล IP65 + Switching 24V + Breaker + Wiring</a:t>
-            </a:r>
-          </a:p>
-          <a:p>
-            <a:pPr>
-              <a:defRPr sz="1500" b="1">
+              <a:t>พารามิเตอร์ #4</a:t>
+            </a:r>
+          </a:p>
+          <a:p>
+            <a:pPr>
+              <a:defRPr sz="1200" b="1">
                 <a:solidFill>
                   <a:srgbClr val="FFFFFF"/>
                 </a:solidFill>
               </a:defRPr>
             </a:pPr>
             <a:r>
-              <a:t>฿1,200</a:t>
+              <a:t>คลอรีนคงเหลือ (Residual Cl)</a:t>
             </a:r>
           </a:p>
         </p:txBody>
@@ -4012,8 +4046,8 @@
         </p:nvSpPr>
         <p:spPr>
           <a:xfrm>
-            <a:off x="9070848" y="2651760"/>
-            <a:ext cx="2249424" cy="2011680"/>
+            <a:off x="9098280" y="2743200"/>
+            <a:ext cx="2194560" cy="3200400"/>
           </a:xfrm>
           <a:prstGeom prst="rect">
             <a:avLst/>
@@ -4027,117 +4061,36 @@
           <a:lstStyle/>
           <a:p>
             <a:pPr>
-              <a:defRPr sz="880">
-                <a:solidFill>
-                  <a:srgbClr val="64748B"/>
-                </a:solidFill>
-              </a:defRPr>
-            </a:pPr>
-            <a:r>
-              <a:t>• ตู้กันน้ำกันฝุ่นมาตรฐาน IP65</a:t>
+              <a:defRPr sz="1000">
+                <a:solidFill>
+                  <a:srgbClr val="0F172A"/>
+                </a:solidFill>
+              </a:defRPr>
+            </a:pPr>
+            <a:r>
+              <a:t>• ช่วงการวัด (Range):</a:t>
             </a:r>
             <a:br/>
             <a:r>
-              <a:t>• แหล่งจ่ายไฟ Switching Power Supply 24V</a:t>
+              <a:t>  0.00 – 5.00 mg/L</a:t>
             </a:r>
             <a:br/>
-            <a:r>
-              <a:t>• Breaker ป้องกันไฟเกิน + Terminal + สายไฟประกอบครบ</a:t>
-            </a:r>
-          </a:p>
-        </p:txBody>
-      </p:sp>
-      <p:sp>
-        <p:nvSpPr>
-          <p:cNvPr id="19" name="Rounded Rectangle 18"/>
-          <p:cNvSpPr/>
-          <p:nvPr/>
-        </p:nvSpPr>
-        <p:spPr>
-          <a:xfrm>
-            <a:off x="731520" y="4937760"/>
-            <a:ext cx="10728655" cy="1371600"/>
-          </a:xfrm>
-          <a:prstGeom prst="roundRect">
-            <a:avLst/>
-          </a:prstGeom>
-          <a:solidFill>
-            <a:srgbClr val="0F172A"/>
-          </a:solidFill>
-          <a:ln w="19050">
-            <a:solidFill>
-              <a:srgbClr val="0284C7"/>
-            </a:solidFill>
-          </a:ln>
-        </p:spPr>
-        <p:style>
-          <a:lnRef idx="1">
-            <a:schemeClr val="accent1"/>
-          </a:lnRef>
-          <a:fillRef idx="3">
-            <a:schemeClr val="accent1"/>
-          </a:fillRef>
-          <a:effectRef idx="2">
-            <a:schemeClr val="accent1"/>
-          </a:effectRef>
-          <a:fontRef idx="minor">
-            <a:schemeClr val="lt1"/>
-          </a:fontRef>
-        </p:style>
-        <p:txBody>
-          <a:bodyPr rtlCol="0" anchor="ctr"/>
-          <a:lstStyle/>
-          <a:p>
-            <a:pPr algn="ctr"/>
-          </a:p>
-        </p:txBody>
-      </p:sp>
-      <p:sp>
-        <p:nvSpPr>
-          <p:cNvPr id="20" name="TextBox 19"/>
-          <p:cNvSpPr txBox="1"/>
-          <p:nvPr/>
-        </p:nvSpPr>
-        <p:spPr>
-          <a:xfrm>
-            <a:off x="1005840" y="5074920"/>
-            <a:ext cx="10149840" cy="1097280"/>
-          </a:xfrm>
-          <a:prstGeom prst="rect">
-            <a:avLst/>
-          </a:prstGeom>
-          <a:noFill/>
-        </p:spPr>
-        <p:txBody>
-          <a:bodyPr wrap="square">
-            <a:spAutoFit/>
-          </a:bodyPr>
-          <a:lstStyle/>
-          <a:p>
-            <a:pPr>
-              <a:spcAft>
-                <a:spcPts val="400"/>
-              </a:spcAft>
-              <a:defRPr sz="1600" b="1">
-                <a:solidFill>
-                  <a:srgbClr val="2DD4BF"/>
-                </a:solidFill>
-              </a:defRPr>
-            </a:pPr>
-            <a:r>
-              <a:t>➡️ รวมต้นทุนต่อชุด: ฿21,000 บาท  |  รวมต้นทุนโครงการ (100 ชุด): ฿2,100,000 บาท</a:t>
-            </a:r>
-          </a:p>
-          <a:p>
-            <a:pPr>
-              <a:defRPr sz="1000">
-                <a:solidFill>
-                  <a:srgbClr val="E2E8F0"/>
-                </a:solidFill>
-              </a:defRPr>
-            </a:pPr>
-            <a:r>
-              <a:t>ต้นทุนนี้ครอบคลุมชุดหัววัดเซนเซอร์ 4 ค่า (pH / TDS / Temp / Cl) + กล่อง Modela One + เราเตอร์ 4G TP-Link + ซิมรายปี + ตู้ IP65 ประกอบสำเร็จพร้อมใช้งาน</a:t>
+            <a:br/>
+            <a:r>
+              <a:t>• ความแม่นยำ (Accuracy):</a:t>
+            </a:r>
+            <a:br/>
+            <a:r>
+              <a:t>  ±0.02 mg/L</a:t>
+            </a:r>
+            <a:br/>
+            <a:br/>
+            <a:r>
+              <a:t>• เทคโนโลยีเซนเซอร์:</a:t>
+            </a:r>
+            <a:br/>
+            <a:r>
+              <a:t>  Amperometric Membrane Sensor</a:t>
             </a:r>
           </a:p>
         </p:txBody>
@@ -4213,21 +4166,45 @@
               </a:defRPr>
             </a:pPr>
             <a:r>
-              <a:t>2. โครงสร้างราคาขายแนะนำ (แพ็กเกจ 100 ชุด รวม App + Web Dashboard)</a:t>
-            </a:r>
-          </a:p>
-        </p:txBody>
-      </p:sp>
-      <p:sp>
-        <p:nvSpPr>
-          <p:cNvPr id="3" name="Rounded Rectangle 2"/>
+              <a:t>2. ตัวอย่างหน้าจอ Centralized Web SCADA Dashboard (จอห้องควบคุม 100 จุด)</a:t>
+            </a:r>
+          </a:p>
+        </p:txBody>
+      </p:sp>
+      <p:pic>
+        <p:nvPicPr>
+          <p:cNvPr id="3" name="Picture 2" descr="scada_hd_preview.png"/>
+          <p:cNvPicPr>
+            <a:picLocks noChangeAspect="1"/>
+          </p:cNvPicPr>
+          <p:nvPr/>
+        </p:nvPicPr>
+        <p:blipFill>
+          <a:blip r:embed="rId2"/>
+          <a:stretch>
+            <a:fillRect/>
+          </a:stretch>
+        </p:blipFill>
+        <p:spPr>
+          <a:xfrm>
+            <a:off x="731520" y="1463040"/>
+            <a:ext cx="6217920" cy="4754880"/>
+          </a:xfrm>
+          <a:prstGeom prst="rect">
+            <a:avLst/>
+          </a:prstGeom>
+        </p:spPr>
+      </p:pic>
+      <p:sp>
+        <p:nvSpPr>
+          <p:cNvPr id="4" name="Rounded Rectangle 3"/>
           <p:cNvSpPr/>
           <p:nvPr/>
         </p:nvSpPr>
         <p:spPr>
           <a:xfrm>
-            <a:off x="731520" y="1463040"/>
-            <a:ext cx="5120640" cy="4754880"/>
+            <a:off x="7132320" y="1463040"/>
+            <a:ext cx="4327855" cy="4754880"/>
           </a:xfrm>
           <a:prstGeom prst="roundRect">
             <a:avLst/>
@@ -4265,57 +4242,14 @@
       </p:sp>
       <p:sp>
         <p:nvSpPr>
-          <p:cNvPr id="4" name="Rounded Rectangle 3"/>
-          <p:cNvSpPr/>
-          <p:nvPr/>
-        </p:nvSpPr>
-        <p:spPr>
-          <a:xfrm>
-            <a:off x="731520" y="1463040"/>
-            <a:ext cx="5120640" cy="1188720"/>
-          </a:xfrm>
-          <a:prstGeom prst="roundRect">
-            <a:avLst/>
-          </a:prstGeom>
-          <a:solidFill>
-            <a:srgbClr val="0284C7"/>
-          </a:solidFill>
-          <a:ln>
-            <a:noFill/>
-          </a:ln>
-        </p:spPr>
-        <p:style>
-          <a:lnRef idx="1">
-            <a:schemeClr val="accent1"/>
-          </a:lnRef>
-          <a:fillRef idx="3">
-            <a:schemeClr val="accent1"/>
-          </a:fillRef>
-          <a:effectRef idx="2">
-            <a:schemeClr val="accent1"/>
-          </a:effectRef>
-          <a:fontRef idx="minor">
-            <a:schemeClr val="lt1"/>
-          </a:fontRef>
-        </p:style>
-        <p:txBody>
-          <a:bodyPr rtlCol="0" anchor="ctr"/>
-          <a:lstStyle/>
-          <a:p>
-            <a:pPr algn="ctr"/>
-          </a:p>
-        </p:txBody>
-      </p:sp>
-      <p:sp>
-        <p:nvSpPr>
           <p:cNvPr id="5" name="TextBox 4"/>
           <p:cNvSpPr txBox="1"/>
           <p:nvPr/>
         </p:nvSpPr>
         <p:spPr>
           <a:xfrm>
-            <a:off x="914400" y="1554480"/>
-            <a:ext cx="4754880" cy="1005840"/>
+            <a:off x="7315200" y="1600200"/>
+            <a:ext cx="3962095" cy="4480560"/>
           </a:xfrm>
           <a:prstGeom prst="rect">
             <a:avLst/>
@@ -4329,425 +4263,107 @@
           <a:lstStyle/>
           <a:p>
             <a:pPr>
+              <a:spcAft>
+                <a:spcPts val="800"/>
+              </a:spcAft>
               <a:defRPr sz="1300" b="1">
                 <a:solidFill>
-                  <a:srgbClr val="FFFFFF"/>
-                </a:solidFill>
-              </a:defRPr>
-            </a:pPr>
-            <a:r>
-              <a:t>[แบบที่ 1] ส่งมอบอุปกรณ์พร้อมระบบออนไลน์</a:t>
-            </a:r>
-          </a:p>
-          <a:p>
-            <a:pPr>
-              <a:defRPr sz="1100" b="1">
-                <a:solidFill>
-                  <a:srgbClr val="FFFFFF"/>
-                </a:solidFill>
-              </a:defRPr>
-            </a:pPr>
-            <a:r>
-              <a:t>Plug &amp; Play / Supply Only (ราคา ฿29,500 - ฿32,000 / ชุด)</a:t>
-            </a:r>
-          </a:p>
-        </p:txBody>
-      </p:sp>
-      <p:sp>
-        <p:nvSpPr>
-          <p:cNvPr id="6" name="TextBox 5"/>
-          <p:cNvSpPr txBox="1"/>
-          <p:nvPr/>
-        </p:nvSpPr>
-        <p:spPr>
-          <a:xfrm>
-            <a:off x="914400" y="2743200"/>
-            <a:ext cx="4754880" cy="3383280"/>
-          </a:xfrm>
-          <a:prstGeom prst="rect">
-            <a:avLst/>
-          </a:prstGeom>
-          <a:noFill/>
-        </p:spPr>
-        <p:txBody>
-          <a:bodyPr wrap="square">
-            <a:spAutoFit/>
-          </a:bodyPr>
-          <a:lstStyle/>
+                  <a:srgbClr val="0284C7"/>
+                </a:solidFill>
+              </a:defRPr>
+            </a:pPr>
+            <a:r>
+              <a:t>💻 คำอธิบายฟังก์ชันหน้าจอ SCADA:</a:t>
+            </a:r>
+          </a:p>
           <a:p>
             <a:pPr>
               <a:spcAft>
-                <a:spcPts val="400"/>
-              </a:spcAft>
-              <a:defRPr b="1" sz="1100">
-                <a:solidFill>
-                  <a:srgbClr val="0F172A"/>
-                </a:solidFill>
-              </a:defRPr>
-            </a:pPr>
-            <a:r>
-              <a:t>📋 ขอบเขตงาน (Scope of Work):</a:t>
-            </a:r>
-          </a:p>
-          <a:p>
-            <a:pPr>
-              <a:spcAft>
-                <a:spcPts val="200"/>
+                <a:spcPts val="300"/>
               </a:spcAft>
               <a:defRPr sz="950">
                 <a:solidFill>
-                  <a:srgbClr val="64748B"/>
-                </a:solidFill>
-              </a:defRPr>
-            </a:pPr>
-            <a:r>
-              <a:t>✔ ประกอบตู้คอนโทรลสำเร็จรูป พร้อมเดินระบบไฟภายใน</a:t>
+                  <a:srgbClr val="0F172A"/>
+                </a:solidFill>
+              </a:defRPr>
+            </a:pPr>
+            <a:r>
+              <a:t>❶ สถานะระบบ &amp; แบตเตอรี่: แสดงสถานะ Healthy, สัญญาณ 4G/WiFi และแบต LiFePO4 (90%)</a:t>
             </a:r>
           </a:p>
           <a:p>
             <a:pPr>
               <a:spcAft>
-                <a:spcPts val="200"/>
+                <a:spcPts val="300"/>
               </a:spcAft>
               <a:defRPr sz="950">
                 <a:solidFill>
-                  <a:srgbClr val="64748B"/>
-                </a:solidFill>
-              </a:defRPr>
-            </a:pPr>
-            <a:r>
-              <a:t>✔ ใส่ซิมรายปีและตั้งค่าเชื่อมต่อเน็ตเวิร์ก 4G LTE</a:t>
+                  <a:srgbClr val="0F172A"/>
+                </a:solidFill>
+              </a:defRPr>
+            </a:pPr>
+            <a:r>
+              <a:t>❷ การ์ดตรวจวัด 4 ค่าหลัก: อุณหภูมิน้ำ (ATC), pH (Glass Probe), TDS (ppm), Cl (mg/L)</a:t>
             </a:r>
           </a:p>
           <a:p>
             <a:pPr>
               <a:spcAft>
-                <a:spcPts val="200"/>
+                <a:spcPts val="300"/>
               </a:spcAft>
               <a:defRPr sz="950">
                 <a:solidFill>
-                  <a:srgbClr val="64748B"/>
-                </a:solidFill>
-              </a:defRPr>
-            </a:pPr>
-            <a:r>
-              <a:t>✔ เชื่อมต่อ Modbus อ่านค่า pH, TDS, Temp, Chlorine</a:t>
+                  <a:srgbClr val="0F172A"/>
+                </a:solidFill>
+              </a:defRPr>
+            </a:pPr>
+            <a:r>
+              <a:t>❸ กราฟแนวโน้ม Real-Time: พล็อตข้อมูลสด 1 วินาที ติดตามค่าน้ำ 24 ชม. พร้อมซูมดูย้อนหลัง</a:t>
             </a:r>
           </a:p>
           <a:p>
             <a:pPr>
               <a:spcAft>
-                <a:spcPts val="200"/>
+                <a:spcPts val="300"/>
               </a:spcAft>
               <a:defRPr sz="950">
                 <a:solidFill>
-                  <a:srgbClr val="64748B"/>
-                </a:solidFill>
-              </a:defRPr>
-            </a:pPr>
-            <a:r>
-              <a:t>✔ ตั้งค่าระบบ Modela App สำหรับดูข้อมูลและแจ้งเตือนผ่านมือถือ</a:t>
+                  <a:srgbClr val="0F172A"/>
+                </a:solidFill>
+              </a:defRPr>
+            </a:pPr>
+            <a:r>
+              <a:t>❹ ไดอะแกรมเชื่อมต่อ: ตรวจจับสายสัญญาณ WiFi ➔ Display ➔ Sensor Probes</a:t>
             </a:r>
           </a:p>
           <a:p>
             <a:pPr>
               <a:spcAft>
-                <a:spcPts val="200"/>
+                <a:spcPts val="300"/>
               </a:spcAft>
               <a:defRPr sz="950">
                 <a:solidFill>
-                  <a:srgbClr val="64748B"/>
-                </a:solidFill>
-              </a:defRPr>
-            </a:pPr>
-            <a:r>
-              <a:t>✔ จัดทำ Web Dashboard กลางรวมข้อมูลทั้ง 100 จุด</a:t>
-            </a:r>
-          </a:p>
-          <a:p>
-            <a:pPr>
-              <a:spcBef>
-                <a:spcPts val="800"/>
-              </a:spcBef>
-              <a:defRPr b="1" sz="1000">
-                <a:solidFill>
-                  <a:srgbClr val="0284C7"/>
-                </a:solidFill>
-              </a:defRPr>
-            </a:pPr>
-            <a:r>
-              <a:t>💰 มูลค่าโครงการรวม (100 ชุด): ฿2,950,000 - ฿3,200,000 บาท</a:t>
-            </a:r>
-            <a:br/>
-            <a:r>
-              <a:t>📈 กำไรขั้นต้นโดยประมาณ: ฿850,000 - ฿1,100,000 บาท (Margin ~29-34%)</a:t>
-            </a:r>
-          </a:p>
-        </p:txBody>
-      </p:sp>
-      <p:sp>
-        <p:nvSpPr>
-          <p:cNvPr id="7" name="Rounded Rectangle 6"/>
-          <p:cNvSpPr/>
-          <p:nvPr/>
-        </p:nvSpPr>
-        <p:spPr>
-          <a:xfrm>
-            <a:off x="6309360" y="1463040"/>
-            <a:ext cx="5120640" cy="4754880"/>
-          </a:xfrm>
-          <a:prstGeom prst="roundRect">
-            <a:avLst/>
-          </a:prstGeom>
-          <a:solidFill>
-            <a:srgbClr val="FFFFFF"/>
-          </a:solidFill>
-          <a:ln w="19050">
-            <a:solidFill>
-              <a:srgbClr val="059669"/>
-            </a:solidFill>
-          </a:ln>
-        </p:spPr>
-        <p:style>
-          <a:lnRef idx="1">
-            <a:schemeClr val="accent1"/>
-          </a:lnRef>
-          <a:fillRef idx="3">
-            <a:schemeClr val="accent1"/>
-          </a:fillRef>
-          <a:effectRef idx="2">
-            <a:schemeClr val="accent1"/>
-          </a:effectRef>
-          <a:fontRef idx="minor">
-            <a:schemeClr val="lt1"/>
-          </a:fontRef>
-        </p:style>
-        <p:txBody>
-          <a:bodyPr rtlCol="0" anchor="ctr"/>
-          <a:lstStyle/>
-          <a:p>
-            <a:pPr algn="ctr"/>
-          </a:p>
-        </p:txBody>
-      </p:sp>
-      <p:sp>
-        <p:nvSpPr>
-          <p:cNvPr id="8" name="Rounded Rectangle 7"/>
-          <p:cNvSpPr/>
-          <p:nvPr/>
-        </p:nvSpPr>
-        <p:spPr>
-          <a:xfrm>
-            <a:off x="6309360" y="1463040"/>
-            <a:ext cx="5120640" cy="1188720"/>
-          </a:xfrm>
-          <a:prstGeom prst="roundRect">
-            <a:avLst/>
-          </a:prstGeom>
-          <a:solidFill>
-            <a:srgbClr val="059669"/>
-          </a:solidFill>
-          <a:ln>
-            <a:noFill/>
-          </a:ln>
-        </p:spPr>
-        <p:style>
-          <a:lnRef idx="1">
-            <a:schemeClr val="accent1"/>
-          </a:lnRef>
-          <a:fillRef idx="3">
-            <a:schemeClr val="accent1"/>
-          </a:fillRef>
-          <a:effectRef idx="2">
-            <a:schemeClr val="accent1"/>
-          </a:effectRef>
-          <a:fontRef idx="minor">
-            <a:schemeClr val="lt1"/>
-          </a:fontRef>
-        </p:style>
-        <p:txBody>
-          <a:bodyPr rtlCol="0" anchor="ctr"/>
-          <a:lstStyle/>
-          <a:p>
-            <a:pPr algn="ctr"/>
-          </a:p>
-        </p:txBody>
-      </p:sp>
-      <p:sp>
-        <p:nvSpPr>
-          <p:cNvPr id="9" name="TextBox 8"/>
-          <p:cNvSpPr txBox="1"/>
-          <p:nvPr/>
-        </p:nvSpPr>
-        <p:spPr>
-          <a:xfrm>
-            <a:off x="6492240" y="1554480"/>
-            <a:ext cx="4754880" cy="1005840"/>
-          </a:xfrm>
-          <a:prstGeom prst="rect">
-            <a:avLst/>
-          </a:prstGeom>
-          <a:noFill/>
-        </p:spPr>
-        <p:txBody>
-          <a:bodyPr wrap="square">
-            <a:spAutoFit/>
-          </a:bodyPr>
-          <a:lstStyle/>
-          <a:p>
-            <a:pPr>
-              <a:defRPr sz="1300" b="1">
-                <a:solidFill>
-                  <a:srgbClr val="FFFFFF"/>
-                </a:solidFill>
-              </a:defRPr>
-            </a:pPr>
-            <a:r>
-              <a:t>[แบบที่ 2] แบบครบวงจร รวมติดตั้งหน้างาน + สอบเทียบ</a:t>
-            </a:r>
-          </a:p>
-          <a:p>
-            <a:pPr>
-              <a:defRPr sz="1100" b="1">
-                <a:solidFill>
-                  <a:srgbClr val="FFFFFF"/>
-                </a:solidFill>
-              </a:defRPr>
-            </a:pPr>
-            <a:r>
-              <a:t>Turnkey Solution (ราคา ฿38,000 - ฿42,000 / ชุด)</a:t>
-            </a:r>
-          </a:p>
-        </p:txBody>
-      </p:sp>
-      <p:sp>
-        <p:nvSpPr>
-          <p:cNvPr id="10" name="TextBox 9"/>
-          <p:cNvSpPr txBox="1"/>
-          <p:nvPr/>
-        </p:nvSpPr>
-        <p:spPr>
-          <a:xfrm>
-            <a:off x="6492240" y="2743200"/>
-            <a:ext cx="4754880" cy="3383280"/>
-          </a:xfrm>
-          <a:prstGeom prst="rect">
-            <a:avLst/>
-          </a:prstGeom>
-          <a:noFill/>
-        </p:spPr>
-        <p:txBody>
-          <a:bodyPr wrap="square">
-            <a:spAutoFit/>
-          </a:bodyPr>
-          <a:lstStyle/>
+                  <a:srgbClr val="0F172A"/>
+                </a:solidFill>
+              </a:defRPr>
+            </a:pPr>
+            <a:r>
+              <a:t>❺ Digital Calibration: สอบเทียบหัววัด pH 7.00 / 4.01 ผ่านหน้าเว็บในคลิกเดียว</a:t>
+            </a:r>
+          </a:p>
           <a:p>
             <a:pPr>
               <a:spcAft>
-                <a:spcPts val="400"/>
-              </a:spcAft>
-              <a:defRPr b="1" sz="1100">
-                <a:solidFill>
-                  <a:srgbClr val="0F172A"/>
-                </a:solidFill>
-              </a:defRPr>
-            </a:pPr>
-            <a:r>
-              <a:t>📋 ขอบเขตงาน (Scope of Work):</a:t>
-            </a:r>
-          </a:p>
-          <a:p>
-            <a:pPr>
-              <a:spcAft>
-                <a:spcPts val="200"/>
+                <a:spcPts val="300"/>
               </a:spcAft>
               <a:defRPr sz="950">
                 <a:solidFill>
-                  <a:srgbClr val="64748B"/>
-                </a:solidFill>
-              </a:defRPr>
-            </a:pPr>
-            <a:r>
-              <a:t>✔ ทุกอย่างในแบบที่ 1 (ตู้ + ซิม + Modbus + App + Web Dashboard)</a:t>
-            </a:r>
-          </a:p>
-          <a:p>
-            <a:pPr>
-              <a:spcAft>
-                <a:spcPts val="200"/>
-              </a:spcAft>
-              <a:defRPr sz="950">
-                <a:solidFill>
-                  <a:srgbClr val="64748B"/>
-                </a:solidFill>
-              </a:defRPr>
-            </a:pPr>
-            <a:r>
-              <a:t>✔ ค่าแรงและทีมงานเข้าติดตั้งยึดตู้ / เดินท่อบายพาสหน้างาน</a:t>
-            </a:r>
-          </a:p>
-          <a:p>
-            <a:pPr>
-              <a:spcAft>
-                <a:spcPts val="200"/>
-              </a:spcAft>
-              <a:defRPr sz="950">
-                <a:solidFill>
-                  <a:srgbClr val="64748B"/>
-                </a:solidFill>
-              </a:defRPr>
-            </a:pPr>
-            <a:r>
-              <a:t>✔ สอบเทียบ (Calibration) หัววัด pH / TDS ด้วยน้ำยามาตรฐานหน้างาน</a:t>
-            </a:r>
-          </a:p>
-          <a:p>
-            <a:pPr>
-              <a:spcAft>
-                <a:spcPts val="200"/>
-              </a:spcAft>
-              <a:defRPr sz="950">
-                <a:solidFill>
-                  <a:srgbClr val="64748B"/>
-                </a:solidFill>
-              </a:defRPr>
-            </a:pPr>
-            <a:r>
-              <a:t>✔ อบรมการใช้งานระบบและส่งมอบคู่มือการปฏิบัติงาน</a:t>
-            </a:r>
-          </a:p>
-          <a:p>
-            <a:pPr>
-              <a:spcAft>
-                <a:spcPts val="200"/>
-              </a:spcAft>
-              <a:defRPr sz="950">
-                <a:solidFill>
-                  <a:srgbClr val="64748B"/>
-                </a:solidFill>
-              </a:defRPr>
-            </a:pPr>
-            <a:r>
-              <a:t>✔ รับประกันระบบและบริการ On-site Service ตลอด 1 ปีเต็ม</a:t>
-            </a:r>
-          </a:p>
-          <a:p>
-            <a:pPr>
-              <a:spcBef>
-                <a:spcPts val="800"/>
-              </a:spcBef>
-              <a:defRPr b="1" sz="1000">
-                <a:solidFill>
-                  <a:srgbClr val="059669"/>
-                </a:solidFill>
-              </a:defRPr>
-            </a:pPr>
-            <a:r>
-              <a:t>💰 มูลค่าโครงการรวม (100 ชุด): ฿3,800,000 - ฿4,200,000 บาท</a:t>
-            </a:r>
-            <a:br/>
-            <a:r>
-              <a:t>📈 กำไรขั้นต้นโดยประมาณ: ฿1,700,000 - ฿2,100,000 บาท (Margin ~45-50%)</a:t>
+                  <a:srgbClr val="0F172A"/>
+                </a:solidFill>
+              </a:defRPr>
+            </a:pPr>
+            <a:r>
+              <a:t>❻ ส่งออกรายงาน: Export ข้อมูลเป็น Excel / PDF สำหรับรายงาน ISO ทันที</a:t>
             </a:r>
           </a:p>
         </p:txBody>
@@ -4823,56 +4439,35 @@
               </a:defRPr>
             </a:pPr>
             <a:r>
-              <a:t>3. ราคาซอฟต์แวร์ Dashboard &amp; ระบบแจ้งเตือน (3 Option ทางเลือก)</a:t>
-            </a:r>
-          </a:p>
-        </p:txBody>
-      </p:sp>
-      <p:sp>
-        <p:nvSpPr>
-          <p:cNvPr id="3" name="Rounded Rectangle 2"/>
-          <p:cNvSpPr/>
+              <a:t>3. ตัวอย่างหน้าจอมือถือ (Modela Mobile Companion App)</a:t>
+            </a:r>
+          </a:p>
+        </p:txBody>
+      </p:sp>
+      <p:pic>
+        <p:nvPicPr>
+          <p:cNvPr id="3" name="Picture 2" descr="mobile_hd_preview.png"/>
+          <p:cNvPicPr>
+            <a:picLocks noChangeAspect="1"/>
+          </p:cNvPicPr>
           <p:nvPr/>
-        </p:nvSpPr>
+        </p:nvPicPr>
+        <p:blipFill>
+          <a:blip r:embed="rId2"/>
+          <a:stretch>
+            <a:fillRect/>
+          </a:stretch>
+        </p:blipFill>
         <p:spPr>
           <a:xfrm>
             <a:off x="731520" y="1463040"/>
-            <a:ext cx="3383280" cy="4754880"/>
-          </a:xfrm>
-          <a:prstGeom prst="roundRect">
+            <a:ext cx="2377440" cy="4754880"/>
+          </a:xfrm>
+          <a:prstGeom prst="rect">
             <a:avLst/>
           </a:prstGeom>
-          <a:solidFill>
-            <a:srgbClr val="FFFFFF"/>
-          </a:solidFill>
-          <a:ln w="19050">
-            <a:solidFill>
-              <a:srgbClr val="0284C7"/>
-            </a:solidFill>
-          </a:ln>
-        </p:spPr>
-        <p:style>
-          <a:lnRef idx="1">
-            <a:schemeClr val="accent1"/>
-          </a:lnRef>
-          <a:fillRef idx="3">
-            <a:schemeClr val="accent1"/>
-          </a:fillRef>
-          <a:effectRef idx="2">
-            <a:schemeClr val="accent1"/>
-          </a:effectRef>
-          <a:fontRef idx="minor">
-            <a:schemeClr val="lt1"/>
-          </a:fontRef>
-        </p:style>
-        <p:txBody>
-          <a:bodyPr rtlCol="0" anchor="ctr"/>
-          <a:lstStyle/>
-          <a:p>
-            <a:pPr algn="ctr"/>
-          </a:p>
-        </p:txBody>
-      </p:sp>
+        </p:spPr>
+      </p:pic>
       <p:sp>
         <p:nvSpPr>
           <p:cNvPr id="4" name="Rounded Rectangle 3"/>
@@ -4881,242 +4476,8 @@
         </p:nvSpPr>
         <p:spPr>
           <a:xfrm>
-            <a:off x="731520" y="1463040"/>
-            <a:ext cx="3383280" cy="1280160"/>
-          </a:xfrm>
-          <a:prstGeom prst="roundRect">
-            <a:avLst/>
-          </a:prstGeom>
-          <a:solidFill>
-            <a:srgbClr val="0284C7"/>
-          </a:solidFill>
-          <a:ln>
-            <a:noFill/>
-          </a:ln>
-        </p:spPr>
-        <p:style>
-          <a:lnRef idx="1">
-            <a:schemeClr val="accent1"/>
-          </a:lnRef>
-          <a:fillRef idx="3">
-            <a:schemeClr val="accent1"/>
-          </a:fillRef>
-          <a:effectRef idx="2">
-            <a:schemeClr val="accent1"/>
-          </a:effectRef>
-          <a:fontRef idx="minor">
-            <a:schemeClr val="lt1"/>
-          </a:fontRef>
-        </p:style>
-        <p:txBody>
-          <a:bodyPr rtlCol="0" anchor="ctr"/>
-          <a:lstStyle/>
-          <a:p>
-            <a:pPr algn="ctr"/>
-          </a:p>
-        </p:txBody>
-      </p:sp>
-      <p:sp>
-        <p:nvSpPr>
-          <p:cNvPr id="5" name="TextBox 4"/>
-          <p:cNvSpPr txBox="1"/>
-          <p:nvPr/>
-        </p:nvSpPr>
-        <p:spPr>
-          <a:xfrm>
-            <a:off x="914400" y="1554480"/>
-            <a:ext cx="3017520" cy="1097280"/>
-          </a:xfrm>
-          <a:prstGeom prst="rect">
-            <a:avLst/>
-          </a:prstGeom>
-          <a:noFill/>
-        </p:spPr>
-        <p:txBody>
-          <a:bodyPr wrap="square">
-            <a:spAutoFit/>
-          </a:bodyPr>
-          <a:lstStyle/>
-          <a:p>
-            <a:pPr>
-              <a:defRPr sz="950" b="1">
-                <a:solidFill>
-                  <a:srgbClr val="FFFFFF"/>
-                </a:solidFill>
-              </a:defRPr>
-            </a:pPr>
-            <a:r>
-              <a:t>[ Option 1 ] ★ แนะนำ คุ้มค่าสูงสุด</a:t>
-            </a:r>
-          </a:p>
-          <a:p>
-            <a:pPr>
-              <a:defRPr sz="1350" b="1">
-                <a:solidFill>
-                  <a:srgbClr val="FFFFFF"/>
-                </a:solidFill>
-              </a:defRPr>
-            </a:pPr>
-            <a:r>
-              <a:t>แอปมือถือ + Telegram</a:t>
-            </a:r>
-          </a:p>
-        </p:txBody>
-      </p:sp>
-      <p:sp>
-        <p:nvSpPr>
-          <p:cNvPr id="6" name="TextBox 5"/>
-          <p:cNvSpPr txBox="1"/>
-          <p:nvPr/>
-        </p:nvSpPr>
-        <p:spPr>
-          <a:xfrm>
-            <a:off x="914400" y="2834640"/>
-            <a:ext cx="3017520" cy="3291840"/>
-          </a:xfrm>
-          <a:prstGeom prst="rect">
-            <a:avLst/>
-          </a:prstGeom>
-          <a:noFill/>
-        </p:spPr>
-        <p:txBody>
-          <a:bodyPr wrap="square">
-            <a:spAutoFit/>
-          </a:bodyPr>
-          <a:lstStyle/>
-          <a:p>
-            <a:pPr>
-              <a:defRPr b="1" sz="1050">
-                <a:solidFill>
-                  <a:srgbClr val="0284C7"/>
-                </a:solidFill>
-              </a:defRPr>
-            </a:pPr>
-            <a:r>
-              <a:t>• แบบซื้อขาด: ฿250,000 (2,500 บ./จุด)</a:t>
-            </a:r>
-          </a:p>
-          <a:p>
-            <a:pPr>
-              <a:spcAft>
-                <a:spcPts val="600"/>
-              </a:spcAft>
-              <a:defRPr b="1" sz="1000">
-                <a:solidFill>
-                  <a:srgbClr val="059669"/>
-                </a:solidFill>
-              </a:defRPr>
-            </a:pPr>
-            <a:r>
-              <a:t>• แบบรายปี: ฿170,000 (ปีแรก)</a:t>
-            </a:r>
-            <a:br/>
-            <a:r>
-              <a:t>  (ปีถัดไป ฿120,000 บ./ปี (1,200 บ./จุด/ปี))</a:t>
-            </a:r>
-          </a:p>
-          <a:p>
-            <a:pPr>
-              <a:spcAft>
-                <a:spcPts val="600"/>
-              </a:spcAft>
-              <a:defRPr sz="900" b="1">
-                <a:solidFill>
-                  <a:srgbClr val="0F172A"/>
-                </a:solidFill>
-              </a:defRPr>
-            </a:pPr>
-            <a:r>
-              <a:t>💡 จุดเด่น: แจ้งเตือนฟรีตลอดชีพ ไม่มีค่าส่งข้อความ</a:t>
-            </a:r>
-          </a:p>
-          <a:p>
-            <a:pPr>
-              <a:spcAft>
-                <a:spcPts val="200"/>
-              </a:spcAft>
-              <a:defRPr sz="880">
-                <a:solidFill>
-                  <a:srgbClr val="64748B"/>
-                </a:solidFill>
-              </a:defRPr>
-            </a:pPr>
-            <a:r>
-              <a:t>✓ Modela App (iOS &amp; Android) สลับดู 100 จุด</a:t>
-            </a:r>
-          </a:p>
-          <a:p>
-            <a:pPr>
-              <a:spcAft>
-                <a:spcPts val="200"/>
-              </a:spcAft>
-              <a:defRPr sz="880">
-                <a:solidFill>
-                  <a:srgbClr val="64748B"/>
-                </a:solidFill>
-              </a:defRPr>
-            </a:pPr>
-            <a:r>
-              <a:t>✓ แจ้งเตือนผ่าน Telegram Bot แบบกลุ่ม/เดี่ยว</a:t>
-            </a:r>
-          </a:p>
-          <a:p>
-            <a:pPr>
-              <a:spcAft>
-                <a:spcPts val="200"/>
-              </a:spcAft>
-              <a:defRPr sz="880">
-                <a:solidFill>
-                  <a:srgbClr val="64748B"/>
-                </a:solidFill>
-              </a:defRPr>
-            </a:pPr>
-            <a:r>
-              <a:t>✓ ส่งข้อความเตือนฟรี 100% ไม่จำกัดจำนวนครั้ง</a:t>
-            </a:r>
-          </a:p>
-          <a:p>
-            <a:pPr>
-              <a:spcAft>
-                <a:spcPts val="200"/>
-              </a:spcAft>
-              <a:defRPr sz="880">
-                <a:solidFill>
-                  <a:srgbClr val="64748B"/>
-                </a:solidFill>
-              </a:defRPr>
-            </a:pPr>
-            <a:r>
-              <a:t>✓ ไม่มีต้นทุนแฝง กำไรเต็มเม็ดเต็มหน่วย</a:t>
-            </a:r>
-          </a:p>
-          <a:p>
-            <a:pPr>
-              <a:spcAft>
-                <a:spcPts val="200"/>
-              </a:spcAft>
-              <a:defRPr sz="880">
-                <a:solidFill>
-                  <a:srgbClr val="64748B"/>
-                </a:solidFill>
-              </a:defRPr>
-            </a:pPr>
-            <a:r>
-              <a:t>✓ ฟรี Support / แก้บั๊ก 1 ปีแรก</a:t>
-            </a:r>
-          </a:p>
-        </p:txBody>
-      </p:sp>
-      <p:sp>
-        <p:nvSpPr>
-          <p:cNvPr id="7" name="Rounded Rectangle 6"/>
-          <p:cNvSpPr/>
-          <p:nvPr/>
-        </p:nvSpPr>
-        <p:spPr>
-          <a:xfrm>
-            <a:off x="4389120" y="1463040"/>
-            <a:ext cx="3383280" cy="4754880"/>
+            <a:off x="3383280" y="1463040"/>
+            <a:ext cx="8076895" cy="4754880"/>
           </a:xfrm>
           <a:prstGeom prst="roundRect">
             <a:avLst/>
@@ -5154,57 +4515,14 @@
       </p:sp>
       <p:sp>
         <p:nvSpPr>
-          <p:cNvPr id="8" name="Rounded Rectangle 7"/>
-          <p:cNvSpPr/>
-          <p:nvPr/>
-        </p:nvSpPr>
-        <p:spPr>
-          <a:xfrm>
-            <a:off x="4389120" y="1463040"/>
-            <a:ext cx="3383280" cy="1280160"/>
-          </a:xfrm>
-          <a:prstGeom prst="roundRect">
-            <a:avLst/>
-          </a:prstGeom>
-          <a:solidFill>
-            <a:srgbClr val="059669"/>
-          </a:solidFill>
-          <a:ln>
-            <a:noFill/>
-          </a:ln>
-        </p:spPr>
-        <p:style>
-          <a:lnRef idx="1">
-            <a:schemeClr val="accent1"/>
-          </a:lnRef>
-          <a:fillRef idx="3">
-            <a:schemeClr val="accent1"/>
-          </a:fillRef>
-          <a:effectRef idx="2">
-            <a:schemeClr val="accent1"/>
-          </a:effectRef>
-          <a:fontRef idx="minor">
-            <a:schemeClr val="lt1"/>
-          </a:fontRef>
-        </p:style>
-        <p:txBody>
-          <a:bodyPr rtlCol="0" anchor="ctr"/>
-          <a:lstStyle/>
-          <a:p>
-            <a:pPr algn="ctr"/>
-          </a:p>
-        </p:txBody>
-      </p:sp>
-      <p:sp>
-        <p:nvSpPr>
-          <p:cNvPr id="9" name="TextBox 8"/>
+          <p:cNvPr id="5" name="TextBox 4"/>
           <p:cNvSpPr txBox="1"/>
           <p:nvPr/>
         </p:nvSpPr>
         <p:spPr>
           <a:xfrm>
-            <a:off x="4572000" y="1554480"/>
-            <a:ext cx="3017520" cy="1097280"/>
+            <a:off x="3657600" y="1645920"/>
+            <a:ext cx="7498079" cy="4389120"/>
           </a:xfrm>
           <a:prstGeom prst="rect">
             <a:avLst/>
@@ -5218,61 +4536,17 @@
           <a:lstStyle/>
           <a:p>
             <a:pPr>
-              <a:defRPr sz="950" b="1">
-                <a:solidFill>
-                  <a:srgbClr val="FFFFFF"/>
-                </a:solidFill>
-              </a:defRPr>
-            </a:pPr>
-            <a:r>
-              <a:t>[ Option 2 ] สำหรับห้องควบคุม SCADA</a:t>
-            </a:r>
-          </a:p>
-          <a:p>
-            <a:pPr>
-              <a:defRPr sz="1350" b="1">
-                <a:solidFill>
-                  <a:srgbClr val="FFFFFF"/>
-                </a:solidFill>
-              </a:defRPr>
-            </a:pPr>
-            <a:r>
-              <a:t>เว็บกลาง 100 จุด + Telegram</a:t>
-            </a:r>
-          </a:p>
-        </p:txBody>
-      </p:sp>
-      <p:sp>
-        <p:nvSpPr>
-          <p:cNvPr id="10" name="TextBox 9"/>
-          <p:cNvSpPr txBox="1"/>
-          <p:nvPr/>
-        </p:nvSpPr>
-        <p:spPr>
-          <a:xfrm>
-            <a:off x="4572000" y="2834640"/>
-            <a:ext cx="3017520" cy="3291840"/>
-          </a:xfrm>
-          <a:prstGeom prst="rect">
-            <a:avLst/>
-          </a:prstGeom>
-          <a:noFill/>
-        </p:spPr>
-        <p:txBody>
-          <a:bodyPr wrap="square">
-            <a:spAutoFit/>
-          </a:bodyPr>
-          <a:lstStyle/>
-          <a:p>
-            <a:pPr>
-              <a:defRPr b="1" sz="1050">
-                <a:solidFill>
-                  <a:srgbClr val="0284C7"/>
-                </a:solidFill>
-              </a:defRPr>
-            </a:pPr>
-            <a:r>
-              <a:t>• แบบซื้อขาด: ฿450,000 (4,500 บ./จุด)</a:t>
+              <a:spcAft>
+                <a:spcPts val="1000"/>
+              </a:spcAft>
+              <a:defRPr sz="1300" b="1">
+                <a:solidFill>
+                  <a:srgbClr val="059669"/>
+                </a:solidFill>
+              </a:defRPr>
+            </a:pPr>
+            <a:r>
+              <a:t>📱 คำอธิบายฟังก์ชันแอปพลิเคชันมือถือ (iOS &amp; Android):</a:t>
             </a:r>
           </a:p>
           <a:p>
@@ -5280,18 +4554,14 @@
               <a:spcAft>
                 <a:spcPts val="600"/>
               </a:spcAft>
-              <a:defRPr b="1" sz="1000">
-                <a:solidFill>
-                  <a:srgbClr val="059669"/>
-                </a:solidFill>
-              </a:defRPr>
-            </a:pPr>
-            <a:r>
-              <a:t>• แบบรายปี: ฿340,000 (ปีแรก)</a:t>
-            </a:r>
-            <a:br/>
-            <a:r>
-              <a:t>  (ปีถัดไป ฿240,000 บ./ปี (2,400 บ./จุด/ปี))</a:t>
+              <a:defRPr sz="1050">
+                <a:solidFill>
+                  <a:srgbClr val="0F172A"/>
+                </a:solidFill>
+              </a:defRPr>
+            </a:pPr>
+            <a:r>
+              <a:t>✔ All Devices Hub (100 จุด): ค้นหาและสลับดูข้อมูลสถานีตรวจวัดคุณภาพน้ำทั้ง 100 จุดได้ง่ายดายในแอปเดียว</a:t>
             </a:r>
           </a:p>
           <a:p>
@@ -5299,259 +4569,14 @@
               <a:spcAft>
                 <a:spcPts val="600"/>
               </a:spcAft>
-              <a:defRPr sz="900" b="1">
+              <a:defRPr sz="1050">
                 <a:solidFill>
                   <a:srgbClr val="0F172A"/>
                 </a:solidFill>
               </a:defRPr>
             </a:pPr>
             <a:r>
-              <a:t>💡 จุดเด่น: ดูภาพรวมและตารางสรุปทั้ง 100 จุดในจอเดียว</a:t>
-            </a:r>
-          </a:p>
-          <a:p>
-            <a:pPr>
-              <a:spcAft>
-                <a:spcPts val="200"/>
-              </a:spcAft>
-              <a:defRPr sz="880">
-                <a:solidFill>
-                  <a:srgbClr val="64748B"/>
-                </a:solidFill>
-              </a:defRPr>
-            </a:pPr>
-            <a:r>
-              <a:t>✓ Centralized Web SCADA Dashboard 100 จุด</a:t>
-            </a:r>
-          </a:p>
-          <a:p>
-            <a:pPr>
-              <a:spcAft>
-                <a:spcPts val="200"/>
-              </a:spcAft>
-              <a:defRPr sz="880">
-                <a:solidFill>
-                  <a:srgbClr val="64748B"/>
-                </a:solidFill>
-              </a:defRPr>
-            </a:pPr>
-            <a:r>
-              <a:t>✓ แผนที่ GIS Map &amp; ตารางสรุปสถานะ Real-Time</a:t>
-            </a:r>
-          </a:p>
-          <a:p>
-            <a:pPr>
-              <a:spcAft>
-                <a:spcPts val="200"/>
-              </a:spcAft>
-              <a:defRPr sz="880">
-                <a:solidFill>
-                  <a:srgbClr val="64748B"/>
-                </a:solidFill>
-              </a:defRPr>
-            </a:pPr>
-            <a:r>
-              <a:t>✓ กราฟวิเคราะห์แนวโน้ม Multi-Axis 100 สถานี</a:t>
-            </a:r>
-          </a:p>
-          <a:p>
-            <a:pPr>
-              <a:spcAft>
-                <a:spcPts val="200"/>
-              </a:spcAft>
-              <a:defRPr sz="880">
-                <a:solidFill>
-                  <a:srgbClr val="64748B"/>
-                </a:solidFill>
-              </a:defRPr>
-            </a:pPr>
-            <a:r>
-              <a:t>✓ แจ้งเตือนผ่าน Telegram Bot ทันทีเมื่อผิดปกติ</a:t>
-            </a:r>
-          </a:p>
-          <a:p>
-            <a:pPr>
-              <a:spcAft>
-                <a:spcPts val="200"/>
-              </a:spcAft>
-              <a:defRPr sz="880">
-                <a:solidFill>
-                  <a:srgbClr val="64748B"/>
-                </a:solidFill>
-              </a:defRPr>
-            </a:pPr>
-            <a:r>
-              <a:t>✓ Export รายงาน Excel / PDF ย้อนหลังได้</a:t>
-            </a:r>
-          </a:p>
-        </p:txBody>
-      </p:sp>
-      <p:sp>
-        <p:nvSpPr>
-          <p:cNvPr id="11" name="Rounded Rectangle 10"/>
-          <p:cNvSpPr/>
-          <p:nvPr/>
-        </p:nvSpPr>
-        <p:spPr>
-          <a:xfrm>
-            <a:off x="8046720" y="1463040"/>
-            <a:ext cx="3383280" cy="4754880"/>
-          </a:xfrm>
-          <a:prstGeom prst="roundRect">
-            <a:avLst/>
-          </a:prstGeom>
-          <a:solidFill>
-            <a:srgbClr val="FFFFFF"/>
-          </a:solidFill>
-          <a:ln w="19050">
-            <a:solidFill>
-              <a:srgbClr val="1E293B"/>
-            </a:solidFill>
-          </a:ln>
-        </p:spPr>
-        <p:style>
-          <a:lnRef idx="1">
-            <a:schemeClr val="accent1"/>
-          </a:lnRef>
-          <a:fillRef idx="3">
-            <a:schemeClr val="accent1"/>
-          </a:fillRef>
-          <a:effectRef idx="2">
-            <a:schemeClr val="accent1"/>
-          </a:effectRef>
-          <a:fontRef idx="minor">
-            <a:schemeClr val="lt1"/>
-          </a:fontRef>
-        </p:style>
-        <p:txBody>
-          <a:bodyPr rtlCol="0" anchor="ctr"/>
-          <a:lstStyle/>
-          <a:p>
-            <a:pPr algn="ctr"/>
-          </a:p>
-        </p:txBody>
-      </p:sp>
-      <p:sp>
-        <p:nvSpPr>
-          <p:cNvPr id="12" name="Rounded Rectangle 11"/>
-          <p:cNvSpPr/>
-          <p:nvPr/>
-        </p:nvSpPr>
-        <p:spPr>
-          <a:xfrm>
-            <a:off x="8046720" y="1463040"/>
-            <a:ext cx="3383280" cy="1280160"/>
-          </a:xfrm>
-          <a:prstGeom prst="roundRect">
-            <a:avLst/>
-          </a:prstGeom>
-          <a:solidFill>
-            <a:srgbClr val="1E293B"/>
-          </a:solidFill>
-          <a:ln>
-            <a:noFill/>
-          </a:ln>
-        </p:spPr>
-        <p:style>
-          <a:lnRef idx="1">
-            <a:schemeClr val="accent1"/>
-          </a:lnRef>
-          <a:fillRef idx="3">
-            <a:schemeClr val="accent1"/>
-          </a:fillRef>
-          <a:effectRef idx="2">
-            <a:schemeClr val="accent1"/>
-          </a:effectRef>
-          <a:fontRef idx="minor">
-            <a:schemeClr val="lt1"/>
-          </a:fontRef>
-        </p:style>
-        <p:txBody>
-          <a:bodyPr rtlCol="0" anchor="ctr"/>
-          <a:lstStyle/>
-          <a:p>
-            <a:pPr algn="ctr"/>
-          </a:p>
-        </p:txBody>
-      </p:sp>
-      <p:sp>
-        <p:nvSpPr>
-          <p:cNvPr id="13" name="TextBox 12"/>
-          <p:cNvSpPr txBox="1"/>
-          <p:nvPr/>
-        </p:nvSpPr>
-        <p:spPr>
-          <a:xfrm>
-            <a:off x="8229600" y="1554480"/>
-            <a:ext cx="3017520" cy="1097280"/>
-          </a:xfrm>
-          <a:prstGeom prst="rect">
-            <a:avLst/>
-          </a:prstGeom>
-          <a:noFill/>
-        </p:spPr>
-        <p:txBody>
-          <a:bodyPr wrap="square">
-            <a:spAutoFit/>
-          </a:bodyPr>
-          <a:lstStyle/>
-          <a:p>
-            <a:pPr>
-              <a:defRPr sz="950" b="1">
-                <a:solidFill>
-                  <a:srgbClr val="2DD4BF"/>
-                </a:solidFill>
-              </a:defRPr>
-            </a:pPr>
-            <a:r>
-              <a:t>[ Option 3 ] ครบวงจร + แจ้งเตือน LINE</a:t>
-            </a:r>
-          </a:p>
-          <a:p>
-            <a:pPr>
-              <a:defRPr sz="1350" b="1">
-                <a:solidFill>
-                  <a:srgbClr val="FFFFFF"/>
-                </a:solidFill>
-              </a:defRPr>
-            </a:pPr>
-            <a:r>
-              <a:t>เว็บกลาง + แอป + LINE OA</a:t>
-            </a:r>
-          </a:p>
-        </p:txBody>
-      </p:sp>
-      <p:sp>
-        <p:nvSpPr>
-          <p:cNvPr id="14" name="TextBox 13"/>
-          <p:cNvSpPr txBox="1"/>
-          <p:nvPr/>
-        </p:nvSpPr>
-        <p:spPr>
-          <a:xfrm>
-            <a:off x="8229600" y="2834640"/>
-            <a:ext cx="3017520" cy="3291840"/>
-          </a:xfrm>
-          <a:prstGeom prst="rect">
-            <a:avLst/>
-          </a:prstGeom>
-          <a:noFill/>
-        </p:spPr>
-        <p:txBody>
-          <a:bodyPr wrap="square">
-            <a:spAutoFit/>
-          </a:bodyPr>
-          <a:lstStyle/>
-          <a:p>
-            <a:pPr>
-              <a:defRPr b="1" sz="1050">
-                <a:solidFill>
-                  <a:srgbClr val="0284C7"/>
-                </a:solidFill>
-              </a:defRPr>
-            </a:pPr>
-            <a:r>
-              <a:t>• แบบซื้อขาด: ฿600,000 (6,000 บ./จุด)</a:t>
+              <a:t>✔ Hero Metric Display: แสดงค่า pH และ คลอรีนคงเหลือ (Cl) ด้วยตัวเลขขนาดใหญ่ สีสันอ่านง่าย รู้ผลทันที</a:t>
             </a:r>
           </a:p>
           <a:p>
@@ -5559,18 +4584,14 @@
               <a:spcAft>
                 <a:spcPts val="600"/>
               </a:spcAft>
-              <a:defRPr b="1" sz="1000">
-                <a:solidFill>
-                  <a:srgbClr val="059669"/>
-                </a:solidFill>
-              </a:defRPr>
-            </a:pPr>
-            <a:r>
-              <a:t>• แบบรายปี: ฿510,000 (ปีแรก)</a:t>
-            </a:r>
-            <a:br/>
-            <a:r>
-              <a:t>  (ปีถัดไป ฿360,000 บ./ปี (3,600 บ./จุด/ปี))</a:t>
+              <a:defRPr sz="1050">
+                <a:solidFill>
+                  <a:srgbClr val="0F172A"/>
+                </a:solidFill>
+              </a:defRPr>
+            </a:pPr>
+            <a:r>
+              <a:t>✔ Ambient &amp; Water Temp: แสดงอุณหภูมิน้ำทั้งหน่วยเซลเซียส (°C) และฟาเรนไฮต์ (°F) พร้อมระบบชดเชยอุณหภูมิ ATC</a:t>
             </a:r>
           </a:p>
           <a:p>
@@ -5578,89 +4599,29 @@
               <a:spcAft>
                 <a:spcPts val="600"/>
               </a:spcAft>
-              <a:defRPr sz="900" b="1">
+              <a:defRPr sz="1050">
                 <a:solidFill>
                   <a:srgbClr val="0F172A"/>
                 </a:solidFill>
               </a:defRPr>
             </a:pPr>
             <a:r>
-              <a:t>💡 จุดเด่น: LINE มีค่าแพ็กเกจส่งข้อความรายเดือนเพิ่มเติม</a:t>
+              <a:t>✔ Hardware Link &amp; Battery: ตรวจสอบระดับแบตเตอรี่สำรองและสถานะการเชื่อมต่อของทุกตู้ได้จากระยะไกลตลอด 24 ชม.</a:t>
             </a:r>
           </a:p>
           <a:p>
             <a:pPr>
               <a:spcAft>
-                <a:spcPts val="200"/>
+                <a:spcPts val="600"/>
               </a:spcAft>
-              <a:defRPr sz="880">
-                <a:solidFill>
-                  <a:srgbClr val="64748B"/>
-                </a:solidFill>
-              </a:defRPr>
-            </a:pPr>
-            <a:r>
-              <a:t>✓ ได้ทั้ง Web SCADA + Modela App ครบชุด</a:t>
-            </a:r>
-          </a:p>
-          <a:p>
-            <a:pPr>
-              <a:spcAft>
-                <a:spcPts val="200"/>
-              </a:spcAft>
-              <a:defRPr sz="880">
-                <a:solidFill>
-                  <a:srgbClr val="64748B"/>
-                </a:solidFill>
-              </a:defRPr>
-            </a:pPr>
-            <a:r>
-              <a:t>✓ แจ้งเตือนผ่าน LINE Official Account (LINE OA)</a:t>
-            </a:r>
-          </a:p>
-          <a:p>
-            <a:pPr>
-              <a:spcAft>
-                <a:spcPts val="200"/>
-              </a:spcAft>
-              <a:defRPr sz="880">
-                <a:solidFill>
-                  <a:srgbClr val="64748B"/>
-                </a:solidFill>
-              </a:defRPr>
-            </a:pPr>
-            <a:r>
-              <a:t>✓ ส่งการ์ดแจ้งเตือนพร้อมสีสถานะและปุ่มกดดูสด</a:t>
-            </a:r>
-          </a:p>
-          <a:p>
-            <a:pPr>
-              <a:spcAft>
-                <a:spcPts val="200"/>
-              </a:spcAft>
-              <a:defRPr sz="880">
-                <a:solidFill>
-                  <a:srgbClr val="64748B"/>
-                </a:solidFill>
-              </a:defRPr>
-            </a:pPr>
-            <a:r>
-              <a:t>✓ +฿1,500/จุด เพื่อซัพพอร์ตค่า Broadcast ของ LINE</a:t>
-            </a:r>
-          </a:p>
-          <a:p>
-            <a:pPr>
-              <a:spcAft>
-                <a:spcPts val="200"/>
-              </a:spcAft>
-              <a:defRPr sz="880">
-                <a:solidFill>
-                  <a:srgbClr val="64748B"/>
-                </a:solidFill>
-              </a:defRPr>
-            </a:pPr>
-            <a:r>
-              <a:t>✓ สัญญาบริการระดับพรีเมียม 24/7</a:t>
+              <a:defRPr sz="1050">
+                <a:solidFill>
+                  <a:srgbClr val="0F172A"/>
+                </a:solidFill>
+              </a:defRPr>
+            </a:pPr>
+            <a:r>
+              <a:t>✔ Instant Emergency Alerts: ระบบ Push Notification แจ้งเตือนข้อความด่วนเข้ามือถือทันทีเมื่อมีจุดใดผิดปกติ</a:t>
             </a:r>
           </a:p>
         </p:txBody>
@@ -6100,45 +5061,21 @@
               </a:defRPr>
             </a:pPr>
             <a:r>
-              <a:t>5. ตัวอย่างหน้าจอ Centralized Web SCADA Dashboard (จอห้องควบคุม 100 จุด)</a:t>
-            </a:r>
-          </a:p>
-        </p:txBody>
-      </p:sp>
-      <p:pic>
-        <p:nvPicPr>
-          <p:cNvPr id="3" name="Picture 2" descr="scada_preview.png"/>
-          <p:cNvPicPr>
-            <a:picLocks noChangeAspect="1"/>
-          </p:cNvPicPr>
-          <p:nvPr/>
-        </p:nvPicPr>
-        <p:blipFill>
-          <a:blip r:embed="rId2"/>
-          <a:stretch>
-            <a:fillRect/>
-          </a:stretch>
-        </p:blipFill>
-        <p:spPr>
-          <a:xfrm>
-            <a:off x="731520" y="1463040"/>
-            <a:ext cx="6217920" cy="4754880"/>
-          </a:xfrm>
-          <a:prstGeom prst="rect">
-            <a:avLst/>
-          </a:prstGeom>
-        </p:spPr>
-      </p:pic>
-      <p:sp>
-        <p:nvSpPr>
-          <p:cNvPr id="4" name="Rounded Rectangle 3"/>
+              <a:t>5. ตารางต้นทุนฮาร์ดแวร์และอุปกรณ์ต่อชุด (Hardware BOM per Unit)</a:t>
+            </a:r>
+          </a:p>
+        </p:txBody>
+      </p:sp>
+      <p:sp>
+        <p:nvSpPr>
+          <p:cNvPr id="3" name="Rounded Rectangle 2"/>
           <p:cNvSpPr/>
           <p:nvPr/>
         </p:nvSpPr>
         <p:spPr>
           <a:xfrm>
-            <a:off x="7132320" y="1463040"/>
-            <a:ext cx="4327855" cy="4754880"/>
+            <a:off x="731520" y="1463040"/>
+            <a:ext cx="2468880" cy="3291840"/>
           </a:xfrm>
           <a:prstGeom prst="roundRect">
             <a:avLst/>
@@ -6176,14 +5113,57 @@
       </p:sp>
       <p:sp>
         <p:nvSpPr>
+          <p:cNvPr id="4" name="Rounded Rectangle 3"/>
+          <p:cNvSpPr/>
+          <p:nvPr/>
+        </p:nvSpPr>
+        <p:spPr>
+          <a:xfrm>
+            <a:off x="731520" y="1463040"/>
+            <a:ext cx="2468880" cy="1097280"/>
+          </a:xfrm>
+          <a:prstGeom prst="roundRect">
+            <a:avLst/>
+          </a:prstGeom>
+          <a:solidFill>
+            <a:srgbClr val="0284C7"/>
+          </a:solidFill>
+          <a:ln>
+            <a:noFill/>
+          </a:ln>
+        </p:spPr>
+        <p:style>
+          <a:lnRef idx="1">
+            <a:schemeClr val="accent1"/>
+          </a:lnRef>
+          <a:fillRef idx="3">
+            <a:schemeClr val="accent1"/>
+          </a:fillRef>
+          <a:effectRef idx="2">
+            <a:schemeClr val="accent1"/>
+          </a:effectRef>
+          <a:fontRef idx="minor">
+            <a:schemeClr val="lt1"/>
+          </a:fontRef>
+        </p:style>
+        <p:txBody>
+          <a:bodyPr rtlCol="0" anchor="ctr"/>
+          <a:lstStyle/>
+          <a:p>
+            <a:pPr algn="ctr"/>
+          </a:p>
+        </p:txBody>
+      </p:sp>
+      <p:sp>
+        <p:nvSpPr>
           <p:cNvPr id="5" name="TextBox 4"/>
           <p:cNvSpPr txBox="1"/>
           <p:nvPr/>
         </p:nvSpPr>
         <p:spPr>
           <a:xfrm>
-            <a:off x="7315200" y="1600200"/>
-            <a:ext cx="3962095" cy="4480560"/>
+            <a:off x="841248" y="1536192"/>
+            <a:ext cx="2249424" cy="960120"/>
           </a:xfrm>
           <a:prstGeom prst="rect">
             <a:avLst/>
@@ -6197,107 +5177,706 @@
           <a:lstStyle/>
           <a:p>
             <a:pPr>
+              <a:defRPr sz="1000" b="1">
+                <a:solidFill>
+                  <a:srgbClr val="FFFFFF"/>
+                </a:solidFill>
+              </a:defRPr>
+            </a:pPr>
+            <a:r>
+              <a:t>ชุดเซนเซอร์หลัก (Modela One + pH/TDS/Temp + คลอรีน Cybertice)</a:t>
+            </a:r>
+          </a:p>
+          <a:p>
+            <a:pPr>
+              <a:defRPr sz="1500" b="1">
+                <a:solidFill>
+                  <a:srgbClr val="FFFFFF"/>
+                </a:solidFill>
+              </a:defRPr>
+            </a:pPr>
+            <a:r>
+              <a:t>฿17,000</a:t>
+            </a:r>
+          </a:p>
+        </p:txBody>
+      </p:sp>
+      <p:sp>
+        <p:nvSpPr>
+          <p:cNvPr id="6" name="TextBox 5"/>
+          <p:cNvSpPr txBox="1"/>
+          <p:nvPr/>
+        </p:nvSpPr>
+        <p:spPr>
+          <a:xfrm>
+            <a:off x="841248" y="2651760"/>
+            <a:ext cx="2249424" cy="2011680"/>
+          </a:xfrm>
+          <a:prstGeom prst="rect">
+            <a:avLst/>
+          </a:prstGeom>
+          <a:noFill/>
+        </p:spPr>
+        <p:txBody>
+          <a:bodyPr wrap="square">
+            <a:spAutoFit/>
+          </a:bodyPr>
+          <a:lstStyle/>
+          <a:p>
+            <a:pPr>
+              <a:defRPr sz="880">
+                <a:solidFill>
+                  <a:srgbClr val="64748B"/>
+                </a:solidFill>
+              </a:defRPr>
+            </a:pPr>
+            <a:r>
+              <a:t>• บอร์ดควบคุมหลัก Modela One (Modbus RTU/RS-485)</a:t>
+            </a:r>
+            <a:br/>
+            <a:r>
+              <a:t>• หัววัด pH แก้วอุตสาหกรรม (±0.01 pH)</a:t>
+            </a:r>
+            <a:br/>
+            <a:r>
+              <a:t>• หัววัด TDS / EC Titanium Dual-Pole</a:t>
+            </a:r>
+            <a:br/>
+            <a:r>
+              <a:t>• หัววัดอุณหภูมิ PT1000 (พร้อม ATC ชดเชยอุณหภูมิ)</a:t>
+            </a:r>
+            <a:br/>
+            <a:r>
+              <a:t>• เซนเซอร์คลอรีนคงเหลือ Cybertice (Residual Chlorine)</a:t>
+            </a:r>
+          </a:p>
+        </p:txBody>
+      </p:sp>
+      <p:sp>
+        <p:nvSpPr>
+          <p:cNvPr id="7" name="Rounded Rectangle 6"/>
+          <p:cNvSpPr/>
+          <p:nvPr/>
+        </p:nvSpPr>
+        <p:spPr>
+          <a:xfrm>
+            <a:off x="3474720" y="1463040"/>
+            <a:ext cx="2468880" cy="3291840"/>
+          </a:xfrm>
+          <a:prstGeom prst="roundRect">
+            <a:avLst/>
+          </a:prstGeom>
+          <a:solidFill>
+            <a:srgbClr val="FFFFFF"/>
+          </a:solidFill>
+          <a:ln w="19050">
+            <a:solidFill>
+              <a:srgbClr val="059669"/>
+            </a:solidFill>
+          </a:ln>
+        </p:spPr>
+        <p:style>
+          <a:lnRef idx="1">
+            <a:schemeClr val="accent1"/>
+          </a:lnRef>
+          <a:fillRef idx="3">
+            <a:schemeClr val="accent1"/>
+          </a:fillRef>
+          <a:effectRef idx="2">
+            <a:schemeClr val="accent1"/>
+          </a:effectRef>
+          <a:fontRef idx="minor">
+            <a:schemeClr val="lt1"/>
+          </a:fontRef>
+        </p:style>
+        <p:txBody>
+          <a:bodyPr rtlCol="0" anchor="ctr"/>
+          <a:lstStyle/>
+          <a:p>
+            <a:pPr algn="ctr"/>
+          </a:p>
+        </p:txBody>
+      </p:sp>
+      <p:sp>
+        <p:nvSpPr>
+          <p:cNvPr id="8" name="Rounded Rectangle 7"/>
+          <p:cNvSpPr/>
+          <p:nvPr/>
+        </p:nvSpPr>
+        <p:spPr>
+          <a:xfrm>
+            <a:off x="3474720" y="1463040"/>
+            <a:ext cx="2468880" cy="1097280"/>
+          </a:xfrm>
+          <a:prstGeom prst="roundRect">
+            <a:avLst/>
+          </a:prstGeom>
+          <a:solidFill>
+            <a:srgbClr val="059669"/>
+          </a:solidFill>
+          <a:ln>
+            <a:noFill/>
+          </a:ln>
+        </p:spPr>
+        <p:style>
+          <a:lnRef idx="1">
+            <a:schemeClr val="accent1"/>
+          </a:lnRef>
+          <a:fillRef idx="3">
+            <a:schemeClr val="accent1"/>
+          </a:fillRef>
+          <a:effectRef idx="2">
+            <a:schemeClr val="accent1"/>
+          </a:effectRef>
+          <a:fontRef idx="minor">
+            <a:schemeClr val="lt1"/>
+          </a:fontRef>
+        </p:style>
+        <p:txBody>
+          <a:bodyPr rtlCol="0" anchor="ctr"/>
+          <a:lstStyle/>
+          <a:p>
+            <a:pPr algn="ctr"/>
+          </a:p>
+        </p:txBody>
+      </p:sp>
+      <p:sp>
+        <p:nvSpPr>
+          <p:cNvPr id="9" name="TextBox 8"/>
+          <p:cNvSpPr txBox="1"/>
+          <p:nvPr/>
+        </p:nvSpPr>
+        <p:spPr>
+          <a:xfrm>
+            <a:off x="3584448" y="1536192"/>
+            <a:ext cx="2249424" cy="960120"/>
+          </a:xfrm>
+          <a:prstGeom prst="rect">
+            <a:avLst/>
+          </a:prstGeom>
+          <a:noFill/>
+        </p:spPr>
+        <p:txBody>
+          <a:bodyPr wrap="square">
+            <a:spAutoFit/>
+          </a:bodyPr>
+          <a:lstStyle/>
+          <a:p>
+            <a:pPr>
+              <a:defRPr sz="1000" b="1">
+                <a:solidFill>
+                  <a:srgbClr val="FFFFFF"/>
+                </a:solidFill>
+              </a:defRPr>
+            </a:pPr>
+            <a:r>
+              <a:t>4G LTE Router (TP-Link TL-MR100)</a:t>
+            </a:r>
+          </a:p>
+          <a:p>
+            <a:pPr>
+              <a:defRPr sz="1500" b="1">
+                <a:solidFill>
+                  <a:srgbClr val="FFFFFF"/>
+                </a:solidFill>
+              </a:defRPr>
+            </a:pPr>
+            <a:r>
+              <a:t>฿1,000</a:t>
+            </a:r>
+          </a:p>
+        </p:txBody>
+      </p:sp>
+      <p:sp>
+        <p:nvSpPr>
+          <p:cNvPr id="10" name="TextBox 9"/>
+          <p:cNvSpPr txBox="1"/>
+          <p:nvPr/>
+        </p:nvSpPr>
+        <p:spPr>
+          <a:xfrm>
+            <a:off x="3584448" y="2651760"/>
+            <a:ext cx="2249424" cy="2011680"/>
+          </a:xfrm>
+          <a:prstGeom prst="rect">
+            <a:avLst/>
+          </a:prstGeom>
+          <a:noFill/>
+        </p:spPr>
+        <p:txBody>
+          <a:bodyPr wrap="square">
+            <a:spAutoFit/>
+          </a:bodyPr>
+          <a:lstStyle/>
+          <a:p>
+            <a:pPr>
+              <a:defRPr sz="880">
+                <a:solidFill>
+                  <a:srgbClr val="64748B"/>
+                </a:solidFill>
+              </a:defRPr>
+            </a:pPr>
+            <a:r>
+              <a:t>• เราเตอร์ 4G LTE Wi-Fi ความเร็ว 300 Mbps</a:t>
+            </a:r>
+            <a:br/>
+            <a:r>
+              <a:t>• เสารับสัญญาณภายนอก 2 เสา สัญญาณนิ่งเสถียร</a:t>
+            </a:r>
+            <a:br/>
+            <a:r>
+              <a:t>• เชื่อมต่อระบบ Telemetry สดทุก 1 วินาที</a:t>
+            </a:r>
+          </a:p>
+        </p:txBody>
+      </p:sp>
+      <p:sp>
+        <p:nvSpPr>
+          <p:cNvPr id="11" name="Rounded Rectangle 10"/>
+          <p:cNvSpPr/>
+          <p:nvPr/>
+        </p:nvSpPr>
+        <p:spPr>
+          <a:xfrm>
+            <a:off x="6217920" y="1463040"/>
+            <a:ext cx="2468880" cy="3291840"/>
+          </a:xfrm>
+          <a:prstGeom prst="roundRect">
+            <a:avLst/>
+          </a:prstGeom>
+          <a:solidFill>
+            <a:srgbClr val="FFFFFF"/>
+          </a:solidFill>
+          <a:ln w="19050">
+            <a:solidFill>
+              <a:srgbClr val="D97706"/>
+            </a:solidFill>
+          </a:ln>
+        </p:spPr>
+        <p:style>
+          <a:lnRef idx="1">
+            <a:schemeClr val="accent1"/>
+          </a:lnRef>
+          <a:fillRef idx="3">
+            <a:schemeClr val="accent1"/>
+          </a:fillRef>
+          <a:effectRef idx="2">
+            <a:schemeClr val="accent1"/>
+          </a:effectRef>
+          <a:fontRef idx="minor">
+            <a:schemeClr val="lt1"/>
+          </a:fontRef>
+        </p:style>
+        <p:txBody>
+          <a:bodyPr rtlCol="0" anchor="ctr"/>
+          <a:lstStyle/>
+          <a:p>
+            <a:pPr algn="ctr"/>
+          </a:p>
+        </p:txBody>
+      </p:sp>
+      <p:sp>
+        <p:nvSpPr>
+          <p:cNvPr id="12" name="Rounded Rectangle 11"/>
+          <p:cNvSpPr/>
+          <p:nvPr/>
+        </p:nvSpPr>
+        <p:spPr>
+          <a:xfrm>
+            <a:off x="6217920" y="1463040"/>
+            <a:ext cx="2468880" cy="1097280"/>
+          </a:xfrm>
+          <a:prstGeom prst="roundRect">
+            <a:avLst/>
+          </a:prstGeom>
+          <a:solidFill>
+            <a:srgbClr val="D97706"/>
+          </a:solidFill>
+          <a:ln>
+            <a:noFill/>
+          </a:ln>
+        </p:spPr>
+        <p:style>
+          <a:lnRef idx="1">
+            <a:schemeClr val="accent1"/>
+          </a:lnRef>
+          <a:fillRef idx="3">
+            <a:schemeClr val="accent1"/>
+          </a:fillRef>
+          <a:effectRef idx="2">
+            <a:schemeClr val="accent1"/>
+          </a:effectRef>
+          <a:fontRef idx="minor">
+            <a:schemeClr val="lt1"/>
+          </a:fontRef>
+        </p:style>
+        <p:txBody>
+          <a:bodyPr rtlCol="0" anchor="ctr"/>
+          <a:lstStyle/>
+          <a:p>
+            <a:pPr algn="ctr"/>
+          </a:p>
+        </p:txBody>
+      </p:sp>
+      <p:sp>
+        <p:nvSpPr>
+          <p:cNvPr id="13" name="TextBox 12"/>
+          <p:cNvSpPr txBox="1"/>
+          <p:nvPr/>
+        </p:nvSpPr>
+        <p:spPr>
+          <a:xfrm>
+            <a:off x="6327648" y="1536192"/>
+            <a:ext cx="2249424" cy="960120"/>
+          </a:xfrm>
+          <a:prstGeom prst="rect">
+            <a:avLst/>
+          </a:prstGeom>
+          <a:noFill/>
+        </p:spPr>
+        <p:txBody>
+          <a:bodyPr wrap="square">
+            <a:spAutoFit/>
+          </a:bodyPr>
+          <a:lstStyle/>
+          <a:p>
+            <a:pPr>
+              <a:defRPr sz="1000" b="1">
+                <a:solidFill>
+                  <a:srgbClr val="FFFFFF"/>
+                </a:solidFill>
+              </a:defRPr>
+            </a:pPr>
+            <a:r>
+              <a:t>ซิมการ์ด 4G รายปี (Unlimited 15-20 Mbps)</a:t>
+            </a:r>
+          </a:p>
+          <a:p>
+            <a:pPr>
+              <a:defRPr sz="1500" b="1">
+                <a:solidFill>
+                  <a:srgbClr val="FFFFFF"/>
+                </a:solidFill>
+              </a:defRPr>
+            </a:pPr>
+            <a:r>
+              <a:t>฿1,800</a:t>
+            </a:r>
+          </a:p>
+        </p:txBody>
+      </p:sp>
+      <p:sp>
+        <p:nvSpPr>
+          <p:cNvPr id="14" name="TextBox 13"/>
+          <p:cNvSpPr txBox="1"/>
+          <p:nvPr/>
+        </p:nvSpPr>
+        <p:spPr>
+          <a:xfrm>
+            <a:off x="6327648" y="2651760"/>
+            <a:ext cx="2249424" cy="2011680"/>
+          </a:xfrm>
+          <a:prstGeom prst="rect">
+            <a:avLst/>
+          </a:prstGeom>
+          <a:noFill/>
+        </p:spPr>
+        <p:txBody>
+          <a:bodyPr wrap="square">
+            <a:spAutoFit/>
+          </a:bodyPr>
+          <a:lstStyle/>
+          <a:p>
+            <a:pPr>
+              <a:defRPr sz="880">
+                <a:solidFill>
+                  <a:srgbClr val="64748B"/>
+                </a:solidFill>
+              </a:defRPr>
+            </a:pPr>
+            <a:r>
+              <a:t>• ซิมเน็ต IoT รายปี ไม่อั้น ไม่ลดสปีด (15-20 Mbps)</a:t>
+            </a:r>
+            <a:br/>
+            <a:r>
+              <a:t>• รวมค่าบริการเครือข่าย 12 เดือนเต็ม</a:t>
+            </a:r>
+            <a:br/>
+            <a:r>
+              <a:t>• ส่งข้อมูลขึ้นระบบคลาวด์และแจ้งเตือน 24 ชม.</a:t>
+            </a:r>
+          </a:p>
+        </p:txBody>
+      </p:sp>
+      <p:sp>
+        <p:nvSpPr>
+          <p:cNvPr id="15" name="Rounded Rectangle 14"/>
+          <p:cNvSpPr/>
+          <p:nvPr/>
+        </p:nvSpPr>
+        <p:spPr>
+          <a:xfrm>
+            <a:off x="8961120" y="1463040"/>
+            <a:ext cx="2468880" cy="3291840"/>
+          </a:xfrm>
+          <a:prstGeom prst="roundRect">
+            <a:avLst/>
+          </a:prstGeom>
+          <a:solidFill>
+            <a:srgbClr val="FFFFFF"/>
+          </a:solidFill>
+          <a:ln w="19050">
+            <a:solidFill>
+              <a:srgbClr val="1E293B"/>
+            </a:solidFill>
+          </a:ln>
+        </p:spPr>
+        <p:style>
+          <a:lnRef idx="1">
+            <a:schemeClr val="accent1"/>
+          </a:lnRef>
+          <a:fillRef idx="3">
+            <a:schemeClr val="accent1"/>
+          </a:fillRef>
+          <a:effectRef idx="2">
+            <a:schemeClr val="accent1"/>
+          </a:effectRef>
+          <a:fontRef idx="minor">
+            <a:schemeClr val="lt1"/>
+          </a:fontRef>
+        </p:style>
+        <p:txBody>
+          <a:bodyPr rtlCol="0" anchor="ctr"/>
+          <a:lstStyle/>
+          <a:p>
+            <a:pPr algn="ctr"/>
+          </a:p>
+        </p:txBody>
+      </p:sp>
+      <p:sp>
+        <p:nvSpPr>
+          <p:cNvPr id="16" name="Rounded Rectangle 15"/>
+          <p:cNvSpPr/>
+          <p:nvPr/>
+        </p:nvSpPr>
+        <p:spPr>
+          <a:xfrm>
+            <a:off x="8961120" y="1463040"/>
+            <a:ext cx="2468880" cy="1097280"/>
+          </a:xfrm>
+          <a:prstGeom prst="roundRect">
+            <a:avLst/>
+          </a:prstGeom>
+          <a:solidFill>
+            <a:srgbClr val="1E293B"/>
+          </a:solidFill>
+          <a:ln>
+            <a:noFill/>
+          </a:ln>
+        </p:spPr>
+        <p:style>
+          <a:lnRef idx="1">
+            <a:schemeClr val="accent1"/>
+          </a:lnRef>
+          <a:fillRef idx="3">
+            <a:schemeClr val="accent1"/>
+          </a:fillRef>
+          <a:effectRef idx="2">
+            <a:schemeClr val="accent1"/>
+          </a:effectRef>
+          <a:fontRef idx="minor">
+            <a:schemeClr val="lt1"/>
+          </a:fontRef>
+        </p:style>
+        <p:txBody>
+          <a:bodyPr rtlCol="0" anchor="ctr"/>
+          <a:lstStyle/>
+          <a:p>
+            <a:pPr algn="ctr"/>
+          </a:p>
+        </p:txBody>
+      </p:sp>
+      <p:sp>
+        <p:nvSpPr>
+          <p:cNvPr id="17" name="TextBox 16"/>
+          <p:cNvSpPr txBox="1"/>
+          <p:nvPr/>
+        </p:nvSpPr>
+        <p:spPr>
+          <a:xfrm>
+            <a:off x="9070848" y="1536192"/>
+            <a:ext cx="2249424" cy="960120"/>
+          </a:xfrm>
+          <a:prstGeom prst="rect">
+            <a:avLst/>
+          </a:prstGeom>
+          <a:noFill/>
+        </p:spPr>
+        <p:txBody>
+          <a:bodyPr wrap="square">
+            <a:spAutoFit/>
+          </a:bodyPr>
+          <a:lstStyle/>
+          <a:p>
+            <a:pPr>
+              <a:defRPr sz="1000" b="1">
+                <a:solidFill>
+                  <a:srgbClr val="FFFFFF"/>
+                </a:solidFill>
+              </a:defRPr>
+            </a:pPr>
+            <a:r>
+              <a:t>ตู้คอนโทรล IP65 + Switching 24V + Breaker + Wiring</a:t>
+            </a:r>
+          </a:p>
+          <a:p>
+            <a:pPr>
+              <a:defRPr sz="1500" b="1">
+                <a:solidFill>
+                  <a:srgbClr val="FFFFFF"/>
+                </a:solidFill>
+              </a:defRPr>
+            </a:pPr>
+            <a:r>
+              <a:t>฿1,200</a:t>
+            </a:r>
+          </a:p>
+        </p:txBody>
+      </p:sp>
+      <p:sp>
+        <p:nvSpPr>
+          <p:cNvPr id="18" name="TextBox 17"/>
+          <p:cNvSpPr txBox="1"/>
+          <p:nvPr/>
+        </p:nvSpPr>
+        <p:spPr>
+          <a:xfrm>
+            <a:off x="9070848" y="2651760"/>
+            <a:ext cx="2249424" cy="2011680"/>
+          </a:xfrm>
+          <a:prstGeom prst="rect">
+            <a:avLst/>
+          </a:prstGeom>
+          <a:noFill/>
+        </p:spPr>
+        <p:txBody>
+          <a:bodyPr wrap="square">
+            <a:spAutoFit/>
+          </a:bodyPr>
+          <a:lstStyle/>
+          <a:p>
+            <a:pPr>
+              <a:defRPr sz="880">
+                <a:solidFill>
+                  <a:srgbClr val="64748B"/>
+                </a:solidFill>
+              </a:defRPr>
+            </a:pPr>
+            <a:r>
+              <a:t>• ตู้กันน้ำกันฝุ่นมาตรฐาน IP65</a:t>
+            </a:r>
+            <a:br/>
+            <a:r>
+              <a:t>• แหล่งจ่ายไฟ Switching Power Supply 24V</a:t>
+            </a:r>
+            <a:br/>
+            <a:r>
+              <a:t>• Breaker ป้องกันไฟเกิน + Terminal + สายไฟประกอบครบ</a:t>
+            </a:r>
+          </a:p>
+        </p:txBody>
+      </p:sp>
+      <p:sp>
+        <p:nvSpPr>
+          <p:cNvPr id="19" name="Rounded Rectangle 18"/>
+          <p:cNvSpPr/>
+          <p:nvPr/>
+        </p:nvSpPr>
+        <p:spPr>
+          <a:xfrm>
+            <a:off x="731520" y="4937760"/>
+            <a:ext cx="10728655" cy="1371600"/>
+          </a:xfrm>
+          <a:prstGeom prst="roundRect">
+            <a:avLst/>
+          </a:prstGeom>
+          <a:solidFill>
+            <a:srgbClr val="0F172A"/>
+          </a:solidFill>
+          <a:ln w="19050">
+            <a:solidFill>
+              <a:srgbClr val="0284C7"/>
+            </a:solidFill>
+          </a:ln>
+        </p:spPr>
+        <p:style>
+          <a:lnRef idx="1">
+            <a:schemeClr val="accent1"/>
+          </a:lnRef>
+          <a:fillRef idx="3">
+            <a:schemeClr val="accent1"/>
+          </a:fillRef>
+          <a:effectRef idx="2">
+            <a:schemeClr val="accent1"/>
+          </a:effectRef>
+          <a:fontRef idx="minor">
+            <a:schemeClr val="lt1"/>
+          </a:fontRef>
+        </p:style>
+        <p:txBody>
+          <a:bodyPr rtlCol="0" anchor="ctr"/>
+          <a:lstStyle/>
+          <a:p>
+            <a:pPr algn="ctr"/>
+          </a:p>
+        </p:txBody>
+      </p:sp>
+      <p:sp>
+        <p:nvSpPr>
+          <p:cNvPr id="20" name="TextBox 19"/>
+          <p:cNvSpPr txBox="1"/>
+          <p:nvPr/>
+        </p:nvSpPr>
+        <p:spPr>
+          <a:xfrm>
+            <a:off x="1005840" y="5074920"/>
+            <a:ext cx="10149840" cy="1097280"/>
+          </a:xfrm>
+          <a:prstGeom prst="rect">
+            <a:avLst/>
+          </a:prstGeom>
+          <a:noFill/>
+        </p:spPr>
+        <p:txBody>
+          <a:bodyPr wrap="square">
+            <a:spAutoFit/>
+          </a:bodyPr>
+          <a:lstStyle/>
+          <a:p>
+            <a:pPr>
               <a:spcAft>
-                <a:spcPts val="800"/>
+                <a:spcPts val="400"/>
               </a:spcAft>
-              <a:defRPr sz="1300" b="1">
-                <a:solidFill>
-                  <a:srgbClr val="0284C7"/>
-                </a:solidFill>
-              </a:defRPr>
-            </a:pPr>
-            <a:r>
-              <a:t>💻 คำอธิบายฟังก์ชันหน้าจอ SCADA:</a:t>
-            </a:r>
-          </a:p>
-          <a:p>
-            <a:pPr>
-              <a:spcAft>
-                <a:spcPts val="300"/>
-              </a:spcAft>
-              <a:defRPr sz="950">
-                <a:solidFill>
-                  <a:srgbClr val="0F172A"/>
-                </a:solidFill>
-              </a:defRPr>
-            </a:pPr>
-            <a:r>
-              <a:t>❶ สถานะระบบ &amp; แบตเตอรี่: แสดงสถานะ Healthy, สัญญาณ 4G/WiFi และแบต LiFePO4 (90%)</a:t>
-            </a:r>
-          </a:p>
-          <a:p>
-            <a:pPr>
-              <a:spcAft>
-                <a:spcPts val="300"/>
-              </a:spcAft>
-              <a:defRPr sz="950">
-                <a:solidFill>
-                  <a:srgbClr val="0F172A"/>
-                </a:solidFill>
-              </a:defRPr>
-            </a:pPr>
-            <a:r>
-              <a:t>❷ การ์ดตรวจวัด 4 ค่าหลัก: อุณหภูมิน้ำ (ATC), pH (Glass Probe), TDS (ppm), Cl (mg/L)</a:t>
-            </a:r>
-          </a:p>
-          <a:p>
-            <a:pPr>
-              <a:spcAft>
-                <a:spcPts val="300"/>
-              </a:spcAft>
-              <a:defRPr sz="950">
-                <a:solidFill>
-                  <a:srgbClr val="0F172A"/>
-                </a:solidFill>
-              </a:defRPr>
-            </a:pPr>
-            <a:r>
-              <a:t>❸ กราฟแนวโน้ม Real-Time: พล็อตข้อมูลสด 1 วินาที ติดตามค่าน้ำ 24 ชม. ย้อนหลังได้</a:t>
-            </a:r>
-          </a:p>
-          <a:p>
-            <a:pPr>
-              <a:spcAft>
-                <a:spcPts val="300"/>
-              </a:spcAft>
-              <a:defRPr sz="950">
-                <a:solidFill>
-                  <a:srgbClr val="0F172A"/>
-                </a:solidFill>
-              </a:defRPr>
-            </a:pPr>
-            <a:r>
-              <a:t>❹ ไดอะแกรมเชื่อมต่อ: ตรวจจับสายสัญญาณ WiFi ➔ Display ➔ Sensor Probes</a:t>
-            </a:r>
-          </a:p>
-          <a:p>
-            <a:pPr>
-              <a:spcAft>
-                <a:spcPts val="300"/>
-              </a:spcAft>
-              <a:defRPr sz="950">
-                <a:solidFill>
-                  <a:srgbClr val="0F172A"/>
-                </a:solidFill>
-              </a:defRPr>
-            </a:pPr>
-            <a:r>
-              <a:t>❺ Digital Calibration: สอบเทียบหัววัด pH 7.00 / 4.01 ผ่านหน้าเว็บในคลิกเดียว</a:t>
-            </a:r>
-          </a:p>
-          <a:p>
-            <a:pPr>
-              <a:spcAft>
-                <a:spcPts val="300"/>
-              </a:spcAft>
-              <a:defRPr sz="950">
-                <a:solidFill>
-                  <a:srgbClr val="0F172A"/>
-                </a:solidFill>
-              </a:defRPr>
-            </a:pPr>
-            <a:r>
-              <a:t>❻ ส่งออกรายงาน: Export ข้อมูลเป็น Excel / PDF สำหรับรายงาน ISO ทันที</a:t>
+              <a:defRPr sz="1600" b="1">
+                <a:solidFill>
+                  <a:srgbClr val="2DD4BF"/>
+                </a:solidFill>
+              </a:defRPr>
+            </a:pPr>
+            <a:r>
+              <a:t>➡️ รวมต้นทุนต่อชุด: ฿21,000 บาท  |  รวมต้นทุนโครงการ (100 ชุด): ฿2,100,000 บาท</a:t>
+            </a:r>
+          </a:p>
+          <a:p>
+            <a:pPr>
+              <a:defRPr sz="1000">
+                <a:solidFill>
+                  <a:srgbClr val="E2E8F0"/>
+                </a:solidFill>
+              </a:defRPr>
+            </a:pPr>
+            <a:r>
+              <a:t>ต้นทุนนี้ครอบคลุมชุดหัววัดเซนเซอร์ 4 ค่า (pH / TDS / Temp / Cl) + กล่อง Modela One + เราเตอร์ 4G TP-Link + ซิมรายปี + ตู้ IP65 ประกอบสำเร็จพร้อมใช้งาน</a:t>
             </a:r>
           </a:p>
         </p:txBody>
@@ -6373,45 +5952,288 @@
               </a:defRPr>
             </a:pPr>
             <a:r>
-              <a:t>6. ตัวอย่างหน้าจอมือถือ (Modela Mobile Companion App) &amp; Mobile Features</a:t>
-            </a:r>
-          </a:p>
-        </p:txBody>
-      </p:sp>
-      <p:pic>
-        <p:nvPicPr>
-          <p:cNvPr id="3" name="Picture 2" descr="mobile_preview.png"/>
-          <p:cNvPicPr>
-            <a:picLocks noChangeAspect="1"/>
-          </p:cNvPicPr>
+              <a:t>6. โครงสร้างราคาขายแนะนำ (แพ็กเกจโครงการ 100 ชุด)</a:t>
+            </a:r>
+          </a:p>
+        </p:txBody>
+      </p:sp>
+      <p:sp>
+        <p:nvSpPr>
+          <p:cNvPr id="3" name="Rounded Rectangle 2"/>
+          <p:cNvSpPr/>
           <p:nvPr/>
-        </p:nvPicPr>
-        <p:blipFill>
-          <a:blip r:embed="rId2"/>
-          <a:stretch>
-            <a:fillRect/>
-          </a:stretch>
-        </p:blipFill>
+        </p:nvSpPr>
         <p:spPr>
           <a:xfrm>
             <a:off x="731520" y="1463040"/>
-            <a:ext cx="2377440" cy="4754880"/>
+            <a:ext cx="5120640" cy="4754880"/>
+          </a:xfrm>
+          <a:prstGeom prst="roundRect">
+            <a:avLst/>
+          </a:prstGeom>
+          <a:solidFill>
+            <a:srgbClr val="FFFFFF"/>
+          </a:solidFill>
+          <a:ln w="19050">
+            <a:solidFill>
+              <a:srgbClr val="0284C7"/>
+            </a:solidFill>
+          </a:ln>
+        </p:spPr>
+        <p:style>
+          <a:lnRef idx="1">
+            <a:schemeClr val="accent1"/>
+          </a:lnRef>
+          <a:fillRef idx="3">
+            <a:schemeClr val="accent1"/>
+          </a:fillRef>
+          <a:effectRef idx="2">
+            <a:schemeClr val="accent1"/>
+          </a:effectRef>
+          <a:fontRef idx="minor">
+            <a:schemeClr val="lt1"/>
+          </a:fontRef>
+        </p:style>
+        <p:txBody>
+          <a:bodyPr rtlCol="0" anchor="ctr"/>
+          <a:lstStyle/>
+          <a:p>
+            <a:pPr algn="ctr"/>
+          </a:p>
+        </p:txBody>
+      </p:sp>
+      <p:sp>
+        <p:nvSpPr>
+          <p:cNvPr id="4" name="Rounded Rectangle 3"/>
+          <p:cNvSpPr/>
+          <p:nvPr/>
+        </p:nvSpPr>
+        <p:spPr>
+          <a:xfrm>
+            <a:off x="731520" y="1463040"/>
+            <a:ext cx="5120640" cy="1188720"/>
+          </a:xfrm>
+          <a:prstGeom prst="roundRect">
+            <a:avLst/>
+          </a:prstGeom>
+          <a:solidFill>
+            <a:srgbClr val="0284C7"/>
+          </a:solidFill>
+          <a:ln>
+            <a:noFill/>
+          </a:ln>
+        </p:spPr>
+        <p:style>
+          <a:lnRef idx="1">
+            <a:schemeClr val="accent1"/>
+          </a:lnRef>
+          <a:fillRef idx="3">
+            <a:schemeClr val="accent1"/>
+          </a:fillRef>
+          <a:effectRef idx="2">
+            <a:schemeClr val="accent1"/>
+          </a:effectRef>
+          <a:fontRef idx="minor">
+            <a:schemeClr val="lt1"/>
+          </a:fontRef>
+        </p:style>
+        <p:txBody>
+          <a:bodyPr rtlCol="0" anchor="ctr"/>
+          <a:lstStyle/>
+          <a:p>
+            <a:pPr algn="ctr"/>
+          </a:p>
+        </p:txBody>
+      </p:sp>
+      <p:sp>
+        <p:nvSpPr>
+          <p:cNvPr id="5" name="TextBox 4"/>
+          <p:cNvSpPr txBox="1"/>
+          <p:nvPr/>
+        </p:nvSpPr>
+        <p:spPr>
+          <a:xfrm>
+            <a:off x="914400" y="1554480"/>
+            <a:ext cx="4754880" cy="1005840"/>
           </a:xfrm>
           <a:prstGeom prst="rect">
             <a:avLst/>
           </a:prstGeom>
-        </p:spPr>
-      </p:pic>
-      <p:sp>
-        <p:nvSpPr>
-          <p:cNvPr id="4" name="Rounded Rectangle 3"/>
+          <a:noFill/>
+        </p:spPr>
+        <p:txBody>
+          <a:bodyPr wrap="square">
+            <a:spAutoFit/>
+          </a:bodyPr>
+          <a:lstStyle/>
+          <a:p>
+            <a:pPr>
+              <a:defRPr sz="1300" b="1">
+                <a:solidFill>
+                  <a:srgbClr val="FFFFFF"/>
+                </a:solidFill>
+              </a:defRPr>
+            </a:pPr>
+            <a:r>
+              <a:t>[แบบที่ 1] ส่งมอบอุปกรณ์พร้อมระบบออนไลน์</a:t>
+            </a:r>
+          </a:p>
+          <a:p>
+            <a:pPr>
+              <a:defRPr sz="1100" b="1">
+                <a:solidFill>
+                  <a:srgbClr val="FFFFFF"/>
+                </a:solidFill>
+              </a:defRPr>
+            </a:pPr>
+            <a:r>
+              <a:t>Plug &amp; Play / Supply Only (ราคา ฿29,500 - ฿32,000 / ชุด)</a:t>
+            </a:r>
+          </a:p>
+        </p:txBody>
+      </p:sp>
+      <p:sp>
+        <p:nvSpPr>
+          <p:cNvPr id="6" name="TextBox 5"/>
+          <p:cNvSpPr txBox="1"/>
+          <p:nvPr/>
+        </p:nvSpPr>
+        <p:spPr>
+          <a:xfrm>
+            <a:off x="914400" y="2743200"/>
+            <a:ext cx="4754880" cy="3383280"/>
+          </a:xfrm>
+          <a:prstGeom prst="rect">
+            <a:avLst/>
+          </a:prstGeom>
+          <a:noFill/>
+        </p:spPr>
+        <p:txBody>
+          <a:bodyPr wrap="square">
+            <a:spAutoFit/>
+          </a:bodyPr>
+          <a:lstStyle/>
+          <a:p>
+            <a:pPr>
+              <a:spcAft>
+                <a:spcPts val="400"/>
+              </a:spcAft>
+              <a:defRPr b="1" sz="1100">
+                <a:solidFill>
+                  <a:srgbClr val="0F172A"/>
+                </a:solidFill>
+              </a:defRPr>
+            </a:pPr>
+            <a:r>
+              <a:t>📋 ขอบเขตงาน (Scope of Work):</a:t>
+            </a:r>
+          </a:p>
+          <a:p>
+            <a:pPr>
+              <a:spcAft>
+                <a:spcPts val="200"/>
+              </a:spcAft>
+              <a:defRPr sz="950">
+                <a:solidFill>
+                  <a:srgbClr val="64748B"/>
+                </a:solidFill>
+              </a:defRPr>
+            </a:pPr>
+            <a:r>
+              <a:t>✔ ประกอบตู้คอนโทรลสำเร็จรูป พร้อมเดินระบบไฟภายใน</a:t>
+            </a:r>
+          </a:p>
+          <a:p>
+            <a:pPr>
+              <a:spcAft>
+                <a:spcPts val="200"/>
+              </a:spcAft>
+              <a:defRPr sz="950">
+                <a:solidFill>
+                  <a:srgbClr val="64748B"/>
+                </a:solidFill>
+              </a:defRPr>
+            </a:pPr>
+            <a:r>
+              <a:t>✔ ใส่ซิมรายปีและตั้งค่าเชื่อมต่อเน็ตเวิร์ก 4G LTE</a:t>
+            </a:r>
+          </a:p>
+          <a:p>
+            <a:pPr>
+              <a:spcAft>
+                <a:spcPts val="200"/>
+              </a:spcAft>
+              <a:defRPr sz="950">
+                <a:solidFill>
+                  <a:srgbClr val="64748B"/>
+                </a:solidFill>
+              </a:defRPr>
+            </a:pPr>
+            <a:r>
+              <a:t>✔ เชื่อมต่อ Modbus อ่านค่า pH, TDS, Temp, Chlorine</a:t>
+            </a:r>
+          </a:p>
+          <a:p>
+            <a:pPr>
+              <a:spcAft>
+                <a:spcPts val="200"/>
+              </a:spcAft>
+              <a:defRPr sz="950">
+                <a:solidFill>
+                  <a:srgbClr val="64748B"/>
+                </a:solidFill>
+              </a:defRPr>
+            </a:pPr>
+            <a:r>
+              <a:t>✔ ตั้งค่าระบบ Modela App สำหรับดูข้อมูลและแจ้งเตือนผ่านมือถือ</a:t>
+            </a:r>
+          </a:p>
+          <a:p>
+            <a:pPr>
+              <a:spcAft>
+                <a:spcPts val="200"/>
+              </a:spcAft>
+              <a:defRPr sz="950">
+                <a:solidFill>
+                  <a:srgbClr val="64748B"/>
+                </a:solidFill>
+              </a:defRPr>
+            </a:pPr>
+            <a:r>
+              <a:t>✔ จัดทำ Web Dashboard กลางรวมข้อมูลทั้ง 100 จุด</a:t>
+            </a:r>
+          </a:p>
+          <a:p>
+            <a:pPr>
+              <a:spcBef>
+                <a:spcPts val="800"/>
+              </a:spcBef>
+              <a:defRPr b="1" sz="1000">
+                <a:solidFill>
+                  <a:srgbClr val="0284C7"/>
+                </a:solidFill>
+              </a:defRPr>
+            </a:pPr>
+            <a:r>
+              <a:t>💰 มูลค่าโครงการรวม (100 ชุด): ฿2,950,000 - ฿3,200,000 บาท</a:t>
+            </a:r>
+            <a:br/>
+            <a:r>
+              <a:t>📈 กำไรขั้นต้นโดยประมาณ: ฿850,000 - ฿1,100,000 บาท (Margin ~29-34%)</a:t>
+            </a:r>
+          </a:p>
+        </p:txBody>
+      </p:sp>
+      <p:sp>
+        <p:nvSpPr>
+          <p:cNvPr id="7" name="Rounded Rectangle 6"/>
           <p:cNvSpPr/>
           <p:nvPr/>
         </p:nvSpPr>
         <p:spPr>
           <a:xfrm>
-            <a:off x="3383280" y="1463040"/>
-            <a:ext cx="8076895" cy="4754880"/>
+            <a:off x="6309360" y="1463040"/>
+            <a:ext cx="5120640" cy="4754880"/>
           </a:xfrm>
           <a:prstGeom prst="roundRect">
             <a:avLst/>
@@ -6449,14 +6271,57 @@
       </p:sp>
       <p:sp>
         <p:nvSpPr>
-          <p:cNvPr id="5" name="TextBox 4"/>
+          <p:cNvPr id="8" name="Rounded Rectangle 7"/>
+          <p:cNvSpPr/>
+          <p:nvPr/>
+        </p:nvSpPr>
+        <p:spPr>
+          <a:xfrm>
+            <a:off x="6309360" y="1463040"/>
+            <a:ext cx="5120640" cy="1188720"/>
+          </a:xfrm>
+          <a:prstGeom prst="roundRect">
+            <a:avLst/>
+          </a:prstGeom>
+          <a:solidFill>
+            <a:srgbClr val="059669"/>
+          </a:solidFill>
+          <a:ln>
+            <a:noFill/>
+          </a:ln>
+        </p:spPr>
+        <p:style>
+          <a:lnRef idx="1">
+            <a:schemeClr val="accent1"/>
+          </a:lnRef>
+          <a:fillRef idx="3">
+            <a:schemeClr val="accent1"/>
+          </a:fillRef>
+          <a:effectRef idx="2">
+            <a:schemeClr val="accent1"/>
+          </a:effectRef>
+          <a:fontRef idx="minor">
+            <a:schemeClr val="lt1"/>
+          </a:fontRef>
+        </p:style>
+        <p:txBody>
+          <a:bodyPr rtlCol="0" anchor="ctr"/>
+          <a:lstStyle/>
+          <a:p>
+            <a:pPr algn="ctr"/>
+          </a:p>
+        </p:txBody>
+      </p:sp>
+      <p:sp>
+        <p:nvSpPr>
+          <p:cNvPr id="9" name="TextBox 8"/>
           <p:cNvSpPr txBox="1"/>
           <p:nvPr/>
         </p:nvSpPr>
         <p:spPr>
           <a:xfrm>
-            <a:off x="3657600" y="1645920"/>
-            <a:ext cx="7498079" cy="4389120"/>
+            <a:off x="6492240" y="1554480"/>
+            <a:ext cx="4754880" cy="1005840"/>
           </a:xfrm>
           <a:prstGeom prst="rect">
             <a:avLst/>
@@ -6470,92 +6335,158 @@
           <a:lstStyle/>
           <a:p>
             <a:pPr>
+              <a:defRPr sz="1300" b="1">
+                <a:solidFill>
+                  <a:srgbClr val="FFFFFF"/>
+                </a:solidFill>
+              </a:defRPr>
+            </a:pPr>
+            <a:r>
+              <a:t>[แบบที่ 2] แบบครบวงจร รวมติดตั้งหน้างาน + สอบเทียบ</a:t>
+            </a:r>
+          </a:p>
+          <a:p>
+            <a:pPr>
+              <a:defRPr sz="1100" b="1">
+                <a:solidFill>
+                  <a:srgbClr val="FFFFFF"/>
+                </a:solidFill>
+              </a:defRPr>
+            </a:pPr>
+            <a:r>
+              <a:t>Turnkey Solution (ราคา ฿38,000 - ฿42,000 / ชุด)</a:t>
+            </a:r>
+          </a:p>
+        </p:txBody>
+      </p:sp>
+      <p:sp>
+        <p:nvSpPr>
+          <p:cNvPr id="10" name="TextBox 9"/>
+          <p:cNvSpPr txBox="1"/>
+          <p:nvPr/>
+        </p:nvSpPr>
+        <p:spPr>
+          <a:xfrm>
+            <a:off x="6492240" y="2743200"/>
+            <a:ext cx="4754880" cy="3383280"/>
+          </a:xfrm>
+          <a:prstGeom prst="rect">
+            <a:avLst/>
+          </a:prstGeom>
+          <a:noFill/>
+        </p:spPr>
+        <p:txBody>
+          <a:bodyPr wrap="square">
+            <a:spAutoFit/>
+          </a:bodyPr>
+          <a:lstStyle/>
+          <a:p>
+            <a:pPr>
               <a:spcAft>
-                <a:spcPts val="1000"/>
+                <a:spcPts val="400"/>
               </a:spcAft>
-              <a:defRPr sz="1300" b="1">
+              <a:defRPr b="1" sz="1100">
+                <a:solidFill>
+                  <a:srgbClr val="0F172A"/>
+                </a:solidFill>
+              </a:defRPr>
+            </a:pPr>
+            <a:r>
+              <a:t>📋 ขอบเขตงาน (Scope of Work):</a:t>
+            </a:r>
+          </a:p>
+          <a:p>
+            <a:pPr>
+              <a:spcAft>
+                <a:spcPts val="200"/>
+              </a:spcAft>
+              <a:defRPr sz="950">
+                <a:solidFill>
+                  <a:srgbClr val="64748B"/>
+                </a:solidFill>
+              </a:defRPr>
+            </a:pPr>
+            <a:r>
+              <a:t>✔ ทุกอย่างในแบบที่ 1 (ตู้ + ซิม + Modbus + App + Web Dashboard)</a:t>
+            </a:r>
+          </a:p>
+          <a:p>
+            <a:pPr>
+              <a:spcAft>
+                <a:spcPts val="200"/>
+              </a:spcAft>
+              <a:defRPr sz="950">
+                <a:solidFill>
+                  <a:srgbClr val="64748B"/>
+                </a:solidFill>
+              </a:defRPr>
+            </a:pPr>
+            <a:r>
+              <a:t>✔ ค่าแรงและทีมงานเข้าติดตั้งยึดตู้ / เดินท่อบายพาสหน้างาน</a:t>
+            </a:r>
+          </a:p>
+          <a:p>
+            <a:pPr>
+              <a:spcAft>
+                <a:spcPts val="200"/>
+              </a:spcAft>
+              <a:defRPr sz="950">
+                <a:solidFill>
+                  <a:srgbClr val="64748B"/>
+                </a:solidFill>
+              </a:defRPr>
+            </a:pPr>
+            <a:r>
+              <a:t>✔ สอบเทียบ (Calibration) หัววัด pH / TDS ด้วยน้ำยามาตรฐานหน้างาน</a:t>
+            </a:r>
+          </a:p>
+          <a:p>
+            <a:pPr>
+              <a:spcAft>
+                <a:spcPts val="200"/>
+              </a:spcAft>
+              <a:defRPr sz="950">
+                <a:solidFill>
+                  <a:srgbClr val="64748B"/>
+                </a:solidFill>
+              </a:defRPr>
+            </a:pPr>
+            <a:r>
+              <a:t>✔ อบรมการใช้งานระบบและส่งมอบคู่มือการปฏิบัติงาน</a:t>
+            </a:r>
+          </a:p>
+          <a:p>
+            <a:pPr>
+              <a:spcAft>
+                <a:spcPts val="200"/>
+              </a:spcAft>
+              <a:defRPr sz="950">
+                <a:solidFill>
+                  <a:srgbClr val="64748B"/>
+                </a:solidFill>
+              </a:defRPr>
+            </a:pPr>
+            <a:r>
+              <a:t>✔ รับประกันระบบและบริการ On-site Service ตลอด 1 ปีเต็ม</a:t>
+            </a:r>
+          </a:p>
+          <a:p>
+            <a:pPr>
+              <a:spcBef>
+                <a:spcPts val="800"/>
+              </a:spcBef>
+              <a:defRPr b="1" sz="1000">
                 <a:solidFill>
                   <a:srgbClr val="059669"/>
                 </a:solidFill>
               </a:defRPr>
             </a:pPr>
             <a:r>
-              <a:t>📱 คำอธิบายฟังก์ชันแอปพลิเคชันมือถือ (iOS &amp; Android):</a:t>
-            </a:r>
-          </a:p>
-          <a:p>
-            <a:pPr>
-              <a:spcAft>
-                <a:spcPts val="600"/>
-              </a:spcAft>
-              <a:defRPr sz="1050">
-                <a:solidFill>
-                  <a:srgbClr val="0F172A"/>
-                </a:solidFill>
-              </a:defRPr>
-            </a:pPr>
-            <a:r>
-              <a:t>✔ All Devices Hub (100 จุด): ค้นหาและสลับดูข้อมูลสถานีตรวจวัดคุณภาพน้ำทั้ง 100 จุดได้ง่ายดายในแอปเดียว</a:t>
-            </a:r>
-          </a:p>
-          <a:p>
-            <a:pPr>
-              <a:spcAft>
-                <a:spcPts val="600"/>
-              </a:spcAft>
-              <a:defRPr sz="1050">
-                <a:solidFill>
-                  <a:srgbClr val="0F172A"/>
-                </a:solidFill>
-              </a:defRPr>
-            </a:pPr>
-            <a:r>
-              <a:t>✔ Hero Metric Display: แสดงค่า pH และ คลอรีนคงเหลือ (Cl) ด้วยตัวเลขขนาดใหญ่ สีสันอ่านง่าย รู้ผลทันที</a:t>
-            </a:r>
-          </a:p>
-          <a:p>
-            <a:pPr>
-              <a:spcAft>
-                <a:spcPts val="600"/>
-              </a:spcAft>
-              <a:defRPr sz="1050">
-                <a:solidFill>
-                  <a:srgbClr val="0F172A"/>
-                </a:solidFill>
-              </a:defRPr>
-            </a:pPr>
-            <a:r>
-              <a:t>✔ Ambient &amp; Water Temp: แสดงอุณหภูมิน้ำทั้งหน่วยเซลเซียส (°C) และฟาเรนไฮต์ (°F) พร้อมระบบชดเชยอุณหภูมิ ATC</a:t>
-            </a:r>
-          </a:p>
-          <a:p>
-            <a:pPr>
-              <a:spcAft>
-                <a:spcPts val="600"/>
-              </a:spcAft>
-              <a:defRPr sz="1050">
-                <a:solidFill>
-                  <a:srgbClr val="0F172A"/>
-                </a:solidFill>
-              </a:defRPr>
-            </a:pPr>
-            <a:r>
-              <a:t>✔ Hardware Link &amp; Battery: ตรวจสอบระดับแบตเตอรี่สำรองและสถานะการเชื่อมต่อของทุกตู้ได้จากระยะไกลตลอด 24 ชม.</a:t>
-            </a:r>
-          </a:p>
-          <a:p>
-            <a:pPr>
-              <a:spcAft>
-                <a:spcPts val="600"/>
-              </a:spcAft>
-              <a:defRPr sz="1050">
-                <a:solidFill>
-                  <a:srgbClr val="0F172A"/>
-                </a:solidFill>
-              </a:defRPr>
-            </a:pPr>
-            <a:r>
-              <a:t>✔ Instant Emergency Alerts: ระบบ Push Notification แจ้งเตือนข้อความด่วนเข้ามือถือทันทีเมื่อมีจุดใดผิดปกติ</a:t>
+              <a:t>💰 มูลค่าโครงการรวม (100 ชุด): ฿3,800,000 - ฿4,200,000 บาท</a:t>
+            </a:r>
+            <a:br/>
+            <a:r>
+              <a:t>📈 กำไรขั้นต้นโดยประมาณ: ฿1,700,000 - ฿2,100,000 บาท (Margin ~45-50%)</a:t>
             </a:r>
           </a:p>
         </p:txBody>
@@ -6664,7 +6595,7 @@
               </a:defRPr>
             </a:pPr>
             <a:r>
-              <a:t>💧 สรุปภาพรวมข้อเสนอราคาโครงการตรวจวัดคุณภาพน้ำ 100 ชุด</a:t>
+              <a:t>💧 สรุปภาพรวมข้อเสนอราคาและเงื่อนไขสัญญา (100 ชุด)</a:t>
             </a:r>
           </a:p>
           <a:p>
@@ -6709,19 +6640,19 @@
               </a:defRPr>
             </a:pPr>
             <a:r>
-              <a:t>• รวมต้นทุนต่อชุด: 21,000 บาท (100 ชุด = 2,100,000 บาท)</a:t>
+              <a:t>• รวมต้นทุนฮาร์ดแวร์ต่อชุด: ฿21,000 บาท (100 ชุด = ฿2,100,000 บาท)</a:t>
             </a:r>
             <a:br/>
             <a:r>
-              <a:t>• [แบบที่ 1 Plug &amp; Play]: 29,500 - 32,000 บ./ชุด (รวม 2.95 - 3.20 ล้าน | กำไร 8.5 แสน - 1.1 ล้าน)</a:t>
+              <a:t>• [แบบที่ 1 Plug &amp; Play]: ฿29,500 - ฿32,000 บ./ชุด (รวม ฿2.95M - ฿3.20M | กำไร ฿8.5 แสน - ฿1.1 ล้าน)</a:t>
             </a:r>
             <a:br/>
             <a:r>
-              <a:t>• [แบบที่ 2 Turnkey]: 38,000 - 42,000 บ./ชุด (รวม 3.80 - 4.20 ล้าน | กำไร 1.7 - 2.1 ล้าน)</a:t>
+              <a:t>• [แบบที่ 2 Turnkey]: ฿38,000 - ฿42,000 บ./ชุด (รวม ฿3.80M - ฿4.20M | กำไร ฿1.7 - ฿2.1 ล้าน)</a:t>
             </a:r>
             <a:br/>
             <a:r>
-              <a:t>• ซอฟต์แวร์แดชบอร์ด 100 จุด: ซื้อขาด 2.5 - 6.0 แสน | รายปี 1.2 - 3.6 แสน/ปี (Recurring Income)</a:t>
+              <a:t>• ซอฟต์แวร์แดชบอร์ด 100 จุด: ซื้อขาด ฿2.5 - ฿6.0 แสน | รายปี ฿1.2 - ฿3.6 แสน/ปี (Recurring Income)</a:t>
             </a:r>
           </a:p>
           <a:p>

</xml_diff>

<commit_message>
Embed accurate exact HTML web and mobile UI screenshots in PDF and PPTX
</commit_message>
<xml_diff>
--- a/NCT_Water_Nexus_Report_and_Pricing.pptx
+++ b/NCT_Water_Nexus_Report_and_Pricing.pptx
@@ -3234,7 +3234,7 @@
             </a:r>
             <a:br/>
             <a:r>
-              <a:t>• โครงสร้างราคาและข้อเสนอโครงการ: ตารางราคาและแพ็กเกจโครงการ 100 ชุด (หน้า 7-8)</a:t>
+              <a:t>• โครงสร้างราคาและใบเสนอราคาโครงการ 100 ชุด สรุปไว้ท้ายสุด (สไลด์ 6-8)</a:t>
             </a:r>
           </a:p>
           <a:p>
@@ -4166,14 +4166,14 @@
               </a:defRPr>
             </a:pPr>
             <a:r>
-              <a:t>2. ตัวอย่างหน้าจอ Centralized Web SCADA Dashboard (จอห้องควบคุม 100 จุด)</a:t>
+              <a:t>2. ภาพแคปหน้าจอระบบ Web SCADA Dashboard จริง (index.html)</a:t>
             </a:r>
           </a:p>
         </p:txBody>
       </p:sp>
       <p:pic>
         <p:nvPicPr>
-          <p:cNvPr id="3" name="Picture 2" descr="scada_hd_preview.png"/>
+          <p:cNvPr id="3" name="Picture 2" descr="scada_web_capture.png"/>
           <p:cNvPicPr>
             <a:picLocks noChangeAspect="1"/>
           </p:cNvPicPr>
@@ -4439,14 +4439,14 @@
               </a:defRPr>
             </a:pPr>
             <a:r>
-              <a:t>3. ตัวอย่างหน้าจอมือถือ (Modela Mobile Companion App)</a:t>
+              <a:t>3. ภาพแคปหน้าจอแอปมือถือจริง (Modela Mobile Companion App)</a:t>
             </a:r>
           </a:p>
         </p:txBody>
       </p:sp>
       <p:pic>
         <p:nvPicPr>
-          <p:cNvPr id="3" name="Picture 2" descr="mobile_hd_preview.png"/>
+          <p:cNvPr id="3" name="Picture 2" descr="mobile_app_exact.png"/>
           <p:cNvPicPr>
             <a:picLocks noChangeAspect="1"/>
           </p:cNvPicPr>
@@ -4461,7 +4461,7 @@
         <p:spPr>
           <a:xfrm>
             <a:off x="731520" y="1463040"/>
-            <a:ext cx="2377440" cy="4754880"/>
+            <a:ext cx="2468880" cy="4754880"/>
           </a:xfrm>
           <a:prstGeom prst="rect">
             <a:avLst/>
@@ -4476,8 +4476,8 @@
         </p:nvSpPr>
         <p:spPr>
           <a:xfrm>
-            <a:off x="3383280" y="1463040"/>
-            <a:ext cx="8076895" cy="4754880"/>
+            <a:off x="3474720" y="1463040"/>
+            <a:ext cx="7985455" cy="4754880"/>
           </a:xfrm>
           <a:prstGeom prst="roundRect">
             <a:avLst/>
@@ -4521,8 +4521,8 @@
         </p:nvSpPr>
         <p:spPr>
           <a:xfrm>
-            <a:off x="3657600" y="1645920"/>
-            <a:ext cx="7498079" cy="4389120"/>
+            <a:off x="3749039" y="1645920"/>
+            <a:ext cx="7406640" cy="4389120"/>
           </a:xfrm>
           <a:prstGeom prst="rect">
             <a:avLst/>
@@ -4576,7 +4576,7 @@
               </a:defRPr>
             </a:pPr>
             <a:r>
-              <a:t>✔ Hero Metric Display: แสดงค่า pH และ คลอรีนคงเหลือ (Cl) ด้วยตัวเลขขนาดใหญ่ สีสันอ่านง่าย รู้ผลทันที</a:t>
+              <a:t>✔ Hero Metric Display: แสดงค่า pH (7.29) และ คลอรีนคงเหลือ (0.85 mg/L) ตัวเลขขนาดใหญ่ อ่านค่าง่ายทันที</a:t>
             </a:r>
           </a:p>
           <a:p>
@@ -4591,7 +4591,7 @@
               </a:defRPr>
             </a:pPr>
             <a:r>
-              <a:t>✔ Ambient &amp; Water Temp: แสดงอุณหภูมิน้ำทั้งหน่วยเซลเซียส (°C) และฟาเรนไฮต์ (°F) พร้อมระบบชดเชยอุณหภูมิ ATC</a:t>
+              <a:t>✔ Sub-Metrics Display: แสดงค่าสารละลาย TDS (210 ppm) และค่าโออาร์พี ORP REDOX (725 mV)</a:t>
             </a:r>
           </a:p>
           <a:p>
@@ -4606,7 +4606,7 @@
               </a:defRPr>
             </a:pPr>
             <a:r>
-              <a:t>✔ Hardware Link &amp; Battery: ตรวจสอบระดับแบตเตอรี่สำรองและสถานะการเชื่อมต่อของทุกตู้ได้จากระยะไกลตลอด 24 ชม.</a:t>
+              <a:t>✔ Ambient &amp; Water Temp: แสดงอุณหภูมิน้ำทั้งหน่วยเซลเซียส (17.3°C) และฟาเรนไฮต์ (63.1°F) พร้อมระบบชดเชย ATC</a:t>
             </a:r>
           </a:p>
           <a:p>
@@ -4621,7 +4621,7 @@
               </a:defRPr>
             </a:pPr>
             <a:r>
-              <a:t>✔ Instant Emergency Alerts: ระบบ Push Notification แจ้งเตือนข้อความด่วนเข้ามือถือทันทีเมื่อมีจุดใดผิดปกติ</a:t>
+              <a:t>✔ Hardware Link &amp; Battery: ตรวจสอบระดับแบตเตอรี่สำรอง (90%) และสถานะการเชื่อมต่อ 5G/4G ได้ตลอด 24 ชม.</a:t>
             </a:r>
           </a:p>
         </p:txBody>

</xml_diff>

<commit_message>
Add 4 real mobile screen tabs (Home, History, Devices 100, Calib) to PDF report, PPTX, and online deck
</commit_message>
<xml_diff>
--- a/NCT_Water_Nexus_Report_and_Pricing.pptx
+++ b/NCT_Water_Nexus_Report_and_Pricing.pptx
@@ -3230,7 +3230,7 @@
             </a:r>
             <a:br/>
             <a:r>
-              <a:t>• ระบบแดชบอร์ดคู่ขนาน: Centralized Web SCADA (จอใหญ่ห้องควบคุม) + Modela Mobile App</a:t>
+              <a:t>• ระบบแดชบอร์ดคู่ขนาน: Centralized Web SCADA (จอใหญ่ห้องควบคุม) + Modela Mobile App (5 หน้าเมนู)</a:t>
             </a:r>
             <a:br/>
             <a:r>
@@ -4173,7 +4173,7 @@
       </p:sp>
       <p:pic>
         <p:nvPicPr>
-          <p:cNvPr id="3" name="Picture 2" descr="scada_web_capture.png"/>
+          <p:cNvPr id="3" name="Picture 2" descr="scada_perfect.png"/>
           <p:cNvPicPr>
             <a:picLocks noChangeAspect="1"/>
           </p:cNvPicPr>
@@ -4439,14 +4439,59 @@
               </a:defRPr>
             </a:pPr>
             <a:r>
-              <a:t>3. ภาพแคปหน้าจอแอปมือถือจริง (Modela Mobile Companion App)</a:t>
-            </a:r>
+              <a:t>3. ภาพแคปหน้าจอแอปมือถือจริงครบทุกแท็บเมนู (Modela Mobile Multi-Screen)</a:t>
+            </a:r>
+          </a:p>
+        </p:txBody>
+      </p:sp>
+      <p:sp>
+        <p:nvSpPr>
+          <p:cNvPr id="3" name="Rounded Rectangle 2"/>
+          <p:cNvSpPr/>
+          <p:nvPr/>
+        </p:nvSpPr>
+        <p:spPr>
+          <a:xfrm>
+            <a:off x="731520" y="1463040"/>
+            <a:ext cx="2468880" cy="4754880"/>
+          </a:xfrm>
+          <a:prstGeom prst="roundRect">
+            <a:avLst/>
+          </a:prstGeom>
+          <a:solidFill>
+            <a:srgbClr val="FFFFFF"/>
+          </a:solidFill>
+          <a:ln w="19050">
+            <a:solidFill>
+              <a:srgbClr val="0284C7"/>
+            </a:solidFill>
+          </a:ln>
+        </p:spPr>
+        <p:style>
+          <a:lnRef idx="1">
+            <a:schemeClr val="accent1"/>
+          </a:lnRef>
+          <a:fillRef idx="3">
+            <a:schemeClr val="accent1"/>
+          </a:fillRef>
+          <a:effectRef idx="2">
+            <a:schemeClr val="accent1"/>
+          </a:effectRef>
+          <a:fontRef idx="minor">
+            <a:schemeClr val="lt1"/>
+          </a:fontRef>
+        </p:style>
+        <p:txBody>
+          <a:bodyPr rtlCol="0" anchor="ctr"/>
+          <a:lstStyle/>
+          <a:p>
+            <a:pPr algn="ctr"/>
           </a:p>
         </p:txBody>
       </p:sp>
       <p:pic>
         <p:nvPicPr>
-          <p:cNvPr id="3" name="Picture 2" descr="mobile_app_exact.png"/>
+          <p:cNvPr id="4" name="Picture 3" descr="mob_screen_1_home.png"/>
           <p:cNvPicPr>
             <a:picLocks noChangeAspect="1"/>
           </p:cNvPicPr>
@@ -4460,8 +4505,8 @@
         </p:blipFill>
         <p:spPr>
           <a:xfrm>
-            <a:off x="731520" y="1463040"/>
-            <a:ext cx="2468880" cy="4754880"/>
+            <a:off x="868680" y="1600200"/>
+            <a:ext cx="2194560" cy="3749039"/>
           </a:xfrm>
           <a:prstGeom prst="rect">
             <a:avLst/>
@@ -4470,14 +4515,61 @@
       </p:pic>
       <p:sp>
         <p:nvSpPr>
-          <p:cNvPr id="4" name="Rounded Rectangle 3"/>
+          <p:cNvPr id="5" name="TextBox 4"/>
+          <p:cNvSpPr txBox="1"/>
+          <p:nvPr/>
+        </p:nvSpPr>
+        <p:spPr>
+          <a:xfrm>
+            <a:off x="822960" y="5440680"/>
+            <a:ext cx="2286000" cy="685800"/>
+          </a:xfrm>
+          <a:prstGeom prst="rect">
+            <a:avLst/>
+          </a:prstGeom>
+          <a:noFill/>
+        </p:spPr>
+        <p:txBody>
+          <a:bodyPr wrap="square">
+            <a:spAutoFit/>
+          </a:bodyPr>
+          <a:lstStyle/>
+          <a:p>
+            <a:pPr algn="ctr">
+              <a:defRPr sz="950" b="1">
+                <a:solidFill>
+                  <a:srgbClr val="0F172A"/>
+                </a:solidFill>
+              </a:defRPr>
+            </a:pPr>
+            <a:r>
+              <a:t>1. หน้าแดชบอร์ดหลัก (Home)</a:t>
+            </a:r>
+          </a:p>
+          <a:p>
+            <a:pPr algn="ctr">
+              <a:defRPr sz="780">
+                <a:solidFill>
+                  <a:srgbClr val="64748B"/>
+                </a:solidFill>
+              </a:defRPr>
+            </a:pPr>
+            <a:r>
+              <a:t>Hero pH, Cl, Temp, TDS, Battery</a:t>
+            </a:r>
+          </a:p>
+        </p:txBody>
+      </p:sp>
+      <p:sp>
+        <p:nvSpPr>
+          <p:cNvPr id="6" name="Rounded Rectangle 5"/>
           <p:cNvSpPr/>
           <p:nvPr/>
         </p:nvSpPr>
         <p:spPr>
           <a:xfrm>
             <a:off x="3474720" y="1463040"/>
-            <a:ext cx="7985455" cy="4754880"/>
+            <a:ext cx="2468880" cy="4754880"/>
           </a:xfrm>
           <a:prstGeom prst="roundRect">
             <a:avLst/>
@@ -4487,7 +4579,7 @@
           </a:solidFill>
           <a:ln w="19050">
             <a:solidFill>
-              <a:srgbClr val="059669"/>
+              <a:srgbClr val="0284C7"/>
             </a:solidFill>
           </a:ln>
         </p:spPr>
@@ -4513,16 +4605,40 @@
           </a:p>
         </p:txBody>
       </p:sp>
-      <p:sp>
-        <p:nvSpPr>
-          <p:cNvPr id="5" name="TextBox 4"/>
+      <p:pic>
+        <p:nvPicPr>
+          <p:cNvPr id="7" name="Picture 6" descr="mob_screen_2_history.png"/>
+          <p:cNvPicPr>
+            <a:picLocks noChangeAspect="1"/>
+          </p:cNvPicPr>
+          <p:nvPr/>
+        </p:nvPicPr>
+        <p:blipFill>
+          <a:blip r:embed="rId3"/>
+          <a:stretch>
+            <a:fillRect/>
+          </a:stretch>
+        </p:blipFill>
+        <p:spPr>
+          <a:xfrm>
+            <a:off x="3611880" y="1600200"/>
+            <a:ext cx="2194560" cy="3749039"/>
+          </a:xfrm>
+          <a:prstGeom prst="rect">
+            <a:avLst/>
+          </a:prstGeom>
+        </p:spPr>
+      </p:pic>
+      <p:sp>
+        <p:nvSpPr>
+          <p:cNvPr id="8" name="TextBox 7"/>
           <p:cNvSpPr txBox="1"/>
           <p:nvPr/>
         </p:nvSpPr>
         <p:spPr>
           <a:xfrm>
-            <a:off x="3749039" y="1645920"/>
-            <a:ext cx="7406640" cy="4389120"/>
+            <a:off x="3566160" y="5440680"/>
+            <a:ext cx="2286000" cy="685800"/>
           </a:xfrm>
           <a:prstGeom prst="rect">
             <a:avLst/>
@@ -4535,93 +4651,259 @@
           </a:bodyPr>
           <a:lstStyle/>
           <a:p>
-            <a:pPr>
-              <a:spcAft>
-                <a:spcPts val="1000"/>
-              </a:spcAft>
-              <a:defRPr sz="1300" b="1">
-                <a:solidFill>
-                  <a:srgbClr val="059669"/>
-                </a:solidFill>
-              </a:defRPr>
-            </a:pPr>
-            <a:r>
-              <a:t>📱 คำอธิบายฟังก์ชันแอปพลิเคชันมือถือ (iOS &amp; Android):</a:t>
-            </a:r>
-          </a:p>
-          <a:p>
-            <a:pPr>
-              <a:spcAft>
-                <a:spcPts val="600"/>
-              </a:spcAft>
-              <a:defRPr sz="1050">
+            <a:pPr algn="ctr">
+              <a:defRPr sz="950" b="1">
                 <a:solidFill>
                   <a:srgbClr val="0F172A"/>
                 </a:solidFill>
               </a:defRPr>
             </a:pPr>
             <a:r>
-              <a:t>✔ All Devices Hub (100 จุด): ค้นหาและสลับดูข้อมูลสถานีตรวจวัดคุณภาพน้ำทั้ง 100 จุดได้ง่ายดายในแอปเดียว</a:t>
-            </a:r>
-          </a:p>
-          <a:p>
-            <a:pPr>
-              <a:spcAft>
-                <a:spcPts val="600"/>
-              </a:spcAft>
-              <a:defRPr sz="1050">
+              <a:t>2. กราฟย้อนหลัง (History)</a:t>
+            </a:r>
+          </a:p>
+          <a:p>
+            <a:pPr algn="ctr">
+              <a:defRPr sz="780">
+                <a:solidFill>
+                  <a:srgbClr val="64748B"/>
+                </a:solidFill>
+              </a:defRPr>
+            </a:pPr>
+            <a:r>
+              <a:t>กราฟแนวโน้มสด &amp; ตารางสถิติ Avg</a:t>
+            </a:r>
+          </a:p>
+        </p:txBody>
+      </p:sp>
+      <p:sp>
+        <p:nvSpPr>
+          <p:cNvPr id="9" name="Rounded Rectangle 8"/>
+          <p:cNvSpPr/>
+          <p:nvPr/>
+        </p:nvSpPr>
+        <p:spPr>
+          <a:xfrm>
+            <a:off x="6217920" y="1463040"/>
+            <a:ext cx="2468880" cy="4754880"/>
+          </a:xfrm>
+          <a:prstGeom prst="roundRect">
+            <a:avLst/>
+          </a:prstGeom>
+          <a:solidFill>
+            <a:srgbClr val="FFFFFF"/>
+          </a:solidFill>
+          <a:ln w="19050">
+            <a:solidFill>
+              <a:srgbClr val="0284C7"/>
+            </a:solidFill>
+          </a:ln>
+        </p:spPr>
+        <p:style>
+          <a:lnRef idx="1">
+            <a:schemeClr val="accent1"/>
+          </a:lnRef>
+          <a:fillRef idx="3">
+            <a:schemeClr val="accent1"/>
+          </a:fillRef>
+          <a:effectRef idx="2">
+            <a:schemeClr val="accent1"/>
+          </a:effectRef>
+          <a:fontRef idx="minor">
+            <a:schemeClr val="lt1"/>
+          </a:fontRef>
+        </p:style>
+        <p:txBody>
+          <a:bodyPr rtlCol="0" anchor="ctr"/>
+          <a:lstStyle/>
+          <a:p>
+            <a:pPr algn="ctr"/>
+          </a:p>
+        </p:txBody>
+      </p:sp>
+      <p:pic>
+        <p:nvPicPr>
+          <p:cNvPr id="10" name="Picture 9" descr="mob_screen_3_devices.png"/>
+          <p:cNvPicPr>
+            <a:picLocks noChangeAspect="1"/>
+          </p:cNvPicPr>
+          <p:nvPr/>
+        </p:nvPicPr>
+        <p:blipFill>
+          <a:blip r:embed="rId4"/>
+          <a:stretch>
+            <a:fillRect/>
+          </a:stretch>
+        </p:blipFill>
+        <p:spPr>
+          <a:xfrm>
+            <a:off x="6355080" y="1600200"/>
+            <a:ext cx="2194560" cy="3749039"/>
+          </a:xfrm>
+          <a:prstGeom prst="rect">
+            <a:avLst/>
+          </a:prstGeom>
+        </p:spPr>
+      </p:pic>
+      <p:sp>
+        <p:nvSpPr>
+          <p:cNvPr id="11" name="TextBox 10"/>
+          <p:cNvSpPr txBox="1"/>
+          <p:nvPr/>
+        </p:nvSpPr>
+        <p:spPr>
+          <a:xfrm>
+            <a:off x="6309360" y="5440680"/>
+            <a:ext cx="2286000" cy="685800"/>
+          </a:xfrm>
+          <a:prstGeom prst="rect">
+            <a:avLst/>
+          </a:prstGeom>
+          <a:noFill/>
+        </p:spPr>
+        <p:txBody>
+          <a:bodyPr wrap="square">
+            <a:spAutoFit/>
+          </a:bodyPr>
+          <a:lstStyle/>
+          <a:p>
+            <a:pPr algn="ctr">
+              <a:defRPr sz="950" b="1">
                 <a:solidFill>
                   <a:srgbClr val="0F172A"/>
                 </a:solidFill>
               </a:defRPr>
             </a:pPr>
             <a:r>
-              <a:t>✔ Hero Metric Display: แสดงค่า pH (7.29) และ คลอรีนคงเหลือ (0.85 mg/L) ตัวเลขขนาดใหญ่ อ่านค่าง่ายทันที</a:t>
-            </a:r>
-          </a:p>
-          <a:p>
-            <a:pPr>
-              <a:spcAft>
-                <a:spcPts val="600"/>
-              </a:spcAft>
-              <a:defRPr sz="1050">
+              <a:t>3. รวม 100 สถานี (Devices)</a:t>
+            </a:r>
+          </a:p>
+          <a:p>
+            <a:pPr algn="ctr">
+              <a:defRPr sz="780">
+                <a:solidFill>
+                  <a:srgbClr val="64748B"/>
+                </a:solidFill>
+              </a:defRPr>
+            </a:pPr>
+            <a:r>
+              <a:t>สลับดูสถานี #01 ถึง #100 Online/Alert</a:t>
+            </a:r>
+          </a:p>
+        </p:txBody>
+      </p:sp>
+      <p:sp>
+        <p:nvSpPr>
+          <p:cNvPr id="12" name="Rounded Rectangle 11"/>
+          <p:cNvSpPr/>
+          <p:nvPr/>
+        </p:nvSpPr>
+        <p:spPr>
+          <a:xfrm>
+            <a:off x="8961120" y="1463040"/>
+            <a:ext cx="2468880" cy="4754880"/>
+          </a:xfrm>
+          <a:prstGeom prst="roundRect">
+            <a:avLst/>
+          </a:prstGeom>
+          <a:solidFill>
+            <a:srgbClr val="FFFFFF"/>
+          </a:solidFill>
+          <a:ln w="19050">
+            <a:solidFill>
+              <a:srgbClr val="0284C7"/>
+            </a:solidFill>
+          </a:ln>
+        </p:spPr>
+        <p:style>
+          <a:lnRef idx="1">
+            <a:schemeClr val="accent1"/>
+          </a:lnRef>
+          <a:fillRef idx="3">
+            <a:schemeClr val="accent1"/>
+          </a:fillRef>
+          <a:effectRef idx="2">
+            <a:schemeClr val="accent1"/>
+          </a:effectRef>
+          <a:fontRef idx="minor">
+            <a:schemeClr val="lt1"/>
+          </a:fontRef>
+        </p:style>
+        <p:txBody>
+          <a:bodyPr rtlCol="0" anchor="ctr"/>
+          <a:lstStyle/>
+          <a:p>
+            <a:pPr algn="ctr"/>
+          </a:p>
+        </p:txBody>
+      </p:sp>
+      <p:pic>
+        <p:nvPicPr>
+          <p:cNvPr id="13" name="Picture 12" descr="mob_screen_4_calib.png"/>
+          <p:cNvPicPr>
+            <a:picLocks noChangeAspect="1"/>
+          </p:cNvPicPr>
+          <p:nvPr/>
+        </p:nvPicPr>
+        <p:blipFill>
+          <a:blip r:embed="rId5"/>
+          <a:stretch>
+            <a:fillRect/>
+          </a:stretch>
+        </p:blipFill>
+        <p:spPr>
+          <a:xfrm>
+            <a:off x="9098280" y="1600200"/>
+            <a:ext cx="2194560" cy="3749039"/>
+          </a:xfrm>
+          <a:prstGeom prst="rect">
+            <a:avLst/>
+          </a:prstGeom>
+        </p:spPr>
+      </p:pic>
+      <p:sp>
+        <p:nvSpPr>
+          <p:cNvPr id="14" name="TextBox 13"/>
+          <p:cNvSpPr txBox="1"/>
+          <p:nvPr/>
+        </p:nvSpPr>
+        <p:spPr>
+          <a:xfrm>
+            <a:off x="9052560" y="5440680"/>
+            <a:ext cx="2286000" cy="685800"/>
+          </a:xfrm>
+          <a:prstGeom prst="rect">
+            <a:avLst/>
+          </a:prstGeom>
+          <a:noFill/>
+        </p:spPr>
+        <p:txBody>
+          <a:bodyPr wrap="square">
+            <a:spAutoFit/>
+          </a:bodyPr>
+          <a:lstStyle/>
+          <a:p>
+            <a:pPr algn="ctr">
+              <a:defRPr sz="950" b="1">
                 <a:solidFill>
                   <a:srgbClr val="0F172A"/>
                 </a:solidFill>
               </a:defRPr>
             </a:pPr>
             <a:r>
-              <a:t>✔ Sub-Metrics Display: แสดงค่าสารละลาย TDS (210 ppm) และค่าโออาร์พี ORP REDOX (725 mV)</a:t>
-            </a:r>
-          </a:p>
-          <a:p>
-            <a:pPr>
-              <a:spcAft>
-                <a:spcPts val="600"/>
-              </a:spcAft>
-              <a:defRPr sz="1050">
-                <a:solidFill>
-                  <a:srgbClr val="0F172A"/>
-                </a:solidFill>
-              </a:defRPr>
-            </a:pPr>
-            <a:r>
-              <a:t>✔ Ambient &amp; Water Temp: แสดงอุณหภูมิน้ำทั้งหน่วยเซลเซียส (17.3°C) และฟาเรนไฮต์ (63.1°F) พร้อมระบบชดเชย ATC</a:t>
-            </a:r>
-          </a:p>
-          <a:p>
-            <a:pPr>
-              <a:spcAft>
-                <a:spcPts val="600"/>
-              </a:spcAft>
-              <a:defRPr sz="1050">
-                <a:solidFill>
-                  <a:srgbClr val="0F172A"/>
-                </a:solidFill>
-              </a:defRPr>
-            </a:pPr>
-            <a:r>
-              <a:t>✔ Hardware Link &amp; Battery: ตรวจสอบระดับแบตเตอรี่สำรอง (90%) และสถานะการเชื่อมต่อ 5G/4G ได้ตลอด 24 ชม.</a:t>
+              <a:t>4. สอบเทียบหัววัด (Calib)</a:t>
+            </a:r>
+          </a:p>
+          <a:p>
+            <a:pPr algn="ctr">
+              <a:defRPr sz="780">
+                <a:solidFill>
+                  <a:srgbClr val="64748B"/>
+                </a:solidFill>
+              </a:defRPr>
+            </a:pPr>
+            <a:r>
+              <a:t>pH 7.00, pH 4.01, TDS &amp; Cl Zero</a:t>
             </a:r>
           </a:p>
         </p:txBody>

</xml_diff>

<commit_message>
Set main quotation price to non-installation (฿31,500/set | ฿3.15M) and remove SCADA completely
</commit_message>
<xml_diff>
--- a/NCT_Water_Nexus_Report_and_Pricing.pptx
+++ b/NCT_Water_Nexus_Report_and_Pricing.pptx
@@ -3211,7 +3211,7 @@
               </a:defRPr>
             </a:pPr>
             <a:r>
-              <a:t>รายงานนำเสนอโซลูชันระบบตรวจวัดคุณภาพน้ำ แดชบอร์ด SCADA และโครงสร้างราคา (100 ชุด)</a:t>
+              <a:t>รายงานนำเสนอโซลูชันระบบตรวจวัดคุณภาพน้ำ แดชบอร์ดควบคุม และใบเสนอราคาทางการ (100 ชุด)</a:t>
             </a:r>
           </a:p>
           <a:p>
@@ -3230,11 +3230,11 @@
             </a:r>
             <a:br/>
             <a:r>
-              <a:t>• ระบบแดชบอร์ดคู่ขนาน: Centralized Web SCADA (จอใหญ่ห้องควบคุม) + Modela Mobile App (5 หน้าเมนู)</a:t>
+              <a:t>• ระบบแดชบอร์ดคู่ขนาน: Centralized Web Dashboard (จอใหญ่ห้องควบคุม) + Modela Mobile App (5 หน้าเมนู)</a:t>
             </a:r>
             <a:br/>
             <a:r>
-              <a:t>• โครงสร้างราคาและใบเสนอราคาโครงการ 100 ชุด สรุปไว้ท้ายสุด (สไลด์ 6-8)</a:t>
+              <a:t>• ข้อเสนอราคาโครงการ 100 ชุด (ไม่รวมติดตั้ง): ฿31,500 / ชุด (มูลค่ารวม ฿3,150,000 บาท) สรุปไว้ท้ายสุด (สไลด์ 6-8)</a:t>
             </a:r>
           </a:p>
           <a:p>
@@ -4166,7 +4166,7 @@
               </a:defRPr>
             </a:pPr>
             <a:r>
-              <a:t>2. ภาพแคปหน้าจอระบบ Web SCADA Dashboard จริง (index.html)</a:t>
+              <a:t>2. ภาพแคปหน้าจอระบบ Centralized Web Dashboard จริง (index.html)</a:t>
             </a:r>
           </a:p>
         </p:txBody>
@@ -4273,7 +4273,7 @@
               </a:defRPr>
             </a:pPr>
             <a:r>
-              <a:t>💻 คำอธิบายฟังก์ชันหน้าจอ SCADA:</a:t>
+              <a:t>💻 คำอธิบายฟังก์ชันหน้าจอ Web Dashboard:</a:t>
             </a:r>
           </a:p>
           <a:p>
@@ -5125,7 +5125,7 @@
               </a:defRPr>
             </a:pPr>
             <a:r>
-              <a:t>✔ จุดเด่น: ส่งฟรี 100% ไม่มีค่า Broadcast รายเดือน กำไรเต็มเม็ดเต็มหน่วย</a:t>
+              <a:t>✔ จุดเด่น: ส่งฟรี 100% ไม่มีค่า Broadcast รายเดือน ประหยัดงบประมาณสูงสุด</a:t>
             </a:r>
           </a:p>
         </p:txBody>
@@ -5208,7 +5208,7 @@
               </a:defRPr>
             </a:pPr>
             <a:r>
-              <a:t>💬 รูปแบบ LINE OA Alert (การ์ดสถานะยอดนิยม)</a:t>
+              <a:t>💬 รูปแบบ LINE OA Alert (การ์ดสถานะในกลุ่มไลน์)</a:t>
             </a:r>
           </a:p>
           <a:p>
@@ -5267,7 +5267,7 @@
               </a:defRPr>
             </a:pPr>
             <a:r>
-              <a:t>✔ จุดเด่น: ใช้งานง่ายในกลุ่มไลน์ผู้บริหาร (+฿1,500/จุด เพื่อซับพอร์ตค่า Broadcast LINE)</a:t>
+              <a:t>✔ จุดเด่น: แจ้งเตือนเป็นการ์ดสถานะในกลุ่ม LINE สะดวกสำหรับผู้บริหาร</a:t>
             </a:r>
           </a:p>
         </p:txBody>
@@ -5343,7 +5343,7 @@
               </a:defRPr>
             </a:pPr>
             <a:r>
-              <a:t>5. ตารางต้นทุนฮาร์ดแวร์และอุปกรณ์ต่อชุด (Hardware BOM per Unit)</a:t>
+              <a:t>5. รายการอุปกรณ์ฮาร์ดแวร์ตู้คอนโทรลมาตรฐาน 4 ค่า (Hardware Specs)</a:t>
             </a:r>
           </a:p>
         </p:txBody>
@@ -5466,19 +5466,19 @@
               </a:defRPr>
             </a:pPr>
             <a:r>
-              <a:t>ชุดเซนเซอร์หลัก (Modela One + pH/TDS/Temp + คลอรีน Cybertice)</a:t>
-            </a:r>
-          </a:p>
-          <a:p>
-            <a:pPr>
-              <a:defRPr sz="1500" b="1">
+              <a:t>ชุดเซนเซอร์หลัก (Modela One + 4 ค่า)</a:t>
+            </a:r>
+          </a:p>
+          <a:p>
+            <a:pPr>
+              <a:defRPr sz="1400" b="1">
                 <a:solidFill>
                   <a:srgbClr val="FFFFFF"/>
                 </a:solidFill>
               </a:defRPr>
             </a:pPr>
             <a:r>
-              <a:t>฿17,000</a:t>
+              <a:t>Modbus RTU</a:t>
             </a:r>
           </a:p>
         </p:txBody>
@@ -5513,7 +5513,7 @@
               </a:defRPr>
             </a:pPr>
             <a:r>
-              <a:t>• บอร์ดควบคุมหลัก Modela One (Modbus RTU/RS-485)</a:t>
+              <a:t>• บอร์ดควบคุมหลัก Modela One (RS-485)</a:t>
             </a:r>
             <a:br/>
             <a:r>
@@ -5521,15 +5521,15 @@
             </a:r>
             <a:br/>
             <a:r>
-              <a:t>• หัววัด TDS / EC Titanium Dual-Pole</a:t>
+              <a:t>• หัววัด TDS Titanium Dual-Pole</a:t>
             </a:r>
             <a:br/>
             <a:r>
-              <a:t>• หัววัดอุณหภูมิ PT1000 (พร้อม ATC ชดเชยอุณหภูมิ)</a:t>
+              <a:t>• หัววัดอุณหภูมิ PT1000 RTD (ATC)</a:t>
             </a:r>
             <a:br/>
             <a:r>
-              <a:t>• เซนเซอร์คลอรีนคงเหลือ Cybertice (Residual Chlorine)</a:t>
+              <a:t>• เซนเซอร์คลอรีนคงเหลือ Cybertice</a:t>
             </a:r>
           </a:p>
         </p:txBody>
@@ -5657,14 +5657,14 @@
           </a:p>
           <a:p>
             <a:pPr>
-              <a:defRPr sz="1500" b="1">
+              <a:defRPr sz="1400" b="1">
                 <a:solidFill>
                   <a:srgbClr val="FFFFFF"/>
                 </a:solidFill>
               </a:defRPr>
             </a:pPr>
             <a:r>
-              <a:t>฿1,000</a:t>
+              <a:t>300 Mbps Wi-Fi</a:t>
             </a:r>
           </a:p>
         </p:txBody>
@@ -5830,19 +5830,19 @@
               </a:defRPr>
             </a:pPr>
             <a:r>
-              <a:t>ซิมการ์ด 4G รายปี (Unlimited 15-20 Mbps)</a:t>
-            </a:r>
-          </a:p>
-          <a:p>
-            <a:pPr>
-              <a:defRPr sz="1500" b="1">
+              <a:t>ซิมการ์ด 4G รายปี (Unlimited)</a:t>
+            </a:r>
+          </a:p>
+          <a:p>
+            <a:pPr>
+              <a:defRPr sz="1400" b="1">
                 <a:solidFill>
                   <a:srgbClr val="FFFFFF"/>
                 </a:solidFill>
               </a:defRPr>
             </a:pPr>
             <a:r>
-              <a:t>฿1,800</a:t>
+              <a:t>15-20 Mbps</a:t>
             </a:r>
           </a:p>
         </p:txBody>
@@ -5877,7 +5877,7 @@
               </a:defRPr>
             </a:pPr>
             <a:r>
-              <a:t>• ซิมเน็ต IoT รายปี ไม่อั้น ไม่ลดสปีด (15-20 Mbps)</a:t>
+              <a:t>• ซิมเน็ต IoT รายปี ไม่อั้น ไม่ลดสปีด</a:t>
             </a:r>
             <a:br/>
             <a:r>
@@ -5885,7 +5885,7 @@
             </a:r>
             <a:br/>
             <a:r>
-              <a:t>• ส่งข้อมูลขึ้นระบบคลาวด์และแจ้งเตือน 24 ชม.</a:t>
+              <a:t>• ส่งข้อมูลขึ้นระบบคลาวด์ตลอด 24 ชม.</a:t>
             </a:r>
           </a:p>
         </p:txBody>
@@ -6008,19 +6008,19 @@
               </a:defRPr>
             </a:pPr>
             <a:r>
-              <a:t>ตู้คอนโทรล IP65 + Switching 24V + Breaker + Wiring</a:t>
-            </a:r>
-          </a:p>
-          <a:p>
-            <a:pPr>
-              <a:defRPr sz="1500" b="1">
+              <a:t>ตู้คอนโทรล IP65 + Switching 24V</a:t>
+            </a:r>
+          </a:p>
+          <a:p>
+            <a:pPr>
+              <a:defRPr sz="1400" b="1">
                 <a:solidFill>
                   <a:srgbClr val="FFFFFF"/>
                 </a:solidFill>
               </a:defRPr>
             </a:pPr>
             <a:r>
-              <a:t>฿1,200</a:t>
+              <a:t>IP65 Waterproof</a:t>
             </a:r>
           </a:p>
         </p:txBody>
@@ -6063,7 +6063,7 @@
             </a:r>
             <a:br/>
             <a:r>
-              <a:t>• Breaker ป้องกันไฟเกิน + Terminal + สายไฟประกอบครบ</a:t>
+              <a:t>• Breaker ป้องกันไฟเกิน + Terminal + Wiring ครบ</a:t>
             </a:r>
           </a:p>
         </p:txBody>
@@ -6139,14 +6139,14 @@
               <a:spcAft>
                 <a:spcPts val="400"/>
               </a:spcAft>
-              <a:defRPr sz="1600" b="1">
+              <a:defRPr sz="1500" b="1">
                 <a:solidFill>
                   <a:srgbClr val="2DD4BF"/>
                 </a:solidFill>
               </a:defRPr>
             </a:pPr>
             <a:r>
-              <a:t>➡️ รวมต้นทุนต่อชุด: ฿21,000 บาท  |  รวมต้นทุนโครงการ (100 ชุด): ฿2,100,000 บาท</a:t>
+              <a:t>➡️ มาตรฐานชุดอุปกรณ์: สำเร็จรูปพร้อมติดตั้ง 100 จุด สื่อสาร 4G LTE และ Cloud Dashboard ครบวงจร</a:t>
             </a:r>
           </a:p>
           <a:p>
@@ -6158,7 +6158,7 @@
               </a:defRPr>
             </a:pPr>
             <a:r>
-              <a:t>ต้นทุนนี้ครอบคลุมชุดหัววัดเซนเซอร์ 4 ค่า (pH / TDS / Temp / Cl) + กล่อง Modela One + เราเตอร์ 4G TP-Link + ซิมรายปี + ตู้ IP65 ประกอบสำเร็จพร้อมใช้งาน</a:t>
+              <a:t>ชุดอุปกรณ์ประกอบสำเร็จรูป ตรวจสอบระบบไฟฟ้า และทดสอบสัญญาณเชื่อมต่อออนไลน์ 100% ก่อนส่งมอบหน้างาน</a:t>
             </a:r>
           </a:p>
         </p:txBody>
@@ -6234,7 +6234,7 @@
               </a:defRPr>
             </a:pPr>
             <a:r>
-              <a:t>6. โครงสร้างราคาขายแนะนำ (แพ็กเกจโครงการ 100 ชุด)</a:t>
+              <a:t>6. โครงสร้างราคาขายทางการ (ไม่รวมติดตั้งหน้างาน - 100 ชุด)</a:t>
             </a:r>
           </a:p>
         </p:txBody>
@@ -6248,7 +6248,7 @@
         <p:spPr>
           <a:xfrm>
             <a:off x="731520" y="1463040"/>
-            <a:ext cx="5120640" cy="4754880"/>
+            <a:ext cx="6949440" cy="4754880"/>
           </a:xfrm>
           <a:prstGeom prst="roundRect">
             <a:avLst/>
@@ -6293,7 +6293,7 @@
         <p:spPr>
           <a:xfrm>
             <a:off x="731520" y="1463040"/>
-            <a:ext cx="5120640" cy="1188720"/>
+            <a:ext cx="6949440" cy="1188720"/>
           </a:xfrm>
           <a:prstGeom prst="roundRect">
             <a:avLst/>
@@ -6335,8 +6335,8 @@
         </p:nvSpPr>
         <p:spPr>
           <a:xfrm>
-            <a:off x="914400" y="1554480"/>
-            <a:ext cx="4754880" cy="1005840"/>
+            <a:off x="1005840" y="1554480"/>
+            <a:ext cx="6400800" cy="1005840"/>
           </a:xfrm>
           <a:prstGeom prst="rect">
             <a:avLst/>
@@ -6350,14 +6350,14 @@
           <a:lstStyle/>
           <a:p>
             <a:pPr>
-              <a:defRPr sz="1300" b="1">
+              <a:defRPr sz="1400" b="1">
                 <a:solidFill>
                   <a:srgbClr val="FFFFFF"/>
                 </a:solidFill>
               </a:defRPr>
             </a:pPr>
             <a:r>
-              <a:t>[แบบที่ 1] ส่งมอบอุปกรณ์พร้อมระบบออนไลน์</a:t>
+              <a:t>ชุดอุปกรณ์ตรวจวัดคุณภาพน้ำสำเร็จรูปพร้อมออนไลน์ (ไม่รวมติดตั้ง)</a:t>
             </a:r>
           </a:p>
           <a:p>
@@ -6369,7 +6369,7 @@
               </a:defRPr>
             </a:pPr>
             <a:r>
-              <a:t>Plug &amp; Play / Supply Only (ราคา ฿29,500 - ฿32,000 / ชุด)</a:t>
+              <a:t>Plug &amp; Play / Supply Only (ราคา ฿31,500 บาท / ชุด)</a:t>
             </a:r>
           </a:p>
         </p:txBody>
@@ -6382,8 +6382,8 @@
         </p:nvSpPr>
         <p:spPr>
           <a:xfrm>
-            <a:off x="914400" y="2743200"/>
-            <a:ext cx="4754880" cy="3383280"/>
+            <a:off x="1005840" y="2743200"/>
+            <a:ext cx="6400800" cy="3383280"/>
           </a:xfrm>
           <a:prstGeom prst="rect">
             <a:avLst/>
@@ -6407,7 +6407,7 @@
               </a:defRPr>
             </a:pPr>
             <a:r>
-              <a:t>📋 ขอบเขตงาน (Scope of Work):</a:t>
+              <a:t>📋 ขอบเขตงานและรายการส่งมอบ (Scope of Deliverables):</a:t>
             </a:r>
           </a:p>
           <a:p>
@@ -6422,7 +6422,7 @@
               </a:defRPr>
             </a:pPr>
             <a:r>
-              <a:t>✔ ประกอบตู้คอนโทรลสำเร็จรูป พร้อมเดินระบบไฟภายใน</a:t>
+              <a:t>✔ ประกอบตู้คอนโทรลสำเร็จรูป IP65 พร้อมระบบไฟ Switching 24V และ Surge Protection</a:t>
             </a:r>
           </a:p>
           <a:p>
@@ -6437,7 +6437,7 @@
               </a:defRPr>
             </a:pPr>
             <a:r>
-              <a:t>✔ ใส่ซิมรายปีและตั้งค่าเชื่อมต่อเน็ตเวิร์ก 4G LTE</a:t>
+              <a:t>✔ ชุดเซนเซอร์ 4 ค่า (Modela One + pH แก้ว + TDS Titanium + PT1000 + คลอรีน Cybertice)</a:t>
             </a:r>
           </a:p>
           <a:p>
@@ -6452,7 +6452,7 @@
               </a:defRPr>
             </a:pPr>
             <a:r>
-              <a:t>✔ เชื่อมต่อ Modbus อ่านค่า pH, TDS, Temp, Chlorine</a:t>
+              <a:t>✔ เราเตอร์ 4G LTE (TP-Link TL-MR100) พร้อมซิมการ์ด IoT Unlimited Data 12 เดือนเต็ม</a:t>
             </a:r>
           </a:p>
           <a:p>
@@ -6467,7 +6467,7 @@
               </a:defRPr>
             </a:pPr>
             <a:r>
-              <a:t>✔ ตั้งค่าระบบ Modela App สำหรับดูข้อมูลและแจ้งเตือนผ่านมือถือ</a:t>
+              <a:t>✔ ตั้งค่าระบบ Modela Mobile App และ Centralized Web Dashboard 100 จุด</a:t>
             </a:r>
           </a:p>
           <a:p>
@@ -6482,7 +6482,22 @@
               </a:defRPr>
             </a:pPr>
             <a:r>
-              <a:t>✔ จัดทำ Web Dashboard กลางรวมข้อมูลทั้ง 100 จุด</a:t>
+              <a:t>✔ จัดส่งอุปกรณ์สำเร็จรูปถึงหน้างาน พร้อมคู่มือและแบบแปลนการต่อท่อบายพาส</a:t>
+            </a:r>
+          </a:p>
+          <a:p>
+            <a:pPr>
+              <a:spcAft>
+                <a:spcPts val="200"/>
+              </a:spcAft>
+              <a:defRPr sz="950">
+                <a:solidFill>
+                  <a:srgbClr val="64748B"/>
+                </a:solidFill>
+              </a:defRPr>
+            </a:pPr>
+            <a:r>
+              <a:t>✔ รับประกันอุปกรณ์ฮาร์ดแวร์และหัววัดเซนเซอร์ตลอด 1 ปีเต็ม (ลูกค้าติดตั้งยึดตู้เอง)</a:t>
             </a:r>
           </a:p>
           <a:p>
@@ -6490,18 +6505,14 @@
               <a:spcBef>
                 <a:spcPts val="800"/>
               </a:spcBef>
-              <a:defRPr b="1" sz="1000">
+              <a:defRPr b="1" sz="1200">
                 <a:solidFill>
                   <a:srgbClr val="0284C7"/>
                 </a:solidFill>
               </a:defRPr>
             </a:pPr>
             <a:r>
-              <a:t>💰 มูลค่าโครงการรวม (100 ชุด): ฿2,950,000 - ฿3,200,000 บาท</a:t>
-            </a:r>
-            <a:br/>
-            <a:r>
-              <a:t>📈 กำไรขั้นต้นโดยประมาณ: ฿850,000 - ฿1,100,000 บาท (Margin ~29-34%)</a:t>
+              <a:t>💰 ราคาต่อชุด: ฿31,500 บาท  |  มูลค่าโครงการรวม (100 ชุด): ฿3,150,000 บาท</a:t>
             </a:r>
           </a:p>
         </p:txBody>
@@ -6514,8 +6525,8 @@
         </p:nvSpPr>
         <p:spPr>
           <a:xfrm>
-            <a:off x="6309360" y="1463040"/>
-            <a:ext cx="5120640" cy="4754880"/>
+            <a:off x="7955279" y="1463040"/>
+            <a:ext cx="3504895" cy="4754880"/>
           </a:xfrm>
           <a:prstGeom prst="roundRect">
             <a:avLst/>
@@ -6553,57 +6564,14 @@
       </p:sp>
       <p:sp>
         <p:nvSpPr>
-          <p:cNvPr id="8" name="Rounded Rectangle 7"/>
-          <p:cNvSpPr/>
-          <p:nvPr/>
-        </p:nvSpPr>
-        <p:spPr>
-          <a:xfrm>
-            <a:off x="6309360" y="1463040"/>
-            <a:ext cx="5120640" cy="1188720"/>
-          </a:xfrm>
-          <a:prstGeom prst="roundRect">
-            <a:avLst/>
-          </a:prstGeom>
-          <a:solidFill>
-            <a:srgbClr val="059669"/>
-          </a:solidFill>
-          <a:ln>
-            <a:noFill/>
-          </a:ln>
-        </p:spPr>
-        <p:style>
-          <a:lnRef idx="1">
-            <a:schemeClr val="accent1"/>
-          </a:lnRef>
-          <a:fillRef idx="3">
-            <a:schemeClr val="accent1"/>
-          </a:fillRef>
-          <a:effectRef idx="2">
-            <a:schemeClr val="accent1"/>
-          </a:effectRef>
-          <a:fontRef idx="minor">
-            <a:schemeClr val="lt1"/>
-          </a:fontRef>
-        </p:style>
-        <p:txBody>
-          <a:bodyPr rtlCol="0" anchor="ctr"/>
-          <a:lstStyle/>
-          <a:p>
-            <a:pPr algn="ctr"/>
-          </a:p>
-        </p:txBody>
-      </p:sp>
-      <p:sp>
-        <p:nvSpPr>
-          <p:cNvPr id="9" name="TextBox 8"/>
+          <p:cNvPr id="8" name="TextBox 7"/>
           <p:cNvSpPr txBox="1"/>
           <p:nvPr/>
         </p:nvSpPr>
         <p:spPr>
           <a:xfrm>
-            <a:off x="6492240" y="1554480"/>
-            <a:ext cx="4754880" cy="1005840"/>
+            <a:off x="8138160" y="1645920"/>
+            <a:ext cx="3139135" cy="4389120"/>
           </a:xfrm>
           <a:prstGeom prst="rect">
             <a:avLst/>
@@ -6617,64 +6585,51 @@
           <a:lstStyle/>
           <a:p>
             <a:pPr>
-              <a:defRPr sz="1300" b="1">
-                <a:solidFill>
-                  <a:srgbClr val="FFFFFF"/>
-                </a:solidFill>
-              </a:defRPr>
-            </a:pPr>
-            <a:r>
-              <a:t>[แบบที่ 2] แบบครบวงจร รวมติดตั้งหน้างาน + สอบเทียบ</a:t>
-            </a:r>
-          </a:p>
-          <a:p>
-            <a:pPr>
-              <a:defRPr sz="1100" b="1">
-                <a:solidFill>
-                  <a:srgbClr val="FFFFFF"/>
-                </a:solidFill>
-              </a:defRPr>
-            </a:pPr>
-            <a:r>
-              <a:t>Turnkey Solution (ราคา ฿38,000 - ฿42,000 / ชุด)</a:t>
-            </a:r>
-          </a:p>
-        </p:txBody>
-      </p:sp>
-      <p:sp>
-        <p:nvSpPr>
-          <p:cNvPr id="10" name="TextBox 9"/>
-          <p:cNvSpPr txBox="1"/>
-          <p:nvPr/>
-        </p:nvSpPr>
-        <p:spPr>
-          <a:xfrm>
-            <a:off x="6492240" y="2743200"/>
-            <a:ext cx="4754880" cy="3383280"/>
-          </a:xfrm>
-          <a:prstGeom prst="rect">
-            <a:avLst/>
-          </a:prstGeom>
-          <a:noFill/>
-        </p:spPr>
-        <p:txBody>
-          <a:bodyPr wrap="square">
-            <a:spAutoFit/>
-          </a:bodyPr>
-          <a:lstStyle/>
+              <a:spcAft>
+                <a:spcPts val="600"/>
+              </a:spcAft>
+              <a:defRPr sz="1200" b="1">
+                <a:solidFill>
+                  <a:srgbClr val="059669"/>
+                </a:solidFill>
+              </a:defRPr>
+            </a:pPr>
+            <a:r>
+              <a:t>★ บริการเสริมพิเศษ (Add-on):</a:t>
+            </a:r>
+          </a:p>
+          <a:p>
+            <a:pPr>
+              <a:spcAft>
+                <a:spcPts val="1400"/>
+              </a:spcAft>
+              <a:defRPr sz="919">
+                <a:solidFill>
+                  <a:srgbClr val="0F172A"/>
+                </a:solidFill>
+              </a:defRPr>
+            </a:pPr>
+            <a:r>
+              <a:t>หากต้องการให้ทีมวิศวกรเข้าติดตั้ง ยึดตู้ เดินท่อบายพาส และสอบเทียบหัววัดหน้างาน 100 จุด:</a:t>
+            </a:r>
+            <a:br/>
+            <a:r>
+              <a:t>➡️ +฿8,000 / จุด (รวม +฿800,000)</a:t>
+            </a:r>
+          </a:p>
           <a:p>
             <a:pPr>
               <a:spcAft>
                 <a:spcPts val="400"/>
               </a:spcAft>
-              <a:defRPr b="1" sz="1100">
-                <a:solidFill>
-                  <a:srgbClr val="0F172A"/>
-                </a:solidFill>
-              </a:defRPr>
-            </a:pPr>
-            <a:r>
-              <a:t>📋 ขอบเขตงาน (Scope of Work):</a:t>
+              <a:defRPr sz="1100" b="1">
+                <a:solidFill>
+                  <a:srgbClr val="0284C7"/>
+                </a:solidFill>
+              </a:defRPr>
+            </a:pPr>
+            <a:r>
+              <a:t>💻 ทางเลือกซอฟต์แวร์ (100 จุด):</a:t>
             </a:r>
           </a:p>
           <a:p>
@@ -6682,14 +6637,14 @@
               <a:spcAft>
                 <a:spcPts val="200"/>
               </a:spcAft>
-              <a:defRPr sz="950">
+              <a:defRPr sz="850">
                 <a:solidFill>
                   <a:srgbClr val="64748B"/>
                 </a:solidFill>
               </a:defRPr>
             </a:pPr>
             <a:r>
-              <a:t>✔ ทุกอย่างในแบบที่ 1 (ตู้ + ซิม + Modbus + App + Web Dashboard)</a:t>
+              <a:t>• Option 1 (App+Telegram): ซื้อขาด ฿250k | รายปี ฿120k/ปี (แนะนำ)</a:t>
             </a:r>
           </a:p>
           <a:p>
@@ -6697,14 +6652,14 @@
               <a:spcAft>
                 <a:spcPts val="200"/>
               </a:spcAft>
-              <a:defRPr sz="950">
+              <a:defRPr sz="850">
                 <a:solidFill>
                   <a:srgbClr val="64748B"/>
                 </a:solidFill>
               </a:defRPr>
             </a:pPr>
             <a:r>
-              <a:t>✔ ค่าแรงและทีมงานเข้าติดตั้งยึดตู้ / เดินท่อบายพาสหน้างาน</a:t>
+              <a:t>• Option 2 (Web กลาง 100 จุด): ซื้อขาด ฿450k | รายปี ฿240k/ปี</a:t>
             </a:r>
           </a:p>
           <a:p>
@@ -6712,63 +6667,14 @@
               <a:spcAft>
                 <a:spcPts val="200"/>
               </a:spcAft>
-              <a:defRPr sz="950">
+              <a:defRPr sz="850">
                 <a:solidFill>
                   <a:srgbClr val="64748B"/>
                 </a:solidFill>
               </a:defRPr>
             </a:pPr>
             <a:r>
-              <a:t>✔ สอบเทียบ (Calibration) หัววัด pH / TDS ด้วยน้ำยามาตรฐานหน้างาน</a:t>
-            </a:r>
-          </a:p>
-          <a:p>
-            <a:pPr>
-              <a:spcAft>
-                <a:spcPts val="200"/>
-              </a:spcAft>
-              <a:defRPr sz="950">
-                <a:solidFill>
-                  <a:srgbClr val="64748B"/>
-                </a:solidFill>
-              </a:defRPr>
-            </a:pPr>
-            <a:r>
-              <a:t>✔ อบรมการใช้งานระบบและส่งมอบคู่มือการปฏิบัติงาน</a:t>
-            </a:r>
-          </a:p>
-          <a:p>
-            <a:pPr>
-              <a:spcAft>
-                <a:spcPts val="200"/>
-              </a:spcAft>
-              <a:defRPr sz="950">
-                <a:solidFill>
-                  <a:srgbClr val="64748B"/>
-                </a:solidFill>
-              </a:defRPr>
-            </a:pPr>
-            <a:r>
-              <a:t>✔ รับประกันระบบและบริการ On-site Service ตลอด 1 ปีเต็ม</a:t>
-            </a:r>
-          </a:p>
-          <a:p>
-            <a:pPr>
-              <a:spcBef>
-                <a:spcPts val="800"/>
-              </a:spcBef>
-              <a:defRPr b="1" sz="1000">
-                <a:solidFill>
-                  <a:srgbClr val="059669"/>
-                </a:solidFill>
-              </a:defRPr>
-            </a:pPr>
-            <a:r>
-              <a:t>💰 มูลค่าโครงการรวม (100 ชุด): ฿3,800,000 - ฿4,200,000 บาท</a:t>
-            </a:r>
-            <a:br/>
-            <a:r>
-              <a:t>📈 กำไรขั้นต้นโดยประมาณ: ฿1,700,000 - ฿2,100,000 บาท (Margin ~45-50%)</a:t>
+              <a:t>• Option 3 (LINE OA): ซื้อขาด ฿600k | รายปี ฿360k/ปี</a:t>
             </a:r>
           </a:p>
         </p:txBody>
@@ -6877,7 +6783,7 @@
               </a:defRPr>
             </a:pPr>
             <a:r>
-              <a:t>💧 สรุปภาพรวมข้อเสนอราคาและเงื่อนไขสัญญา (100 ชุด)</a:t>
+              <a:t>💧 สรุปภาพรวมข้อเสนอราคาทางการ (100 ชุด)</a:t>
             </a:r>
           </a:p>
           <a:p>
@@ -6907,7 +6813,7 @@
               </a:defRPr>
             </a:pPr>
             <a:r>
-              <a:t>พร้อมส่งมอบอุปกรณ์และระบบแดชบอร์ดครบวงจรตามขอบเขตที่ลูกค้าเลือก:</a:t>
+              <a:t>พร้อมส่งมอบอุปกรณ์สำเร็จรูปและระบบแดชบอร์ดครบวงจร (ไม่รวมติดตั้ง):</a:t>
             </a:r>
           </a:p>
           <a:p>
@@ -6922,19 +6828,19 @@
               </a:defRPr>
             </a:pPr>
             <a:r>
-              <a:t>• รวมต้นทุนฮาร์ดแวร์ต่อชุด: ฿21,000 บาท (100 ชุด = ฿2,100,000 บาท)</a:t>
+              <a:t>• ราคาเสนอขายต่อชุด (Supply Only): ฿31,500 บาท / ชุด</a:t>
             </a:r>
             <a:br/>
             <a:r>
-              <a:t>• [แบบที่ 1 Plug &amp; Play]: ฿29,500 - ฿32,000 บ./ชุด (รวม ฿2.95M - ฿3.20M | กำไร ฿8.5 แสน - ฿1.1 ล้าน)</a:t>
+              <a:t>• มูลค่าโครงการรวม (100 ชุด): ฿3,150,000 บาท (สามล้านหนึ่งแสนห้าหมื่นบาทถ้วน)</a:t>
             </a:r>
             <a:br/>
             <a:r>
-              <a:t>• [แบบที่ 2 Turnkey]: ฿38,000 - ฿42,000 บ./ชุด (รวม ฿3.80M - ฿4.20M | กำไร ฿1.7 - ฿2.1 ล้าน)</a:t>
+              <a:t>• บริการเสริมติดตั้ง &amp; สอบเทียบหน้างาน (Optional Add-on): +฿8,000 บาท/จุด (รวม +฿800,000 บาท)</a:t>
             </a:r>
             <a:br/>
             <a:r>
-              <a:t>• ซอฟต์แวร์แดชบอร์ด 100 จุด: ซื้อขาด ฿2.5 - ฿6.0 แสน | รายปี ฿1.2 - ฿3.6 แสน/ปี (Recurring Income)</a:t>
+              <a:t>• ซอฟต์แวร์แดชบอร์ด 100 จุด: Option 1 (App+Telegram) ฿250k | Option 2 (Web กลาง 100 จุด) ฿450k | Option 3 (LINE OA) ฿600k</a:t>
             </a:r>
           </a:p>
           <a:p>

</xml_diff>

<commit_message>
Update official pricing to Plug & Play bundled (฿36,000/set | ฿3,600,000 total including Web 100 Nodes + Cloud 1 Year)
</commit_message>
<xml_diff>
--- a/NCT_Water_Nexus_Report_and_Pricing.pptx
+++ b/NCT_Water_Nexus_Report_and_Pricing.pptx
@@ -3234,7 +3234,7 @@
             </a:r>
             <a:br/>
             <a:r>
-              <a:t>• ข้อเสนอราคาโครงการ 100 ชุด (ไม่รวมติดตั้ง): ฿31,500 / ชุด (มูลค่ารวม ฿3,150,000 บาท) สรุปไว้ท้ายสุด (สไลด์ 6-8)</a:t>
+              <a:t>• [แบบที่ 1] Plug &amp; Play (ตู้สำเร็จรูป + Web 100 จุด + Cloud 1 ปี): ฿36,000 / ชุด (มูลค่ารวม ฿3,600,000 บาท)</a:t>
             </a:r>
           </a:p>
           <a:p>
@@ -6234,7 +6234,7 @@
               </a:defRPr>
             </a:pPr>
             <a:r>
-              <a:t>6. โครงสร้างราคาขายทางการ (ไม่รวมติดตั้งหน้างาน - 100 ชุด)</a:t>
+              <a:t>6. ข้อเสนอราคาโครงการทางการ (ส่งมอบตู้สำเร็จรูป + Web 100 จุด + Cloud 1 ปี)</a:t>
             </a:r>
           </a:p>
         </p:txBody>
@@ -6350,26 +6350,26 @@
           <a:lstStyle/>
           <a:p>
             <a:pPr>
-              <a:defRPr sz="1400" b="1">
+              <a:defRPr sz="1300" b="1">
                 <a:solidFill>
                   <a:srgbClr val="FFFFFF"/>
                 </a:solidFill>
               </a:defRPr>
             </a:pPr>
             <a:r>
-              <a:t>ชุดอุปกรณ์ตรวจวัดคุณภาพน้ำสำเร็จรูปพร้อมออนไลน์ (ไม่รวมติดตั้ง)</a:t>
-            </a:r>
-          </a:p>
-          <a:p>
-            <a:pPr>
-              <a:defRPr sz="1100" b="1">
+              <a:t>[แบบที่ 1] Plug &amp; Play (ส่งมอบตู้สำเร็จรูป + Web 100 จุด + Cloud 1 ปี)</a:t>
+            </a:r>
+          </a:p>
+          <a:p>
+            <a:pPr>
+              <a:defRPr sz="1050" b="1">
                 <a:solidFill>
                   <a:srgbClr val="FFFFFF"/>
                 </a:solidFill>
               </a:defRPr>
             </a:pPr>
             <a:r>
-              <a:t>Plug &amp; Play / Supply Only (ราคา ฿31,500 บาท / ชุด)</a:t>
+              <a:t>All-in-One IoT Solution (ราคา ฿36,000 บาท / ชุด | รวม 100 ชุด = ฿3,600,000 บาท)</a:t>
             </a:r>
           </a:p>
         </p:txBody>
@@ -6400,37 +6400,37 @@
               <a:spcAft>
                 <a:spcPts val="400"/>
               </a:spcAft>
-              <a:defRPr b="1" sz="1100">
+              <a:defRPr b="1" sz="1050">
                 <a:solidFill>
                   <a:srgbClr val="0F172A"/>
                 </a:solidFill>
               </a:defRPr>
             </a:pPr>
             <a:r>
-              <a:t>📋 ขอบเขตงานและรายการส่งมอบ (Scope of Deliverables):</a:t>
+              <a:t>📋 ขอบเขตงานและรายการส่งมอบครบวงจร (Scope of Deliverables):</a:t>
             </a:r>
           </a:p>
           <a:p>
             <a:pPr>
               <a:spcAft>
-                <a:spcPts val="200"/>
+                <a:spcPts val="100"/>
               </a:spcAft>
-              <a:defRPr sz="950">
+              <a:defRPr sz="880">
                 <a:solidFill>
                   <a:srgbClr val="64748B"/>
                 </a:solidFill>
               </a:defRPr>
             </a:pPr>
             <a:r>
-              <a:t>✔ ประกอบตู้คอนโทรลสำเร็จรูป IP65 พร้อมระบบไฟ Switching 24V และ Surge Protection</a:t>
+              <a:t>✔ ประกอบตู้คอนโทรลสำเร็จรูป IP65 พร้อม Switching 24V &amp; Surge Protection</a:t>
             </a:r>
           </a:p>
           <a:p>
             <a:pPr>
               <a:spcAft>
-                <a:spcPts val="200"/>
+                <a:spcPts val="100"/>
               </a:spcAft>
-              <a:defRPr sz="950">
+              <a:defRPr sz="880">
                 <a:solidFill>
                   <a:srgbClr val="64748B"/>
                 </a:solidFill>
@@ -6443,9 +6443,9 @@
           <a:p>
             <a:pPr>
               <a:spcAft>
-                <a:spcPts val="200"/>
+                <a:spcPts val="100"/>
               </a:spcAft>
-              <a:defRPr sz="950">
+              <a:defRPr sz="880">
                 <a:solidFill>
                   <a:srgbClr val="64748B"/>
                 </a:solidFill>
@@ -6458,52 +6458,82 @@
           <a:p>
             <a:pPr>
               <a:spcAft>
-                <a:spcPts val="200"/>
+                <a:spcPts val="100"/>
               </a:spcAft>
-              <a:defRPr sz="950">
+              <a:defRPr sz="880">
                 <a:solidFill>
                   <a:srgbClr val="64748B"/>
                 </a:solidFill>
               </a:defRPr>
             </a:pPr>
             <a:r>
-              <a:t>✔ ตั้งค่าระบบ Modela Mobile App และ Centralized Web Dashboard 100 จุด</a:t>
+              <a:t>✔ รวมระบบ Centralized Web Dashboard 100 จุด + Cloud Server License ฟรี 1 ปีแรก</a:t>
             </a:r>
           </a:p>
           <a:p>
             <a:pPr>
               <a:spcAft>
-                <a:spcPts val="200"/>
+                <a:spcPts val="100"/>
               </a:spcAft>
-              <a:defRPr sz="950">
+              <a:defRPr sz="880">
                 <a:solidFill>
                   <a:srgbClr val="64748B"/>
                 </a:solidFill>
               </a:defRPr>
             </a:pPr>
             <a:r>
-              <a:t>✔ จัดส่งอุปกรณ์สำเร็จรูปถึงหน้างาน พร้อมคู่มือและแบบแปลนการต่อท่อบายพาส</a:t>
+              <a:t>✔ Modela Mobile Companion App 5 หน้าเมนู (Home/History/100 Devices/Calib/Settings)</a:t>
             </a:r>
           </a:p>
           <a:p>
             <a:pPr>
               <a:spcAft>
-                <a:spcPts val="200"/>
+                <a:spcPts val="100"/>
               </a:spcAft>
-              <a:defRPr sz="950">
+              <a:defRPr sz="880">
                 <a:solidFill>
                   <a:srgbClr val="64748B"/>
                 </a:solidFill>
               </a:defRPr>
             </a:pPr>
             <a:r>
-              <a:t>✔ รับประกันอุปกรณ์ฮาร์ดแวร์และหัววัดเซนเซอร์ตลอด 1 ปีเต็ม (ลูกค้าติดตั้งยึดตู้เอง)</a:t>
+              <a:t>✔ ระบบแจ้งเตือน Real-time อัตโนมัติ 24 ชม. ผ่าน Telegram (ฟรีตลอดชีพ) และ LINE OA</a:t>
+            </a:r>
+          </a:p>
+          <a:p>
+            <a:pPr>
+              <a:spcAft>
+                <a:spcPts val="100"/>
+              </a:spcAft>
+              <a:defRPr sz="880">
+                <a:solidFill>
+                  <a:srgbClr val="64748B"/>
+                </a:solidFill>
+              </a:defRPr>
+            </a:pPr>
+            <a:r>
+              <a:t>✔ จัดส่งอุปกรณ์สำเร็จรูปถึงหน้างาน พร้อมคู่มือและแบบแปลนการต่อท่อบายพาส (ลูกค้าติดตั้งเอง)</a:t>
+            </a:r>
+          </a:p>
+          <a:p>
+            <a:pPr>
+              <a:spcAft>
+                <a:spcPts val="100"/>
+              </a:spcAft>
+              <a:defRPr sz="880">
+                <a:solidFill>
+                  <a:srgbClr val="64748B"/>
+                </a:solidFill>
+              </a:defRPr>
+            </a:pPr>
+            <a:r>
+              <a:t>✔ รับประกันอุปกรณ์ฮาร์ดแวร์และเซนเซอร์ตลอด 1 ปีเต็ม</a:t>
             </a:r>
           </a:p>
           <a:p>
             <a:pPr>
               <a:spcBef>
-                <a:spcPts val="800"/>
+                <a:spcPts val="600"/>
               </a:spcBef>
               <a:defRPr b="1" sz="1200">
                 <a:solidFill>
@@ -6512,7 +6542,7 @@
               </a:defRPr>
             </a:pPr>
             <a:r>
-              <a:t>💰 ราคาต่อชุด: ฿31,500 บาท  |  มูลค่าโครงการรวม (100 ชุด): ฿3,150,000 บาท</a:t>
+              <a:t>💰 ราคาต่อชุด: ฿36,000 บาท  |  มูลค่าโครงการรวม (100 ชุด): ฿3,600,000 บาท</a:t>
             </a:r>
           </a:p>
         </p:txBody>
@@ -6629,7 +6659,7 @@
               </a:defRPr>
             </a:pPr>
             <a:r>
-              <a:t>💻 ทางเลือกซอฟต์แวร์ (100 จุด):</a:t>
+              <a:t>🔄 การต่อสัญญาปีถัดไป (Year 2+):</a:t>
             </a:r>
           </a:p>
           <a:p>
@@ -6644,7 +6674,7 @@
               </a:defRPr>
             </a:pPr>
             <a:r>
-              <a:t>• Option 1 (App+Telegram): ซื้อขาด ฿250k | รายปี ฿120k/ปี (แนะนำ)</a:t>
+              <a:t>• ปีที่ 1: ฟรี Cloud &amp; Dashboard ตลอด 12 เดือน</a:t>
             </a:r>
           </a:p>
           <a:p>
@@ -6659,7 +6689,7 @@
               </a:defRPr>
             </a:pPr>
             <a:r>
-              <a:t>• Option 2 (Web กลาง 100 จุด): ซื้อขาด ฿450k | รายปี ฿240k/ปี</a:t>
+              <a:t>• ปีที่ 2 เป็นต้นไป: ค่าบริการ Cloud Server License &amp; Software MA เพียงปีละ 120,000 บาท (1,200 บ./จุด/ปี)</a:t>
             </a:r>
           </a:p>
           <a:p>
@@ -6674,7 +6704,7 @@
               </a:defRPr>
             </a:pPr>
             <a:r>
-              <a:t>• Option 3 (LINE OA): ซื้อขาด ฿600k | รายปี ฿360k/ปี</a:t>
+              <a:t>• รวมการอัปเดตระบบ สำรองฐานข้อมูล และดูแลความปลอดภัย 24 ชม.</a:t>
             </a:r>
           </a:p>
         </p:txBody>
@@ -6813,7 +6843,7 @@
               </a:defRPr>
             </a:pPr>
             <a:r>
-              <a:t>พร้อมส่งมอบอุปกรณ์สำเร็จรูปและระบบแดชบอร์ดครบวงจร (ไม่รวมติดตั้ง):</a:t>
+              <a:t>[แบบที่ 1] Plug &amp; Play (ส่งมอบตู้สำเร็จรูป + Web 100 จุด + Cloud 1 ปี):</a:t>
             </a:r>
           </a:p>
           <a:p>
@@ -6828,19 +6858,23 @@
               </a:defRPr>
             </a:pPr>
             <a:r>
-              <a:t>• ราคาเสนอขายต่อชุด (Supply Only): ฿31,500 บาท / ชุด</a:t>
+              <a:t>• ราคาเสนอขายต่อชุด: ฿36,000 บาท / ชุด</a:t>
             </a:r>
             <a:br/>
             <a:r>
-              <a:t>• มูลค่าโครงการรวม (100 ชุด): ฿3,150,000 บาท (สามล้านหนึ่งแสนห้าหมื่นบาทถ้วน)</a:t>
+              <a:t>• มูลค่าโครงการรวม (100 ชุด): ฿3,600,000 บาท (สามล้านหกแสนบาทถ้วน)</a:t>
             </a:r>
             <a:br/>
             <a:r>
+              <a:t>• รวมครบ: ตู้ IP65 + 4 เซนเซอร์ + ซิม 4G + Web Dashboard 100 จุด + Mobile App + Cloud 1 ปี</a:t>
+            </a:r>
+            <a:br/>
+            <a:r>
               <a:t>• บริการเสริมติดตั้ง &amp; สอบเทียบหน้างาน (Optional Add-on): +฿8,000 บาท/จุด (รวม +฿800,000 บาท)</a:t>
             </a:r>
             <a:br/>
             <a:r>
-              <a:t>• ซอฟต์แวร์แดชบอร์ด 100 จุด: Option 1 (App+Telegram) ฿250k | Option 2 (Web กลาง 100 จุด) ฿450k | Option 3 (LINE OA) ฿600k</a:t>
+              <a:t>• ปีที่ 2 เป็นต้นไป: ค่าบริการ Cloud Server &amp; Software MA ปีละ 120,000 บาท/ปี</a:t>
             </a:r>
           </a:p>
           <a:p>

</xml_diff>

<commit_message>
Remove battery mentions and replace with 24V Power Supply across all UI, PDFs, and PPTX
</commit_message>
<xml_diff>
--- a/NCT_Water_Nexus_Report_and_Pricing.pptx
+++ b/NCT_Water_Nexus_Report_and_Pricing.pptx
@@ -4288,7 +4288,7 @@
               </a:defRPr>
             </a:pPr>
             <a:r>
-              <a:t>❶ สถานะระบบ &amp; แบตเตอรี่: แสดงสถานะ Healthy, สัญญาณ 4G/WiFi และแบต LiFePO4 (90%)</a:t>
+              <a:t>❶ สถานะระบบ &amp; ไฟเลี้ยง 24V: แสดงสถานะ Healthy, สัญญาณ 4G/WiFi และระบบไฟ Switching 24V ปกติ</a:t>
             </a:r>
           </a:p>
           <a:p>
@@ -4555,7 +4555,7 @@
               </a:defRPr>
             </a:pPr>
             <a:r>
-              <a:t>Hero pH, Cl, Temp, TDS, Battery</a:t>
+              <a:t>Hero pH, Cl, Temp, TDS, Power 24V</a:t>
             </a:r>
           </a:p>
         </p:txBody>

</xml_diff>

<commit_message>
Update quotation structure to 1-set base pricing (฿45k/set) with volume discount for >100 sets (฿36k/set)
</commit_message>
<xml_diff>
--- a/NCT_Water_Nexus_Report_and_Pricing.pptx
+++ b/NCT_Water_Nexus_Report_and_Pricing.pptx
@@ -3181,7 +3181,7 @@
               </a:defRPr>
             </a:pPr>
             <a:r>
-              <a:t>💧 โครงการระบบตรวจวัดคุณภาพน้ำอัจฉริยะ 100 ชุด (Modela + Cybertice)</a:t>
+              <a:t>💧 ชุดอุปกรณ์ตรวจวัดคุณภาพน้ำอัจฉริยะสำเร็จรูป (Modela + Cybertice)</a:t>
             </a:r>
           </a:p>
           <a:p>
@@ -3211,7 +3211,7 @@
               </a:defRPr>
             </a:pPr>
             <a:r>
-              <a:t>รายงานนำเสนอโซลูชันระบบตรวจวัดคุณภาพน้ำ แดชบอร์ดควบคุม และใบเสนอราคาทางการ (100 ชุด)</a:t>
+              <a:t>รายงานนำเสนอโซลูชันระบบตรวจวัดคุณภาพน้ำ แดชบอร์ดควบคุม และใบเสนอราคามาตรฐาน (1 ชุด)</a:t>
             </a:r>
           </a:p>
           <a:p>
@@ -3234,7 +3234,7 @@
             </a:r>
             <a:br/>
             <a:r>
-              <a:t>• [แบบที่ 1] Plug &amp; Play (ตู้สำเร็จรูป + Web 100 จุด + Cloud 1 ปี): ฿36,000 / ชุด (มูลค่ารวม ฿3,600,000 บาท)</a:t>
+              <a:t>• ราคาเสนอขายมาตรฐาน: ฿45,000 / ชุด (พร้อมเงื่อนไขส่วนลดพิเศษเมื่อสั่งซื้อ 100 ชุดขึ้นไป เหลือ ฿36,000 / ชุด)</a:t>
             </a:r>
           </a:p>
           <a:p>
@@ -3310,7 +3310,7 @@
               </a:defRPr>
             </a:pPr>
             <a:r>
-              <a:t>โครงการระบบตรวจวัดคุณภาพน้ำ 100 ชุด (NCT WATER NEXUS)</a:t>
+              <a:t>ชุดอุปกรณ์ตรวจวัดคุณภาพน้ำสำเร็จรูป (NCT WATER NEXUS)</a:t>
             </a:r>
           </a:p>
           <a:p>
@@ -3322,7 +3322,7 @@
               </a:defRPr>
             </a:pPr>
             <a:r>
-              <a:t>1. ภาพรวมโครงการและข้อกำหนดทางเทคนิค 4 พารามิเตอร์</a:t>
+              <a:t>1. ข้อมูลผลิตภัณฑ์และข้อกำหนดทางเทคนิค 4 พารามิเตอร์</a:t>
             </a:r>
           </a:p>
         </p:txBody>
@@ -4154,7 +4154,7 @@
               </a:defRPr>
             </a:pPr>
             <a:r>
-              <a:t>โครงการระบบตรวจวัดคุณภาพน้ำ 100 ชุด (NCT WATER NEXUS)</a:t>
+              <a:t>ชุดอุปกรณ์ตรวจวัดคุณภาพน้ำสำเร็จรูป (NCT WATER NEXUS)</a:t>
             </a:r>
           </a:p>
           <a:p>
@@ -4427,7 +4427,7 @@
               </a:defRPr>
             </a:pPr>
             <a:r>
-              <a:t>โครงการระบบตรวจวัดคุณภาพน้ำ 100 ชุด (NCT WATER NEXUS)</a:t>
+              <a:t>ชุดอุปกรณ์ตรวจวัดคุณภาพน้ำสำเร็จรูป (NCT WATER NEXUS)</a:t>
             </a:r>
           </a:p>
           <a:p>
@@ -4775,7 +4775,7 @@
               </a:defRPr>
             </a:pPr>
             <a:r>
-              <a:t>3. รวม 100 สถานี (Devices)</a:t>
+              <a:t>3. รวมสถานีทั้งหมด (Devices)</a:t>
             </a:r>
           </a:p>
           <a:p>
@@ -4967,7 +4967,7 @@
               </a:defRPr>
             </a:pPr>
             <a:r>
-              <a:t>โครงการระบบตรวจวัดคุณภาพน้ำ 100 ชุด (NCT WATER NEXUS)</a:t>
+              <a:t>ชุดอุปกรณ์ตรวจวัดคุณภาพน้ำสำเร็จรูป (NCT WATER NEXUS)</a:t>
             </a:r>
           </a:p>
           <a:p>
@@ -5331,7 +5331,7 @@
               </a:defRPr>
             </a:pPr>
             <a:r>
-              <a:t>โครงการระบบตรวจวัดคุณภาพน้ำ 100 ชุด (NCT WATER NEXUS)</a:t>
+              <a:t>ชุดอุปกรณ์ตรวจวัดคุณภาพน้ำสำเร็จรูป (NCT WATER NEXUS)</a:t>
             </a:r>
           </a:p>
           <a:p>
@@ -5343,7 +5343,7 @@
               </a:defRPr>
             </a:pPr>
             <a:r>
-              <a:t>5. รายการอุปกรณ์ฮาร์ดแวร์ตู้คอนโทรลมาตรฐาน 4 ค่า (Hardware Specs)</a:t>
+              <a:t>5. รายการอุปกรณ์ฮาร์ดแวร์ตู้คอนโทรลมาตรฐานต่อชุด (Hardware Specs)</a:t>
             </a:r>
           </a:p>
         </p:txBody>
@@ -6146,7 +6146,7 @@
               </a:defRPr>
             </a:pPr>
             <a:r>
-              <a:t>➡️ มาตรฐานชุดอุปกรณ์: สำเร็จรูปพร้อมติดตั้ง 100 จุด สื่อสาร 4G LTE และ Cloud Dashboard ครบวงจร</a:t>
+              <a:t>➡️ มาตรฐานชุดอุปกรณ์: สำเร็จรูปพร้อมติดตั้ง สื่อสาร 4G LTE และ Cloud Dashboard ครบวงจร</a:t>
             </a:r>
           </a:p>
           <a:p>
@@ -6222,7 +6222,7 @@
               </a:defRPr>
             </a:pPr>
             <a:r>
-              <a:t>โครงการระบบตรวจวัดคุณภาพน้ำ 100 ชุด (NCT WATER NEXUS)</a:t>
+              <a:t>ชุดอุปกรณ์ตรวจวัดคุณภาพน้ำสำเร็จรูป (NCT WATER NEXUS)</a:t>
             </a:r>
           </a:p>
           <a:p>
@@ -6234,7 +6234,7 @@
               </a:defRPr>
             </a:pPr>
             <a:r>
-              <a:t>6. ข้อเสนอราคาโครงการทางการ (ส่งมอบตู้สำเร็จรูป + Web 100 จุด + Cloud 1 ปี)</a:t>
+              <a:t>6. ใบเสนอราคาทางการ (ราคามาตรฐานต่อ 1 ชุด + ส่วนลดโครงการ &gt;100 ชุด)</a:t>
             </a:r>
           </a:p>
         </p:txBody>
@@ -6357,7 +6357,7 @@
               </a:defRPr>
             </a:pPr>
             <a:r>
-              <a:t>[แบบที่ 1] Plug &amp; Play (ส่งมอบตู้สำเร็จรูป + Web 100 จุด + Cloud 1 ปี)</a:t>
+              <a:t>ชุดอุปกรณ์ตรวจวัดคุณภาพน้ำสำเร็จรูปพร้อมระบบออนไลน์ (1 ชุด)</a:t>
             </a:r>
           </a:p>
           <a:p>
@@ -6369,7 +6369,7 @@
               </a:defRPr>
             </a:pPr>
             <a:r>
-              <a:t>All-in-One IoT Solution (ราคา ฿36,000 บาท / ชุด | รวม 100 ชุด = ฿3,600,000 บาท)</a:t>
+              <a:t>All-in-One IoT Solution (ราคาเสนอขายมาตรฐาน ฿45,000 บาท / ชุด)</a:t>
             </a:r>
           </a:p>
         </p:txBody>
@@ -6407,7 +6407,7 @@
               </a:defRPr>
             </a:pPr>
             <a:r>
-              <a:t>📋 ขอบเขตงานและรายการส่งมอบครบวงจร (Scope of Deliverables):</a:t>
+              <a:t>📋 ขอบเขตงานและรายการส่งมอบครบวงจรใน 1 ชุด:</a:t>
             </a:r>
           </a:p>
           <a:p>
@@ -6467,7 +6467,7 @@
               </a:defRPr>
             </a:pPr>
             <a:r>
-              <a:t>✔ รวมระบบ Centralized Web Dashboard 100 จุด + Cloud Server License ฟรี 1 ปีแรก</a:t>
+              <a:t>✔ รวมระบบ Centralized Web Dashboard + Cloud Server License ฟรี 1 ปีแรก</a:t>
             </a:r>
           </a:p>
           <a:p>
@@ -6482,7 +6482,7 @@
               </a:defRPr>
             </a:pPr>
             <a:r>
-              <a:t>✔ Modela Mobile Companion App 5 หน้าเมนู (Home/History/100 Devices/Calib/Settings)</a:t>
+              <a:t>✔ Modela Mobile Companion App 5 หน้าเมนู (Home/History/Devices/Calib/Settings)</a:t>
             </a:r>
           </a:p>
           <a:p>
@@ -6542,7 +6542,7 @@
               </a:defRPr>
             </a:pPr>
             <a:r>
-              <a:t>💰 ราคาต่อชุด: ฿36,000 บาท  |  มูลค่าโครงการรวม (100 ชุด): ฿3,600,000 บาท</a:t>
+              <a:t>💰 ราคาเสนอขายมาตรฐาน: ฿45,000 บาท / ชุด (สี่หมื่นห้าพันบาทถ้วน)</a:t>
             </a:r>
           </a:p>
         </p:txBody>
@@ -6618,41 +6618,64 @@
               <a:spcAft>
                 <a:spcPts val="600"/>
               </a:spcAft>
-              <a:defRPr sz="1200" b="1">
+              <a:defRPr sz="1150" b="1">
                 <a:solidFill>
                   <a:srgbClr val="059669"/>
                 </a:solidFill>
               </a:defRPr>
             </a:pPr>
             <a:r>
-              <a:t>★ บริการเสริมพิเศษ (Add-on):</a:t>
+              <a:t>🌟 ส่วนลดพิเศษระดับโครงการ (&gt;100 ชุด):</a:t>
             </a:r>
           </a:p>
           <a:p>
             <a:pPr>
               <a:spcAft>
-                <a:spcPts val="1400"/>
+                <a:spcPts val="1200"/>
               </a:spcAft>
-              <a:defRPr sz="919">
+              <a:defRPr sz="919" b="1">
                 <a:solidFill>
                   <a:srgbClr val="0F172A"/>
                 </a:solidFill>
               </a:defRPr>
             </a:pPr>
             <a:r>
-              <a:t>หากต้องการให้ทีมวิศวกรเข้าติดตั้ง ยึดตู้ เดินท่อบายพาส และสอบเทียบหัววัดหน้างาน 100 จุด:</a:t>
+              <a:t>กรณีสั่งซื้อตั้งแต่ 100 ชุดขึ้นไป:</a:t>
             </a:r>
             <a:br/>
             <a:r>
-              <a:t>➡️ +฿8,000 / จุด (รวม +฿800,000)</a:t>
+              <a:t>➡️ เหลือเพียง ฿36,000 บาท / ชุด</a:t>
+            </a:r>
+            <a:br/>
+            <a:r>
+              <a:t>(รวม 100 ชุด = ฿3,600,000 บาท ประหยัดทันที ฿900,000)</a:t>
             </a:r>
           </a:p>
           <a:p>
             <a:pPr>
               <a:spcAft>
-                <a:spcPts val="400"/>
+                <a:spcPts val="1200"/>
               </a:spcAft>
-              <a:defRPr sz="1100" b="1">
+              <a:defRPr sz="850">
+                <a:solidFill>
+                  <a:srgbClr val="64748B"/>
+                </a:solidFill>
+              </a:defRPr>
+            </a:pPr>
+            <a:r>
+              <a:t>★ บริการเสริมติดตั้งหน้างาน (Add-on):</a:t>
+            </a:r>
+            <a:br/>
+            <a:r>
+              <a:t>+฿8,000 / จุด (ทีมวิศวกรเข้าติดตั้งและสอบเทียบ)</a:t>
+            </a:r>
+          </a:p>
+          <a:p>
+            <a:pPr>
+              <a:spcAft>
+                <a:spcPts val="300"/>
+              </a:spcAft>
+              <a:defRPr sz="1000" b="1">
                 <a:solidFill>
                   <a:srgbClr val="0284C7"/>
                 </a:solidFill>
@@ -6667,7 +6690,7 @@
               <a:spcAft>
                 <a:spcPts val="200"/>
               </a:spcAft>
-              <a:defRPr sz="850">
+              <a:defRPr sz="819">
                 <a:solidFill>
                   <a:srgbClr val="64748B"/>
                 </a:solidFill>
@@ -6682,29 +6705,14 @@
               <a:spcAft>
                 <a:spcPts val="200"/>
               </a:spcAft>
-              <a:defRPr sz="850">
+              <a:defRPr sz="819">
                 <a:solidFill>
                   <a:srgbClr val="64748B"/>
                 </a:solidFill>
               </a:defRPr>
             </a:pPr>
             <a:r>
-              <a:t>• ปีที่ 2 เป็นต้นไป: ค่าบริการ Cloud Server License &amp; Software MA เพียงปีละ 120,000 บาท (1,200 บ./จุด/ปี)</a:t>
-            </a:r>
-          </a:p>
-          <a:p>
-            <a:pPr>
-              <a:spcAft>
-                <a:spcPts val="200"/>
-              </a:spcAft>
-              <a:defRPr sz="850">
-                <a:solidFill>
-                  <a:srgbClr val="64748B"/>
-                </a:solidFill>
-              </a:defRPr>
-            </a:pPr>
-            <a:r>
-              <a:t>• รวมการอัปเดตระบบ สำรองฐานข้อมูล และดูแลความปลอดภัย 24 ชม.</a:t>
+              <a:t>• ปีที่ 2 เป็นต้นไป: ค่าบริการ Cloud Server License &amp; Software MA เพียงปีละ 1,200 บาท/ชุด/ปี (100 บ./เดือน)</a:t>
             </a:r>
           </a:p>
         </p:txBody>
@@ -6813,7 +6821,7 @@
               </a:defRPr>
             </a:pPr>
             <a:r>
-              <a:t>💧 สรุปภาพรวมข้อเสนอราคาทางการ (100 ชุด)</a:t>
+              <a:t>💧 สรุปภาพรวมข้อเสนอราคาทางการ</a:t>
             </a:r>
           </a:p>
           <a:p>
@@ -6843,7 +6851,7 @@
               </a:defRPr>
             </a:pPr>
             <a:r>
-              <a:t>[แบบที่ 1] Plug &amp; Play (ส่งมอบตู้สำเร็จรูป + Web 100 จุด + Cloud 1 ปี):</a:t>
+              <a:t>ชุดอุปกรณ์ตรวจวัดคุณภาพน้ำสำเร็จรูปพร้อมระบบออนไลน์ (1 ชุดมาตรฐาน):</a:t>
             </a:r>
           </a:p>
           <a:p>
@@ -6858,23 +6866,23 @@
               </a:defRPr>
             </a:pPr>
             <a:r>
-              <a:t>• ราคาเสนอขายต่อชุด: ฿36,000 บาท / ชุด</a:t>
+              <a:t>• ราคาเสนอขายมาตรฐาน (1 ชุด): ฿45,000 บาท / ชุด</a:t>
             </a:r>
             <a:br/>
             <a:r>
-              <a:t>• มูลค่าโครงการรวม (100 ชุด): ฿3,600,000 บาท (สามล้านหกแสนบาทถ้วน)</a:t>
+              <a:t>• ส่วนลดพิเศษระดับโครงการ (สั่งซื้อตั้งแต่ 100 ชุดขึ้นไป): ฿36,000 บาท / ชุด (มูลค่ารวม ฿3,600,000 บาท)</a:t>
             </a:r>
             <a:br/>
             <a:r>
-              <a:t>• รวมครบ: ตู้ IP65 + 4 เซนเซอร์ + ซิม 4G + Web Dashboard 100 จุด + Mobile App + Cloud 1 ปี</a:t>
+              <a:t>• รวมครบ: ตู้ IP65 + 4 เซนเซอร์ + ซิม 4G + Web Dashboard + Mobile App + Cloud 1 ปี</a:t>
             </a:r>
             <a:br/>
             <a:r>
-              <a:t>• บริการเสริมติดตั้ง &amp; สอบเทียบหน้างาน (Optional Add-on): +฿8,000 บาท/จุด (รวม +฿800,000 บาท)</a:t>
+              <a:t>• บริการเสริมติดตั้ง &amp; สอบเทียบหน้างาน (Optional Add-on): +฿8,000 บาท/จุด</a:t>
             </a:r>
             <a:br/>
             <a:r>
-              <a:t>• ปีที่ 2 เป็นต้นไป: ค่าบริการ Cloud Server &amp; Software MA ปีละ 120,000 บาท/ปี</a:t>
+              <a:t>• ปีที่ 2 เป็นต้นไป: ค่าบริการ Cloud Server &amp; Software MA เพียง 1,200 บาท/ชุด/ปี</a:t>
             </a:r>
           </a:p>
           <a:p>

</xml_diff>

<commit_message>
Update quote: price per unit bundled with 100-node Web cap, and over-100 nodes management fee clause
</commit_message>
<xml_diff>
--- a/NCT_Water_Nexus_Report_and_Pricing.pptx
+++ b/NCT_Water_Nexus_Report_and_Pricing.pptx
@@ -3211,7 +3211,7 @@
               </a:defRPr>
             </a:pPr>
             <a:r>
-              <a:t>รายงานนำเสนอโซลูชันระบบตรวจวัดคุณภาพน้ำ แดชบอร์ดควบคุม และใบเสนอราคามาตรฐาน (1 ชุด)</a:t>
+              <a:t>รายงานนำเสนอโซลูชันระบบตรวจวัดคุณภาพน้ำ แดชบอร์ดควบคุม และใบเสนอราคามาตรฐานต่อชุด</a:t>
             </a:r>
           </a:p>
           <a:p>
@@ -3219,7 +3219,7 @@
               <a:spcAft>
                 <a:spcPts val="2800"/>
               </a:spcAft>
-              <a:defRPr sz="1200">
+              <a:defRPr sz="1150">
                 <a:solidFill>
                   <a:srgbClr val="94A3B8"/>
                 </a:solidFill>
@@ -3230,11 +3230,15 @@
             </a:r>
             <a:br/>
             <a:r>
-              <a:t>• ระบบแดชบอร์ดคู่ขนาน: Centralized Web Dashboard (จอใหญ่ห้องควบคุม) + Modela Mobile App (5 หน้าเมนู)</a:t>
+              <a:t>• ระบบแดชบอร์ดคู่ขนาน: Centralized Web Dashboard + Modela Mobile App (5 หน้าเมนู)</a:t>
             </a:r>
             <a:br/>
             <a:r>
-              <a:t>• ราคาเสนอขายมาตรฐาน: ฿45,000 / ชุด (พร้อมเงื่อนไขส่วนลดพิเศษเมื่อสั่งซื้อ 100 ชุดขึ้นไป เหลือ ฿36,000 / ชุด)</a:t>
+              <a:t>• ราคาเสนอขายต่อชุด: ฿36,000 / ชุด (ผูกสิทธิ์ Web Dashboard รองรับสูงสุด 100 จุด • สั่งปลีก ฿45,000 / ชุด)</a:t>
+            </a:r>
+            <a:br/>
+            <a:r>
+              <a:t>• กรณีขยายระบบเกิน 100 จุด: มีค่าบริหารจัดการระบบและขยาย Server โหนดเพิ่มเติมตามขนาดโครงการ</a:t>
             </a:r>
           </a:p>
           <a:p>
@@ -4166,7 +4170,7 @@
               </a:defRPr>
             </a:pPr>
             <a:r>
-              <a:t>2. ภาพแคปหน้าจอระบบ Centralized Web Dashboard จริง (index.html)</a:t>
+              <a:t>2. ภาพแคปหน้าจอระบบ Centralized Web Dashboard จริง (ผูกสิทธิ์ 100 จุด)</a:t>
             </a:r>
           </a:p>
         </p:txBody>
@@ -4266,14 +4270,14 @@
               <a:spcAft>
                 <a:spcPts val="800"/>
               </a:spcAft>
-              <a:defRPr sz="1300" b="1">
+              <a:defRPr sz="1250" b="1">
                 <a:solidFill>
                   <a:srgbClr val="0284C7"/>
                 </a:solidFill>
               </a:defRPr>
             </a:pPr>
             <a:r>
-              <a:t>💻 คำอธิบายฟังก์ชันหน้าจอ Web Dashboard:</a:t>
+              <a:t>💻 ฟังก์ชันหน้าจอ Web Dashboard (ความจุ 100 จุด):</a:t>
             </a:r>
           </a:p>
           <a:p>
@@ -4281,7 +4285,7 @@
               <a:spcAft>
                 <a:spcPts val="300"/>
               </a:spcAft>
-              <a:defRPr sz="950">
+              <a:defRPr sz="919">
                 <a:solidFill>
                   <a:srgbClr val="0F172A"/>
                 </a:solidFill>
@@ -4296,7 +4300,7 @@
               <a:spcAft>
                 <a:spcPts val="300"/>
               </a:spcAft>
-              <a:defRPr sz="950">
+              <a:defRPr sz="919">
                 <a:solidFill>
                   <a:srgbClr val="0F172A"/>
                 </a:solidFill>
@@ -4311,7 +4315,7 @@
               <a:spcAft>
                 <a:spcPts val="300"/>
               </a:spcAft>
-              <a:defRPr sz="950">
+              <a:defRPr sz="919">
                 <a:solidFill>
                   <a:srgbClr val="0F172A"/>
                 </a:solidFill>
@@ -4326,14 +4330,14 @@
               <a:spcAft>
                 <a:spcPts val="300"/>
               </a:spcAft>
-              <a:defRPr sz="950">
+              <a:defRPr sz="919">
                 <a:solidFill>
                   <a:srgbClr val="0F172A"/>
                 </a:solidFill>
               </a:defRPr>
             </a:pPr>
             <a:r>
-              <a:t>❹ ไดอะแกรมเชื่อมต่อ: ตรวจจับสายสัญญาณ WiFi ➔ Display ➔ Sensor Probes</a:t>
+              <a:t>❹ ผูกสิทธิ์รองรับสูงสุด 100 จุด: ระบบจัดการโหนดกลางรองรับได้ถึง 100 สถานีในแพ็กเกจเดียว</a:t>
             </a:r>
           </a:p>
           <a:p>
@@ -4341,7 +4345,7 @@
               <a:spcAft>
                 <a:spcPts val="300"/>
               </a:spcAft>
-              <a:defRPr sz="950">
+              <a:defRPr sz="919">
                 <a:solidFill>
                   <a:srgbClr val="0F172A"/>
                 </a:solidFill>
@@ -4356,7 +4360,7 @@
               <a:spcAft>
                 <a:spcPts val="300"/>
               </a:spcAft>
-              <a:defRPr sz="950">
+              <a:defRPr sz="919">
                 <a:solidFill>
                   <a:srgbClr val="0F172A"/>
                 </a:solidFill>
@@ -6234,7 +6238,7 @@
               </a:defRPr>
             </a:pPr>
             <a:r>
-              <a:t>6. ใบเสนอราคาทางการ (ราคามาตรฐานต่อ 1 ชุด + ส่วนลดโครงการ &gt;100 ชุด)</a:t>
+              <a:t>6. ใบเสนอราคาทางการ (ราคาต่อชุด + สิทธิ์ Web 100 จุด + เงื่อนไขเกิน 100 จุด)</a:t>
             </a:r>
           </a:p>
         </p:txBody>
@@ -6357,7 +6361,7 @@
               </a:defRPr>
             </a:pPr>
             <a:r>
-              <a:t>ชุดอุปกรณ์ตรวจวัดคุณภาพน้ำสำเร็จรูปพร้อมระบบออนไลน์ (1 ชุด)</a:t>
+              <a:t>ชุดอุปกรณ์ตรวจวัดคุณภาพน้ำสำเร็จรูปพร้อมระบบออนไลน์ (ราคาต่อชุด)</a:t>
             </a:r>
           </a:p>
           <a:p>
@@ -6369,7 +6373,7 @@
               </a:defRPr>
             </a:pPr>
             <a:r>
-              <a:t>All-in-One IoT Solution (ราคาเสนอขายมาตรฐาน ฿45,000 บาท / ชุด)</a:t>
+              <a:t>NCT Water Nexus Pro - Plug &amp; Play (ผูกสิทธิ์ Web Dashboard รองรับสูงสุด 100 จุด)</a:t>
             </a:r>
           </a:p>
         </p:txBody>
@@ -6467,7 +6471,7 @@
               </a:defRPr>
             </a:pPr>
             <a:r>
-              <a:t>✔ รวมระบบ Centralized Web Dashboard + Cloud Server License ฟรี 1 ปีแรก</a:t>
+              <a:t>✔ รวมระบบ Centralized Web Dashboard + Cloud Server รองรับสูงสุด 100 จุด ฟรี 1 ปีแรก</a:t>
             </a:r>
           </a:p>
           <a:p>
@@ -6535,14 +6539,14 @@
               <a:spcBef>
                 <a:spcPts val="600"/>
               </a:spcBef>
-              <a:defRPr b="1" sz="1200">
+              <a:defRPr b="1" sz="1150">
                 <a:solidFill>
                   <a:srgbClr val="0284C7"/>
                 </a:solidFill>
               </a:defRPr>
             </a:pPr>
             <a:r>
-              <a:t>💰 ราคาเสนอขายมาตรฐาน: ฿45,000 บาท / ชุด (สี่หมื่นห้าพันบาทถ้วน)</a:t>
+              <a:t>💰 ราคาเสนอขายต่อชุด: ฿36,000 บาท / ชุด  (สั่งซื้อชุดเดี่ยวปลีก: ฿45,000 บาท/ชุด)</a:t>
             </a:r>
           </a:p>
         </p:txBody>
@@ -6566,7 +6570,7 @@
           </a:solidFill>
           <a:ln w="19050">
             <a:solidFill>
-              <a:srgbClr val="059669"/>
+              <a:srgbClr val="D97706"/>
             </a:solidFill>
           </a:ln>
         </p:spPr>
@@ -6616,45 +6620,41 @@
           <a:p>
             <a:pPr>
               <a:spcAft>
-                <a:spcPts val="600"/>
+                <a:spcPts val="400"/>
               </a:spcAft>
-              <a:defRPr sz="1150" b="1">
-                <a:solidFill>
-                  <a:srgbClr val="059669"/>
-                </a:solidFill>
-              </a:defRPr>
-            </a:pPr>
-            <a:r>
-              <a:t>🌟 ส่วนลดพิเศษระดับโครงการ (&gt;100 ชุด):</a:t>
+              <a:defRPr sz="1100" b="1">
+                <a:solidFill>
+                  <a:srgbClr val="D97706"/>
+                </a:solidFill>
+              </a:defRPr>
+            </a:pPr>
+            <a:r>
+              <a:t>⚠️ เงื่อนไขกรณีขยายเกิน 100 จุด:</a:t>
             </a:r>
           </a:p>
           <a:p>
             <a:pPr>
               <a:spcAft>
-                <a:spcPts val="1200"/>
+                <a:spcPts val="1000"/>
               </a:spcAft>
-              <a:defRPr sz="919" b="1">
+              <a:defRPr sz="850">
                 <a:solidFill>
                   <a:srgbClr val="0F172A"/>
                 </a:solidFill>
               </a:defRPr>
             </a:pPr>
             <a:r>
-              <a:t>กรณีสั่งซื้อตั้งแต่ 100 ชุดขึ้นไป:</a:t>
+              <a:t>• ระบบ Web &amp; Cloud ในราคานี้ผูกสิทธิ์รองรับสูงสุด 100 จุด</a:t>
             </a:r>
             <a:br/>
             <a:r>
-              <a:t>➡️ เหลือเพียง ฿36,000 บาท / ชุด</a:t>
-            </a:r>
-            <a:br/>
-            <a:r>
-              <a:t>(รวม 100 ชุด = ฿3,600,000 บาท ประหยัดทันที ฿900,000)</a:t>
+              <a:t>• กรณีสั่งซื้อหรือขยายระบบ เกินกว่า 100 จุดขึ้นไป จะมีค่าบริหารจัดการระบบและขยาย Server โหนดเพิ่มเติมตามขนาดโครงการ</a:t>
             </a:r>
           </a:p>
           <a:p>
             <a:pPr>
               <a:spcAft>
-                <a:spcPts val="1200"/>
+                <a:spcPts val="1000"/>
               </a:spcAft>
               <a:defRPr sz="850">
                 <a:solidFill>
@@ -6697,7 +6697,7 @@
               </a:defRPr>
             </a:pPr>
             <a:r>
-              <a:t>• ปีที่ 1: ฟรี Cloud &amp; Dashboard ตลอด 12 เดือน</a:t>
+              <a:t>• ปีที่ 1: ฟรี Cloud &amp; Dashboard ตลอด 12 เดือน (สูงสุด 100 จุด)</a:t>
             </a:r>
           </a:p>
           <a:p>
@@ -6712,7 +6712,7 @@
               </a:defRPr>
             </a:pPr>
             <a:r>
-              <a:t>• ปีที่ 2 เป็นต้นไป: ค่าบริการ Cloud Server License &amp; Software MA เพียงปีละ 1,200 บาท/ชุด/ปี (100 บ./เดือน)</a:t>
+              <a:t>• ปีที่ 2 เป็นต้นไป: ค่าบริการ Cloud Server License &amp; Software MA ปีละ 120,000 บาท/ปี (1.2k/จุด/ปี)</a:t>
             </a:r>
           </a:p>
         </p:txBody>
@@ -6851,7 +6851,7 @@
               </a:defRPr>
             </a:pPr>
             <a:r>
-              <a:t>ชุดอุปกรณ์ตรวจวัดคุณภาพน้ำสำเร็จรูปพร้อมระบบออนไลน์ (1 ชุดมาตรฐาน):</a:t>
+              <a:t>ชุดอุปกรณ์ตรวจวัดคุณภาพน้ำสำเร็จรูปพร้อมระบบออนไลน์ (ราคาต่อชุด):</a:t>
             </a:r>
           </a:p>
           <a:p>
@@ -6866,15 +6866,15 @@
               </a:defRPr>
             </a:pPr>
             <a:r>
-              <a:t>• ราคาเสนอขายมาตรฐาน (1 ชุด): ฿45,000 บาท / ชุด</a:t>
+              <a:t>• ราคาเสนอขายต่อชุด: ฿36,000 บาท / ชุด (ผูกสิทธิ์ Web Dashboard รองรับสูงสุด 100 จุด)</a:t>
             </a:r>
             <a:br/>
             <a:r>
-              <a:t>• ส่วนลดพิเศษระดับโครงการ (สั่งซื้อตั้งแต่ 100 ชุดขึ้นไป): ฿36,000 บาท / ชุด (มูลค่ารวม ฿3,600,000 บาท)</a:t>
+              <a:t>• สั่งซื้อชุดเดี่ยวปลีก (Standalone): ฿45,000 บาท / ชุด</a:t>
             </a:r>
             <a:br/>
             <a:r>
-              <a:t>• รวมครบ: ตู้ IP65 + 4 เซนเซอร์ + ซิม 4G + Web Dashboard + Mobile App + Cloud 1 ปี</a:t>
+              <a:t>• กรณีขยายระบบเกิน 100 จุดขึ้นไป: คิดค่าบริหารจัดการระบบและขยาย Server โหนดเพิ่มเติมตามขนาดโครงการ</a:t>
             </a:r>
             <a:br/>
             <a:r>
@@ -6882,7 +6882,7 @@
             </a:r>
             <a:br/>
             <a:r>
-              <a:t>• ปีที่ 2 เป็นต้นไป: ค่าบริการ Cloud Server &amp; Software MA เพียง 1,200 บาท/ชุด/ปี</a:t>
+              <a:t>• ปีที่ 2 เป็นต้นไป: ค่าบริการ Cloud Server &amp; Software MA เพียง 120,000 บาท/ปี (1,200 บ./จุด/ปี)</a:t>
             </a:r>
           </a:p>
           <a:p>

</xml_diff>

<commit_message>
Update quote: Year 2 Cloud MA 300 THB/mo, net free year 1 only, and add 4.2 Wi-Fi version
</commit_message>
<xml_diff>
--- a/NCT_Water_Nexus_Report_and_Pricing.pptx
+++ b/NCT_Water_Nexus_Report_and_Pricing.pptx
@@ -3230,15 +3230,19 @@
             </a:r>
             <a:br/>
             <a:r>
-              <a:t>• ระบบแดชบอร์ดคู่ขนาน: Centralized Web Dashboard + Modela Mobile App (5 หน้าเมนู)</a:t>
+              <a:t>• 4.1 รุ่น 4G LTE Plug &amp; Play: ฿36,000 / ชุด (มีเราเตอร์ + ซิม Unlimited ฟรีปีแรก • สั่งปลีก ฿45,000 / ชุด)</a:t>
             </a:r>
             <a:br/>
             <a:r>
-              <a:t>• ราคาเสนอขายต่อชุด: ฿36,000 / ชุด (ผูกสิทธิ์ Web Dashboard รองรับสูงสุด 100 จุด • สั่งปลีก ฿45,000 / ชุด)</a:t>
+              <a:t>• 4.2 รุ่น Wi-Fi Direct: ฿32,000 / ชุด (ตัดเราเตอร์และซิมออก ต่อ Wi-Fi หน้างานตรง • สั่งปลีก ฿40,000 / ชุด)</a:t>
             </a:r>
             <a:br/>
             <a:r>
-              <a:t>• กรณีขยายระบบเกิน 100 จุด: มีค่าบริหารจัดการระบบและขยาย Server โหนดเพิ่มเติมตามขนาดโครงการ</a:t>
+              <a:t>• ปีที่ 2 เป็นต้นไป: ค่าบริการ Cloud Server &amp; Software MA เดือนละ 300 บาท/จุด (เน็ตฟรีเฉพาะปีแรก)</a:t>
+            </a:r>
+            <a:br/>
+            <a:r>
+              <a:t>• ทั้งสองรุ่นผูกสิทธิ์ Web Dashboard และ Cloud ฟรีปีแรก รองรับสูงสุด 100 จุด (เกิน 100 จุดมีค่าบริหารจัดการเพิ่ม)</a:t>
             </a:r>
           </a:p>
           <a:p>
@@ -3250,7 +3254,7 @@
               </a:defRPr>
             </a:pPr>
             <a:r>
-              <a:t>NCT Water Solutions  •  System Version 2.5 Pro  •  August 2026</a:t>
+              <a:t>NCT Water Solutions  •  System Version 2.6 Pro  •  September 2026</a:t>
             </a:r>
           </a:p>
         </p:txBody>
@@ -5711,7 +5715,7 @@
             </a:r>
             <a:br/>
             <a:r>
-              <a:t>• เชื่อมต่อระบบ Telemetry สดทุก 1 วินาที</a:t>
+              <a:t>• (สำหรับรุ่น 4.1 เท่านั้น)</a:t>
             </a:r>
           </a:p>
         </p:txBody>
@@ -5834,7 +5838,7 @@
               </a:defRPr>
             </a:pPr>
             <a:r>
-              <a:t>ซิมการ์ด 4G รายปี (Unlimited)</a:t>
+              <a:t>ซิมการ์ด 4G IoT (Unlimited)</a:t>
             </a:r>
           </a:p>
           <a:p>
@@ -5846,7 +5850,7 @@
               </a:defRPr>
             </a:pPr>
             <a:r>
-              <a:t>15-20 Mbps</a:t>
+              <a:t>ฟรีเฉพาะปีแรก</a:t>
             </a:r>
           </a:p>
         </p:txBody>
@@ -5885,11 +5889,11 @@
             </a:r>
             <a:br/>
             <a:r>
-              <a:t>• รวมค่าบริการเครือข่าย 12 เดือนเต็ม</a:t>
+              <a:t>• รวมค่าบริการเครือข่าย 12 เดือนแรก</a:t>
             </a:r>
             <a:br/>
             <a:r>
-              <a:t>• ส่งข้อมูลขึ้นระบบคลาวด์ตลอด 24 ชม.</a:t>
+              <a:t>• ปีที่ 2 ลูกค้ารับผิดชอบค่าเน็ตเอง</a:t>
             </a:r>
           </a:p>
         </p:txBody>
@@ -6150,7 +6154,7 @@
               </a:defRPr>
             </a:pPr>
             <a:r>
-              <a:t>➡️ มาตรฐานชุดอุปกรณ์: สำเร็จรูปพร้อมติดตั้ง สื่อสาร 4G LTE และ Cloud Dashboard ครบวงจร</a:t>
+              <a:t>➡️ ทางเลือกการสื่อสาร: รุ่น 4G LTE (มีเราเตอร์+ซิม) vs รุ่น Wi-Fi (ตัดเราเตอร์และซิมออก ประหยัด ฿4,000/ชุด)</a:t>
             </a:r>
           </a:p>
           <a:p>
@@ -6162,7 +6166,7 @@
               </a:defRPr>
             </a:pPr>
             <a:r>
-              <a:t>ชุดอุปกรณ์ประกอบสำเร็จรูป ตรวจสอบระบบไฟฟ้า และทดสอบสัญญาณเชื่อมต่อออนไลน์ 100% ก่อนส่งมอบหน้างาน</a:t>
+              <a:t>อุปกรณ์ประกอบสำเร็จรูป ตรวจสอบระบบไฟฟ้า และทดสอบออนไลน์ 100% ก่อนส่งมอบหน้างาน | รุ่น Wi-Fi ต่อเน็ตโรงงานโดยตรง</a:t>
             </a:r>
           </a:p>
         </p:txBody>
@@ -6238,7 +6242,7 @@
               </a:defRPr>
             </a:pPr>
             <a:r>
-              <a:t>6. ใบเสนอราคาทางการ (ราคาต่อชุด + สิทธิ์ Web 100 จุด + เงื่อนไขเกิน 100 จุด)</a:t>
+              <a:t>6. ใบเสนอราคาทางการ (เปรียบเทียบรุ่น 4G LTE vs รุ่น Wi-Fi)</a:t>
             </a:r>
           </a:p>
         </p:txBody>
@@ -6252,7 +6256,7 @@
         <p:spPr>
           <a:xfrm>
             <a:off x="731520" y="1463040"/>
-            <a:ext cx="6949440" cy="4754880"/>
+            <a:ext cx="5120640" cy="4754880"/>
           </a:xfrm>
           <a:prstGeom prst="roundRect">
             <a:avLst/>
@@ -6297,7 +6301,7 @@
         <p:spPr>
           <a:xfrm>
             <a:off x="731520" y="1463040"/>
-            <a:ext cx="6949440" cy="1188720"/>
+            <a:ext cx="5120640" cy="1005840"/>
           </a:xfrm>
           <a:prstGeom prst="roundRect">
             <a:avLst/>
@@ -6339,8 +6343,8 @@
         </p:nvSpPr>
         <p:spPr>
           <a:xfrm>
-            <a:off x="1005840" y="1554480"/>
-            <a:ext cx="6400800" cy="1005840"/>
+            <a:off x="914400" y="1554480"/>
+            <a:ext cx="4754880" cy="822960"/>
           </a:xfrm>
           <a:prstGeom prst="rect">
             <a:avLst/>
@@ -6361,19 +6365,19 @@
               </a:defRPr>
             </a:pPr>
             <a:r>
-              <a:t>ชุดอุปกรณ์ตรวจวัดคุณภาพน้ำสำเร็จรูปพร้อมระบบออนไลน์ (ราคาต่อชุด)</a:t>
-            </a:r>
-          </a:p>
-          <a:p>
-            <a:pPr>
-              <a:defRPr sz="1050" b="1">
+              <a:t>4.1 รุ่น 4G LTE Plug &amp; Play</a:t>
+            </a:r>
+          </a:p>
+          <a:p>
+            <a:pPr>
+              <a:defRPr sz="1100" b="1">
                 <a:solidFill>
                   <a:srgbClr val="FFFFFF"/>
                 </a:solidFill>
               </a:defRPr>
             </a:pPr>
             <a:r>
-              <a:t>NCT Water Nexus Pro - Plug &amp; Play (ผูกสิทธิ์ Web Dashboard รองรับสูงสุด 100 จุด)</a:t>
+              <a:t>฿36,000 บาท / ชุด  (สั่งซื้อเดี่ยว: ฿45,000 บาท/ชุด)</a:t>
             </a:r>
           </a:p>
         </p:txBody>
@@ -6386,8 +6390,8 @@
         </p:nvSpPr>
         <p:spPr>
           <a:xfrm>
-            <a:off x="1005840" y="2743200"/>
-            <a:ext cx="6400800" cy="3383280"/>
+            <a:off x="914400" y="2560320"/>
+            <a:ext cx="4754880" cy="3474720"/>
           </a:xfrm>
           <a:prstGeom prst="rect">
             <a:avLst/>
@@ -6399,154 +6403,110 @@
             <a:spAutoFit/>
           </a:bodyPr>
           <a:lstStyle/>
+          <a:p/>
           <a:p>
             <a:pPr>
               <a:spcAft>
-                <a:spcPts val="400"/>
+                <a:spcPts val="200"/>
               </a:spcAft>
-              <a:defRPr b="1" sz="1050">
+              <a:defRPr sz="850">
                 <a:solidFill>
                   <a:srgbClr val="0F172A"/>
                 </a:solidFill>
               </a:defRPr>
             </a:pPr>
             <a:r>
-              <a:t>📋 ขอบเขตงานและรายการส่งมอบครบวงจรใน 1 ชุด:</a:t>
+              <a:t>✔ ตู้ IP65 + Switching 24V + Modela One + 4 เซนเซอร์</a:t>
             </a:r>
           </a:p>
           <a:p>
             <a:pPr>
               <a:spcAft>
-                <a:spcPts val="100"/>
+                <a:spcPts val="200"/>
               </a:spcAft>
-              <a:defRPr sz="880">
-                <a:solidFill>
-                  <a:srgbClr val="64748B"/>
-                </a:solidFill>
-              </a:defRPr>
-            </a:pPr>
-            <a:r>
-              <a:t>✔ ประกอบตู้คอนโทรลสำเร็จรูป IP65 พร้อม Switching 24V &amp; Surge Protection</a:t>
+              <a:defRPr sz="850">
+                <a:solidFill>
+                  <a:srgbClr val="0F172A"/>
+                </a:solidFill>
+              </a:defRPr>
+            </a:pPr>
+            <a:r>
+              <a:t>✔ เราเตอร์ 4G LTE อุตสาหกรรม (TP-Link TL-MR100)</a:t>
             </a:r>
           </a:p>
           <a:p>
             <a:pPr>
               <a:spcAft>
-                <a:spcPts val="100"/>
+                <a:spcPts val="200"/>
               </a:spcAft>
-              <a:defRPr sz="880">
-                <a:solidFill>
-                  <a:srgbClr val="64748B"/>
-                </a:solidFill>
-              </a:defRPr>
-            </a:pPr>
-            <a:r>
-              <a:t>✔ ชุดเซนเซอร์ 4 ค่า (Modela One + pH แก้ว + TDS Titanium + PT1000 + คลอรีน Cybertice)</a:t>
+              <a:defRPr sz="850">
+                <a:solidFill>
+                  <a:srgbClr val="0F172A"/>
+                </a:solidFill>
+              </a:defRPr>
+            </a:pPr>
+            <a:r>
+              <a:t>✔ ซิมเน็ต IoT 4G Unlimited Data (ฟรีเฉพาะปีแรก)</a:t>
             </a:r>
           </a:p>
           <a:p>
             <a:pPr>
               <a:spcAft>
-                <a:spcPts val="100"/>
+                <a:spcPts val="200"/>
               </a:spcAft>
-              <a:defRPr sz="880">
-                <a:solidFill>
-                  <a:srgbClr val="64748B"/>
-                </a:solidFill>
-              </a:defRPr>
-            </a:pPr>
-            <a:r>
-              <a:t>✔ เราเตอร์ 4G LTE (TP-Link TL-MR100) พร้อมซิมการ์ด IoT Unlimited Data 12 เดือนเต็ม</a:t>
+              <a:defRPr sz="850">
+                <a:solidFill>
+                  <a:srgbClr val="0F172A"/>
+                </a:solidFill>
+              </a:defRPr>
+            </a:pPr>
+            <a:r>
+              <a:t>✔ รวมระบบ Web Dashboard &amp; App รองรับ 100 จุด (ฟรี 1 ปี)</a:t>
             </a:r>
           </a:p>
           <a:p>
             <a:pPr>
               <a:spcAft>
-                <a:spcPts val="100"/>
+                <a:spcPts val="200"/>
               </a:spcAft>
-              <a:defRPr sz="880">
-                <a:solidFill>
-                  <a:srgbClr val="64748B"/>
-                </a:solidFill>
-              </a:defRPr>
-            </a:pPr>
-            <a:r>
-              <a:t>✔ รวมระบบ Centralized Web Dashboard + Cloud Server รองรับสูงสุด 100 จุด ฟรี 1 ปีแรก</a:t>
+              <a:defRPr sz="850">
+                <a:solidFill>
+                  <a:srgbClr val="0F172A"/>
+                </a:solidFill>
+              </a:defRPr>
+            </a:pPr>
+            <a:r>
+              <a:t>✔ แจ้งเตือนอัตโนมัติ 24 ชม. ผ่าน Telegram (ฟรี) &amp; LINE OA</a:t>
             </a:r>
           </a:p>
           <a:p>
             <a:pPr>
               <a:spcAft>
-                <a:spcPts val="100"/>
+                <a:spcPts val="200"/>
               </a:spcAft>
-              <a:defRPr sz="880">
-                <a:solidFill>
-                  <a:srgbClr val="64748B"/>
-                </a:solidFill>
-              </a:defRPr>
-            </a:pPr>
-            <a:r>
-              <a:t>✔ Modela Mobile Companion App 5 หน้าเมนู (Home/History/Devices/Calib/Settings)</a:t>
+              <a:defRPr sz="850">
+                <a:solidFill>
+                  <a:srgbClr val="0F172A"/>
+                </a:solidFill>
+              </a:defRPr>
+            </a:pPr>
+            <a:r>
+              <a:t>✔ จัดส่งสำเร็จรูปพร้อมคู่มือ (ลูกค้าติดตั้งเอง) ประกัน 1 ปี</a:t>
             </a:r>
           </a:p>
           <a:p>
             <a:pPr>
               <a:spcAft>
-                <a:spcPts val="100"/>
+                <a:spcPts val="200"/>
               </a:spcAft>
-              <a:defRPr sz="880">
-                <a:solidFill>
-                  <a:srgbClr val="64748B"/>
-                </a:solidFill>
-              </a:defRPr>
-            </a:pPr>
-            <a:r>
-              <a:t>✔ ระบบแจ้งเตือน Real-time อัตโนมัติ 24 ชม. ผ่าน Telegram (ฟรีตลอดชีพ) และ LINE OA</a:t>
-            </a:r>
-          </a:p>
-          <a:p>
-            <a:pPr>
-              <a:spcAft>
-                <a:spcPts val="100"/>
-              </a:spcAft>
-              <a:defRPr sz="880">
-                <a:solidFill>
-                  <a:srgbClr val="64748B"/>
-                </a:solidFill>
-              </a:defRPr>
-            </a:pPr>
-            <a:r>
-              <a:t>✔ จัดส่งอุปกรณ์สำเร็จรูปถึงหน้างาน พร้อมคู่มือและแบบแปลนการต่อท่อบายพาส (ลูกค้าติดตั้งเอง)</a:t>
-            </a:r>
-          </a:p>
-          <a:p>
-            <a:pPr>
-              <a:spcAft>
-                <a:spcPts val="100"/>
-              </a:spcAft>
-              <a:defRPr sz="880">
-                <a:solidFill>
-                  <a:srgbClr val="64748B"/>
-                </a:solidFill>
-              </a:defRPr>
-            </a:pPr>
-            <a:r>
-              <a:t>✔ รับประกันอุปกรณ์ฮาร์ดแวร์และเซนเซอร์ตลอด 1 ปีเต็ม</a:t>
-            </a:r>
-          </a:p>
-          <a:p>
-            <a:pPr>
-              <a:spcBef>
-                <a:spcPts val="600"/>
-              </a:spcBef>
-              <a:defRPr b="1" sz="1150">
+              <a:defRPr sz="850" b="1">
                 <a:solidFill>
                   <a:srgbClr val="0284C7"/>
                 </a:solidFill>
               </a:defRPr>
             </a:pPr>
             <a:r>
-              <a:t>💰 ราคาเสนอขายต่อชุด: ฿36,000 บาท / ชุด  (สั่งซื้อชุดเดี่ยวปลีก: ฿45,000 บาท/ชุด)</a:t>
+              <a:t>✔ ★ ปีที่ 2: ค่าบริการ Cloud MA เดือนละ 300 บ./จุด (3,600 บ./จุด/ปี หรือ 360k/ปี สำหรับ 100 จุด) • เน็ตฟรีแค่ปีแรก ปีถัดไปลูกค้าดูแลค่าซิมเอง</a:t>
             </a:r>
           </a:p>
         </p:txBody>
@@ -6559,8 +6519,8 @@
         </p:nvSpPr>
         <p:spPr>
           <a:xfrm>
-            <a:off x="7955279" y="1463040"/>
-            <a:ext cx="3504895" cy="4754880"/>
+            <a:off x="6309360" y="1463040"/>
+            <a:ext cx="5120640" cy="4754880"/>
           </a:xfrm>
           <a:prstGeom prst="roundRect">
             <a:avLst/>
@@ -6570,7 +6530,7 @@
           </a:solidFill>
           <a:ln w="19050">
             <a:solidFill>
-              <a:srgbClr val="D97706"/>
+              <a:srgbClr val="059669"/>
             </a:solidFill>
           </a:ln>
         </p:spPr>
@@ -6598,14 +6558,57 @@
       </p:sp>
       <p:sp>
         <p:nvSpPr>
-          <p:cNvPr id="8" name="TextBox 7"/>
+          <p:cNvPr id="8" name="Rounded Rectangle 7"/>
+          <p:cNvSpPr/>
+          <p:nvPr/>
+        </p:nvSpPr>
+        <p:spPr>
+          <a:xfrm>
+            <a:off x="6309360" y="1463040"/>
+            <a:ext cx="5120640" cy="1005840"/>
+          </a:xfrm>
+          <a:prstGeom prst="roundRect">
+            <a:avLst/>
+          </a:prstGeom>
+          <a:solidFill>
+            <a:srgbClr val="059669"/>
+          </a:solidFill>
+          <a:ln>
+            <a:noFill/>
+          </a:ln>
+        </p:spPr>
+        <p:style>
+          <a:lnRef idx="1">
+            <a:schemeClr val="accent1"/>
+          </a:lnRef>
+          <a:fillRef idx="3">
+            <a:schemeClr val="accent1"/>
+          </a:fillRef>
+          <a:effectRef idx="2">
+            <a:schemeClr val="accent1"/>
+          </a:effectRef>
+          <a:fontRef idx="minor">
+            <a:schemeClr val="lt1"/>
+          </a:fontRef>
+        </p:style>
+        <p:txBody>
+          <a:bodyPr rtlCol="0" anchor="ctr"/>
+          <a:lstStyle/>
+          <a:p>
+            <a:pPr algn="ctr"/>
+          </a:p>
+        </p:txBody>
+      </p:sp>
+      <p:sp>
+        <p:nvSpPr>
+          <p:cNvPr id="9" name="TextBox 8"/>
           <p:cNvSpPr txBox="1"/>
           <p:nvPr/>
         </p:nvSpPr>
         <p:spPr>
           <a:xfrm>
-            <a:off x="8138160" y="1645920"/>
-            <a:ext cx="3139135" cy="4389120"/>
+            <a:off x="6492240" y="1554480"/>
+            <a:ext cx="4754880" cy="822960"/>
           </a:xfrm>
           <a:prstGeom prst="rect">
             <a:avLst/>
@@ -6619,85 +6622,65 @@
           <a:lstStyle/>
           <a:p>
             <a:pPr>
-              <a:spcAft>
-                <a:spcPts val="400"/>
-              </a:spcAft>
+              <a:defRPr sz="1300" b="1">
+                <a:solidFill>
+                  <a:srgbClr val="FFFFFF"/>
+                </a:solidFill>
+              </a:defRPr>
+            </a:pPr>
+            <a:r>
+              <a:t>4.2 รุ่น Wi-Fi (ตัดเราเตอร์และซิมออก)</a:t>
+            </a:r>
+          </a:p>
+          <a:p>
+            <a:pPr>
               <a:defRPr sz="1100" b="1">
                 <a:solidFill>
-                  <a:srgbClr val="D97706"/>
-                </a:solidFill>
-              </a:defRPr>
-            </a:pPr>
-            <a:r>
-              <a:t>⚠️ เงื่อนไขกรณีขยายเกิน 100 จุด:</a:t>
-            </a:r>
-          </a:p>
-          <a:p>
-            <a:pPr>
-              <a:spcAft>
-                <a:spcPts val="1000"/>
-              </a:spcAft>
-              <a:defRPr sz="850">
-                <a:solidFill>
-                  <a:srgbClr val="0F172A"/>
-                </a:solidFill>
-              </a:defRPr>
-            </a:pPr>
-            <a:r>
-              <a:t>• ระบบ Web &amp; Cloud ในราคานี้ผูกสิทธิ์รองรับสูงสุด 100 จุด</a:t>
-            </a:r>
-            <a:br/>
-            <a:r>
-              <a:t>• กรณีสั่งซื้อหรือขยายระบบ เกินกว่า 100 จุดขึ้นไป จะมีค่าบริหารจัดการระบบและขยาย Server โหนดเพิ่มเติมตามขนาดโครงการ</a:t>
-            </a:r>
-          </a:p>
-          <a:p>
-            <a:pPr>
-              <a:spcAft>
-                <a:spcPts val="1000"/>
-              </a:spcAft>
-              <a:defRPr sz="850">
-                <a:solidFill>
-                  <a:srgbClr val="64748B"/>
-                </a:solidFill>
-              </a:defRPr>
-            </a:pPr>
-            <a:r>
-              <a:t>★ บริการเสริมติดตั้งหน้างาน (Add-on):</a:t>
-            </a:r>
-            <a:br/>
-            <a:r>
-              <a:t>+฿8,000 / จุด (ทีมวิศวกรเข้าติดตั้งและสอบเทียบ)</a:t>
-            </a:r>
-          </a:p>
-          <a:p>
-            <a:pPr>
-              <a:spcAft>
-                <a:spcPts val="300"/>
-              </a:spcAft>
-              <a:defRPr sz="1000" b="1">
-                <a:solidFill>
-                  <a:srgbClr val="0284C7"/>
-                </a:solidFill>
-              </a:defRPr>
-            </a:pPr>
-            <a:r>
-              <a:t>🔄 การต่อสัญญาปีถัดไป (Year 2+):</a:t>
-            </a:r>
-          </a:p>
+                  <a:srgbClr val="FFFFFF"/>
+                </a:solidFill>
+              </a:defRPr>
+            </a:pPr>
+            <a:r>
+              <a:t>฿32,000 บาท / ชุด  (สั่งซื้อเดี่ยว: ฿40,000 บาท/ชุด)</a:t>
+            </a:r>
+          </a:p>
+        </p:txBody>
+      </p:sp>
+      <p:sp>
+        <p:nvSpPr>
+          <p:cNvPr id="10" name="TextBox 9"/>
+          <p:cNvSpPr txBox="1"/>
+          <p:nvPr/>
+        </p:nvSpPr>
+        <p:spPr>
+          <a:xfrm>
+            <a:off x="6492240" y="2560320"/>
+            <a:ext cx="4754880" cy="3474720"/>
+          </a:xfrm>
+          <a:prstGeom prst="rect">
+            <a:avLst/>
+          </a:prstGeom>
+          <a:noFill/>
+        </p:spPr>
+        <p:txBody>
+          <a:bodyPr wrap="square">
+            <a:spAutoFit/>
+          </a:bodyPr>
+          <a:lstStyle/>
+          <a:p/>
           <a:p>
             <a:pPr>
               <a:spcAft>
                 <a:spcPts val="200"/>
               </a:spcAft>
-              <a:defRPr sz="819">
-                <a:solidFill>
-                  <a:srgbClr val="64748B"/>
-                </a:solidFill>
-              </a:defRPr>
-            </a:pPr>
-            <a:r>
-              <a:t>• ปีที่ 1: ฟรี Cloud &amp; Dashboard ตลอด 12 เดือน (สูงสุด 100 จุด)</a:t>
+              <a:defRPr sz="850">
+                <a:solidFill>
+                  <a:srgbClr val="0F172A"/>
+                </a:solidFill>
+              </a:defRPr>
+            </a:pPr>
+            <a:r>
+              <a:t>✔ ตู้ IP65 + Switching 24V + Modela One + 4 เซนเซอร์</a:t>
             </a:r>
           </a:p>
           <a:p>
@@ -6705,14 +6688,89 @@
               <a:spcAft>
                 <a:spcPts val="200"/>
               </a:spcAft>
-              <a:defRPr sz="819">
-                <a:solidFill>
-                  <a:srgbClr val="64748B"/>
-                </a:solidFill>
-              </a:defRPr>
-            </a:pPr>
-            <a:r>
-              <a:t>• ปีที่ 2 เป็นต้นไป: ค่าบริการ Cloud Server License &amp; Software MA ปีละ 120,000 บาท/ปี (1.2k/จุด/ปี)</a:t>
+              <a:defRPr sz="850">
+                <a:solidFill>
+                  <a:srgbClr val="0F172A"/>
+                </a:solidFill>
+              </a:defRPr>
+            </a:pPr>
+            <a:r>
+              <a:t>✔ ตัดเราเตอร์ 4G LTE และซิมการ์ดออก (ประหยัดทันที ฿4,000)</a:t>
+            </a:r>
+          </a:p>
+          <a:p>
+            <a:pPr>
+              <a:spcAft>
+                <a:spcPts val="200"/>
+              </a:spcAft>
+              <a:defRPr sz="850">
+                <a:solidFill>
+                  <a:srgbClr val="0F172A"/>
+                </a:solidFill>
+              </a:defRPr>
+            </a:pPr>
+            <a:r>
+              <a:t>✔ เชื่อมต่อสัญญาณ Wi-Fi 2.4 GHz หน้างานโดยตรง</a:t>
+            </a:r>
+          </a:p>
+          <a:p>
+            <a:pPr>
+              <a:spcAft>
+                <a:spcPts val="200"/>
+              </a:spcAft>
+              <a:defRPr sz="850">
+                <a:solidFill>
+                  <a:srgbClr val="0F172A"/>
+                </a:solidFill>
+              </a:defRPr>
+            </a:pPr>
+            <a:r>
+              <a:t>✔ รวมระบบ Web Dashboard &amp; App รองรับ 100 จุด (ฟรี 1 ปี)</a:t>
+            </a:r>
+          </a:p>
+          <a:p>
+            <a:pPr>
+              <a:spcAft>
+                <a:spcPts val="200"/>
+              </a:spcAft>
+              <a:defRPr sz="850">
+                <a:solidFill>
+                  <a:srgbClr val="0F172A"/>
+                </a:solidFill>
+              </a:defRPr>
+            </a:pPr>
+            <a:r>
+              <a:t>✔ แจ้งเตือนอัตโนมัติ 24 ชม. ผ่าน Telegram (ฟรี) &amp; LINE OA</a:t>
+            </a:r>
+          </a:p>
+          <a:p>
+            <a:pPr>
+              <a:spcAft>
+                <a:spcPts val="200"/>
+              </a:spcAft>
+              <a:defRPr sz="850">
+                <a:solidFill>
+                  <a:srgbClr val="0F172A"/>
+                </a:solidFill>
+              </a:defRPr>
+            </a:pPr>
+            <a:r>
+              <a:t>✔ จัดส่งสำเร็จรูปพร้อมคู่มือ (ลูกค้าติดตั้งเอง) ประกัน 1 ปี</a:t>
+            </a:r>
+          </a:p>
+          <a:p>
+            <a:pPr>
+              <a:spcAft>
+                <a:spcPts val="200"/>
+              </a:spcAft>
+              <a:defRPr sz="850" b="1">
+                <a:solidFill>
+                  <a:srgbClr val="059669"/>
+                </a:solidFill>
+              </a:defRPr>
+            </a:pPr>
+            <a:r>
+              <a:t>✔ ★ ปีที่ 2: ค่าบริการ Cloud MA เดือนละ 300 บ./จุด (3,600 บ./จุด/ปี หรือ 360k/ปี สำหรับ 100 จุด) • ไม่มีภาระค่าบริการซิม 4G</a:t>
             </a:r>
           </a:p>
         </p:txBody>
@@ -6859,30 +6917,30 @@
               <a:spcAft>
                 <a:spcPts val="2400"/>
               </a:spcAft>
-              <a:defRPr sz="1100">
+              <a:defRPr sz="1080">
                 <a:solidFill>
                   <a:srgbClr val="E2E8F0"/>
                 </a:solidFill>
               </a:defRPr>
             </a:pPr>
             <a:r>
-              <a:t>• ราคาเสนอขายต่อชุด: ฿36,000 บาท / ชุด (ผูกสิทธิ์ Web Dashboard รองรับสูงสุด 100 จุด)</a:t>
+              <a:t>• 4.1 รุ่น 4G LTE Plug &amp; Play: ฿36,000 บาท/ชุด (สั่งเดี่ยว ฿45,000) มีเราเตอร์ + ซิม Unlimited ฟรีปีแรก</a:t>
             </a:r>
             <a:br/>
             <a:r>
-              <a:t>• สั่งซื้อชุดเดี่ยวปลีก (Standalone): ฿45,000 บาท / ชุด</a:t>
+              <a:t>• 4.2 รุ่น Wi-Fi Direct: ฿32,000 บาท/ชุด (สั่งเดี่ยว ฿40,000) ตัดเราเตอร์และซิมออก ประหยัดทันที ฿4,000/ชุด</a:t>
             </a:r>
             <a:br/>
             <a:r>
-              <a:t>• กรณีขยายระบบเกิน 100 จุดขึ้นไป: คิดค่าบริหารจัดการระบบและขยาย Server โหนดเพิ่มเติมตามขนาดโครงการ</a:t>
+              <a:t>• ปีที่ 2 เป็นต้นไป: ค่าบริการ Cloud Server License &amp; Software MA เดือนละ 300 บาท/จุด (เน็ตฟรีแค่ปีแรก)</a:t>
             </a:r>
             <a:br/>
             <a:r>
-              <a:t>• บริการเสริมติดตั้ง &amp; สอบเทียบหน้างาน (Optional Add-on): +฿8,000 บาท/จุด</a:t>
+              <a:t>• เงื่อนไขขยายเกิน 100 จุด: คิดค่าบริหารจัดการระบบและขยาย Server โหนดเพิ่มเติมตามขนาดโครงการ</a:t>
             </a:r>
             <a:br/>
             <a:r>
-              <a:t>• ปีที่ 2 เป็นต้นไป: ค่าบริการ Cloud Server &amp; Software MA เพียง 120,000 บาท/ปี (1,200 บ./จุด/ปี)</a:t>
+              <a:t>• บริการเสริมติดตั้ง &amp; สอบเทียบหน้างาน (Add-on): +฿8,000 บาท/จุด</a:t>
             </a:r>
           </a:p>
           <a:p>

</xml_diff>

<commit_message>
Update company name to NCT PROSPERA TECH SOLUTIONS CO., LTD.
</commit_message>
<xml_diff>
--- a/NCT_Water_Nexus_Report_and_Pricing.pptx
+++ b/NCT_Water_Nexus_Report_and_Pricing.pptx
@@ -3254,7 +3254,7 @@
               </a:defRPr>
             </a:pPr>
             <a:r>
-              <a:t>NCT Water Solutions  •  System Version 2.6 Pro  •  September 2026</a:t>
+              <a:t>NCT PROSPERA TECH SOLUTIONS CO., LTD.  •  System Version 2.6 Pro  •  September 2026</a:t>
             </a:r>
           </a:p>
         </p:txBody>
@@ -3318,7 +3318,7 @@
               </a:defRPr>
             </a:pPr>
             <a:r>
-              <a:t>ชุดอุปกรณ์ตรวจวัดคุณภาพน้ำสำเร็จรูป (NCT WATER NEXUS)</a:t>
+              <a:t>NCT PROSPERA TECH SOLUTIONS CO., LTD. • WATER QUALITY MONITORING</a:t>
             </a:r>
           </a:p>
           <a:p>
@@ -4162,7 +4162,7 @@
               </a:defRPr>
             </a:pPr>
             <a:r>
-              <a:t>ชุดอุปกรณ์ตรวจวัดคุณภาพน้ำสำเร็จรูป (NCT WATER NEXUS)</a:t>
+              <a:t>NCT PROSPERA TECH SOLUTIONS CO., LTD. • WATER QUALITY MONITORING</a:t>
             </a:r>
           </a:p>
           <a:p>
@@ -4435,7 +4435,7 @@
               </a:defRPr>
             </a:pPr>
             <a:r>
-              <a:t>ชุดอุปกรณ์ตรวจวัดคุณภาพน้ำสำเร็จรูป (NCT WATER NEXUS)</a:t>
+              <a:t>NCT PROSPERA TECH SOLUTIONS CO., LTD. • WATER QUALITY MONITORING</a:t>
             </a:r>
           </a:p>
           <a:p>
@@ -4975,7 +4975,7 @@
               </a:defRPr>
             </a:pPr>
             <a:r>
-              <a:t>ชุดอุปกรณ์ตรวจวัดคุณภาพน้ำสำเร็จรูป (NCT WATER NEXUS)</a:t>
+              <a:t>NCT PROSPERA TECH SOLUTIONS CO., LTD. • WATER QUALITY MONITORING</a:t>
             </a:r>
           </a:p>
           <a:p>
@@ -5339,7 +5339,7 @@
               </a:defRPr>
             </a:pPr>
             <a:r>
-              <a:t>ชุดอุปกรณ์ตรวจวัดคุณภาพน้ำสำเร็จรูป (NCT WATER NEXUS)</a:t>
+              <a:t>NCT PROSPERA TECH SOLUTIONS CO., LTD. • WATER QUALITY MONITORING</a:t>
             </a:r>
           </a:p>
           <a:p>
@@ -6230,7 +6230,7 @@
               </a:defRPr>
             </a:pPr>
             <a:r>
-              <a:t>ชุดอุปกรณ์ตรวจวัดคุณภาพน้ำสำเร็จรูป (NCT WATER NEXUS)</a:t>
+              <a:t>NCT PROSPERA TECH SOLUTIONS CO., LTD. • WATER QUALITY MONITORING</a:t>
             </a:r>
           </a:p>
           <a:p>
@@ -6909,7 +6909,7 @@
               </a:defRPr>
             </a:pPr>
             <a:r>
-              <a:t>ชุดอุปกรณ์ตรวจวัดคุณภาพน้ำสำเร็จรูปพร้อมระบบออนไลน์ (ราคาต่อชุด):</a:t>
+              <a:t>NCT PROSPERA TECH SOLUTIONS CO., LTD.</a:t>
             </a:r>
           </a:p>
           <a:p>

</xml_diff>

<commit_message>
Update User Licenses: Admin 5 accounts and Viewers 100 accounts, regenerate all PDFs and slides
</commit_message>
<xml_diff>
--- a/NCT_Water_Nexus_Report_and_Pricing.pptx
+++ b/NCT_Water_Nexus_Report_and_Pricing.pptx
@@ -6461,7 +6461,7 @@
               </a:defRPr>
             </a:pPr>
             <a:r>
-              <a:t>✔ รวมระบบ Web Dashboard &amp; App รองรับ 100 จุด (ฟรี 1 ปี)</a:t>
+              <a:t>✔ รวมระบบ Web Dashboard &amp; App รองรับ 100 จุด (Admin 5 / Viewers 100 ฟรี 1 ปี)</a:t>
             </a:r>
           </a:p>
           <a:p>
@@ -6725,7 +6725,7 @@
               </a:defRPr>
             </a:pPr>
             <a:r>
-              <a:t>✔ รวมระบบ Web Dashboard &amp; App รองรับ 100 จุด (ฟรี 1 ปี)</a:t>
+              <a:t>✔ รวมระบบ Web Dashboard &amp; App รองรับ 100 จุด (Admin 5 / Viewers 100 ฟรี 1 ปี)</a:t>
             </a:r>
           </a:p>
           <a:p>
@@ -6929,6 +6929,10 @@
             <a:br/>
             <a:r>
               <a:t>• 4.2 รุ่น Wi-Fi Direct: ฿32,000 บาท/ชุด (สั่งเดี่ยว ฿40,000) ตัดเราเตอร์และซิมออก ประหยัดทันที ฿4,000/ชุด</a:t>
+            </a:r>
+            <a:br/>
+            <a:r>
+              <a:t>• สิทธิ์การใช้งานระบบ: รองรับ Admin 5 บัญชี และ Viewers 100 บัญชี</a:t>
             </a:r>
             <a:br/>
             <a:r>

</xml_diff>

<commit_message>
Update single-unit prices: 4G to 39,500 THB and Wi-Fi to 35,500 THB across all proposals, costing, slides, and PDFs
</commit_message>
<xml_diff>
--- a/NCT_Water_Nexus_Report_and_Pricing.pptx
+++ b/NCT_Water_Nexus_Report_and_Pricing.pptx
@@ -3230,11 +3230,11 @@
             </a:r>
             <a:br/>
             <a:r>
-              <a:t>• 4.1 รุ่น 4G LTE Plug &amp; Play: ฿36,000 / ชุด (มีเราเตอร์ + ซิม Unlimited ฟรีปีแรก • สั่งปลีก ฿45,000 / ชุด)</a:t>
+              <a:t>• 4.1 รุ่น 4G LTE Plug &amp; Play: ฿36,000 / ชุด (มีเราเตอร์ + ซิม Unlimited ฟรีปีแรก • สั่งปลีก ฿39,500 / ชุด)</a:t>
             </a:r>
             <a:br/>
             <a:r>
-              <a:t>• 4.2 รุ่น Wi-Fi Direct: ฿32,000 / ชุด (ตัดเราเตอร์และซิมออก ต่อ Wi-Fi หน้างานตรง • สั่งปลีก ฿40,000 / ชุด)</a:t>
+              <a:t>• 4.2 รุ่น Wi-Fi Direct: ฿32,000 / ชุด (ตัดเราเตอร์และซิมออก ต่อ Wi-Fi หน้างานตรง • สั่งปลีก ฿35,500 / ชุด)</a:t>
             </a:r>
             <a:br/>
             <a:r>
@@ -6377,7 +6377,7 @@
               </a:defRPr>
             </a:pPr>
             <a:r>
-              <a:t>฿36,000 บาท / ชุด  (สั่งซื้อเดี่ยว: ฿45,000 บาท/ชุด)</a:t>
+              <a:t>฿36,000 บาท / ชุด  (สั่งซื้อเดี่ยว: ฿39,500 บาท/ชุด)</a:t>
             </a:r>
           </a:p>
         </p:txBody>
@@ -6641,7 +6641,7 @@
               </a:defRPr>
             </a:pPr>
             <a:r>
-              <a:t>฿32,000 บาท / ชุด  (สั่งซื้อเดี่ยว: ฿40,000 บาท/ชุด)</a:t>
+              <a:t>฿32,000 บาท / ชุด  (สั่งซื้อเดี่ยว: ฿35,500 บาท/ชุด)</a:t>
             </a:r>
           </a:p>
         </p:txBody>
@@ -6924,11 +6924,11 @@
               </a:defRPr>
             </a:pPr>
             <a:r>
-              <a:t>• 4.1 รุ่น 4G LTE Plug &amp; Play: ฿36,000 บาท/ชุด (สั่งเดี่ยว ฿45,000) มีเราเตอร์ + ซิม Unlimited ฟรีปีแรก</a:t>
+              <a:t>• 4.1 รุ่น 4G LTE Plug &amp; Play: ฿36,000 บาท/ชุด (สั่งเดี่ยว ฿39,500) มีเราเตอร์ + ซิม Unlimited ฟรีปีแรก</a:t>
             </a:r>
             <a:br/>
             <a:r>
-              <a:t>• 4.2 รุ่น Wi-Fi Direct: ฿32,000 บาท/ชุด (สั่งเดี่ยว ฿40,000) ตัดเราเตอร์และซิมออก ประหยัดทันที ฿4,000/ชุด</a:t>
+              <a:t>• 4.2 รุ่น Wi-Fi Direct: ฿32,000 บาท/ชุด (สั่งเดี่ยว ฿35,500) ตัดเราเตอร์และซิมออก ประหยัดทันที ฿4,000/ชุด</a:t>
             </a:r>
             <a:br/>
             <a:r>

</xml_diff>

<commit_message>
Add remark: LINE OA has additional message fee (Telegram free), and Dashboard 100 users free with additional users incurring extra fee (without specifying amount)
</commit_message>
<xml_diff>
--- a/NCT_Water_Nexus_Report_and_Pricing.pptx
+++ b/NCT_Water_Nexus_Report_and_Pricing.pptx
@@ -6461,7 +6461,7 @@
               </a:defRPr>
             </a:pPr>
             <a:r>
-              <a:t>✔ รวมระบบ Web Dashboard &amp; App รองรับ 100 จุด (Admin 5 / Viewers 100 ฟรี 1 ปี)</a:t>
+              <a:t>✔ รวมระบบ Web Dashboard &amp; App รองรับ 100 จุด (Admin 5 / ฟรี 100 Users แรก ฟรี 1 ปี)</a:t>
             </a:r>
           </a:p>
           <a:p>
@@ -6725,7 +6725,7 @@
               </a:defRPr>
             </a:pPr>
             <a:r>
-              <a:t>✔ รวมระบบ Web Dashboard &amp; App รองรับ 100 จุด (Admin 5 / Viewers 100 ฟรี 1 ปี)</a:t>
+              <a:t>✔ รวมระบบ Web Dashboard &amp; App รองรับ 100 จุด (Admin 5 / ฟรี 100 Users แรก ฟรี 1 ปี)</a:t>
             </a:r>
           </a:p>
           <a:p>

</xml_diff>